<commit_message>
deck: rewrite architecture slide as native PPTX diagram
Replaces the simple lane diagram on slide 6 with a comprehensive
end-to-end engineering view drawn in PowerPoint shapes. Text is
guaranteed-accurate (no AI image regeneration drift):

- GCP boundary with europe-west2 region label
- External actors (Client, Executive) + sales-ledger data source
- Top row: Scoring Service with guardrails callout, Vertex AI Endpoint,
  Dashboard UI
- Middle: Bounds Calibration, Secret Manager, BigQuery warehouse with
  named tables/views, Reconciliation Service, ML Ops Pipeline, Cloud
  Storage
- Pub/Sub topics: clicks, predictions, anomaly
- Breaker Automation + Activation Service with SA360/SSGTM/OCI sinks
- CI/CD strip: GitHub → WIF → Cloud Build → Artifact Registry → Cloud Run
- Legend bar at the bottom
- Also fixes the footer page numbers swapped on the deliverables /
  architecture slides during the earlier renumber.

Co-Authored-By: Claude Opus 4.7 (1M context) <noreply@anthropic.com>
</commit_message>
<xml_diff>
--- a/docs/client-demo-deck.pptx
+++ b/docs/client-demo-deck.pptx
@@ -9624,7 +9624,7 @@
                 </a:solidFill>
                 <a:latin typeface="Calibri"/>
               </a:rPr>
-              <a:t>6 / 15</a:t>
+              <a:t>5 / 15</a:t>
             </a:r>
           </a:p>
         </p:txBody>
@@ -9694,7 +9694,7 @@
                 </a:solidFill>
                 <a:latin typeface="Calibri"/>
               </a:rPr>
-              <a:t>ARCHITECTURE, IN ONE PICTURE</a:t>
+              <a:t>PREDICTIVE RPC ESTIMATOR</a:t>
             </a:r>
           </a:p>
           <a:p>
@@ -9705,7 +9705,7 @@
                 </a:solidFill>
                 <a:latin typeface="Calibri"/>
               </a:rPr>
-              <a:t>How it works</a:t>
+              <a:t>End-to-end architecture</a:t>
             </a:r>
           </a:p>
         </p:txBody>
@@ -9761,13 +9761,101 @@
         </p:nvSpPr>
         <p:spPr>
           <a:xfrm>
-            <a:off x="457200" y="1463040"/>
-            <a:ext cx="1554480" cy="822960"/>
+            <a:off x="1188720" y="1051560"/>
+            <a:ext cx="10424160" cy="5303520"/>
           </a:xfrm>
           <a:prstGeom prst="roundRect">
             <a:avLst>
-              <a:gd name="adj" fmla="val 15000"/>
+              <a:gd name="adj" fmla="val 2000"/>
             </a:avLst>
+          </a:prstGeom>
+          <a:solidFill>
+            <a:srgbClr val="ECEFF4"/>
+          </a:solidFill>
+          <a:ln w="12700">
+            <a:solidFill>
+              <a:srgbClr val="B8BFCC"/>
+            </a:solidFill>
+          </a:ln>
+        </p:spPr>
+        <p:style>
+          <a:lnRef idx="1">
+            <a:schemeClr val="accent1"/>
+          </a:lnRef>
+          <a:fillRef idx="3">
+            <a:schemeClr val="accent1"/>
+          </a:fillRef>
+          <a:effectRef idx="2">
+            <a:schemeClr val="accent1"/>
+          </a:effectRef>
+          <a:fontRef idx="minor">
+            <a:schemeClr val="lt1"/>
+          </a:fontRef>
+        </p:style>
+        <p:txBody>
+          <a:bodyPr rtlCol="0" anchor="ctr"/>
+          <a:lstStyle/>
+          <a:p>
+            <a:pPr algn="ctr"/>
+          </a:p>
+        </p:txBody>
+      </p:sp>
+      <p:sp>
+        <p:nvSpPr>
+          <p:cNvPr id="5" name="TextBox 4"/>
+          <p:cNvSpPr txBox="1"/>
+          <p:nvPr/>
+        </p:nvSpPr>
+        <p:spPr>
+          <a:xfrm>
+            <a:off x="1325880" y="1097280"/>
+            <a:ext cx="5486400" cy="320040"/>
+          </a:xfrm>
+          <a:prstGeom prst="rect">
+            <a:avLst/>
+          </a:prstGeom>
+          <a:noFill/>
+        </p:spPr>
+        <p:txBody>
+          <a:bodyPr wrap="none">
+            <a:spAutoFit/>
+          </a:bodyPr>
+          <a:lstStyle/>
+          <a:p>
+            <a:r>
+              <a:rPr sz="1200" b="1" i="0">
+                <a:solidFill>
+                  <a:srgbClr val="0B1F3A"/>
+                </a:solidFill>
+                <a:latin typeface="Calibri"/>
+              </a:rPr>
+              <a:t>Google Cloud Platform</a:t>
+            </a:r>
+            <a:r>
+              <a:rPr sz="1100" b="0" i="1">
+                <a:solidFill>
+                  <a:srgbClr val="6B7380"/>
+                </a:solidFill>
+                <a:latin typeface="Calibri"/>
+              </a:rPr>
+              <a:t>    europe-west2 (London)</a:t>
+            </a:r>
+          </a:p>
+        </p:txBody>
+      </p:sp>
+      <p:sp>
+        <p:nvSpPr>
+          <p:cNvPr id="6" name="Oval 5"/>
+          <p:cNvSpPr/>
+          <p:nvPr/>
+        </p:nvSpPr>
+        <p:spPr>
+          <a:xfrm>
+            <a:off x="137160" y="1828800"/>
+            <a:ext cx="292608" cy="292608"/>
+          </a:xfrm>
+          <a:prstGeom prst="ellipse">
+            <a:avLst/>
           </a:prstGeom>
           <a:solidFill>
             <a:srgbClr val="333F52"/>
@@ -9791,52 +9879,29 @@
           </a:fontRef>
         </p:style>
         <p:txBody>
-          <a:bodyPr rtlCol="0" anchor="ctr" wrap="square"/>
+          <a:bodyPr rtlCol="0" anchor="ctr"/>
           <a:lstStyle/>
           <a:p>
             <a:pPr algn="ctr"/>
-            <a:r>
-              <a:rPr sz="1300" b="1" i="0">
-                <a:solidFill>
-                  <a:srgbClr val="FFFFFF"/>
-                </a:solidFill>
-                <a:latin typeface="Calibri"/>
-              </a:rPr>
-              <a:t>Client app</a:t>
-            </a:r>
-          </a:p>
-          <a:p>
-            <a:pPr algn="ctr"/>
-            <a:r>
-              <a:rPr sz="900" b="0" i="0">
-                <a:solidFill>
-                  <a:srgbClr val="F4F6FA"/>
-                </a:solidFill>
-                <a:latin typeface="Calibri"/>
-              </a:rPr>
-              <a:t>browser / server</a:t>
-            </a:r>
-          </a:p>
-        </p:txBody>
-      </p:sp>
-      <p:sp>
-        <p:nvSpPr>
-          <p:cNvPr id="5" name="Rounded Rectangle 4"/>
+          </a:p>
+        </p:txBody>
+      </p:sp>
+      <p:sp>
+        <p:nvSpPr>
+          <p:cNvPr id="7" name="Isosceles Triangle 6"/>
           <p:cNvSpPr/>
           <p:nvPr/>
         </p:nvSpPr>
         <p:spPr>
           <a:xfrm>
-            <a:off x="2331720" y="1463040"/>
-            <a:ext cx="1554480" cy="822960"/>
-          </a:xfrm>
-          <a:prstGeom prst="roundRect">
-            <a:avLst>
-              <a:gd name="adj" fmla="val 15000"/>
-            </a:avLst>
+            <a:off x="91440" y="2084832"/>
+            <a:ext cx="384048" cy="411480"/>
+          </a:xfrm>
+          <a:prstGeom prst="triangle">
+            <a:avLst/>
           </a:prstGeom>
           <a:solidFill>
-            <a:srgbClr val="0F6E7A"/>
+            <a:srgbClr val="333F52"/>
           </a:solidFill>
           <a:ln>
             <a:noFill/>
@@ -9857,52 +9922,76 @@
           </a:fontRef>
         </p:style>
         <p:txBody>
-          <a:bodyPr rtlCol="0" anchor="ctr" wrap="square"/>
+          <a:bodyPr rtlCol="0" anchor="ctr"/>
           <a:lstStyle/>
           <a:p>
             <a:pPr algn="ctr"/>
-            <a:r>
-              <a:rPr sz="1300" b="1" i="0">
-                <a:solidFill>
-                  <a:srgbClr val="FFFFFF"/>
-                </a:solidFill>
-                <a:latin typeface="Calibri"/>
-              </a:rPr>
-              <a:t>Scoring API</a:t>
-            </a:r>
-          </a:p>
+          </a:p>
+        </p:txBody>
+      </p:sp>
+      <p:sp>
+        <p:nvSpPr>
+          <p:cNvPr id="8" name="TextBox 7"/>
+          <p:cNvSpPr txBox="1"/>
+          <p:nvPr/>
+        </p:nvSpPr>
+        <p:spPr>
+          <a:xfrm>
+            <a:off x="-228600" y="2514600"/>
+            <a:ext cx="1024128" cy="502920"/>
+          </a:xfrm>
+          <a:prstGeom prst="rect">
+            <a:avLst/>
+          </a:prstGeom>
+          <a:noFill/>
+        </p:spPr>
+        <p:txBody>
+          <a:bodyPr wrap="square">
+            <a:spAutoFit/>
+          </a:bodyPr>
+          <a:lstStyle/>
           <a:p>
             <a:pPr algn="ctr"/>
             <a:r>
-              <a:rPr sz="900" b="0" i="0">
-                <a:solidFill>
-                  <a:srgbClr val="F4F6FA"/>
-                </a:solidFill>
-                <a:latin typeface="Calibri"/>
-              </a:rPr>
-              <a:t>Cloud Run · Rust</a:t>
-            </a:r>
-          </a:p>
-        </p:txBody>
-      </p:sp>
-      <p:sp>
-        <p:nvSpPr>
-          <p:cNvPr id="6" name="Rounded Rectangle 5"/>
+              <a:rPr sz="900" b="1" i="0">
+                <a:solidFill>
+                  <a:srgbClr val="333F52"/>
+                </a:solidFill>
+                <a:latin typeface="Calibri"/>
+              </a:rPr>
+              <a:t>Client</a:t>
+            </a:r>
+          </a:p>
+          <a:p>
+            <a:pPr algn="ctr"/>
+            <a:r>
+              <a:rPr sz="800" b="0" i="0">
+                <a:solidFill>
+                  <a:srgbClr val="6B7380"/>
+                </a:solidFill>
+                <a:latin typeface="Calibri"/>
+              </a:rPr>
+              <a:t>Ad bidding systems</a:t>
+            </a:r>
+          </a:p>
+        </p:txBody>
+      </p:sp>
+      <p:sp>
+        <p:nvSpPr>
+          <p:cNvPr id="9" name="Oval 8"/>
           <p:cNvSpPr/>
           <p:nvPr/>
         </p:nvSpPr>
         <p:spPr>
           <a:xfrm>
-            <a:off x="4206240" y="1463040"/>
-            <a:ext cx="1554480" cy="822960"/>
-          </a:xfrm>
-          <a:prstGeom prst="roundRect">
-            <a:avLst>
-              <a:gd name="adj" fmla="val 15000"/>
-            </a:avLst>
+            <a:off x="11567160" y="1828800"/>
+            <a:ext cx="292608" cy="292608"/>
+          </a:xfrm>
+          <a:prstGeom prst="ellipse">
+            <a:avLst/>
           </a:prstGeom>
           <a:solidFill>
-            <a:srgbClr val="0B1F3A"/>
+            <a:srgbClr val="333F52"/>
           </a:solidFill>
           <a:ln>
             <a:noFill/>
@@ -9923,52 +10012,29 @@
           </a:fontRef>
         </p:style>
         <p:txBody>
-          <a:bodyPr rtlCol="0" anchor="ctr" wrap="square"/>
+          <a:bodyPr rtlCol="0" anchor="ctr"/>
           <a:lstStyle/>
           <a:p>
             <a:pPr algn="ctr"/>
-            <a:r>
-              <a:rPr sz="1300" b="1" i="0">
-                <a:solidFill>
-                  <a:srgbClr val="FFFFFF"/>
-                </a:solidFill>
-                <a:latin typeface="Calibri"/>
-              </a:rPr>
-              <a:t>Vertex AI</a:t>
-            </a:r>
-          </a:p>
-          <a:p>
-            <a:pPr algn="ctr"/>
-            <a:r>
-              <a:rPr sz="900" b="0" i="0">
-                <a:solidFill>
-                  <a:srgbClr val="F4F6FA"/>
-                </a:solidFill>
-                <a:latin typeface="Calibri"/>
-              </a:rPr>
-              <a:t>XGBoost regressor</a:t>
-            </a:r>
-          </a:p>
-        </p:txBody>
-      </p:sp>
-      <p:sp>
-        <p:nvSpPr>
-          <p:cNvPr id="7" name="Rounded Rectangle 6"/>
+          </a:p>
+        </p:txBody>
+      </p:sp>
+      <p:sp>
+        <p:nvSpPr>
+          <p:cNvPr id="10" name="Isosceles Triangle 9"/>
           <p:cNvSpPr/>
           <p:nvPr/>
         </p:nvSpPr>
         <p:spPr>
           <a:xfrm>
-            <a:off x="6080760" y="1463040"/>
-            <a:ext cx="1554480" cy="822960"/>
-          </a:xfrm>
-          <a:prstGeom prst="roundRect">
-            <a:avLst>
-              <a:gd name="adj" fmla="val 15000"/>
-            </a:avLst>
+            <a:off x="11521440" y="2084832"/>
+            <a:ext cx="384048" cy="411480"/>
+          </a:xfrm>
+          <a:prstGeom prst="triangle">
+            <a:avLst/>
           </a:prstGeom>
           <a:solidFill>
-            <a:srgbClr val="D97306"/>
+            <a:srgbClr val="333F52"/>
           </a:solidFill>
           <a:ln>
             <a:noFill/>
@@ -9989,52 +10055,76 @@
           </a:fontRef>
         </p:style>
         <p:txBody>
-          <a:bodyPr rtlCol="0" anchor="ctr" wrap="square"/>
+          <a:bodyPr rtlCol="0" anchor="ctr"/>
           <a:lstStyle/>
           <a:p>
             <a:pPr algn="ctr"/>
-            <a:r>
-              <a:rPr sz="1300" b="1" i="0">
-                <a:solidFill>
-                  <a:srgbClr val="FFFFFF"/>
-                </a:solidFill>
-                <a:latin typeface="Calibri"/>
-              </a:rPr>
-              <a:t>Pub/Sub</a:t>
-            </a:r>
-          </a:p>
+          </a:p>
+        </p:txBody>
+      </p:sp>
+      <p:sp>
+        <p:nvSpPr>
+          <p:cNvPr id="11" name="TextBox 10"/>
+          <p:cNvSpPr txBox="1"/>
+          <p:nvPr/>
+        </p:nvSpPr>
+        <p:spPr>
+          <a:xfrm>
+            <a:off x="11201400" y="2514600"/>
+            <a:ext cx="1024128" cy="502920"/>
+          </a:xfrm>
+          <a:prstGeom prst="rect">
+            <a:avLst/>
+          </a:prstGeom>
+          <a:noFill/>
+        </p:spPr>
+        <p:txBody>
+          <a:bodyPr wrap="square">
+            <a:spAutoFit/>
+          </a:bodyPr>
+          <a:lstStyle/>
           <a:p>
             <a:pPr algn="ctr"/>
             <a:r>
-              <a:rPr sz="900" b="0" i="0">
-                <a:solidFill>
-                  <a:srgbClr val="F4F6FA"/>
-                </a:solidFill>
-                <a:latin typeface="Calibri"/>
-              </a:rPr>
-              <a:t>predictions stream</a:t>
-            </a:r>
-          </a:p>
-        </p:txBody>
-      </p:sp>
-      <p:sp>
-        <p:nvSpPr>
-          <p:cNvPr id="8" name="Rounded Rectangle 7"/>
+              <a:rPr sz="900" b="1" i="0">
+                <a:solidFill>
+                  <a:srgbClr val="333F52"/>
+                </a:solidFill>
+                <a:latin typeface="Calibri"/>
+              </a:rPr>
+              <a:t>Executive</a:t>
+            </a:r>
+          </a:p>
+          <a:p>
+            <a:pPr algn="ctr"/>
+            <a:r>
+              <a:rPr sz="800" b="0" i="0">
+                <a:solidFill>
+                  <a:srgbClr val="6B7380"/>
+                </a:solidFill>
+                <a:latin typeface="Calibri"/>
+              </a:rPr>
+              <a:t>stakeholders</a:t>
+            </a:r>
+          </a:p>
+        </p:txBody>
+      </p:sp>
+      <p:sp>
+        <p:nvSpPr>
+          <p:cNvPr id="12" name="Can 11"/>
           <p:cNvSpPr/>
           <p:nvPr/>
         </p:nvSpPr>
         <p:spPr>
           <a:xfrm>
-            <a:off x="7955280" y="1463040"/>
-            <a:ext cx="1554480" cy="822960"/>
-          </a:xfrm>
-          <a:prstGeom prst="roundRect">
-            <a:avLst>
-              <a:gd name="adj" fmla="val 15000"/>
-            </a:avLst>
+            <a:off x="182880" y="5212080"/>
+            <a:ext cx="365760" cy="457200"/>
+          </a:xfrm>
+          <a:prstGeom prst="can">
+            <a:avLst/>
           </a:prstGeom>
           <a:solidFill>
-            <a:srgbClr val="0F6E7A"/>
+            <a:srgbClr val="6B7380"/>
           </a:solidFill>
           <a:ln>
             <a:noFill/>
@@ -10055,17 +10145,484 @@
           </a:fontRef>
         </p:style>
         <p:txBody>
-          <a:bodyPr rtlCol="0" anchor="ctr" wrap="square"/>
+          <a:bodyPr rtlCol="0" anchor="ctr"/>
           <a:lstStyle/>
           <a:p>
             <a:pPr algn="ctr"/>
-            <a:r>
-              <a:rPr sz="1300" b="1" i="0">
+          </a:p>
+        </p:txBody>
+      </p:sp>
+      <p:sp>
+        <p:nvSpPr>
+          <p:cNvPr id="13" name="TextBox 12"/>
+          <p:cNvSpPr txBox="1"/>
+          <p:nvPr/>
+        </p:nvSpPr>
+        <p:spPr>
+          <a:xfrm>
+            <a:off x="-137160" y="5715000"/>
+            <a:ext cx="1005840" cy="411480"/>
+          </a:xfrm>
+          <a:prstGeom prst="rect">
+            <a:avLst/>
+          </a:prstGeom>
+          <a:noFill/>
+        </p:spPr>
+        <p:txBody>
+          <a:bodyPr wrap="square">
+            <a:spAutoFit/>
+          </a:bodyPr>
+          <a:lstStyle/>
+          <a:p>
+            <a:pPr algn="ctr"/>
+            <a:r>
+              <a:rPr sz="900" b="1" i="0">
+                <a:solidFill>
+                  <a:srgbClr val="333F52"/>
+                </a:solidFill>
+                <a:latin typeface="Calibri"/>
+              </a:rPr>
+              <a:t>Sales ledger
+data source</a:t>
+            </a:r>
+          </a:p>
+        </p:txBody>
+      </p:sp>
+      <p:sp>
+        <p:nvSpPr>
+          <p:cNvPr id="14" name="Rounded Rectangle 13"/>
+          <p:cNvSpPr/>
+          <p:nvPr/>
+        </p:nvSpPr>
+        <p:spPr>
+          <a:xfrm>
+            <a:off x="1371600" y="1417320"/>
+            <a:ext cx="2743200" cy="1508760"/>
+          </a:xfrm>
+          <a:prstGeom prst="roundRect">
+            <a:avLst>
+              <a:gd name="adj" fmla="val 12000"/>
+            </a:avLst>
+          </a:prstGeom>
+          <a:solidFill>
+            <a:srgbClr val="4E88E6"/>
+          </a:solidFill>
+          <a:ln>
+            <a:noFill/>
+          </a:ln>
+        </p:spPr>
+        <p:style>
+          <a:lnRef idx="1">
+            <a:schemeClr val="accent1"/>
+          </a:lnRef>
+          <a:fillRef idx="3">
+            <a:schemeClr val="accent1"/>
+          </a:fillRef>
+          <a:effectRef idx="2">
+            <a:schemeClr val="accent1"/>
+          </a:effectRef>
+          <a:fontRef idx="minor">
+            <a:schemeClr val="lt1"/>
+          </a:fontRef>
+        </p:style>
+        <p:txBody>
+          <a:bodyPr rtlCol="0" anchor="ctr" tIns="54864" bIns="54864" wrap="square"/>
+          <a:lstStyle/>
+          <a:p>
+            <a:pPr algn="ctr"/>
+            <a:r>
+              <a:rPr sz="1200" b="1" i="0">
                 <a:solidFill>
                   <a:srgbClr val="FFFFFF"/>
                 </a:solidFill>
                 <a:latin typeface="Calibri"/>
               </a:rPr>
+              <a:t>Scoring Service  ·  scoring-api</a:t>
+            </a:r>
+          </a:p>
+          <a:p>
+            <a:pPr algn="ctr"/>
+            <a:r>
+              <a:rPr sz="900" b="0" i="0">
+                <a:solidFill>
+                  <a:srgbClr val="FFFFFF"/>
+                </a:solidFill>
+                <a:latin typeface="Calibri"/>
+              </a:rPr>
+              <a:t>Rust 1.89  ·  Cloud Run</a:t>
+            </a:r>
+          </a:p>
+        </p:txBody>
+      </p:sp>
+      <p:sp>
+        <p:nvSpPr>
+          <p:cNvPr id="15" name="Rounded Rectangle 14"/>
+          <p:cNvSpPr/>
+          <p:nvPr/>
+        </p:nvSpPr>
+        <p:spPr>
+          <a:xfrm>
+            <a:off x="1508760" y="2240280"/>
+            <a:ext cx="2468880" cy="640080"/>
+          </a:xfrm>
+          <a:prstGeom prst="roundRect">
+            <a:avLst>
+              <a:gd name="adj" fmla="val 15000"/>
+            </a:avLst>
+          </a:prstGeom>
+          <a:solidFill>
+            <a:srgbClr val="E8F0FE"/>
+          </a:solidFill>
+          <a:ln>
+            <a:noFill/>
+          </a:ln>
+        </p:spPr>
+        <p:style>
+          <a:lnRef idx="1">
+            <a:schemeClr val="accent1"/>
+          </a:lnRef>
+          <a:fillRef idx="3">
+            <a:schemeClr val="accent1"/>
+          </a:fillRef>
+          <a:effectRef idx="2">
+            <a:schemeClr val="accent1"/>
+          </a:effectRef>
+          <a:fontRef idx="minor">
+            <a:schemeClr val="lt1"/>
+          </a:fontRef>
+        </p:style>
+        <p:txBody>
+          <a:bodyPr rtlCol="0" anchor="ctr" lIns="73152" rIns="73152" tIns="36576" bIns="36576"/>
+          <a:lstStyle/>
+          <a:p>
+            <a:pPr algn="ctr"/>
+            <a:r>
+              <a:rPr sz="900" b="1" i="0">
+                <a:solidFill>
+                  <a:srgbClr val="2A5FC3"/>
+                </a:solidFill>
+                <a:latin typeface="Calibri"/>
+              </a:rPr>
+              <a:t>Safety guardrails</a:t>
+            </a:r>
+          </a:p>
+          <a:p>
+            <a:pPr algn="ctr"/>
+            <a:r>
+              <a:rPr sz="800" b="0" i="0">
+                <a:solidFill>
+                  <a:srgbClr val="2A5FC3"/>
+                </a:solidFill>
+                <a:latin typeface="Calibri"/>
+              </a:rPr>
+              <a:t>Bounds  ·  clamp  ·  timeouts  ·  anomaly  ·  breaker  ·  kill-switch</a:t>
+            </a:r>
+          </a:p>
+        </p:txBody>
+      </p:sp>
+      <p:sp>
+        <p:nvSpPr>
+          <p:cNvPr id="16" name="Rounded Rectangle 15"/>
+          <p:cNvSpPr/>
+          <p:nvPr/>
+        </p:nvSpPr>
+        <p:spPr>
+          <a:xfrm>
+            <a:off x="4572000" y="1417320"/>
+            <a:ext cx="2286000" cy="914400"/>
+          </a:xfrm>
+          <a:prstGeom prst="roundRect">
+            <a:avLst>
+              <a:gd name="adj" fmla="val 12000"/>
+            </a:avLst>
+          </a:prstGeom>
+          <a:solidFill>
+            <a:srgbClr val="34A853"/>
+          </a:solidFill>
+          <a:ln>
+            <a:noFill/>
+          </a:ln>
+        </p:spPr>
+        <p:style>
+          <a:lnRef idx="1">
+            <a:schemeClr val="accent1"/>
+          </a:lnRef>
+          <a:fillRef idx="3">
+            <a:schemeClr val="accent1"/>
+          </a:fillRef>
+          <a:effectRef idx="2">
+            <a:schemeClr val="accent1"/>
+          </a:effectRef>
+          <a:fontRef idx="minor">
+            <a:schemeClr val="lt1"/>
+          </a:fontRef>
+        </p:style>
+        <p:txBody>
+          <a:bodyPr rtlCol="0" anchor="ctr" tIns="54864" bIns="54864" wrap="square"/>
+          <a:lstStyle/>
+          <a:p>
+            <a:pPr algn="ctr"/>
+            <a:r>
+              <a:rPr sz="1200" b="1" i="0">
+                <a:solidFill>
+                  <a:srgbClr val="FFFFFF"/>
+                </a:solidFill>
+                <a:latin typeface="Calibri"/>
+              </a:rPr>
+              <a:t>Vertex AI Endpoint</a:t>
+            </a:r>
+          </a:p>
+          <a:p>
+            <a:pPr algn="ctr"/>
+            <a:r>
+              <a:rPr sz="900" b="0" i="0">
+                <a:solidFill>
+                  <a:srgbClr val="FFFFFF"/>
+                </a:solidFill>
+                <a:latin typeface="Calibri"/>
+              </a:rPr>
+              <a:t>XGBoost regressor  ·  rpc-estimator@1</a:t>
+            </a:r>
+          </a:p>
+        </p:txBody>
+      </p:sp>
+      <p:sp>
+        <p:nvSpPr>
+          <p:cNvPr id="17" name="Rounded Rectangle 16"/>
+          <p:cNvSpPr/>
+          <p:nvPr/>
+        </p:nvSpPr>
+        <p:spPr>
+          <a:xfrm>
+            <a:off x="8732520" y="1417320"/>
+            <a:ext cx="2468880" cy="914400"/>
+          </a:xfrm>
+          <a:prstGeom prst="roundRect">
+            <a:avLst>
+              <a:gd name="adj" fmla="val 12000"/>
+            </a:avLst>
+          </a:prstGeom>
+          <a:solidFill>
+            <a:srgbClr val="4E88E6"/>
+          </a:solidFill>
+          <a:ln>
+            <a:noFill/>
+          </a:ln>
+        </p:spPr>
+        <p:style>
+          <a:lnRef idx="1">
+            <a:schemeClr val="accent1"/>
+          </a:lnRef>
+          <a:fillRef idx="3">
+            <a:schemeClr val="accent1"/>
+          </a:fillRef>
+          <a:effectRef idx="2">
+            <a:schemeClr val="accent1"/>
+          </a:effectRef>
+          <a:fontRef idx="minor">
+            <a:schemeClr val="lt1"/>
+          </a:fontRef>
+        </p:style>
+        <p:txBody>
+          <a:bodyPr rtlCol="0" anchor="ctr" tIns="54864" bIns="54864" wrap="square"/>
+          <a:lstStyle/>
+          <a:p>
+            <a:pPr algn="ctr"/>
+            <a:r>
+              <a:rPr sz="1200" b="1" i="0">
+                <a:solidFill>
+                  <a:srgbClr val="FFFFFF"/>
+                </a:solidFill>
+                <a:latin typeface="Calibri"/>
+              </a:rPr>
+              <a:t>Dashboard UI</a:t>
+            </a:r>
+          </a:p>
+          <a:p>
+            <a:pPr algn="ctr"/>
+            <a:r>
+              <a:rPr sz="900" b="0" i="0">
+                <a:solidFill>
+                  <a:srgbClr val="FFFFFF"/>
+                </a:solidFill>
+                <a:latin typeface="Calibri"/>
+              </a:rPr>
+              <a:t>TypeScript / React / nginx  ·  Cloud Run</a:t>
+            </a:r>
+          </a:p>
+        </p:txBody>
+      </p:sp>
+      <p:sp>
+        <p:nvSpPr>
+          <p:cNvPr id="18" name="Rounded Rectangle 17"/>
+          <p:cNvSpPr/>
+          <p:nvPr/>
+        </p:nvSpPr>
+        <p:spPr>
+          <a:xfrm>
+            <a:off x="1371600" y="3200400"/>
+            <a:ext cx="2194560" cy="777240"/>
+          </a:xfrm>
+          <a:prstGeom prst="roundRect">
+            <a:avLst>
+              <a:gd name="adj" fmla="val 12000"/>
+            </a:avLst>
+          </a:prstGeom>
+          <a:solidFill>
+            <a:srgbClr val="4E88E6"/>
+          </a:solidFill>
+          <a:ln>
+            <a:noFill/>
+          </a:ln>
+        </p:spPr>
+        <p:style>
+          <a:lnRef idx="1">
+            <a:schemeClr val="accent1"/>
+          </a:lnRef>
+          <a:fillRef idx="3">
+            <a:schemeClr val="accent1"/>
+          </a:fillRef>
+          <a:effectRef idx="2">
+            <a:schemeClr val="accent1"/>
+          </a:effectRef>
+          <a:fontRef idx="minor">
+            <a:schemeClr val="lt1"/>
+          </a:fontRef>
+        </p:style>
+        <p:txBody>
+          <a:bodyPr rtlCol="0" anchor="ctr" tIns="54864" bIns="54864" wrap="square"/>
+          <a:lstStyle/>
+          <a:p>
+            <a:pPr algn="ctr"/>
+            <a:r>
+              <a:rPr sz="1200" b="1" i="0">
+                <a:solidFill>
+                  <a:srgbClr val="FFFFFF"/>
+                </a:solidFill>
+                <a:latin typeface="Calibri"/>
+              </a:rPr>
+              <a:t>Bounds Calibration</a:t>
+            </a:r>
+          </a:p>
+          <a:p>
+            <a:pPr algn="ctr"/>
+            <a:r>
+              <a:rPr sz="900" b="0" i="0">
+                <a:solidFill>
+                  <a:srgbClr val="FFFFFF"/>
+                </a:solidFill>
+                <a:latin typeface="Calibri"/>
+              </a:rPr>
+              <a:t>Rust  ·  Cloud Run job</a:t>
+            </a:r>
+          </a:p>
+        </p:txBody>
+      </p:sp>
+      <p:sp>
+        <p:nvSpPr>
+          <p:cNvPr id="19" name="Rounded Rectangle 18"/>
+          <p:cNvSpPr/>
+          <p:nvPr/>
+        </p:nvSpPr>
+        <p:spPr>
+          <a:xfrm>
+            <a:off x="3703320" y="2423160"/>
+            <a:ext cx="1463040" cy="502920"/>
+          </a:xfrm>
+          <a:prstGeom prst="roundRect">
+            <a:avLst>
+              <a:gd name="adj" fmla="val 18000"/>
+            </a:avLst>
+          </a:prstGeom>
+          <a:solidFill>
+            <a:srgbClr val="FFFFFF"/>
+          </a:solidFill>
+          <a:ln w="6350">
+            <a:solidFill>
+              <a:srgbClr val="6B7380"/>
+            </a:solidFill>
+          </a:ln>
+        </p:spPr>
+        <p:style>
+          <a:lnRef idx="1">
+            <a:schemeClr val="accent1"/>
+          </a:lnRef>
+          <a:fillRef idx="3">
+            <a:schemeClr val="accent1"/>
+          </a:fillRef>
+          <a:effectRef idx="2">
+            <a:schemeClr val="accent1"/>
+          </a:effectRef>
+          <a:fontRef idx="minor">
+            <a:schemeClr val="lt1"/>
+          </a:fontRef>
+        </p:style>
+        <p:txBody>
+          <a:bodyPr rtlCol="0" anchor="ctr" lIns="54864" rIns="54864"/>
+          <a:lstStyle/>
+          <a:p>
+            <a:pPr algn="ctr"/>
+            <a:r>
+              <a:rPr sz="900" b="1" i="0">
+                <a:solidFill>
+                  <a:srgbClr val="333F52"/>
+                </a:solidFill>
+                <a:latin typeface="Calibri"/>
+              </a:rPr>
+              <a:t>Secret Manager / Config</a:t>
+            </a:r>
+          </a:p>
+        </p:txBody>
+      </p:sp>
+      <p:sp>
+        <p:nvSpPr>
+          <p:cNvPr id="20" name="Rounded Rectangle 19"/>
+          <p:cNvSpPr/>
+          <p:nvPr/>
+        </p:nvSpPr>
+        <p:spPr>
+          <a:xfrm>
+            <a:off x="4572000" y="2971800"/>
+            <a:ext cx="2286000" cy="1371600"/>
+          </a:xfrm>
+          <a:prstGeom prst="roundRect">
+            <a:avLst>
+              <a:gd name="adj" fmla="val 8000"/>
+            </a:avLst>
+          </a:prstGeom>
+          <a:solidFill>
+            <a:srgbClr val="7E57C2"/>
+          </a:solidFill>
+          <a:ln>
+            <a:noFill/>
+          </a:ln>
+        </p:spPr>
+        <p:style>
+          <a:lnRef idx="1">
+            <a:schemeClr val="accent1"/>
+          </a:lnRef>
+          <a:fillRef idx="3">
+            <a:schemeClr val="accent1"/>
+          </a:fillRef>
+          <a:effectRef idx="2">
+            <a:schemeClr val="accent1"/>
+          </a:effectRef>
+          <a:fontRef idx="minor">
+            <a:schemeClr val="lt1"/>
+          </a:fontRef>
+        </p:style>
+        <p:txBody>
+          <a:bodyPr rtlCol="0" anchor="ctr" wrap="square" tIns="73152"/>
+          <a:lstStyle/>
+          <a:p>
+            <a:pPr algn="ctr"/>
+            <a:r>
+              <a:rPr sz="1200" b="1" i="0">
+                <a:solidFill>
+                  <a:srgbClr val="FFFFFF"/>
+                </a:solidFill>
+                <a:latin typeface="Calibri"/>
+              </a:rPr>
               <a:t>BigQuery</a:t>
             </a:r>
           </a:p>
@@ -10074,33 +10631,1450 @@
             <a:r>
               <a:rPr sz="900" b="0" i="0">
                 <a:solidFill>
-                  <a:srgbClr val="F4F6FA"/>
-                </a:solidFill>
-                <a:latin typeface="Calibri"/>
-              </a:rPr>
-              <a:t>analytics + drift</a:t>
+                  <a:srgbClr val="FFFFFF"/>
+                </a:solidFill>
+                <a:latin typeface="Calibri"/>
+              </a:rPr>
+              <a:t>Data warehouse</a:t>
+            </a:r>
+          </a:p>
+          <a:p>
+            <a:pPr algn="ctr">
+              <a:spcBef>
+                <a:spcPts val="600"/>
+              </a:spcBef>
+            </a:pPr>
+            <a:r>
+              <a:rPr sz="800" b="0" i="1">
+                <a:solidFill>
+                  <a:srgbClr val="FFFFFF"/>
+                </a:solidFill>
+                <a:latin typeface="Calibri"/>
+              </a:rPr>
+              <a:t>cm360_clicks  ·  sales_ledger</a:t>
+            </a:r>
+          </a:p>
+          <a:p>
+            <a:pPr algn="ctr"/>
+            <a:r>
+              <a:rPr sz="800" b="0" i="1">
+                <a:solidFill>
+                  <a:srgbClr val="FFFFFF"/>
+                </a:solidFill>
+                <a:latin typeface="Calibri"/>
+              </a:rPr>
+              <a:t>rpc_predictions</a:t>
+            </a:r>
+          </a:p>
+          <a:p>
+            <a:pPr algn="ctr"/>
+            <a:r>
+              <a:rPr sz="800" b="0" i="1">
+                <a:solidFill>
+                  <a:srgbClr val="FFFFFF"/>
+                </a:solidFill>
+                <a:latin typeface="Calibri"/>
+              </a:rPr>
+              <a:t>predictions_vs_revenue</a:t>
+            </a:r>
+          </a:p>
+        </p:txBody>
+      </p:sp>
+      <p:sp>
+        <p:nvSpPr>
+          <p:cNvPr id="21" name="Rounded Rectangle 20"/>
+          <p:cNvSpPr/>
+          <p:nvPr/>
+        </p:nvSpPr>
+        <p:spPr>
+          <a:xfrm>
+            <a:off x="8732520" y="2788920"/>
+            <a:ext cx="2468880" cy="777240"/>
+          </a:xfrm>
+          <a:prstGeom prst="roundRect">
+            <a:avLst>
+              <a:gd name="adj" fmla="val 12000"/>
+            </a:avLst>
+          </a:prstGeom>
+          <a:solidFill>
+            <a:srgbClr val="4E88E6"/>
+          </a:solidFill>
+          <a:ln>
+            <a:noFill/>
+          </a:ln>
+        </p:spPr>
+        <p:style>
+          <a:lnRef idx="1">
+            <a:schemeClr val="accent1"/>
+          </a:lnRef>
+          <a:fillRef idx="3">
+            <a:schemeClr val="accent1"/>
+          </a:fillRef>
+          <a:effectRef idx="2">
+            <a:schemeClr val="accent1"/>
+          </a:effectRef>
+          <a:fontRef idx="minor">
+            <a:schemeClr val="lt1"/>
+          </a:fontRef>
+        </p:style>
+        <p:txBody>
+          <a:bodyPr rtlCol="0" anchor="ctr" tIns="54864" bIns="54864" wrap="square"/>
+          <a:lstStyle/>
+          <a:p>
+            <a:pPr algn="ctr"/>
+            <a:r>
+              <a:rPr sz="1200" b="1" i="0">
+                <a:solidFill>
+                  <a:srgbClr val="FFFFFF"/>
+                </a:solidFill>
+                <a:latin typeface="Calibri"/>
+              </a:rPr>
+              <a:t>Reconciliation Service</a:t>
+            </a:r>
+          </a:p>
+          <a:p>
+            <a:pPr algn="ctr"/>
+            <a:r>
+              <a:rPr sz="900" b="0" i="0">
+                <a:solidFill>
+                  <a:srgbClr val="FFFFFF"/>
+                </a:solidFill>
+                <a:latin typeface="Calibri"/>
+              </a:rPr>
+              <a:t>Python FastAPI  ·  Cloud Run</a:t>
+            </a:r>
+          </a:p>
+        </p:txBody>
+      </p:sp>
+      <p:sp>
+        <p:nvSpPr>
+          <p:cNvPr id="22" name="Rounded Rectangle 21"/>
+          <p:cNvSpPr/>
+          <p:nvPr/>
+        </p:nvSpPr>
+        <p:spPr>
+          <a:xfrm>
+            <a:off x="7315200" y="4160520"/>
+            <a:ext cx="2377440" cy="822960"/>
+          </a:xfrm>
+          <a:prstGeom prst="roundRect">
+            <a:avLst>
+              <a:gd name="adj" fmla="val 12000"/>
+            </a:avLst>
+          </a:prstGeom>
+          <a:solidFill>
+            <a:srgbClr val="0097A7"/>
+          </a:solidFill>
+          <a:ln>
+            <a:noFill/>
+          </a:ln>
+        </p:spPr>
+        <p:style>
+          <a:lnRef idx="1">
+            <a:schemeClr val="accent1"/>
+          </a:lnRef>
+          <a:fillRef idx="3">
+            <a:schemeClr val="accent1"/>
+          </a:fillRef>
+          <a:effectRef idx="2">
+            <a:schemeClr val="accent1"/>
+          </a:effectRef>
+          <a:fontRef idx="minor">
+            <a:schemeClr val="lt1"/>
+          </a:fontRef>
+        </p:style>
+        <p:txBody>
+          <a:bodyPr rtlCol="0" anchor="ctr" tIns="54864" bIns="54864" wrap="square"/>
+          <a:lstStyle/>
+          <a:p>
+            <a:pPr algn="ctr"/>
+            <a:r>
+              <a:rPr sz="1200" b="1" i="0">
+                <a:solidFill>
+                  <a:srgbClr val="FFFFFF"/>
+                </a:solidFill>
+                <a:latin typeface="Calibri"/>
+              </a:rPr>
+              <a:t>ML Ops Pipeline  ·  ml-pipeline</a:t>
+            </a:r>
+          </a:p>
+          <a:p>
+            <a:pPr algn="ctr"/>
+            <a:r>
+              <a:rPr sz="900" b="0" i="0">
+                <a:solidFill>
+                  <a:srgbClr val="FFFFFF"/>
+                </a:solidFill>
+                <a:latin typeface="Calibri"/>
+              </a:rPr>
+              <a:t>Python 3.12  ·  Vertex AI Pipelines</a:t>
+            </a:r>
+          </a:p>
+        </p:txBody>
+      </p:sp>
+      <p:sp>
+        <p:nvSpPr>
+          <p:cNvPr id="23" name="Can 22"/>
+          <p:cNvSpPr/>
+          <p:nvPr/>
+        </p:nvSpPr>
+        <p:spPr>
+          <a:xfrm>
+            <a:off x="10058400" y="4160520"/>
+            <a:ext cx="502920" cy="822960"/>
+          </a:xfrm>
+          <a:prstGeom prst="can">
+            <a:avLst/>
+          </a:prstGeom>
+          <a:solidFill>
+            <a:srgbClr val="6B7380"/>
+          </a:solidFill>
+          <a:ln>
+            <a:noFill/>
+          </a:ln>
+        </p:spPr>
+        <p:style>
+          <a:lnRef idx="1">
+            <a:schemeClr val="accent1"/>
+          </a:lnRef>
+          <a:fillRef idx="3">
+            <a:schemeClr val="accent1"/>
+          </a:fillRef>
+          <a:effectRef idx="2">
+            <a:schemeClr val="accent1"/>
+          </a:effectRef>
+          <a:fontRef idx="minor">
+            <a:schemeClr val="lt1"/>
+          </a:fontRef>
+        </p:style>
+        <p:txBody>
+          <a:bodyPr rtlCol="0" anchor="ctr"/>
+          <a:lstStyle/>
+          <a:p>
+            <a:pPr algn="ctr"/>
+          </a:p>
+        </p:txBody>
+      </p:sp>
+      <p:sp>
+        <p:nvSpPr>
+          <p:cNvPr id="24" name="TextBox 23"/>
+          <p:cNvSpPr txBox="1"/>
+          <p:nvPr/>
+        </p:nvSpPr>
+        <p:spPr>
+          <a:xfrm>
+            <a:off x="9875520" y="5029200"/>
+            <a:ext cx="868680" cy="274320"/>
+          </a:xfrm>
+          <a:prstGeom prst="rect">
+            <a:avLst/>
+          </a:prstGeom>
+          <a:noFill/>
+        </p:spPr>
+        <p:txBody>
+          <a:bodyPr wrap="none">
+            <a:spAutoFit/>
+          </a:bodyPr>
+          <a:lstStyle/>
+          <a:p>
+            <a:pPr algn="ctr"/>
+            <a:r>
+              <a:rPr sz="800" b="1" i="0">
+                <a:solidFill>
+                  <a:srgbClr val="333F52"/>
+                </a:solidFill>
+                <a:latin typeface="Calibri"/>
+              </a:rPr>
+              <a:t>Cloud Storage</a:t>
+            </a:r>
+          </a:p>
+        </p:txBody>
+      </p:sp>
+      <p:sp>
+        <p:nvSpPr>
+          <p:cNvPr id="25" name="Hexagon 24"/>
+          <p:cNvSpPr/>
+          <p:nvPr/>
+        </p:nvSpPr>
+        <p:spPr>
+          <a:xfrm>
+            <a:off x="1371600" y="4160520"/>
+            <a:ext cx="1371600" cy="411480"/>
+          </a:xfrm>
+          <a:prstGeom prst="hexagon">
+            <a:avLst/>
+          </a:prstGeom>
+          <a:solidFill>
+            <a:srgbClr val="A96BDB"/>
+          </a:solidFill>
+          <a:ln>
+            <a:noFill/>
+          </a:ln>
+        </p:spPr>
+        <p:style>
+          <a:lnRef idx="1">
+            <a:schemeClr val="accent1"/>
+          </a:lnRef>
+          <a:fillRef idx="3">
+            <a:schemeClr val="accent1"/>
+          </a:fillRef>
+          <a:effectRef idx="2">
+            <a:schemeClr val="accent1"/>
+          </a:effectRef>
+          <a:fontRef idx="minor">
+            <a:schemeClr val="lt1"/>
+          </a:fontRef>
+        </p:style>
+        <p:txBody>
+          <a:bodyPr rtlCol="0" anchor="ctr" lIns="36576" rIns="36576"/>
+          <a:lstStyle/>
+          <a:p>
+            <a:pPr algn="ctr"/>
+            <a:r>
+              <a:rPr sz="800" b="1" i="0">
+                <a:solidFill>
+                  <a:srgbClr val="FFFFFF"/>
+                </a:solidFill>
+                <a:latin typeface="Calibri"/>
+              </a:rPr>
+              <a:t>Pub/Sub</a:t>
+            </a:r>
+          </a:p>
+        </p:txBody>
+      </p:sp>
+      <p:sp>
+        <p:nvSpPr>
+          <p:cNvPr id="26" name="TextBox 25"/>
+          <p:cNvSpPr txBox="1"/>
+          <p:nvPr/>
+        </p:nvSpPr>
+        <p:spPr>
+          <a:xfrm>
+            <a:off x="1371600" y="4581144"/>
+            <a:ext cx="1371600" cy="292608"/>
+          </a:xfrm>
+          <a:prstGeom prst="rect">
+            <a:avLst/>
+          </a:prstGeom>
+          <a:noFill/>
+        </p:spPr>
+        <p:txBody>
+          <a:bodyPr wrap="none">
+            <a:spAutoFit/>
+          </a:bodyPr>
+          <a:lstStyle/>
+          <a:p>
+            <a:pPr algn="ctr"/>
+            <a:r>
+              <a:rPr sz="800" b="0" i="0">
+                <a:solidFill>
+                  <a:srgbClr val="333F52"/>
+                </a:solidFill>
+                <a:latin typeface="Calibri"/>
+              </a:rPr>
+              <a:t>rpc-clicks-staging</a:t>
+            </a:r>
+          </a:p>
+        </p:txBody>
+      </p:sp>
+      <p:sp>
+        <p:nvSpPr>
+          <p:cNvPr id="27" name="Hexagon 26"/>
+          <p:cNvSpPr/>
+          <p:nvPr/>
+        </p:nvSpPr>
+        <p:spPr>
+          <a:xfrm>
+            <a:off x="3017520" y="4160520"/>
+            <a:ext cx="1371600" cy="411480"/>
+          </a:xfrm>
+          <a:prstGeom prst="hexagon">
+            <a:avLst/>
+          </a:prstGeom>
+          <a:solidFill>
+            <a:srgbClr val="A96BDB"/>
+          </a:solidFill>
+          <a:ln>
+            <a:noFill/>
+          </a:ln>
+        </p:spPr>
+        <p:style>
+          <a:lnRef idx="1">
+            <a:schemeClr val="accent1"/>
+          </a:lnRef>
+          <a:fillRef idx="3">
+            <a:schemeClr val="accent1"/>
+          </a:fillRef>
+          <a:effectRef idx="2">
+            <a:schemeClr val="accent1"/>
+          </a:effectRef>
+          <a:fontRef idx="minor">
+            <a:schemeClr val="lt1"/>
+          </a:fontRef>
+        </p:style>
+        <p:txBody>
+          <a:bodyPr rtlCol="0" anchor="ctr" lIns="36576" rIns="36576"/>
+          <a:lstStyle/>
+          <a:p>
+            <a:pPr algn="ctr"/>
+            <a:r>
+              <a:rPr sz="800" b="1" i="0">
+                <a:solidFill>
+                  <a:srgbClr val="FFFFFF"/>
+                </a:solidFill>
+                <a:latin typeface="Calibri"/>
+              </a:rPr>
+              <a:t>Pub/Sub</a:t>
+            </a:r>
+          </a:p>
+        </p:txBody>
+      </p:sp>
+      <p:sp>
+        <p:nvSpPr>
+          <p:cNvPr id="28" name="TextBox 27"/>
+          <p:cNvSpPr txBox="1"/>
+          <p:nvPr/>
+        </p:nvSpPr>
+        <p:spPr>
+          <a:xfrm>
+            <a:off x="3017520" y="4581144"/>
+            <a:ext cx="1371600" cy="292608"/>
+          </a:xfrm>
+          <a:prstGeom prst="rect">
+            <a:avLst/>
+          </a:prstGeom>
+          <a:noFill/>
+        </p:spPr>
+        <p:txBody>
+          <a:bodyPr wrap="none">
+            <a:spAutoFit/>
+          </a:bodyPr>
+          <a:lstStyle/>
+          <a:p>
+            <a:pPr algn="ctr"/>
+            <a:r>
+              <a:rPr sz="800" b="0" i="0">
+                <a:solidFill>
+                  <a:srgbClr val="333F52"/>
+                </a:solidFill>
+                <a:latin typeface="Calibri"/>
+              </a:rPr>
+              <a:t>rpc-predictions-staging</a:t>
+            </a:r>
+          </a:p>
+        </p:txBody>
+      </p:sp>
+      <p:sp>
+        <p:nvSpPr>
+          <p:cNvPr id="29" name="Hexagon 28"/>
+          <p:cNvSpPr/>
+          <p:nvPr/>
+        </p:nvSpPr>
+        <p:spPr>
+          <a:xfrm>
+            <a:off x="4937760" y="4572000"/>
+            <a:ext cx="1371600" cy="411480"/>
+          </a:xfrm>
+          <a:prstGeom prst="hexagon">
+            <a:avLst/>
+          </a:prstGeom>
+          <a:solidFill>
+            <a:srgbClr val="A96BDB"/>
+          </a:solidFill>
+          <a:ln>
+            <a:noFill/>
+          </a:ln>
+        </p:spPr>
+        <p:style>
+          <a:lnRef idx="1">
+            <a:schemeClr val="accent1"/>
+          </a:lnRef>
+          <a:fillRef idx="3">
+            <a:schemeClr val="accent1"/>
+          </a:fillRef>
+          <a:effectRef idx="2">
+            <a:schemeClr val="accent1"/>
+          </a:effectRef>
+          <a:fontRef idx="minor">
+            <a:schemeClr val="lt1"/>
+          </a:fontRef>
+        </p:style>
+        <p:txBody>
+          <a:bodyPr rtlCol="0" anchor="ctr" lIns="36576" rIns="36576"/>
+          <a:lstStyle/>
+          <a:p>
+            <a:pPr algn="ctr"/>
+            <a:r>
+              <a:rPr sz="800" b="1" i="0">
+                <a:solidFill>
+                  <a:srgbClr val="FFFFFF"/>
+                </a:solidFill>
+                <a:latin typeface="Calibri"/>
+              </a:rPr>
+              <a:t>Pub/Sub</a:t>
+            </a:r>
+          </a:p>
+        </p:txBody>
+      </p:sp>
+      <p:sp>
+        <p:nvSpPr>
+          <p:cNvPr id="30" name="TextBox 29"/>
+          <p:cNvSpPr txBox="1"/>
+          <p:nvPr/>
+        </p:nvSpPr>
+        <p:spPr>
+          <a:xfrm>
+            <a:off x="4937760" y="4992624"/>
+            <a:ext cx="1371600" cy="292608"/>
+          </a:xfrm>
+          <a:prstGeom prst="rect">
+            <a:avLst/>
+          </a:prstGeom>
+          <a:noFill/>
+        </p:spPr>
+        <p:txBody>
+          <a:bodyPr wrap="none">
+            <a:spAutoFit/>
+          </a:bodyPr>
+          <a:lstStyle/>
+          <a:p>
+            <a:pPr algn="ctr"/>
+            <a:r>
+              <a:rPr sz="800" b="0" i="0">
+                <a:solidFill>
+                  <a:srgbClr val="333F52"/>
+                </a:solidFill>
+                <a:latin typeface="Calibri"/>
+              </a:rPr>
+              <a:t>rpc-anomaly-staging</a:t>
+            </a:r>
+          </a:p>
+        </p:txBody>
+      </p:sp>
+      <p:sp>
+        <p:nvSpPr>
+          <p:cNvPr id="31" name="Rounded Rectangle 30"/>
+          <p:cNvSpPr/>
+          <p:nvPr/>
+        </p:nvSpPr>
+        <p:spPr>
+          <a:xfrm>
+            <a:off x="4572000" y="5074920"/>
+            <a:ext cx="2286000" cy="777240"/>
+          </a:xfrm>
+          <a:prstGeom prst="roundRect">
+            <a:avLst>
+              <a:gd name="adj" fmla="val 12000"/>
+            </a:avLst>
+          </a:prstGeom>
+          <a:solidFill>
+            <a:srgbClr val="4E88E6"/>
+          </a:solidFill>
+          <a:ln>
+            <a:noFill/>
+          </a:ln>
+        </p:spPr>
+        <p:style>
+          <a:lnRef idx="1">
+            <a:schemeClr val="accent1"/>
+          </a:lnRef>
+          <a:fillRef idx="3">
+            <a:schemeClr val="accent1"/>
+          </a:fillRef>
+          <a:effectRef idx="2">
+            <a:schemeClr val="accent1"/>
+          </a:effectRef>
+          <a:fontRef idx="minor">
+            <a:schemeClr val="lt1"/>
+          </a:fontRef>
+        </p:style>
+        <p:txBody>
+          <a:bodyPr rtlCol="0" anchor="ctr" tIns="54864" bIns="54864" wrap="square"/>
+          <a:lstStyle/>
+          <a:p>
+            <a:pPr algn="ctr"/>
+            <a:r>
+              <a:rPr sz="1200" b="1" i="0">
+                <a:solidFill>
+                  <a:srgbClr val="FFFFFF"/>
+                </a:solidFill>
+                <a:latin typeface="Calibri"/>
+              </a:rPr>
+              <a:t>Breaker Automation</a:t>
+            </a:r>
+          </a:p>
+          <a:p>
+            <a:pPr algn="ctr"/>
+            <a:r>
+              <a:rPr sz="900" b="0" i="0">
+                <a:solidFill>
+                  <a:srgbClr val="FFFFFF"/>
+                </a:solidFill>
+                <a:latin typeface="Calibri"/>
+              </a:rPr>
+              <a:t>Python  ·  Cloud Run / Functions</a:t>
+            </a:r>
+          </a:p>
+        </p:txBody>
+      </p:sp>
+      <p:sp>
+        <p:nvSpPr>
+          <p:cNvPr id="32" name="Rounded Rectangle 31"/>
+          <p:cNvSpPr/>
+          <p:nvPr/>
+        </p:nvSpPr>
+        <p:spPr>
+          <a:xfrm>
+            <a:off x="8732520" y="5074920"/>
+            <a:ext cx="2468880" cy="777240"/>
+          </a:xfrm>
+          <a:prstGeom prst="roundRect">
+            <a:avLst>
+              <a:gd name="adj" fmla="val 12000"/>
+            </a:avLst>
+          </a:prstGeom>
+          <a:solidFill>
+            <a:srgbClr val="4E88E6"/>
+          </a:solidFill>
+          <a:ln>
+            <a:noFill/>
+          </a:ln>
+        </p:spPr>
+        <p:style>
+          <a:lnRef idx="1">
+            <a:schemeClr val="accent1"/>
+          </a:lnRef>
+          <a:fillRef idx="3">
+            <a:schemeClr val="accent1"/>
+          </a:fillRef>
+          <a:effectRef idx="2">
+            <a:schemeClr val="accent1"/>
+          </a:effectRef>
+          <a:fontRef idx="minor">
+            <a:schemeClr val="lt1"/>
+          </a:fontRef>
+        </p:style>
+        <p:txBody>
+          <a:bodyPr rtlCol="0" anchor="ctr" tIns="54864" bIns="54864" wrap="square"/>
+          <a:lstStyle/>
+          <a:p>
+            <a:pPr algn="ctr"/>
+            <a:r>
+              <a:rPr sz="1200" b="1" i="0">
+                <a:solidFill>
+                  <a:srgbClr val="FFFFFF"/>
+                </a:solidFill>
+                <a:latin typeface="Calibri"/>
+              </a:rPr>
+              <a:t>Activation Service</a:t>
+            </a:r>
+          </a:p>
+          <a:p>
+            <a:pPr algn="ctr"/>
+            <a:r>
+              <a:rPr sz="900" b="0" i="0">
+                <a:solidFill>
+                  <a:srgbClr val="FFFFFF"/>
+                </a:solidFill>
+                <a:latin typeface="Calibri"/>
+              </a:rPr>
+              <a:t>Python 3.12  ·  Cloud Run</a:t>
+            </a:r>
+          </a:p>
+        </p:txBody>
+      </p:sp>
+      <p:sp>
+        <p:nvSpPr>
+          <p:cNvPr id="33" name="TextBox 32"/>
+          <p:cNvSpPr txBox="1"/>
+          <p:nvPr/>
+        </p:nvSpPr>
+        <p:spPr>
+          <a:xfrm>
+            <a:off x="11521440" y="5074920"/>
+            <a:ext cx="640080" cy="228600"/>
+          </a:xfrm>
+          <a:prstGeom prst="rect">
+            <a:avLst/>
+          </a:prstGeom>
+          <a:noFill/>
+        </p:spPr>
+        <p:txBody>
+          <a:bodyPr wrap="none">
+            <a:spAutoFit/>
+          </a:bodyPr>
+          <a:lstStyle/>
+          <a:p>
+            <a:r>
+              <a:rPr sz="900" b="1" i="0">
+                <a:solidFill>
+                  <a:srgbClr val="333F52"/>
+                </a:solidFill>
+                <a:latin typeface="Calibri"/>
+              </a:rPr>
+              <a:t>→ SA360</a:t>
+            </a:r>
+          </a:p>
+        </p:txBody>
+      </p:sp>
+      <p:sp>
+        <p:nvSpPr>
+          <p:cNvPr id="34" name="TextBox 33"/>
+          <p:cNvSpPr txBox="1"/>
+          <p:nvPr/>
+        </p:nvSpPr>
+        <p:spPr>
+          <a:xfrm>
+            <a:off x="11521440" y="5330952"/>
+            <a:ext cx="640080" cy="228600"/>
+          </a:xfrm>
+          <a:prstGeom prst="rect">
+            <a:avLst/>
+          </a:prstGeom>
+          <a:noFill/>
+        </p:spPr>
+        <p:txBody>
+          <a:bodyPr wrap="none">
+            <a:spAutoFit/>
+          </a:bodyPr>
+          <a:lstStyle/>
+          <a:p>
+            <a:r>
+              <a:rPr sz="900" b="1" i="0">
+                <a:solidFill>
+                  <a:srgbClr val="333F52"/>
+                </a:solidFill>
+                <a:latin typeface="Calibri"/>
+              </a:rPr>
+              <a:t>→ SSGTM</a:t>
+            </a:r>
+          </a:p>
+        </p:txBody>
+      </p:sp>
+      <p:sp>
+        <p:nvSpPr>
+          <p:cNvPr id="35" name="TextBox 34"/>
+          <p:cNvSpPr txBox="1"/>
+          <p:nvPr/>
+        </p:nvSpPr>
+        <p:spPr>
+          <a:xfrm>
+            <a:off x="11521440" y="5586984"/>
+            <a:ext cx="640080" cy="228600"/>
+          </a:xfrm>
+          <a:prstGeom prst="rect">
+            <a:avLst/>
+          </a:prstGeom>
+          <a:noFill/>
+        </p:spPr>
+        <p:txBody>
+          <a:bodyPr wrap="none">
+            <a:spAutoFit/>
+          </a:bodyPr>
+          <a:lstStyle/>
+          <a:p>
+            <a:r>
+              <a:rPr sz="900" b="1" i="0">
+                <a:solidFill>
+                  <a:srgbClr val="333F52"/>
+                </a:solidFill>
+                <a:latin typeface="Calibri"/>
+              </a:rPr>
+              <a:t>→ OCI</a:t>
+            </a:r>
+          </a:p>
+        </p:txBody>
+      </p:sp>
+      <p:sp>
+        <p:nvSpPr>
+          <p:cNvPr id="36" name="Rounded Rectangle 35"/>
+          <p:cNvSpPr/>
+          <p:nvPr/>
+        </p:nvSpPr>
+        <p:spPr>
+          <a:xfrm>
+            <a:off x="4892040" y="5989320"/>
+            <a:ext cx="1280160" cy="274320"/>
+          </a:xfrm>
+          <a:prstGeom prst="roundRect">
+            <a:avLst>
+              <a:gd name="adj" fmla="val 30000"/>
+            </a:avLst>
+          </a:prstGeom>
+          <a:solidFill>
+            <a:srgbClr val="FFFFFF"/>
+          </a:solidFill>
+          <a:ln w="6350">
+            <a:solidFill>
+              <a:srgbClr val="D7DBE3"/>
+            </a:solidFill>
+          </a:ln>
+        </p:spPr>
+        <p:style>
+          <a:lnRef idx="1">
+            <a:schemeClr val="accent1"/>
+          </a:lnRef>
+          <a:fillRef idx="3">
+            <a:schemeClr val="accent1"/>
+          </a:fillRef>
+          <a:effectRef idx="2">
+            <a:schemeClr val="accent1"/>
+          </a:effectRef>
+          <a:fontRef idx="minor">
+            <a:schemeClr val="lt1"/>
+          </a:fontRef>
+        </p:style>
+        <p:txBody>
+          <a:bodyPr rtlCol="0" anchor="ctr" lIns="36576" rIns="36576"/>
+          <a:lstStyle/>
+          <a:p>
+            <a:pPr algn="ctr"/>
+            <a:r>
+              <a:rPr sz="800" b="1" i="0">
+                <a:solidFill>
+                  <a:srgbClr val="333F52"/>
+                </a:solidFill>
+                <a:latin typeface="Calibri"/>
+              </a:rPr>
+              <a:t>GitHub</a:t>
             </a:r>
           </a:p>
         </p:txBody>
       </p:sp>
       <p:cxnSp>
         <p:nvCxnSpPr>
-          <p:cNvPr id="9" name="Connector 8"/>
+          <p:cNvPr id="37" name="Connector 36"/>
           <p:cNvCxnSpPr/>
           <p:nvPr/>
         </p:nvCxnSpPr>
         <p:spPr>
           <a:xfrm>
-            <a:off x="2011680" y="1874520"/>
-            <a:ext cx="320040" cy="0"/>
-          </a:xfrm>
-          <a:prstGeom prst="curvedConnector3">
+            <a:off x="6172200" y="6126480"/>
+            <a:ext cx="45720" cy="0"/>
+          </a:xfrm>
+          <a:prstGeom prst="line">
+            <a:avLst/>
+          </a:prstGeom>
+          <a:ln w="9525">
+            <a:solidFill>
+              <a:srgbClr val="6B7380"/>
+            </a:solidFill>
+            <a:tailEnd type="triangle" w="sm" h="sm"/>
+          </a:ln>
+        </p:spPr>
+        <p:style>
+          <a:lnRef idx="2">
+            <a:schemeClr val="accent1"/>
+          </a:lnRef>
+          <a:fillRef idx="0">
+            <a:schemeClr val="accent1"/>
+          </a:fillRef>
+          <a:effectRef idx="1">
+            <a:schemeClr val="accent1"/>
+          </a:effectRef>
+          <a:fontRef idx="minor">
+            <a:schemeClr val="tx1"/>
+          </a:fontRef>
+        </p:style>
+      </p:cxnSp>
+      <p:sp>
+        <p:nvSpPr>
+          <p:cNvPr id="38" name="Rounded Rectangle 37"/>
+          <p:cNvSpPr/>
+          <p:nvPr/>
+        </p:nvSpPr>
+        <p:spPr>
+          <a:xfrm>
+            <a:off x="6217920" y="5989320"/>
+            <a:ext cx="1280160" cy="274320"/>
+          </a:xfrm>
+          <a:prstGeom prst="roundRect">
+            <a:avLst>
+              <a:gd name="adj" fmla="val 30000"/>
+            </a:avLst>
+          </a:prstGeom>
+          <a:solidFill>
+            <a:srgbClr val="FFFFFF"/>
+          </a:solidFill>
+          <a:ln w="6350">
+            <a:solidFill>
+              <a:srgbClr val="D7DBE3"/>
+            </a:solidFill>
+          </a:ln>
+        </p:spPr>
+        <p:style>
+          <a:lnRef idx="1">
+            <a:schemeClr val="accent1"/>
+          </a:lnRef>
+          <a:fillRef idx="3">
+            <a:schemeClr val="accent1"/>
+          </a:fillRef>
+          <a:effectRef idx="2">
+            <a:schemeClr val="accent1"/>
+          </a:effectRef>
+          <a:fontRef idx="minor">
+            <a:schemeClr val="lt1"/>
+          </a:fontRef>
+        </p:style>
+        <p:txBody>
+          <a:bodyPr rtlCol="0" anchor="ctr" lIns="36576" rIns="36576"/>
+          <a:lstStyle/>
+          <a:p>
+            <a:pPr algn="ctr"/>
+            <a:r>
+              <a:rPr sz="800" b="1" i="0">
+                <a:solidFill>
+                  <a:srgbClr val="333F52"/>
+                </a:solidFill>
+                <a:latin typeface="Calibri"/>
+              </a:rPr>
+              <a:t>WIF</a:t>
+            </a:r>
+          </a:p>
+        </p:txBody>
+      </p:sp>
+      <p:cxnSp>
+        <p:nvCxnSpPr>
+          <p:cNvPr id="39" name="Connector 38"/>
+          <p:cNvCxnSpPr/>
+          <p:nvPr/>
+        </p:nvCxnSpPr>
+        <p:spPr>
+          <a:xfrm>
+            <a:off x="7498080" y="6126480"/>
+            <a:ext cx="45720" cy="0"/>
+          </a:xfrm>
+          <a:prstGeom prst="line">
+            <a:avLst/>
+          </a:prstGeom>
+          <a:ln w="9525">
+            <a:solidFill>
+              <a:srgbClr val="6B7380"/>
+            </a:solidFill>
+            <a:tailEnd type="triangle" w="sm" h="sm"/>
+          </a:ln>
+        </p:spPr>
+        <p:style>
+          <a:lnRef idx="2">
+            <a:schemeClr val="accent1"/>
+          </a:lnRef>
+          <a:fillRef idx="0">
+            <a:schemeClr val="accent1"/>
+          </a:fillRef>
+          <a:effectRef idx="1">
+            <a:schemeClr val="accent1"/>
+          </a:effectRef>
+          <a:fontRef idx="minor">
+            <a:schemeClr val="tx1"/>
+          </a:fontRef>
+        </p:style>
+      </p:cxnSp>
+      <p:sp>
+        <p:nvSpPr>
+          <p:cNvPr id="40" name="Rounded Rectangle 39"/>
+          <p:cNvSpPr/>
+          <p:nvPr/>
+        </p:nvSpPr>
+        <p:spPr>
+          <a:xfrm>
+            <a:off x="7543800" y="5989320"/>
+            <a:ext cx="1280160" cy="274320"/>
+          </a:xfrm>
+          <a:prstGeom prst="roundRect">
+            <a:avLst>
+              <a:gd name="adj" fmla="val 30000"/>
+            </a:avLst>
+          </a:prstGeom>
+          <a:solidFill>
+            <a:srgbClr val="FFFFFF"/>
+          </a:solidFill>
+          <a:ln w="6350">
+            <a:solidFill>
+              <a:srgbClr val="D7DBE3"/>
+            </a:solidFill>
+          </a:ln>
+        </p:spPr>
+        <p:style>
+          <a:lnRef idx="1">
+            <a:schemeClr val="accent1"/>
+          </a:lnRef>
+          <a:fillRef idx="3">
+            <a:schemeClr val="accent1"/>
+          </a:fillRef>
+          <a:effectRef idx="2">
+            <a:schemeClr val="accent1"/>
+          </a:effectRef>
+          <a:fontRef idx="minor">
+            <a:schemeClr val="lt1"/>
+          </a:fontRef>
+        </p:style>
+        <p:txBody>
+          <a:bodyPr rtlCol="0" anchor="ctr" lIns="36576" rIns="36576"/>
+          <a:lstStyle/>
+          <a:p>
+            <a:pPr algn="ctr"/>
+            <a:r>
+              <a:rPr sz="800" b="1" i="0">
+                <a:solidFill>
+                  <a:srgbClr val="333F52"/>
+                </a:solidFill>
+                <a:latin typeface="Calibri"/>
+              </a:rPr>
+              <a:t>Cloud Build</a:t>
+            </a:r>
+          </a:p>
+        </p:txBody>
+      </p:sp>
+      <p:cxnSp>
+        <p:nvCxnSpPr>
+          <p:cNvPr id="41" name="Connector 40"/>
+          <p:cNvCxnSpPr/>
+          <p:nvPr/>
+        </p:nvCxnSpPr>
+        <p:spPr>
+          <a:xfrm>
+            <a:off x="8823960" y="6126480"/>
+            <a:ext cx="45720" cy="0"/>
+          </a:xfrm>
+          <a:prstGeom prst="line">
+            <a:avLst/>
+          </a:prstGeom>
+          <a:ln w="9525">
+            <a:solidFill>
+              <a:srgbClr val="6B7380"/>
+            </a:solidFill>
+            <a:tailEnd type="triangle" w="sm" h="sm"/>
+          </a:ln>
+        </p:spPr>
+        <p:style>
+          <a:lnRef idx="2">
+            <a:schemeClr val="accent1"/>
+          </a:lnRef>
+          <a:fillRef idx="0">
+            <a:schemeClr val="accent1"/>
+          </a:fillRef>
+          <a:effectRef idx="1">
+            <a:schemeClr val="accent1"/>
+          </a:effectRef>
+          <a:fontRef idx="minor">
+            <a:schemeClr val="tx1"/>
+          </a:fontRef>
+        </p:style>
+      </p:cxnSp>
+      <p:sp>
+        <p:nvSpPr>
+          <p:cNvPr id="42" name="Rounded Rectangle 41"/>
+          <p:cNvSpPr/>
+          <p:nvPr/>
+        </p:nvSpPr>
+        <p:spPr>
+          <a:xfrm>
+            <a:off x="8869680" y="5989320"/>
+            <a:ext cx="1280160" cy="274320"/>
+          </a:xfrm>
+          <a:prstGeom prst="roundRect">
+            <a:avLst>
+              <a:gd name="adj" fmla="val 30000"/>
+            </a:avLst>
+          </a:prstGeom>
+          <a:solidFill>
+            <a:srgbClr val="FFFFFF"/>
+          </a:solidFill>
+          <a:ln w="6350">
+            <a:solidFill>
+              <a:srgbClr val="D7DBE3"/>
+            </a:solidFill>
+          </a:ln>
+        </p:spPr>
+        <p:style>
+          <a:lnRef idx="1">
+            <a:schemeClr val="accent1"/>
+          </a:lnRef>
+          <a:fillRef idx="3">
+            <a:schemeClr val="accent1"/>
+          </a:fillRef>
+          <a:effectRef idx="2">
+            <a:schemeClr val="accent1"/>
+          </a:effectRef>
+          <a:fontRef idx="minor">
+            <a:schemeClr val="lt1"/>
+          </a:fontRef>
+        </p:style>
+        <p:txBody>
+          <a:bodyPr rtlCol="0" anchor="ctr" lIns="36576" rIns="36576"/>
+          <a:lstStyle/>
+          <a:p>
+            <a:pPr algn="ctr"/>
+            <a:r>
+              <a:rPr sz="800" b="1" i="0">
+                <a:solidFill>
+                  <a:srgbClr val="333F52"/>
+                </a:solidFill>
+                <a:latin typeface="Calibri"/>
+              </a:rPr>
+              <a:t>Artifact Registry</a:t>
+            </a:r>
+          </a:p>
+        </p:txBody>
+      </p:sp>
+      <p:cxnSp>
+        <p:nvCxnSpPr>
+          <p:cNvPr id="43" name="Connector 42"/>
+          <p:cNvCxnSpPr/>
+          <p:nvPr/>
+        </p:nvCxnSpPr>
+        <p:spPr>
+          <a:xfrm>
+            <a:off x="10149840" y="6126480"/>
+            <a:ext cx="45720" cy="0"/>
+          </a:xfrm>
+          <a:prstGeom prst="line">
+            <a:avLst/>
+          </a:prstGeom>
+          <a:ln w="9525">
+            <a:solidFill>
+              <a:srgbClr val="6B7380"/>
+            </a:solidFill>
+            <a:tailEnd type="triangle" w="sm" h="sm"/>
+          </a:ln>
+        </p:spPr>
+        <p:style>
+          <a:lnRef idx="2">
+            <a:schemeClr val="accent1"/>
+          </a:lnRef>
+          <a:fillRef idx="0">
+            <a:schemeClr val="accent1"/>
+          </a:fillRef>
+          <a:effectRef idx="1">
+            <a:schemeClr val="accent1"/>
+          </a:effectRef>
+          <a:fontRef idx="minor">
+            <a:schemeClr val="tx1"/>
+          </a:fontRef>
+        </p:style>
+      </p:cxnSp>
+      <p:sp>
+        <p:nvSpPr>
+          <p:cNvPr id="44" name="Rounded Rectangle 43"/>
+          <p:cNvSpPr/>
+          <p:nvPr/>
+        </p:nvSpPr>
+        <p:spPr>
+          <a:xfrm>
+            <a:off x="10195560" y="5989320"/>
+            <a:ext cx="1280160" cy="274320"/>
+          </a:xfrm>
+          <a:prstGeom prst="roundRect">
+            <a:avLst>
+              <a:gd name="adj" fmla="val 30000"/>
+            </a:avLst>
+          </a:prstGeom>
+          <a:solidFill>
+            <a:srgbClr val="FFFFFF"/>
+          </a:solidFill>
+          <a:ln w="6350">
+            <a:solidFill>
+              <a:srgbClr val="D7DBE3"/>
+            </a:solidFill>
+          </a:ln>
+        </p:spPr>
+        <p:style>
+          <a:lnRef idx="1">
+            <a:schemeClr val="accent1"/>
+          </a:lnRef>
+          <a:fillRef idx="3">
+            <a:schemeClr val="accent1"/>
+          </a:fillRef>
+          <a:effectRef idx="2">
+            <a:schemeClr val="accent1"/>
+          </a:effectRef>
+          <a:fontRef idx="minor">
+            <a:schemeClr val="lt1"/>
+          </a:fontRef>
+        </p:style>
+        <p:txBody>
+          <a:bodyPr rtlCol="0" anchor="ctr" lIns="36576" rIns="36576"/>
+          <a:lstStyle/>
+          <a:p>
+            <a:pPr algn="ctr"/>
+            <a:r>
+              <a:rPr sz="800" b="1" i="0">
+                <a:solidFill>
+                  <a:srgbClr val="333F52"/>
+                </a:solidFill>
+                <a:latin typeface="Calibri"/>
+              </a:rPr>
+              <a:t>Cloud Run</a:t>
+            </a:r>
+          </a:p>
+        </p:txBody>
+      </p:sp>
+      <p:sp>
+        <p:nvSpPr>
+          <p:cNvPr id="45" name="TextBox 44"/>
+          <p:cNvSpPr txBox="1"/>
+          <p:nvPr/>
+        </p:nvSpPr>
+        <p:spPr>
+          <a:xfrm>
+            <a:off x="4892040" y="5760720"/>
+            <a:ext cx="1828800" cy="201168"/>
+          </a:xfrm>
+          <a:prstGeom prst="rect">
+            <a:avLst/>
+          </a:prstGeom>
+          <a:noFill/>
+        </p:spPr>
+        <p:txBody>
+          <a:bodyPr wrap="none">
+            <a:spAutoFit/>
+          </a:bodyPr>
+          <a:lstStyle/>
+          <a:p>
+            <a:r>
+              <a:rPr sz="800" b="1" i="1">
+                <a:solidFill>
+                  <a:srgbClr val="6B7380"/>
+                </a:solidFill>
+                <a:latin typeface="Calibri"/>
+              </a:rPr>
+              <a:t>Continuous delivery</a:t>
+            </a:r>
+          </a:p>
+        </p:txBody>
+      </p:sp>
+      <p:cxnSp>
+        <p:nvCxnSpPr>
+          <p:cNvPr id="46" name="Connector 45"/>
+          <p:cNvCxnSpPr/>
+          <p:nvPr/>
+        </p:nvCxnSpPr>
+        <p:spPr>
+          <a:xfrm>
+            <a:off x="685800" y="1993392"/>
+            <a:ext cx="685800" cy="0"/>
+          </a:xfrm>
+          <a:prstGeom prst="line">
             <a:avLst/>
           </a:prstGeom>
           <a:ln w="19050">
             <a:solidFill>
-              <a:srgbClr val="333F52"/>
+              <a:srgbClr val="5F6B7C"/>
             </a:solidFill>
+            <a:tailEnd type="triangle" w="sm" h="sm"/>
+          </a:ln>
+        </p:spPr>
+        <p:style>
+          <a:lnRef idx="2">
+            <a:schemeClr val="accent1"/>
+          </a:lnRef>
+          <a:fillRef idx="0">
+            <a:schemeClr val="accent1"/>
+          </a:fillRef>
+          <a:effectRef idx="1">
+            <a:schemeClr val="accent1"/>
+          </a:effectRef>
+          <a:fontRef idx="minor">
+            <a:schemeClr val="tx1"/>
+          </a:fontRef>
+        </p:style>
+      </p:cxnSp>
+      <p:sp>
+        <p:nvSpPr>
+          <p:cNvPr id="47" name="TextBox 46"/>
+          <p:cNvSpPr txBox="1"/>
+          <p:nvPr/>
+        </p:nvSpPr>
+        <p:spPr>
+          <a:xfrm>
+            <a:off x="502920" y="1691640"/>
+            <a:ext cx="960120" cy="274320"/>
+          </a:xfrm>
+          <a:prstGeom prst="rect">
+            <a:avLst/>
+          </a:prstGeom>
+          <a:noFill/>
+        </p:spPr>
+        <p:txBody>
+          <a:bodyPr wrap="square" lIns="18288" rIns="18288" tIns="0" bIns="0">
+            <a:spAutoFit/>
+          </a:bodyPr>
+          <a:lstStyle/>
+          <a:p>
+            <a:pPr algn="ctr"/>
+            <a:r>
+              <a:rPr sz="800" b="0" i="1">
+                <a:solidFill>
+                  <a:srgbClr val="6B7380"/>
+                </a:solidFill>
+                <a:latin typeface="Calibri"/>
+              </a:rPr>
+              <a:t>HTTPS click</a:t>
+            </a:r>
+          </a:p>
+        </p:txBody>
+      </p:sp>
+      <p:cxnSp>
+        <p:nvCxnSpPr>
+          <p:cNvPr id="48" name="Connector 47"/>
+          <p:cNvCxnSpPr/>
+          <p:nvPr/>
+        </p:nvCxnSpPr>
+        <p:spPr>
+          <a:xfrm>
+            <a:off x="4114800" y="1691640"/>
+            <a:ext cx="457200" cy="0"/>
+          </a:xfrm>
+          <a:prstGeom prst="line">
+            <a:avLst/>
+          </a:prstGeom>
+          <a:ln w="19050">
+            <a:solidFill>
+              <a:srgbClr val="5F6B7C"/>
+            </a:solidFill>
+            <a:tailEnd type="triangle" w="sm" h="sm"/>
+          </a:ln>
+        </p:spPr>
+        <p:style>
+          <a:lnRef idx="2">
+            <a:schemeClr val="accent1"/>
+          </a:lnRef>
+          <a:fillRef idx="0">
+            <a:schemeClr val="accent1"/>
+          </a:fillRef>
+          <a:effectRef idx="1">
+            <a:schemeClr val="accent1"/>
+          </a:effectRef>
+          <a:fontRef idx="minor">
+            <a:schemeClr val="tx1"/>
+          </a:fontRef>
+        </p:style>
+      </p:cxnSp>
+      <p:sp>
+        <p:nvSpPr>
+          <p:cNvPr id="49" name="TextBox 48"/>
+          <p:cNvSpPr txBox="1"/>
+          <p:nvPr/>
+        </p:nvSpPr>
+        <p:spPr>
+          <a:xfrm>
+            <a:off x="4114800" y="1481328"/>
+            <a:ext cx="457200" cy="201168"/>
+          </a:xfrm>
+          <a:prstGeom prst="rect">
+            <a:avLst/>
+          </a:prstGeom>
+          <a:noFill/>
+        </p:spPr>
+        <p:txBody>
+          <a:bodyPr wrap="square" lIns="18288" rIns="18288" tIns="0" bIns="0">
+            <a:spAutoFit/>
+          </a:bodyPr>
+          <a:lstStyle/>
+          <a:p>
+            <a:pPr algn="ctr"/>
+            <a:r>
+              <a:rPr sz="700" b="0" i="1">
+                <a:solidFill>
+                  <a:srgbClr val="6B7380"/>
+                </a:solidFill>
+                <a:latin typeface="Calibri"/>
+              </a:rPr>
+              <a:t>predict</a:t>
+            </a:r>
+          </a:p>
+        </p:txBody>
+      </p:sp>
+      <p:cxnSp>
+        <p:nvCxnSpPr>
+          <p:cNvPr id="50" name="Connector 49"/>
+          <p:cNvCxnSpPr/>
+          <p:nvPr/>
+        </p:nvCxnSpPr>
+        <p:spPr>
+          <a:xfrm flipH="1">
+            <a:off x="4114800" y="2057400"/>
+            <a:ext cx="457200" cy="0"/>
+          </a:xfrm>
+          <a:prstGeom prst="line">
+            <a:avLst/>
+          </a:prstGeom>
+          <a:ln w="19050">
+            <a:solidFill>
+              <a:srgbClr val="E87B1E"/>
+            </a:solidFill>
+            <a:tailEnd type="triangle" w="sm" h="sm"/>
+          </a:ln>
+        </p:spPr>
+        <p:style>
+          <a:lnRef idx="2">
+            <a:schemeClr val="accent1"/>
+          </a:lnRef>
+          <a:fillRef idx="0">
+            <a:schemeClr val="accent1"/>
+          </a:fillRef>
+          <a:effectRef idx="1">
+            <a:schemeClr val="accent1"/>
+          </a:effectRef>
+          <a:fontRef idx="minor">
+            <a:schemeClr val="tx1"/>
+          </a:fontRef>
+        </p:style>
+      </p:cxnSp>
+      <p:sp>
+        <p:nvSpPr>
+          <p:cNvPr id="51" name="TextBox 50"/>
+          <p:cNvSpPr txBox="1"/>
+          <p:nvPr/>
+        </p:nvSpPr>
+        <p:spPr>
+          <a:xfrm>
+            <a:off x="4114800" y="2084831"/>
+            <a:ext cx="457200" cy="201168"/>
+          </a:xfrm>
+          <a:prstGeom prst="rect">
+            <a:avLst/>
+          </a:prstGeom>
+          <a:noFill/>
+        </p:spPr>
+        <p:txBody>
+          <a:bodyPr wrap="square" lIns="18288" rIns="18288" tIns="0" bIns="0">
+            <a:spAutoFit/>
+          </a:bodyPr>
+          <a:lstStyle/>
+          <a:p>
+            <a:pPr algn="ctr"/>
+            <a:r>
+              <a:rPr sz="700" b="0" i="1">
+                <a:solidFill>
+                  <a:srgbClr val="E87B1E"/>
+                </a:solidFill>
+                <a:latin typeface="Calibri"/>
+              </a:rPr>
+              <a:t>rpc</a:t>
+            </a:r>
+          </a:p>
+        </p:txBody>
+      </p:sp>
+      <p:cxnSp>
+        <p:nvCxnSpPr>
+          <p:cNvPr id="52" name="Connector 51"/>
+          <p:cNvCxnSpPr/>
+          <p:nvPr/>
+        </p:nvCxnSpPr>
+        <p:spPr>
+          <a:xfrm>
+            <a:off x="3200400" y="2926080"/>
+            <a:ext cx="502920" cy="1234440"/>
+          </a:xfrm>
+          <a:prstGeom prst="line">
+            <a:avLst/>
+          </a:prstGeom>
+          <a:ln w="15875">
+            <a:solidFill>
+              <a:srgbClr val="E87B1E"/>
+            </a:solidFill>
+            <a:tailEnd type="triangle" w="sm" h="sm"/>
           </a:ln>
         </p:spPr>
         <p:style>
@@ -10120,22 +12094,23 @@
       </p:cxnSp>
       <p:cxnSp>
         <p:nvCxnSpPr>
-          <p:cNvPr id="10" name="Connector 9"/>
+          <p:cNvPr id="53" name="Connector 52"/>
           <p:cNvCxnSpPr/>
           <p:nvPr/>
         </p:nvCxnSpPr>
         <p:spPr>
-          <a:xfrm>
-            <a:off x="3886200" y="1874520"/>
-            <a:ext cx="320040" cy="0"/>
-          </a:xfrm>
-          <a:prstGeom prst="curvedConnector3">
-            <a:avLst/>
-          </a:prstGeom>
-          <a:ln w="19050">
+          <a:xfrm flipV="1">
+            <a:off x="4160520" y="4343400"/>
+            <a:ext cx="868680" cy="27432"/>
+          </a:xfrm>
+          <a:prstGeom prst="line">
+            <a:avLst/>
+          </a:prstGeom>
+          <a:ln w="15875">
             <a:solidFill>
-              <a:srgbClr val="333F52"/>
+              <a:srgbClr val="E87B1E"/>
             </a:solidFill>
+            <a:tailEnd type="triangle" w="sm" h="sm"/>
           </a:ln>
         </p:spPr>
         <p:style>
@@ -10155,22 +12130,23 @@
       </p:cxnSp>
       <p:cxnSp>
         <p:nvCxnSpPr>
-          <p:cNvPr id="11" name="Connector 10"/>
+          <p:cNvPr id="54" name="Connector 53"/>
           <p:cNvCxnSpPr/>
           <p:nvPr/>
         </p:nvCxnSpPr>
         <p:spPr>
           <a:xfrm>
-            <a:off x="5760720" y="1874520"/>
-            <a:ext cx="320040" cy="0"/>
-          </a:xfrm>
-          <a:prstGeom prst="curvedConnector3">
-            <a:avLst/>
-          </a:prstGeom>
-          <a:ln w="19050">
+            <a:off x="4114800" y="2697480"/>
+            <a:ext cx="1371600" cy="1874520"/>
+          </a:xfrm>
+          <a:prstGeom prst="line">
+            <a:avLst/>
+          </a:prstGeom>
+          <a:ln w="12700">
             <a:solidFill>
-              <a:srgbClr val="333F52"/>
+              <a:srgbClr val="E87B1E"/>
             </a:solidFill>
+            <a:tailEnd type="triangle" w="sm" h="sm"/>
           </a:ln>
         </p:spPr>
         <p:style>
@@ -10190,22 +12166,23 @@
       </p:cxnSp>
       <p:cxnSp>
         <p:nvCxnSpPr>
-          <p:cNvPr id="12" name="Connector 11"/>
+          <p:cNvPr id="55" name="Connector 54"/>
           <p:cNvCxnSpPr/>
           <p:nvPr/>
         </p:nvCxnSpPr>
         <p:spPr>
           <a:xfrm>
-            <a:off x="7635240" y="1874520"/>
-            <a:ext cx="320040" cy="0"/>
-          </a:xfrm>
-          <a:prstGeom prst="curvedConnector3">
-            <a:avLst/>
-          </a:prstGeom>
-          <a:ln w="19050">
+            <a:off x="685800" y="2148840"/>
+            <a:ext cx="1143000" cy="2011680"/>
+          </a:xfrm>
+          <a:prstGeom prst="line">
+            <a:avLst/>
+          </a:prstGeom>
+          <a:ln w="12700">
             <a:solidFill>
-              <a:srgbClr val="333F52"/>
+              <a:srgbClr val="A96BDB"/>
             </a:solidFill>
+            <a:tailEnd type="triangle" w="sm" h="sm"/>
           </a:ln>
         </p:spPr>
         <p:style>
@@ -10223,16 +12200,702 @@
           </a:fontRef>
         </p:style>
       </p:cxnSp>
-      <p:sp>
-        <p:nvSpPr>
-          <p:cNvPr id="13" name="TextBox 12"/>
+      <p:cxnSp>
+        <p:nvCxnSpPr>
+          <p:cNvPr id="56" name="Connector 55"/>
+          <p:cNvCxnSpPr/>
+          <p:nvPr/>
+        </p:nvCxnSpPr>
+        <p:spPr>
+          <a:xfrm flipV="1">
+            <a:off x="2057400" y="3657600"/>
+            <a:ext cx="2514600" cy="914400"/>
+          </a:xfrm>
+          <a:prstGeom prst="line">
+            <a:avLst/>
+          </a:prstGeom>
+          <a:ln w="12700">
+            <a:solidFill>
+              <a:srgbClr val="A96BDB"/>
+            </a:solidFill>
+            <a:tailEnd type="triangle" w="sm" h="sm"/>
+          </a:ln>
+        </p:spPr>
+        <p:style>
+          <a:lnRef idx="2">
+            <a:schemeClr val="accent1"/>
+          </a:lnRef>
+          <a:fillRef idx="0">
+            <a:schemeClr val="accent1"/>
+          </a:fillRef>
+          <a:effectRef idx="1">
+            <a:schemeClr val="accent1"/>
+          </a:effectRef>
+          <a:fontRef idx="minor">
+            <a:schemeClr val="tx1"/>
+          </a:fontRef>
+        </p:style>
+      </p:cxnSp>
+      <p:cxnSp>
+        <p:nvCxnSpPr>
+          <p:cNvPr id="57" name="Connector 56"/>
+          <p:cNvCxnSpPr/>
+          <p:nvPr/>
+        </p:nvCxnSpPr>
+        <p:spPr>
+          <a:xfrm flipV="1">
+            <a:off x="548640" y="4160520"/>
+            <a:ext cx="4023360" cy="1280160"/>
+          </a:xfrm>
+          <a:prstGeom prst="line">
+            <a:avLst/>
+          </a:prstGeom>
+          <a:ln w="12700">
+            <a:solidFill>
+              <a:srgbClr val="E87B1E"/>
+            </a:solidFill>
+            <a:tailEnd type="triangle" w="sm" h="sm"/>
+          </a:ln>
+        </p:spPr>
+        <p:style>
+          <a:lnRef idx="2">
+            <a:schemeClr val="accent1"/>
+          </a:lnRef>
+          <a:fillRef idx="0">
+            <a:schemeClr val="accent1"/>
+          </a:fillRef>
+          <a:effectRef idx="1">
+            <a:schemeClr val="accent1"/>
+          </a:effectRef>
+          <a:fontRef idx="minor">
+            <a:schemeClr val="tx1"/>
+          </a:fontRef>
+        </p:style>
+      </p:cxnSp>
+      <p:cxnSp>
+        <p:nvCxnSpPr>
+          <p:cNvPr id="58" name="Connector 57"/>
+          <p:cNvCxnSpPr/>
+          <p:nvPr/>
+        </p:nvCxnSpPr>
+        <p:spPr>
+          <a:xfrm>
+            <a:off x="6858000" y="4023360"/>
+            <a:ext cx="914400" cy="137160"/>
+          </a:xfrm>
+          <a:prstGeom prst="line">
+            <a:avLst/>
+          </a:prstGeom>
+          <a:ln w="15875">
+            <a:solidFill>
+              <a:srgbClr val="5F6B7C"/>
+            </a:solidFill>
+            <a:tailEnd type="triangle" w="sm" h="sm"/>
+          </a:ln>
+        </p:spPr>
+        <p:style>
+          <a:lnRef idx="2">
+            <a:schemeClr val="accent1"/>
+          </a:lnRef>
+          <a:fillRef idx="0">
+            <a:schemeClr val="accent1"/>
+          </a:fillRef>
+          <a:effectRef idx="1">
+            <a:schemeClr val="accent1"/>
+          </a:effectRef>
+          <a:fontRef idx="minor">
+            <a:schemeClr val="tx1"/>
+          </a:fontRef>
+        </p:style>
+      </p:cxnSp>
+      <p:sp>
+        <p:nvSpPr>
+          <p:cNvPr id="59" name="TextBox 58"/>
           <p:cNvSpPr txBox="1"/>
           <p:nvPr/>
         </p:nvSpPr>
         <p:spPr>
           <a:xfrm>
-            <a:off x="457200" y="2651760"/>
-            <a:ext cx="11277295" cy="411480"/>
+            <a:off x="6903720" y="3822191"/>
+            <a:ext cx="914400" cy="201168"/>
+          </a:xfrm>
+          <a:prstGeom prst="rect">
+            <a:avLst/>
+          </a:prstGeom>
+          <a:noFill/>
+        </p:spPr>
+        <p:txBody>
+          <a:bodyPr wrap="square" lIns="18288" rIns="18288" tIns="0" bIns="0">
+            <a:spAutoFit/>
+          </a:bodyPr>
+          <a:lstStyle/>
+          <a:p>
+            <a:pPr algn="ctr"/>
+            <a:r>
+              <a:rPr sz="700" b="0" i="1">
+                <a:solidFill>
+                  <a:srgbClr val="6B7380"/>
+                </a:solidFill>
+                <a:latin typeface="Calibri"/>
+              </a:rPr>
+              <a:t>training data</a:t>
+            </a:r>
+          </a:p>
+        </p:txBody>
+      </p:sp>
+      <p:cxnSp>
+        <p:nvCxnSpPr>
+          <p:cNvPr id="60" name="Connector 59"/>
+          <p:cNvCxnSpPr/>
+          <p:nvPr/>
+        </p:nvCxnSpPr>
+        <p:spPr>
+          <a:xfrm>
+            <a:off x="9692640" y="4572000"/>
+            <a:ext cx="365760" cy="0"/>
+          </a:xfrm>
+          <a:prstGeom prst="line">
+            <a:avLst/>
+          </a:prstGeom>
+          <a:ln w="12700">
+            <a:solidFill>
+              <a:srgbClr val="5F6B7C"/>
+            </a:solidFill>
+            <a:tailEnd type="triangle" w="sm" h="sm"/>
+          </a:ln>
+        </p:spPr>
+        <p:style>
+          <a:lnRef idx="2">
+            <a:schemeClr val="accent1"/>
+          </a:lnRef>
+          <a:fillRef idx="0">
+            <a:schemeClr val="accent1"/>
+          </a:fillRef>
+          <a:effectRef idx="1">
+            <a:schemeClr val="accent1"/>
+          </a:effectRef>
+          <a:fontRef idx="minor">
+            <a:schemeClr val="tx1"/>
+          </a:fontRef>
+        </p:style>
+      </p:cxnSp>
+      <p:cxnSp>
+        <p:nvCxnSpPr>
+          <p:cNvPr id="61" name="Connector 60"/>
+          <p:cNvCxnSpPr/>
+          <p:nvPr/>
+        </p:nvCxnSpPr>
+        <p:spPr>
+          <a:xfrm flipH="1" flipV="1">
+            <a:off x="5715000" y="2331720"/>
+            <a:ext cx="2514600" cy="1828800"/>
+          </a:xfrm>
+          <a:prstGeom prst="line">
+            <a:avLst/>
+          </a:prstGeom>
+          <a:ln w="12700">
+            <a:solidFill>
+              <a:srgbClr val="5F6B7C"/>
+            </a:solidFill>
+            <a:prstDash val="dash"/>
+            <a:tailEnd type="triangle" w="sm" h="sm"/>
+          </a:ln>
+        </p:spPr>
+        <p:style>
+          <a:lnRef idx="2">
+            <a:schemeClr val="accent1"/>
+          </a:lnRef>
+          <a:fillRef idx="0">
+            <a:schemeClr val="accent1"/>
+          </a:fillRef>
+          <a:effectRef idx="1">
+            <a:schemeClr val="accent1"/>
+          </a:effectRef>
+          <a:fontRef idx="minor">
+            <a:schemeClr val="tx1"/>
+          </a:fontRef>
+        </p:style>
+      </p:cxnSp>
+      <p:sp>
+        <p:nvSpPr>
+          <p:cNvPr id="62" name="TextBox 61"/>
+          <p:cNvSpPr txBox="1"/>
+          <p:nvPr/>
+        </p:nvSpPr>
+        <p:spPr>
+          <a:xfrm>
+            <a:off x="7498079" y="3200400"/>
+            <a:ext cx="1463040" cy="201168"/>
+          </a:xfrm>
+          <a:prstGeom prst="rect">
+            <a:avLst/>
+          </a:prstGeom>
+          <a:noFill/>
+        </p:spPr>
+        <p:txBody>
+          <a:bodyPr wrap="square" lIns="18288" rIns="18288" tIns="0" bIns="0">
+            <a:spAutoFit/>
+          </a:bodyPr>
+          <a:lstStyle/>
+          <a:p>
+            <a:pPr algn="ctr"/>
+            <a:r>
+              <a:rPr sz="700" b="0" i="1">
+                <a:solidFill>
+                  <a:srgbClr val="6B7380"/>
+                </a:solidFill>
+                <a:latin typeface="Calibri"/>
+              </a:rPr>
+              <a:t>deploy / retrain</a:t>
+            </a:r>
+          </a:p>
+        </p:txBody>
+      </p:sp>
+      <p:cxnSp>
+        <p:nvCxnSpPr>
+          <p:cNvPr id="63" name="Connector 62"/>
+          <p:cNvCxnSpPr/>
+          <p:nvPr/>
+        </p:nvCxnSpPr>
+        <p:spPr>
+          <a:xfrm>
+            <a:off x="6858000" y="3200400"/>
+            <a:ext cx="1874520" cy="0"/>
+          </a:xfrm>
+          <a:prstGeom prst="line">
+            <a:avLst/>
+          </a:prstGeom>
+          <a:ln w="15875">
+            <a:solidFill>
+              <a:srgbClr val="E87B1E"/>
+            </a:solidFill>
+            <a:tailEnd type="triangle" w="sm" h="sm"/>
+          </a:ln>
+        </p:spPr>
+        <p:style>
+          <a:lnRef idx="2">
+            <a:schemeClr val="accent1"/>
+          </a:lnRef>
+          <a:fillRef idx="0">
+            <a:schemeClr val="accent1"/>
+          </a:fillRef>
+          <a:effectRef idx="1">
+            <a:schemeClr val="accent1"/>
+          </a:effectRef>
+          <a:fontRef idx="minor">
+            <a:schemeClr val="tx1"/>
+          </a:fontRef>
+        </p:style>
+      </p:cxnSp>
+      <p:sp>
+        <p:nvSpPr>
+          <p:cNvPr id="64" name="TextBox 63"/>
+          <p:cNvSpPr txBox="1"/>
+          <p:nvPr/>
+        </p:nvSpPr>
+        <p:spPr>
+          <a:xfrm>
+            <a:off x="6949440" y="2944368"/>
+            <a:ext cx="1783080" cy="201168"/>
+          </a:xfrm>
+          <a:prstGeom prst="rect">
+            <a:avLst/>
+          </a:prstGeom>
+          <a:noFill/>
+        </p:spPr>
+        <p:txBody>
+          <a:bodyPr wrap="square" lIns="18288" rIns="18288" tIns="0" bIns="0">
+            <a:spAutoFit/>
+          </a:bodyPr>
+          <a:lstStyle/>
+          <a:p>
+            <a:pPr algn="ctr"/>
+            <a:r>
+              <a:rPr sz="700" b="0" i="1">
+                <a:solidFill>
+                  <a:srgbClr val="E87B1E"/>
+                </a:solidFill>
+                <a:latin typeface="Calibri"/>
+              </a:rPr>
+              <a:t>read predictions_vs_revenue</a:t>
+            </a:r>
+          </a:p>
+        </p:txBody>
+      </p:sp>
+      <p:cxnSp>
+        <p:nvCxnSpPr>
+          <p:cNvPr id="65" name="Connector 64"/>
+          <p:cNvCxnSpPr/>
+          <p:nvPr/>
+        </p:nvCxnSpPr>
+        <p:spPr>
+          <a:xfrm flipV="1">
+            <a:off x="9966960" y="2331720"/>
+            <a:ext cx="0" cy="457200"/>
+          </a:xfrm>
+          <a:prstGeom prst="line">
+            <a:avLst/>
+          </a:prstGeom>
+          <a:ln w="15875">
+            <a:solidFill>
+              <a:srgbClr val="5F6B7C"/>
+            </a:solidFill>
+            <a:tailEnd type="triangle" w="sm" h="sm"/>
+          </a:ln>
+        </p:spPr>
+        <p:style>
+          <a:lnRef idx="2">
+            <a:schemeClr val="accent1"/>
+          </a:lnRef>
+          <a:fillRef idx="0">
+            <a:schemeClr val="accent1"/>
+          </a:fillRef>
+          <a:effectRef idx="1">
+            <a:schemeClr val="accent1"/>
+          </a:effectRef>
+          <a:fontRef idx="minor">
+            <a:schemeClr val="tx1"/>
+          </a:fontRef>
+        </p:style>
+      </p:cxnSp>
+      <p:sp>
+        <p:nvSpPr>
+          <p:cNvPr id="66" name="TextBox 65"/>
+          <p:cNvSpPr txBox="1"/>
+          <p:nvPr/>
+        </p:nvSpPr>
+        <p:spPr>
+          <a:xfrm>
+            <a:off x="10104120" y="2423160"/>
+            <a:ext cx="1097280" cy="201168"/>
+          </a:xfrm>
+          <a:prstGeom prst="rect">
+            <a:avLst/>
+          </a:prstGeom>
+          <a:noFill/>
+        </p:spPr>
+        <p:txBody>
+          <a:bodyPr wrap="square" lIns="18288" rIns="18288" tIns="0" bIns="0">
+            <a:spAutoFit/>
+          </a:bodyPr>
+          <a:lstStyle/>
+          <a:p>
+            <a:pPr algn="ctr"/>
+            <a:r>
+              <a:rPr sz="700" b="0" i="1">
+                <a:solidFill>
+                  <a:srgbClr val="6B7380"/>
+                </a:solidFill>
+                <a:latin typeface="Calibri"/>
+              </a:rPr>
+              <a:t>HTTPS /api</a:t>
+            </a:r>
+          </a:p>
+        </p:txBody>
+      </p:sp>
+      <p:cxnSp>
+        <p:nvCxnSpPr>
+          <p:cNvPr id="67" name="Connector 66"/>
+          <p:cNvCxnSpPr/>
+          <p:nvPr/>
+        </p:nvCxnSpPr>
+        <p:spPr>
+          <a:xfrm flipH="1">
+            <a:off x="11201400" y="1874519"/>
+            <a:ext cx="365760" cy="0"/>
+          </a:xfrm>
+          <a:prstGeom prst="line">
+            <a:avLst/>
+          </a:prstGeom>
+          <a:ln w="15875">
+            <a:solidFill>
+              <a:srgbClr val="5F6B7C"/>
+            </a:solidFill>
+            <a:tailEnd type="triangle" w="sm" h="sm"/>
+          </a:ln>
+        </p:spPr>
+        <p:style>
+          <a:lnRef idx="2">
+            <a:schemeClr val="accent1"/>
+          </a:lnRef>
+          <a:fillRef idx="0">
+            <a:schemeClr val="accent1"/>
+          </a:fillRef>
+          <a:effectRef idx="1">
+            <a:schemeClr val="accent1"/>
+          </a:effectRef>
+          <a:fontRef idx="minor">
+            <a:schemeClr val="tx1"/>
+          </a:fontRef>
+        </p:style>
+      </p:cxnSp>
+      <p:cxnSp>
+        <p:nvCxnSpPr>
+          <p:cNvPr id="68" name="Connector 67"/>
+          <p:cNvCxnSpPr/>
+          <p:nvPr/>
+        </p:nvCxnSpPr>
+        <p:spPr>
+          <a:xfrm flipH="1" flipV="1">
+            <a:off x="4434840" y="2926080"/>
+            <a:ext cx="137160" cy="2423160"/>
+          </a:xfrm>
+          <a:prstGeom prst="line">
+            <a:avLst/>
+          </a:prstGeom>
+          <a:ln w="12700">
+            <a:solidFill>
+              <a:srgbClr val="5F6B7C"/>
+            </a:solidFill>
+            <a:tailEnd type="triangle" w="sm" h="sm"/>
+          </a:ln>
+        </p:spPr>
+        <p:style>
+          <a:lnRef idx="2">
+            <a:schemeClr val="accent1"/>
+          </a:lnRef>
+          <a:fillRef idx="0">
+            <a:schemeClr val="accent1"/>
+          </a:fillRef>
+          <a:effectRef idx="1">
+            <a:schemeClr val="accent1"/>
+          </a:effectRef>
+          <a:fontRef idx="minor">
+            <a:schemeClr val="tx1"/>
+          </a:fontRef>
+        </p:style>
+      </p:cxnSp>
+      <p:cxnSp>
+        <p:nvCxnSpPr>
+          <p:cNvPr id="69" name="Connector 68"/>
+          <p:cNvCxnSpPr/>
+          <p:nvPr/>
+        </p:nvCxnSpPr>
+        <p:spPr>
+          <a:xfrm flipH="1">
+            <a:off x="4114800" y="2423160"/>
+            <a:ext cx="320040" cy="0"/>
+          </a:xfrm>
+          <a:prstGeom prst="line">
+            <a:avLst/>
+          </a:prstGeom>
+          <a:ln w="12700">
+            <a:solidFill>
+              <a:srgbClr val="5F6B7C"/>
+            </a:solidFill>
+            <a:tailEnd type="triangle" w="sm" h="sm"/>
+          </a:ln>
+        </p:spPr>
+        <p:style>
+          <a:lnRef idx="2">
+            <a:schemeClr val="accent1"/>
+          </a:lnRef>
+          <a:fillRef idx="0">
+            <a:schemeClr val="accent1"/>
+          </a:fillRef>
+          <a:effectRef idx="1">
+            <a:schemeClr val="accent1"/>
+          </a:effectRef>
+          <a:fontRef idx="minor">
+            <a:schemeClr val="tx1"/>
+          </a:fontRef>
+        </p:style>
+      </p:cxnSp>
+      <p:sp>
+        <p:nvSpPr>
+          <p:cNvPr id="70" name="TextBox 69"/>
+          <p:cNvSpPr txBox="1"/>
+          <p:nvPr/>
+        </p:nvSpPr>
+        <p:spPr>
+          <a:xfrm>
+            <a:off x="3611880" y="4754880"/>
+            <a:ext cx="1828800" cy="201168"/>
+          </a:xfrm>
+          <a:prstGeom prst="rect">
+            <a:avLst/>
+          </a:prstGeom>
+          <a:noFill/>
+        </p:spPr>
+        <p:txBody>
+          <a:bodyPr wrap="square" lIns="18288" rIns="18288" tIns="0" bIns="0">
+            <a:spAutoFit/>
+          </a:bodyPr>
+          <a:lstStyle/>
+          <a:p>
+            <a:pPr algn="ctr"/>
+            <a:r>
+              <a:rPr sz="700" b="0" i="1">
+                <a:solidFill>
+                  <a:srgbClr val="6B7380"/>
+                </a:solidFill>
+                <a:latin typeface="Calibri"/>
+              </a:rPr>
+              <a:t>flip kill-switch</a:t>
+            </a:r>
+          </a:p>
+        </p:txBody>
+      </p:sp>
+      <p:cxnSp>
+        <p:nvCxnSpPr>
+          <p:cNvPr id="71" name="Connector 70"/>
+          <p:cNvCxnSpPr/>
+          <p:nvPr/>
+        </p:nvCxnSpPr>
+        <p:spPr>
+          <a:xfrm>
+            <a:off x="11201400" y="5458968"/>
+            <a:ext cx="320040" cy="0"/>
+          </a:xfrm>
+          <a:prstGeom prst="line">
+            <a:avLst/>
+          </a:prstGeom>
+          <a:ln w="12700">
+            <a:solidFill>
+              <a:srgbClr val="5F6B7C"/>
+            </a:solidFill>
+            <a:tailEnd type="triangle" w="sm" h="sm"/>
+          </a:ln>
+        </p:spPr>
+        <p:style>
+          <a:lnRef idx="2">
+            <a:schemeClr val="accent1"/>
+          </a:lnRef>
+          <a:fillRef idx="0">
+            <a:schemeClr val="accent1"/>
+          </a:fillRef>
+          <a:effectRef idx="1">
+            <a:schemeClr val="accent1"/>
+          </a:effectRef>
+          <a:fontRef idx="minor">
+            <a:schemeClr val="tx1"/>
+          </a:fontRef>
+        </p:style>
+      </p:cxnSp>
+      <p:cxnSp>
+        <p:nvCxnSpPr>
+          <p:cNvPr id="72" name="Connector 71"/>
+          <p:cNvCxnSpPr/>
+          <p:nvPr/>
+        </p:nvCxnSpPr>
+        <p:spPr>
+          <a:xfrm flipV="1">
+            <a:off x="2468880" y="2926080"/>
+            <a:ext cx="0" cy="274320"/>
+          </a:xfrm>
+          <a:prstGeom prst="line">
+            <a:avLst/>
+          </a:prstGeom>
+          <a:ln w="12700">
+            <a:solidFill>
+              <a:srgbClr val="5F6B7C"/>
+            </a:solidFill>
+            <a:tailEnd type="triangle" w="sm" h="sm"/>
+          </a:ln>
+        </p:spPr>
+        <p:style>
+          <a:lnRef idx="2">
+            <a:schemeClr val="accent1"/>
+          </a:lnRef>
+          <a:fillRef idx="0">
+            <a:schemeClr val="accent1"/>
+          </a:fillRef>
+          <a:effectRef idx="1">
+            <a:schemeClr val="accent1"/>
+          </a:effectRef>
+          <a:fontRef idx="minor">
+            <a:schemeClr val="tx1"/>
+          </a:fontRef>
+        </p:style>
+      </p:cxnSp>
+      <p:sp>
+        <p:nvSpPr>
+          <p:cNvPr id="73" name="TextBox 72"/>
+          <p:cNvSpPr txBox="1"/>
+          <p:nvPr/>
+        </p:nvSpPr>
+        <p:spPr>
+          <a:xfrm>
+            <a:off x="2514600" y="2971800"/>
+            <a:ext cx="1371600" cy="201168"/>
+          </a:xfrm>
+          <a:prstGeom prst="rect">
+            <a:avLst/>
+          </a:prstGeom>
+          <a:noFill/>
+        </p:spPr>
+        <p:txBody>
+          <a:bodyPr wrap="square" lIns="18288" rIns="18288" tIns="0" bIns="0">
+            <a:spAutoFit/>
+          </a:bodyPr>
+          <a:lstStyle/>
+          <a:p>
+            <a:pPr algn="ctr"/>
+            <a:r>
+              <a:rPr sz="700" b="0" i="1">
+                <a:solidFill>
+                  <a:srgbClr val="6B7380"/>
+                </a:solidFill>
+                <a:latin typeface="Calibri"/>
+              </a:rPr>
+              <a:t>segment bounds</a:t>
+            </a:r>
+          </a:p>
+        </p:txBody>
+      </p:sp>
+      <p:sp>
+        <p:nvSpPr>
+          <p:cNvPr id="74" name="Oval 73"/>
+          <p:cNvSpPr/>
+          <p:nvPr/>
+        </p:nvSpPr>
+        <p:spPr>
+          <a:xfrm>
+            <a:off x="457200" y="6373368"/>
+            <a:ext cx="109728" cy="109728"/>
+          </a:xfrm>
+          <a:prstGeom prst="ellipse">
+            <a:avLst/>
+          </a:prstGeom>
+          <a:solidFill>
+            <a:srgbClr val="4E88E6"/>
+          </a:solidFill>
+          <a:ln>
+            <a:noFill/>
+          </a:ln>
+        </p:spPr>
+        <p:style>
+          <a:lnRef idx="1">
+            <a:schemeClr val="accent1"/>
+          </a:lnRef>
+          <a:fillRef idx="3">
+            <a:schemeClr val="accent1"/>
+          </a:fillRef>
+          <a:effectRef idx="2">
+            <a:schemeClr val="accent1"/>
+          </a:effectRef>
+          <a:fontRef idx="minor">
+            <a:schemeClr val="lt1"/>
+          </a:fontRef>
+        </p:style>
+        <p:txBody>
+          <a:bodyPr rtlCol="0" anchor="ctr"/>
+          <a:lstStyle/>
+          <a:p>
+            <a:pPr algn="ctr"/>
+          </a:p>
+        </p:txBody>
+      </p:sp>
+      <p:sp>
+        <p:nvSpPr>
+          <p:cNvPr id="75" name="TextBox 74"/>
+          <p:cNvSpPr txBox="1"/>
+          <p:nvPr/>
+        </p:nvSpPr>
+        <p:spPr>
+          <a:xfrm>
+            <a:off x="621792" y="6336792"/>
+            <a:ext cx="1463040" cy="201168"/>
           </a:xfrm>
           <a:prstGeom prst="rect">
             <a:avLst/>
@@ -10245,34 +12908,416 @@
           </a:bodyPr>
           <a:lstStyle/>
           <a:p>
+            <a:r>
+              <a:rPr sz="800" b="0" i="0">
+                <a:solidFill>
+                  <a:srgbClr val="333F52"/>
+                </a:solidFill>
+                <a:latin typeface="Calibri"/>
+              </a:rPr>
+              <a:t>Service</a:t>
+            </a:r>
+          </a:p>
+        </p:txBody>
+      </p:sp>
+      <p:sp>
+        <p:nvSpPr>
+          <p:cNvPr id="76" name="Oval 75"/>
+          <p:cNvSpPr/>
+          <p:nvPr/>
+        </p:nvSpPr>
+        <p:spPr>
+          <a:xfrm>
+            <a:off x="1874520" y="6373368"/>
+            <a:ext cx="109728" cy="109728"/>
+          </a:xfrm>
+          <a:prstGeom prst="ellipse">
+            <a:avLst/>
+          </a:prstGeom>
+          <a:solidFill>
+            <a:srgbClr val="34A853"/>
+          </a:solidFill>
+          <a:ln>
+            <a:noFill/>
+          </a:ln>
+        </p:spPr>
+        <p:style>
+          <a:lnRef idx="1">
+            <a:schemeClr val="accent1"/>
+          </a:lnRef>
+          <a:fillRef idx="3">
+            <a:schemeClr val="accent1"/>
+          </a:fillRef>
+          <a:effectRef idx="2">
+            <a:schemeClr val="accent1"/>
+          </a:effectRef>
+          <a:fontRef idx="minor">
+            <a:schemeClr val="lt1"/>
+          </a:fontRef>
+        </p:style>
+        <p:txBody>
+          <a:bodyPr rtlCol="0" anchor="ctr"/>
+          <a:lstStyle/>
+          <a:p>
             <a:pPr algn="ctr"/>
-            <a:r>
-              <a:rPr sz="1100" b="0" i="1">
-                <a:solidFill>
-                  <a:srgbClr val="6B7380"/>
-                </a:solidFill>
-                <a:latin typeface="Calibri"/>
-              </a:rPr>
-              <a:t>Each request is wrapped in production safety controls</a:t>
-            </a:r>
-          </a:p>
-        </p:txBody>
-      </p:sp>
-      <p:sp>
-        <p:nvSpPr>
-          <p:cNvPr id="14" name="Rounded Rectangle 13"/>
+          </a:p>
+        </p:txBody>
+      </p:sp>
+      <p:sp>
+        <p:nvSpPr>
+          <p:cNvPr id="77" name="TextBox 76"/>
+          <p:cNvSpPr txBox="1"/>
+          <p:nvPr/>
+        </p:nvSpPr>
+        <p:spPr>
+          <a:xfrm>
+            <a:off x="2039112" y="6336792"/>
+            <a:ext cx="1463040" cy="201168"/>
+          </a:xfrm>
+          <a:prstGeom prst="rect">
+            <a:avLst/>
+          </a:prstGeom>
+          <a:noFill/>
+        </p:spPr>
+        <p:txBody>
+          <a:bodyPr wrap="none">
+            <a:spAutoFit/>
+          </a:bodyPr>
+          <a:lstStyle/>
+          <a:p>
+            <a:r>
+              <a:rPr sz="800" b="0" i="0">
+                <a:solidFill>
+                  <a:srgbClr val="333F52"/>
+                </a:solidFill>
+                <a:latin typeface="Calibri"/>
+              </a:rPr>
+              <a:t>ML/AI runtime</a:t>
+            </a:r>
+          </a:p>
+        </p:txBody>
+      </p:sp>
+      <p:sp>
+        <p:nvSpPr>
+          <p:cNvPr id="78" name="Oval 77"/>
           <p:cNvSpPr/>
           <p:nvPr/>
         </p:nvSpPr>
         <p:spPr>
           <a:xfrm>
-            <a:off x="457200" y="3154680"/>
-            <a:ext cx="1554480" cy="822960"/>
-          </a:xfrm>
-          <a:prstGeom prst="roundRect">
-            <a:avLst>
-              <a:gd name="adj" fmla="val 15000"/>
-            </a:avLst>
+            <a:off x="3291840" y="6373368"/>
+            <a:ext cx="109728" cy="109728"/>
+          </a:xfrm>
+          <a:prstGeom prst="ellipse">
+            <a:avLst/>
+          </a:prstGeom>
+          <a:solidFill>
+            <a:srgbClr val="0097A7"/>
+          </a:solidFill>
+          <a:ln>
+            <a:noFill/>
+          </a:ln>
+        </p:spPr>
+        <p:style>
+          <a:lnRef idx="1">
+            <a:schemeClr val="accent1"/>
+          </a:lnRef>
+          <a:fillRef idx="3">
+            <a:schemeClr val="accent1"/>
+          </a:fillRef>
+          <a:effectRef idx="2">
+            <a:schemeClr val="accent1"/>
+          </a:effectRef>
+          <a:fontRef idx="minor">
+            <a:schemeClr val="lt1"/>
+          </a:fontRef>
+        </p:style>
+        <p:txBody>
+          <a:bodyPr rtlCol="0" anchor="ctr"/>
+          <a:lstStyle/>
+          <a:p>
+            <a:pPr algn="ctr"/>
+          </a:p>
+        </p:txBody>
+      </p:sp>
+      <p:sp>
+        <p:nvSpPr>
+          <p:cNvPr id="79" name="TextBox 78"/>
+          <p:cNvSpPr txBox="1"/>
+          <p:nvPr/>
+        </p:nvSpPr>
+        <p:spPr>
+          <a:xfrm>
+            <a:off x="3456432" y="6336792"/>
+            <a:ext cx="1463040" cy="201168"/>
+          </a:xfrm>
+          <a:prstGeom prst="rect">
+            <a:avLst/>
+          </a:prstGeom>
+          <a:noFill/>
+        </p:spPr>
+        <p:txBody>
+          <a:bodyPr wrap="none">
+            <a:spAutoFit/>
+          </a:bodyPr>
+          <a:lstStyle/>
+          <a:p>
+            <a:r>
+              <a:rPr sz="800" b="0" i="0">
+                <a:solidFill>
+                  <a:srgbClr val="333F52"/>
+                </a:solidFill>
+                <a:latin typeface="Calibri"/>
+              </a:rPr>
+              <a:t>ML pipeline</a:t>
+            </a:r>
+          </a:p>
+        </p:txBody>
+      </p:sp>
+      <p:sp>
+        <p:nvSpPr>
+          <p:cNvPr id="80" name="Oval 79"/>
+          <p:cNvSpPr/>
+          <p:nvPr/>
+        </p:nvSpPr>
+        <p:spPr>
+          <a:xfrm>
+            <a:off x="4709160" y="6373368"/>
+            <a:ext cx="109728" cy="109728"/>
+          </a:xfrm>
+          <a:prstGeom prst="ellipse">
+            <a:avLst/>
+          </a:prstGeom>
+          <a:solidFill>
+            <a:srgbClr val="7E57C2"/>
+          </a:solidFill>
+          <a:ln>
+            <a:noFill/>
+          </a:ln>
+        </p:spPr>
+        <p:style>
+          <a:lnRef idx="1">
+            <a:schemeClr val="accent1"/>
+          </a:lnRef>
+          <a:fillRef idx="3">
+            <a:schemeClr val="accent1"/>
+          </a:fillRef>
+          <a:effectRef idx="2">
+            <a:schemeClr val="accent1"/>
+          </a:effectRef>
+          <a:fontRef idx="minor">
+            <a:schemeClr val="lt1"/>
+          </a:fontRef>
+        </p:style>
+        <p:txBody>
+          <a:bodyPr rtlCol="0" anchor="ctr"/>
+          <a:lstStyle/>
+          <a:p>
+            <a:pPr algn="ctr"/>
+          </a:p>
+        </p:txBody>
+      </p:sp>
+      <p:sp>
+        <p:nvSpPr>
+          <p:cNvPr id="81" name="TextBox 80"/>
+          <p:cNvSpPr txBox="1"/>
+          <p:nvPr/>
+        </p:nvSpPr>
+        <p:spPr>
+          <a:xfrm>
+            <a:off x="4873752" y="6336792"/>
+            <a:ext cx="1463040" cy="201168"/>
+          </a:xfrm>
+          <a:prstGeom prst="rect">
+            <a:avLst/>
+          </a:prstGeom>
+          <a:noFill/>
+        </p:spPr>
+        <p:txBody>
+          <a:bodyPr wrap="none">
+            <a:spAutoFit/>
+          </a:bodyPr>
+          <a:lstStyle/>
+          <a:p>
+            <a:r>
+              <a:rPr sz="800" b="0" i="0">
+                <a:solidFill>
+                  <a:srgbClr val="333F52"/>
+                </a:solidFill>
+                <a:latin typeface="Calibri"/>
+              </a:rPr>
+              <a:t>Data warehouse</a:t>
+            </a:r>
+          </a:p>
+        </p:txBody>
+      </p:sp>
+      <p:sp>
+        <p:nvSpPr>
+          <p:cNvPr id="82" name="Oval 81"/>
+          <p:cNvSpPr/>
+          <p:nvPr/>
+        </p:nvSpPr>
+        <p:spPr>
+          <a:xfrm>
+            <a:off x="6126480" y="6373368"/>
+            <a:ext cx="109728" cy="109728"/>
+          </a:xfrm>
+          <a:prstGeom prst="ellipse">
+            <a:avLst/>
+          </a:prstGeom>
+          <a:solidFill>
+            <a:srgbClr val="A96BDB"/>
+          </a:solidFill>
+          <a:ln>
+            <a:noFill/>
+          </a:ln>
+        </p:spPr>
+        <p:style>
+          <a:lnRef idx="1">
+            <a:schemeClr val="accent1"/>
+          </a:lnRef>
+          <a:fillRef idx="3">
+            <a:schemeClr val="accent1"/>
+          </a:fillRef>
+          <a:effectRef idx="2">
+            <a:schemeClr val="accent1"/>
+          </a:effectRef>
+          <a:fontRef idx="minor">
+            <a:schemeClr val="lt1"/>
+          </a:fontRef>
+        </p:style>
+        <p:txBody>
+          <a:bodyPr rtlCol="0" anchor="ctr"/>
+          <a:lstStyle/>
+          <a:p>
+            <a:pPr algn="ctr"/>
+          </a:p>
+        </p:txBody>
+      </p:sp>
+      <p:sp>
+        <p:nvSpPr>
+          <p:cNvPr id="83" name="TextBox 82"/>
+          <p:cNvSpPr txBox="1"/>
+          <p:nvPr/>
+        </p:nvSpPr>
+        <p:spPr>
+          <a:xfrm>
+            <a:off x="6291072" y="6336792"/>
+            <a:ext cx="1463040" cy="201168"/>
+          </a:xfrm>
+          <a:prstGeom prst="rect">
+            <a:avLst/>
+          </a:prstGeom>
+          <a:noFill/>
+        </p:spPr>
+        <p:txBody>
+          <a:bodyPr wrap="none">
+            <a:spAutoFit/>
+          </a:bodyPr>
+          <a:lstStyle/>
+          <a:p>
+            <a:r>
+              <a:rPr sz="800" b="0" i="0">
+                <a:solidFill>
+                  <a:srgbClr val="333F52"/>
+                </a:solidFill>
+                <a:latin typeface="Calibri"/>
+              </a:rPr>
+              <a:t>Pub/Sub</a:t>
+            </a:r>
+          </a:p>
+        </p:txBody>
+      </p:sp>
+      <p:sp>
+        <p:nvSpPr>
+          <p:cNvPr id="84" name="Oval 83"/>
+          <p:cNvSpPr/>
+          <p:nvPr/>
+        </p:nvSpPr>
+        <p:spPr>
+          <a:xfrm>
+            <a:off x="7543800" y="6373368"/>
+            <a:ext cx="109728" cy="109728"/>
+          </a:xfrm>
+          <a:prstGeom prst="ellipse">
+            <a:avLst/>
+          </a:prstGeom>
+          <a:solidFill>
+            <a:srgbClr val="E87B1E"/>
+          </a:solidFill>
+          <a:ln>
+            <a:noFill/>
+          </a:ln>
+        </p:spPr>
+        <p:style>
+          <a:lnRef idx="1">
+            <a:schemeClr val="accent1"/>
+          </a:lnRef>
+          <a:fillRef idx="3">
+            <a:schemeClr val="accent1"/>
+          </a:fillRef>
+          <a:effectRef idx="2">
+            <a:schemeClr val="accent1"/>
+          </a:effectRef>
+          <a:fontRef idx="minor">
+            <a:schemeClr val="lt1"/>
+          </a:fontRef>
+        </p:style>
+        <p:txBody>
+          <a:bodyPr rtlCol="0" anchor="ctr"/>
+          <a:lstStyle/>
+          <a:p>
+            <a:pPr algn="ctr"/>
+          </a:p>
+        </p:txBody>
+      </p:sp>
+      <p:sp>
+        <p:nvSpPr>
+          <p:cNvPr id="85" name="TextBox 84"/>
+          <p:cNvSpPr txBox="1"/>
+          <p:nvPr/>
+        </p:nvSpPr>
+        <p:spPr>
+          <a:xfrm>
+            <a:off x="7708392" y="6336792"/>
+            <a:ext cx="1463040" cy="201168"/>
+          </a:xfrm>
+          <a:prstGeom prst="rect">
+            <a:avLst/>
+          </a:prstGeom>
+          <a:noFill/>
+        </p:spPr>
+        <p:txBody>
+          <a:bodyPr wrap="none">
+            <a:spAutoFit/>
+          </a:bodyPr>
+          <a:lstStyle/>
+          <a:p>
+            <a:r>
+              <a:rPr sz="800" b="0" i="0">
+                <a:solidFill>
+                  <a:srgbClr val="333F52"/>
+                </a:solidFill>
+                <a:latin typeface="Calibri"/>
+              </a:rPr>
+              <a:t>Data flow</a:t>
+            </a:r>
+          </a:p>
+        </p:txBody>
+      </p:sp>
+      <p:sp>
+        <p:nvSpPr>
+          <p:cNvPr id="86" name="Rectangle 85"/>
+          <p:cNvSpPr/>
+          <p:nvPr/>
+        </p:nvSpPr>
+        <p:spPr>
+          <a:xfrm>
+            <a:off x="0" y="6537960"/>
+            <a:ext cx="12191695" cy="320040"/>
+          </a:xfrm>
+          <a:prstGeom prst="rect">
+            <a:avLst/>
           </a:prstGeom>
           <a:solidFill>
             <a:srgbClr val="F4F6FA"/>
@@ -10296,444 +13341,17 @@
           </a:fontRef>
         </p:style>
         <p:txBody>
-          <a:bodyPr rtlCol="0" anchor="ctr" wrap="square"/>
+          <a:bodyPr rtlCol="0" anchor="ctr" lIns="548640" tIns="54864"/>
           <a:lstStyle/>
           <a:p>
             <a:pPr algn="ctr"/>
             <a:r>
-              <a:rPr sz="1300" b="1" i="0">
-                <a:solidFill>
-                  <a:srgbClr val="0B1F3A"/>
-                </a:solidFill>
-                <a:latin typeface="Calibri"/>
-              </a:rPr>
-              <a:t>Timeouts</a:t>
-            </a:r>
-          </a:p>
-          <a:p>
-            <a:pPr algn="ctr"/>
-            <a:r>
               <a:rPr sz="900" b="0" i="0">
                 <a:solidFill>
                   <a:srgbClr val="6B7380"/>
                 </a:solidFill>
                 <a:latin typeface="Calibri"/>
               </a:rPr>
-              <a:t>model + BQ budgets</a:t>
-            </a:r>
-          </a:p>
-        </p:txBody>
-      </p:sp>
-      <p:sp>
-        <p:nvSpPr>
-          <p:cNvPr id="15" name="Rounded Rectangle 14"/>
-          <p:cNvSpPr/>
-          <p:nvPr/>
-        </p:nvSpPr>
-        <p:spPr>
-          <a:xfrm>
-            <a:off x="2148840" y="3154680"/>
-            <a:ext cx="1554480" cy="822960"/>
-          </a:xfrm>
-          <a:prstGeom prst="roundRect">
-            <a:avLst>
-              <a:gd name="adj" fmla="val 15000"/>
-            </a:avLst>
-          </a:prstGeom>
-          <a:solidFill>
-            <a:srgbClr val="F4F6FA"/>
-          </a:solidFill>
-          <a:ln>
-            <a:noFill/>
-          </a:ln>
-        </p:spPr>
-        <p:style>
-          <a:lnRef idx="1">
-            <a:schemeClr val="accent1"/>
-          </a:lnRef>
-          <a:fillRef idx="3">
-            <a:schemeClr val="accent1"/>
-          </a:fillRef>
-          <a:effectRef idx="2">
-            <a:schemeClr val="accent1"/>
-          </a:effectRef>
-          <a:fontRef idx="minor">
-            <a:schemeClr val="lt1"/>
-          </a:fontRef>
-        </p:style>
-        <p:txBody>
-          <a:bodyPr rtlCol="0" anchor="ctr" wrap="square"/>
-          <a:lstStyle/>
-          <a:p>
-            <a:pPr algn="ctr"/>
-            <a:r>
-              <a:rPr sz="1300" b="1" i="0">
-                <a:solidFill>
-                  <a:srgbClr val="0B1F3A"/>
-                </a:solidFill>
-                <a:latin typeface="Calibri"/>
-              </a:rPr>
-              <a:t>Circuit breaker</a:t>
-            </a:r>
-          </a:p>
-          <a:p>
-            <a:pPr algn="ctr"/>
-            <a:r>
-              <a:rPr sz="900" b="0" i="0">
-                <a:solidFill>
-                  <a:srgbClr val="6B7380"/>
-                </a:solidFill>
-                <a:latin typeface="Calibri"/>
-              </a:rPr>
-              <a:t>fail fast, recover</a:t>
-            </a:r>
-          </a:p>
-        </p:txBody>
-      </p:sp>
-      <p:sp>
-        <p:nvSpPr>
-          <p:cNvPr id="16" name="Rounded Rectangle 15"/>
-          <p:cNvSpPr/>
-          <p:nvPr/>
-        </p:nvSpPr>
-        <p:spPr>
-          <a:xfrm>
-            <a:off x="3840480" y="3154680"/>
-            <a:ext cx="1554480" cy="822960"/>
-          </a:xfrm>
-          <a:prstGeom prst="roundRect">
-            <a:avLst>
-              <a:gd name="adj" fmla="val 15000"/>
-            </a:avLst>
-          </a:prstGeom>
-          <a:solidFill>
-            <a:srgbClr val="F4F6FA"/>
-          </a:solidFill>
-          <a:ln>
-            <a:noFill/>
-          </a:ln>
-        </p:spPr>
-        <p:style>
-          <a:lnRef idx="1">
-            <a:schemeClr val="accent1"/>
-          </a:lnRef>
-          <a:fillRef idx="3">
-            <a:schemeClr val="accent1"/>
-          </a:fillRef>
-          <a:effectRef idx="2">
-            <a:schemeClr val="accent1"/>
-          </a:effectRef>
-          <a:fontRef idx="minor">
-            <a:schemeClr val="lt1"/>
-          </a:fontRef>
-        </p:style>
-        <p:txBody>
-          <a:bodyPr rtlCol="0" anchor="ctr" wrap="square"/>
-          <a:lstStyle/>
-          <a:p>
-            <a:pPr algn="ctr"/>
-            <a:r>
-              <a:rPr sz="1300" b="1" i="0">
-                <a:solidFill>
-                  <a:srgbClr val="0B1F3A"/>
-                </a:solidFill>
-                <a:latin typeface="Calibri"/>
-              </a:rPr>
-              <a:t>Anomaly detection</a:t>
-            </a:r>
-          </a:p>
-          <a:p>
-            <a:pPr algn="ctr"/>
-            <a:r>
-              <a:rPr sz="900" b="0" i="0">
-                <a:solidFill>
-                  <a:srgbClr val="6B7380"/>
-                </a:solidFill>
-                <a:latin typeface="Calibri"/>
-              </a:rPr>
-              <a:t>null-rate window</a:t>
-            </a:r>
-          </a:p>
-        </p:txBody>
-      </p:sp>
-      <p:sp>
-        <p:nvSpPr>
-          <p:cNvPr id="17" name="Rounded Rectangle 16"/>
-          <p:cNvSpPr/>
-          <p:nvPr/>
-        </p:nvSpPr>
-        <p:spPr>
-          <a:xfrm>
-            <a:off x="5532120" y="3154680"/>
-            <a:ext cx="1554480" cy="822960"/>
-          </a:xfrm>
-          <a:prstGeom prst="roundRect">
-            <a:avLst>
-              <a:gd name="adj" fmla="val 15000"/>
-            </a:avLst>
-          </a:prstGeom>
-          <a:solidFill>
-            <a:srgbClr val="F4F6FA"/>
-          </a:solidFill>
-          <a:ln>
-            <a:noFill/>
-          </a:ln>
-        </p:spPr>
-        <p:style>
-          <a:lnRef idx="1">
-            <a:schemeClr val="accent1"/>
-          </a:lnRef>
-          <a:fillRef idx="3">
-            <a:schemeClr val="accent1"/>
-          </a:fillRef>
-          <a:effectRef idx="2">
-            <a:schemeClr val="accent1"/>
-          </a:effectRef>
-          <a:fontRef idx="minor">
-            <a:schemeClr val="lt1"/>
-          </a:fontRef>
-        </p:style>
-        <p:txBody>
-          <a:bodyPr rtlCol="0" anchor="ctr" wrap="square"/>
-          <a:lstStyle/>
-          <a:p>
-            <a:pPr algn="ctr"/>
-            <a:r>
-              <a:rPr sz="1300" b="1" i="0">
-                <a:solidFill>
-                  <a:srgbClr val="0B1F3A"/>
-                </a:solidFill>
-                <a:latin typeface="Calibri"/>
-              </a:rPr>
-              <a:t>Range clamp</a:t>
-            </a:r>
-          </a:p>
-          <a:p>
-            <a:pPr algn="ctr"/>
-            <a:r>
-              <a:rPr sz="900" b="0" i="0">
-                <a:solidFill>
-                  <a:srgbClr val="6B7380"/>
-                </a:solidFill>
-                <a:latin typeface="Calibri"/>
-              </a:rPr>
-              <a:t>no negative RPC</a:t>
-            </a:r>
-          </a:p>
-        </p:txBody>
-      </p:sp>
-      <p:sp>
-        <p:nvSpPr>
-          <p:cNvPr id="18" name="Rounded Rectangle 17"/>
-          <p:cNvSpPr/>
-          <p:nvPr/>
-        </p:nvSpPr>
-        <p:spPr>
-          <a:xfrm>
-            <a:off x="7223760" y="3154680"/>
-            <a:ext cx="1554480" cy="822960"/>
-          </a:xfrm>
-          <a:prstGeom prst="roundRect">
-            <a:avLst>
-              <a:gd name="adj" fmla="val 15000"/>
-            </a:avLst>
-          </a:prstGeom>
-          <a:solidFill>
-            <a:srgbClr val="F4F6FA"/>
-          </a:solidFill>
-          <a:ln>
-            <a:noFill/>
-          </a:ln>
-        </p:spPr>
-        <p:style>
-          <a:lnRef idx="1">
-            <a:schemeClr val="accent1"/>
-          </a:lnRef>
-          <a:fillRef idx="3">
-            <a:schemeClr val="accent1"/>
-          </a:fillRef>
-          <a:effectRef idx="2">
-            <a:schemeClr val="accent1"/>
-          </a:effectRef>
-          <a:fontRef idx="minor">
-            <a:schemeClr val="lt1"/>
-          </a:fontRef>
-        </p:style>
-        <p:txBody>
-          <a:bodyPr rtlCol="0" anchor="ctr" wrap="square"/>
-          <a:lstStyle/>
-          <a:p>
-            <a:pPr algn="ctr"/>
-            <a:r>
-              <a:rPr sz="1300" b="1" i="0">
-                <a:solidFill>
-                  <a:srgbClr val="0B1F3A"/>
-                </a:solidFill>
-                <a:latin typeface="Calibri"/>
-              </a:rPr>
-              <a:t>Explanations</a:t>
-            </a:r>
-          </a:p>
-          <a:p>
-            <a:pPr algn="ctr"/>
-            <a:r>
-              <a:rPr sz="900" b="0" i="0">
-                <a:solidFill>
-                  <a:srgbClr val="6B7380"/>
-                </a:solidFill>
-                <a:latin typeface="Calibri"/>
-              </a:rPr>
-              <a:t>per-feature SHAP</a:t>
-            </a:r>
-          </a:p>
-        </p:txBody>
-      </p:sp>
-      <p:sp>
-        <p:nvSpPr>
-          <p:cNvPr id="19" name="TextBox 18"/>
-          <p:cNvSpPr txBox="1"/>
-          <p:nvPr/>
-        </p:nvSpPr>
-        <p:spPr>
-          <a:xfrm>
-            <a:off x="457200" y="4297680"/>
-            <a:ext cx="11277295" cy="1097280"/>
-          </a:xfrm>
-          <a:prstGeom prst="rect">
-            <a:avLst/>
-          </a:prstGeom>
-          <a:noFill/>
-        </p:spPr>
-        <p:txBody>
-          <a:bodyPr wrap="square">
-            <a:spAutoFit/>
-          </a:bodyPr>
-          <a:lstStyle/>
-          <a:p>
-            <a:pPr>
-              <a:spcAft>
-                <a:spcPts val="300"/>
-              </a:spcAft>
-            </a:pPr>
-            <a:r>
-              <a:rPr sz="1400" b="1" i="0">
-                <a:solidFill>
-                  <a:srgbClr val="0F6E7A"/>
-                </a:solidFill>
-                <a:latin typeface="Calibri"/>
-              </a:rPr>
-              <a:t>Why this shape</a:t>
-            </a:r>
-          </a:p>
-          <a:p>
-            <a:r>
-              <a:rPr sz="1200" b="1" i="0">
-                <a:solidFill>
-                  <a:srgbClr val="D97306"/>
-                </a:solidFill>
-                <a:latin typeface="Calibri"/>
-              </a:rPr>
-              <a:t>•  </a:t>
-            </a:r>
-            <a:r>
-              <a:rPr sz="1200" b="0" i="0">
-                <a:solidFill>
-                  <a:srgbClr val="333F52"/>
-                </a:solidFill>
-                <a:latin typeface="Calibri"/>
-              </a:rPr>
-              <a:t>Stateless API tier scales horizontally with traffic — pay only for what you use.</a:t>
-            </a:r>
-          </a:p>
-          <a:p>
-            <a:r>
-              <a:rPr sz="1200" b="1" i="0">
-                <a:solidFill>
-                  <a:srgbClr val="D97306"/>
-                </a:solidFill>
-                <a:latin typeface="Calibri"/>
-              </a:rPr>
-              <a:t>•  </a:t>
-            </a:r>
-            <a:r>
-              <a:rPr sz="1200" b="0" i="0">
-                <a:solidFill>
-                  <a:srgbClr val="333F52"/>
-                </a:solidFill>
-                <a:latin typeface="Calibri"/>
-              </a:rPr>
-              <a:t>Vertex AI hosts the model, so retraining and versioning never touch the API.</a:t>
-            </a:r>
-          </a:p>
-          <a:p>
-            <a:r>
-              <a:rPr sz="1200" b="1" i="0">
-                <a:solidFill>
-                  <a:srgbClr val="D97306"/>
-                </a:solidFill>
-                <a:latin typeface="Calibri"/>
-              </a:rPr>
-              <a:t>•  </a:t>
-            </a:r>
-            <a:r>
-              <a:rPr sz="1200" b="0" i="0">
-                <a:solidFill>
-                  <a:srgbClr val="333F52"/>
-                </a:solidFill>
-                <a:latin typeface="Calibri"/>
-              </a:rPr>
-              <a:t>Every prediction is captured in BigQuery — same dataset your analysts already use.</a:t>
-            </a:r>
-          </a:p>
-        </p:txBody>
-      </p:sp>
-      <p:sp>
-        <p:nvSpPr>
-          <p:cNvPr id="20" name="Rectangle 19"/>
-          <p:cNvSpPr/>
-          <p:nvPr/>
-        </p:nvSpPr>
-        <p:spPr>
-          <a:xfrm>
-            <a:off x="0" y="6537960"/>
-            <a:ext cx="12191695" cy="320040"/>
-          </a:xfrm>
-          <a:prstGeom prst="rect">
-            <a:avLst/>
-          </a:prstGeom>
-          <a:solidFill>
-            <a:srgbClr val="F4F6FA"/>
-          </a:solidFill>
-          <a:ln>
-            <a:noFill/>
-          </a:ln>
-        </p:spPr>
-        <p:style>
-          <a:lnRef idx="1">
-            <a:schemeClr val="accent1"/>
-          </a:lnRef>
-          <a:fillRef idx="3">
-            <a:schemeClr val="accent1"/>
-          </a:fillRef>
-          <a:effectRef idx="2">
-            <a:schemeClr val="accent1"/>
-          </a:effectRef>
-          <a:fontRef idx="minor">
-            <a:schemeClr val="lt1"/>
-          </a:fontRef>
-        </p:style>
-        <p:txBody>
-          <a:bodyPr rtlCol="0" anchor="ctr" lIns="548640" tIns="54864"/>
-          <a:lstStyle/>
-          <a:p>
-            <a:pPr algn="ctr"/>
-            <a:r>
-              <a:rPr sz="900" b="0" i="0">
-                <a:solidFill>
-                  <a:srgbClr val="6B7380"/>
-                </a:solidFill>
-                <a:latin typeface="Calibri"/>
-              </a:rPr>
               <a:t>Predictive RPC Estimator — Client Demo</a:t>
             </a:r>
           </a:p>
@@ -10741,7 +13359,7 @@
       </p:sp>
       <p:sp>
         <p:nvSpPr>
-          <p:cNvPr id="21" name="TextBox 20"/>
+          <p:cNvPr id="87" name="TextBox 86"/>
           <p:cNvSpPr txBox="1"/>
           <p:nvPr/>
         </p:nvSpPr>
@@ -10769,7 +13387,7 @@
                 </a:solidFill>
                 <a:latin typeface="Calibri"/>
               </a:rPr>
-              <a:t>5 / 15</a:t>
+              <a:t>6 / 15</a:t>
             </a:r>
           </a:p>
         </p:txBody>

</xml_diff>

<commit_message>
deck: redesign architecture slide as 3 disciplined lanes
Replaces the cluttered single-canvas diagram with 3 horizontal swim lanes
and strict routing rules:

- Lane A (Hot path): Client → Scoring API ⇄ Vertex AI ; Dashboard ← Executive
- Lane B (Data plane): Pub/Sub predictions → BigQuery → ML Pipeline → Cloud Storage
- Lane C (Consumption): Breaker → Secret Manager · Reconciliation · Activation → sinks

All arrows are horizontal-within-lane or right-angle inter-lane through
dedicated channels. No arrow traverses any component box. Components are
grid-aligned with even spacing. Guardrails and CI/CD are summarised in a
footnote rather than competing for canvas space.

Co-Authored-By: Claude Opus 4.7 (1M context) <noreply@anthropic.com>
</commit_message>
<xml_diff>
--- a/docs/client-demo-deck.pptx
+++ b/docs/client-demo-deck.pptx
@@ -9761,20 +9761,20 @@
         </p:nvSpPr>
         <p:spPr>
           <a:xfrm>
-            <a:off x="1188720" y="1051560"/>
-            <a:ext cx="10424160" cy="5303520"/>
+            <a:off x="365760" y="1005840"/>
+            <a:ext cx="11460175" cy="5120640"/>
           </a:xfrm>
           <a:prstGeom prst="roundRect">
             <a:avLst>
-              <a:gd name="adj" fmla="val 2000"/>
+              <a:gd name="adj" fmla="val 1500"/>
             </a:avLst>
           </a:prstGeom>
           <a:solidFill>
-            <a:srgbClr val="ECEFF4"/>
+            <a:srgbClr val="F1F3F8"/>
           </a:solidFill>
           <a:ln w="12700">
             <a:solidFill>
-              <a:srgbClr val="B8BFCC"/>
+              <a:srgbClr val="C9CFDA"/>
             </a:solidFill>
           </a:ln>
         </p:spPr>
@@ -9808,8 +9808,8 @@
         </p:nvSpPr>
         <p:spPr>
           <a:xfrm>
-            <a:off x="1325880" y="1097280"/>
-            <a:ext cx="5486400" cy="320040"/>
+            <a:off x="530352" y="1060704"/>
+            <a:ext cx="7315200" cy="274320"/>
           </a:xfrm>
           <a:prstGeom prst="rect">
             <a:avLst/>
@@ -9823,7 +9823,7 @@
           <a:lstStyle/>
           <a:p>
             <a:r>
-              <a:rPr sz="1200" b="1" i="0">
+              <a:rPr sz="1100" b="1" i="0">
                 <a:solidFill>
                   <a:srgbClr val="0B1F3A"/>
                 </a:solidFill>
@@ -9832,7 +9832,7 @@
               <a:t>Google Cloud Platform</a:t>
             </a:r>
             <a:r>
-              <a:rPr sz="1100" b="0" i="1">
+              <a:rPr sz="1000" b="0" i="1">
                 <a:solidFill>
                   <a:srgbClr val="6B7380"/>
                 </a:solidFill>
@@ -9845,14 +9845,449 @@
       </p:sp>
       <p:sp>
         <p:nvSpPr>
-          <p:cNvPr id="6" name="Oval 5"/>
+          <p:cNvPr id="6" name="Rectangle 5"/>
           <p:cNvSpPr/>
           <p:nvPr/>
         </p:nvSpPr>
         <p:spPr>
           <a:xfrm>
-            <a:off x="137160" y="1828800"/>
-            <a:ext cx="292608" cy="292608"/>
+            <a:off x="594360" y="1463040"/>
+            <a:ext cx="11002975" cy="1325880"/>
+          </a:xfrm>
+          <a:prstGeom prst="rect">
+            <a:avLst/>
+          </a:prstGeom>
+          <a:solidFill>
+            <a:srgbClr val="E8EFF7"/>
+          </a:solidFill>
+          <a:ln w="6350">
+            <a:solidFill>
+              <a:srgbClr val="C9CFDA"/>
+            </a:solidFill>
+          </a:ln>
+        </p:spPr>
+        <p:style>
+          <a:lnRef idx="1">
+            <a:schemeClr val="accent1"/>
+          </a:lnRef>
+          <a:fillRef idx="3">
+            <a:schemeClr val="accent1"/>
+          </a:fillRef>
+          <a:effectRef idx="2">
+            <a:schemeClr val="accent1"/>
+          </a:effectRef>
+          <a:fontRef idx="minor">
+            <a:schemeClr val="lt1"/>
+          </a:fontRef>
+        </p:style>
+        <p:txBody>
+          <a:bodyPr rtlCol="0" anchor="ctr"/>
+          <a:lstStyle/>
+          <a:p>
+            <a:pPr algn="ctr"/>
+          </a:p>
+        </p:txBody>
+      </p:sp>
+      <p:sp>
+        <p:nvSpPr>
+          <p:cNvPr id="7" name="TextBox 6"/>
+          <p:cNvSpPr txBox="1"/>
+          <p:nvPr/>
+        </p:nvSpPr>
+        <p:spPr>
+          <a:xfrm>
+            <a:off x="685800" y="1508760"/>
+            <a:ext cx="2743200" cy="228600"/>
+          </a:xfrm>
+          <a:prstGeom prst="rect">
+            <a:avLst/>
+          </a:prstGeom>
+          <a:noFill/>
+        </p:spPr>
+        <p:txBody>
+          <a:bodyPr wrap="none">
+            <a:spAutoFit/>
+          </a:bodyPr>
+          <a:lstStyle/>
+          <a:p>
+            <a:r>
+              <a:rPr sz="800" b="1" i="0">
+                <a:solidFill>
+                  <a:srgbClr val="6B7380"/>
+                </a:solidFill>
+                <a:latin typeface="Calibri"/>
+              </a:rPr>
+              <a:t>HOT PATH · SERVING</a:t>
+            </a:r>
+          </a:p>
+        </p:txBody>
+      </p:sp>
+      <p:sp>
+        <p:nvSpPr>
+          <p:cNvPr id="8" name="Rectangle 7"/>
+          <p:cNvSpPr/>
+          <p:nvPr/>
+        </p:nvSpPr>
+        <p:spPr>
+          <a:xfrm>
+            <a:off x="594360" y="2926080"/>
+            <a:ext cx="11002975" cy="1325880"/>
+          </a:xfrm>
+          <a:prstGeom prst="rect">
+            <a:avLst/>
+          </a:prstGeom>
+          <a:solidFill>
+            <a:srgbClr val="F1ECF8"/>
+          </a:solidFill>
+          <a:ln w="6350">
+            <a:solidFill>
+              <a:srgbClr val="C9CFDA"/>
+            </a:solidFill>
+          </a:ln>
+        </p:spPr>
+        <p:style>
+          <a:lnRef idx="1">
+            <a:schemeClr val="accent1"/>
+          </a:lnRef>
+          <a:fillRef idx="3">
+            <a:schemeClr val="accent1"/>
+          </a:fillRef>
+          <a:effectRef idx="2">
+            <a:schemeClr val="accent1"/>
+          </a:effectRef>
+          <a:fontRef idx="minor">
+            <a:schemeClr val="lt1"/>
+          </a:fontRef>
+        </p:style>
+        <p:txBody>
+          <a:bodyPr rtlCol="0" anchor="ctr"/>
+          <a:lstStyle/>
+          <a:p>
+            <a:pPr algn="ctr"/>
+          </a:p>
+        </p:txBody>
+      </p:sp>
+      <p:sp>
+        <p:nvSpPr>
+          <p:cNvPr id="9" name="TextBox 8"/>
+          <p:cNvSpPr txBox="1"/>
+          <p:nvPr/>
+        </p:nvSpPr>
+        <p:spPr>
+          <a:xfrm>
+            <a:off x="685800" y="2971800"/>
+            <a:ext cx="2743200" cy="228600"/>
+          </a:xfrm>
+          <a:prstGeom prst="rect">
+            <a:avLst/>
+          </a:prstGeom>
+          <a:noFill/>
+        </p:spPr>
+        <p:txBody>
+          <a:bodyPr wrap="none">
+            <a:spAutoFit/>
+          </a:bodyPr>
+          <a:lstStyle/>
+          <a:p>
+            <a:r>
+              <a:rPr sz="800" b="1" i="0">
+                <a:solidFill>
+                  <a:srgbClr val="6B7380"/>
+                </a:solidFill>
+                <a:latin typeface="Calibri"/>
+              </a:rPr>
+              <a:t>DATA PLANE · WAREHOUSE AND TRAINING</a:t>
+            </a:r>
+          </a:p>
+        </p:txBody>
+      </p:sp>
+      <p:sp>
+        <p:nvSpPr>
+          <p:cNvPr id="10" name="Rectangle 9"/>
+          <p:cNvSpPr/>
+          <p:nvPr/>
+        </p:nvSpPr>
+        <p:spPr>
+          <a:xfrm>
+            <a:off x="594360" y="4389120"/>
+            <a:ext cx="11002975" cy="1325880"/>
+          </a:xfrm>
+          <a:prstGeom prst="rect">
+            <a:avLst/>
+          </a:prstGeom>
+          <a:solidFill>
+            <a:srgbClr val="ECF3EE"/>
+          </a:solidFill>
+          <a:ln w="6350">
+            <a:solidFill>
+              <a:srgbClr val="C9CFDA"/>
+            </a:solidFill>
+          </a:ln>
+        </p:spPr>
+        <p:style>
+          <a:lnRef idx="1">
+            <a:schemeClr val="accent1"/>
+          </a:lnRef>
+          <a:fillRef idx="3">
+            <a:schemeClr val="accent1"/>
+          </a:fillRef>
+          <a:effectRef idx="2">
+            <a:schemeClr val="accent1"/>
+          </a:effectRef>
+          <a:fontRef idx="minor">
+            <a:schemeClr val="lt1"/>
+          </a:fontRef>
+        </p:style>
+        <p:txBody>
+          <a:bodyPr rtlCol="0" anchor="ctr"/>
+          <a:lstStyle/>
+          <a:p>
+            <a:pPr algn="ctr"/>
+          </a:p>
+        </p:txBody>
+      </p:sp>
+      <p:sp>
+        <p:nvSpPr>
+          <p:cNvPr id="11" name="TextBox 10"/>
+          <p:cNvSpPr txBox="1"/>
+          <p:nvPr/>
+        </p:nvSpPr>
+        <p:spPr>
+          <a:xfrm>
+            <a:off x="685800" y="4434840"/>
+            <a:ext cx="2743200" cy="228600"/>
+          </a:xfrm>
+          <a:prstGeom prst="rect">
+            <a:avLst/>
+          </a:prstGeom>
+          <a:noFill/>
+        </p:spPr>
+        <p:txBody>
+          <a:bodyPr wrap="none">
+            <a:spAutoFit/>
+          </a:bodyPr>
+          <a:lstStyle/>
+          <a:p>
+            <a:r>
+              <a:rPr sz="800" b="1" i="0">
+                <a:solidFill>
+                  <a:srgbClr val="6B7380"/>
+                </a:solidFill>
+                <a:latin typeface="Calibri"/>
+              </a:rPr>
+              <a:t>CONSUMPTION · RESILIENCE AND ACTIVATION</a:t>
+            </a:r>
+          </a:p>
+        </p:txBody>
+      </p:sp>
+      <p:sp>
+        <p:nvSpPr>
+          <p:cNvPr id="12" name="Rounded Rectangle 11"/>
+          <p:cNvSpPr/>
+          <p:nvPr/>
+        </p:nvSpPr>
+        <p:spPr>
+          <a:xfrm>
+            <a:off x="1554480" y="1874520"/>
+            <a:ext cx="2560320" cy="777240"/>
+          </a:xfrm>
+          <a:prstGeom prst="roundRect">
+            <a:avLst>
+              <a:gd name="adj" fmla="val 10000"/>
+            </a:avLst>
+          </a:prstGeom>
+          <a:solidFill>
+            <a:srgbClr val="4E88E6"/>
+          </a:solidFill>
+          <a:ln>
+            <a:noFill/>
+          </a:ln>
+        </p:spPr>
+        <p:style>
+          <a:lnRef idx="1">
+            <a:schemeClr val="accent1"/>
+          </a:lnRef>
+          <a:fillRef idx="3">
+            <a:schemeClr val="accent1"/>
+          </a:fillRef>
+          <a:effectRef idx="2">
+            <a:schemeClr val="accent1"/>
+          </a:effectRef>
+          <a:fontRef idx="minor">
+            <a:schemeClr val="lt1"/>
+          </a:fontRef>
+        </p:style>
+        <p:txBody>
+          <a:bodyPr rtlCol="0" anchor="ctr" lIns="73152" rIns="73152" wrap="square"/>
+          <a:lstStyle/>
+          <a:p>
+            <a:pPr algn="ctr"/>
+            <a:r>
+              <a:rPr sz="1100" b="1" i="0">
+                <a:solidFill>
+                  <a:srgbClr val="FFFFFF"/>
+                </a:solidFill>
+                <a:latin typeface="Calibri"/>
+              </a:rPr>
+              <a:t>Scoring API</a:t>
+            </a:r>
+          </a:p>
+          <a:p>
+            <a:pPr algn="ctr"/>
+            <a:r>
+              <a:rPr sz="800" b="0" i="0">
+                <a:solidFill>
+                  <a:srgbClr val="FFFFFF"/>
+                </a:solidFill>
+                <a:latin typeface="Calibri"/>
+              </a:rPr>
+              <a:t>Rust 1.89  ·  Cloud Run</a:t>
+            </a:r>
+          </a:p>
+        </p:txBody>
+      </p:sp>
+      <p:sp>
+        <p:nvSpPr>
+          <p:cNvPr id="13" name="Rounded Rectangle 12"/>
+          <p:cNvSpPr/>
+          <p:nvPr/>
+        </p:nvSpPr>
+        <p:spPr>
+          <a:xfrm>
+            <a:off x="4937760" y="1874520"/>
+            <a:ext cx="2377440" cy="777240"/>
+          </a:xfrm>
+          <a:prstGeom prst="roundRect">
+            <a:avLst>
+              <a:gd name="adj" fmla="val 10000"/>
+            </a:avLst>
+          </a:prstGeom>
+          <a:solidFill>
+            <a:srgbClr val="34A853"/>
+          </a:solidFill>
+          <a:ln>
+            <a:noFill/>
+          </a:ln>
+        </p:spPr>
+        <p:style>
+          <a:lnRef idx="1">
+            <a:schemeClr val="accent1"/>
+          </a:lnRef>
+          <a:fillRef idx="3">
+            <a:schemeClr val="accent1"/>
+          </a:fillRef>
+          <a:effectRef idx="2">
+            <a:schemeClr val="accent1"/>
+          </a:effectRef>
+          <a:fontRef idx="minor">
+            <a:schemeClr val="lt1"/>
+          </a:fontRef>
+        </p:style>
+        <p:txBody>
+          <a:bodyPr rtlCol="0" anchor="ctr" lIns="73152" rIns="73152" wrap="square"/>
+          <a:lstStyle/>
+          <a:p>
+            <a:pPr algn="ctr"/>
+            <a:r>
+              <a:rPr sz="1100" b="1" i="0">
+                <a:solidFill>
+                  <a:srgbClr val="FFFFFF"/>
+                </a:solidFill>
+                <a:latin typeface="Calibri"/>
+              </a:rPr>
+              <a:t>Vertex AI Endpoint</a:t>
+            </a:r>
+          </a:p>
+          <a:p>
+            <a:pPr algn="ctr"/>
+            <a:r>
+              <a:rPr sz="800" b="0" i="0">
+                <a:solidFill>
+                  <a:srgbClr val="FFFFFF"/>
+                </a:solidFill>
+                <a:latin typeface="Calibri"/>
+              </a:rPr>
+              <a:t>XGBoost regressor</a:t>
+            </a:r>
+          </a:p>
+        </p:txBody>
+      </p:sp>
+      <p:sp>
+        <p:nvSpPr>
+          <p:cNvPr id="14" name="Rounded Rectangle 13"/>
+          <p:cNvSpPr/>
+          <p:nvPr/>
+        </p:nvSpPr>
+        <p:spPr>
+          <a:xfrm>
+            <a:off x="9052560" y="1874520"/>
+            <a:ext cx="2377440" cy="777240"/>
+          </a:xfrm>
+          <a:prstGeom prst="roundRect">
+            <a:avLst>
+              <a:gd name="adj" fmla="val 10000"/>
+            </a:avLst>
+          </a:prstGeom>
+          <a:solidFill>
+            <a:srgbClr val="4E88E6"/>
+          </a:solidFill>
+          <a:ln>
+            <a:noFill/>
+          </a:ln>
+        </p:spPr>
+        <p:style>
+          <a:lnRef idx="1">
+            <a:schemeClr val="accent1"/>
+          </a:lnRef>
+          <a:fillRef idx="3">
+            <a:schemeClr val="accent1"/>
+          </a:fillRef>
+          <a:effectRef idx="2">
+            <a:schemeClr val="accent1"/>
+          </a:effectRef>
+          <a:fontRef idx="minor">
+            <a:schemeClr val="lt1"/>
+          </a:fontRef>
+        </p:style>
+        <p:txBody>
+          <a:bodyPr rtlCol="0" anchor="ctr" lIns="73152" rIns="73152" wrap="square"/>
+          <a:lstStyle/>
+          <a:p>
+            <a:pPr algn="ctr"/>
+            <a:r>
+              <a:rPr sz="1100" b="1" i="0">
+                <a:solidFill>
+                  <a:srgbClr val="FFFFFF"/>
+                </a:solidFill>
+                <a:latin typeface="Calibri"/>
+              </a:rPr>
+              <a:t>Dashboard UI</a:t>
+            </a:r>
+          </a:p>
+          <a:p>
+            <a:pPr algn="ctr"/>
+            <a:r>
+              <a:rPr sz="800" b="0" i="0">
+                <a:solidFill>
+                  <a:srgbClr val="FFFFFF"/>
+                </a:solidFill>
+                <a:latin typeface="Calibri"/>
+              </a:rPr>
+              <a:t>TypeScript · React · nginx · Cloud Run</a:t>
+            </a:r>
+          </a:p>
+        </p:txBody>
+      </p:sp>
+      <p:sp>
+        <p:nvSpPr>
+          <p:cNvPr id="15" name="Oval 14"/>
+          <p:cNvSpPr/>
+          <p:nvPr/>
+        </p:nvSpPr>
+        <p:spPr>
+          <a:xfrm>
+            <a:off x="777240" y="1920240"/>
+            <a:ext cx="201168" cy="201168"/>
           </a:xfrm>
           <a:prstGeom prst="ellipse">
             <a:avLst/>
@@ -9888,14 +10323,14 @@
       </p:sp>
       <p:sp>
         <p:nvSpPr>
-          <p:cNvPr id="7" name="Isosceles Triangle 6"/>
+          <p:cNvPr id="16" name="Isosceles Triangle 15"/>
           <p:cNvSpPr/>
           <p:nvPr/>
         </p:nvSpPr>
         <p:spPr>
           <a:xfrm>
-            <a:off x="91440" y="2084832"/>
-            <a:ext cx="384048" cy="411480"/>
+            <a:off x="640080" y="2103120"/>
+            <a:ext cx="475488" cy="384048"/>
           </a:xfrm>
           <a:prstGeom prst="triangle">
             <a:avLst/>
@@ -9931,14 +10366,14 @@
       </p:sp>
       <p:sp>
         <p:nvSpPr>
-          <p:cNvPr id="8" name="TextBox 7"/>
+          <p:cNvPr id="17" name="TextBox 16"/>
           <p:cNvSpPr txBox="1"/>
           <p:nvPr/>
         </p:nvSpPr>
         <p:spPr>
           <a:xfrm>
-            <a:off x="-228600" y="2514600"/>
-            <a:ext cx="1024128" cy="502920"/>
+            <a:off x="457200" y="2514600"/>
+            <a:ext cx="841248" cy="274320"/>
           </a:xfrm>
           <a:prstGeom prst="rect">
             <a:avLst/>
@@ -9946,7 +10381,7 @@
           <a:noFill/>
         </p:spPr>
         <p:txBody>
-          <a:bodyPr wrap="square">
+          <a:bodyPr wrap="none">
             <a:spAutoFit/>
           </a:bodyPr>
           <a:lstStyle/>
@@ -9962,30 +10397,18 @@
               <a:t>Client</a:t>
             </a:r>
           </a:p>
-          <a:p>
-            <a:pPr algn="ctr"/>
-            <a:r>
-              <a:rPr sz="800" b="0" i="0">
-                <a:solidFill>
-                  <a:srgbClr val="6B7380"/>
-                </a:solidFill>
-                <a:latin typeface="Calibri"/>
-              </a:rPr>
-              <a:t>Ad bidding systems</a:t>
-            </a:r>
-          </a:p>
-        </p:txBody>
-      </p:sp>
-      <p:sp>
-        <p:nvSpPr>
-          <p:cNvPr id="9" name="Oval 8"/>
+        </p:txBody>
+      </p:sp>
+      <p:sp>
+        <p:nvSpPr>
+          <p:cNvPr id="18" name="Oval 17"/>
           <p:cNvSpPr/>
           <p:nvPr/>
         </p:nvSpPr>
         <p:spPr>
           <a:xfrm>
-            <a:off x="11567160" y="1828800"/>
-            <a:ext cx="292608" cy="292608"/>
+            <a:off x="11155680" y="1920240"/>
+            <a:ext cx="201168" cy="201168"/>
           </a:xfrm>
           <a:prstGeom prst="ellipse">
             <a:avLst/>
@@ -10021,14 +10444,14 @@
       </p:sp>
       <p:sp>
         <p:nvSpPr>
-          <p:cNvPr id="10" name="Isosceles Triangle 9"/>
+          <p:cNvPr id="19" name="Isosceles Triangle 18"/>
           <p:cNvSpPr/>
           <p:nvPr/>
         </p:nvSpPr>
         <p:spPr>
           <a:xfrm>
-            <a:off x="11521440" y="2084832"/>
-            <a:ext cx="384048" cy="411480"/>
+            <a:off x="11018520" y="2103120"/>
+            <a:ext cx="475488" cy="384048"/>
           </a:xfrm>
           <a:prstGeom prst="triangle">
             <a:avLst/>
@@ -10064,14 +10487,14 @@
       </p:sp>
       <p:sp>
         <p:nvSpPr>
-          <p:cNvPr id="11" name="TextBox 10"/>
+          <p:cNvPr id="20" name="TextBox 19"/>
           <p:cNvSpPr txBox="1"/>
           <p:nvPr/>
         </p:nvSpPr>
         <p:spPr>
           <a:xfrm>
-            <a:off x="11201400" y="2514600"/>
-            <a:ext cx="1024128" cy="502920"/>
+            <a:off x="10835640" y="2514600"/>
+            <a:ext cx="841248" cy="274320"/>
           </a:xfrm>
           <a:prstGeom prst="rect">
             <a:avLst/>
@@ -10079,7 +10502,7 @@
           <a:noFill/>
         </p:spPr>
         <p:txBody>
-          <a:bodyPr wrap="square">
+          <a:bodyPr wrap="none">
             <a:spAutoFit/>
           </a:bodyPr>
           <a:lstStyle/>
@@ -10095,30 +10518,514 @@
               <a:t>Executive</a:t>
             </a:r>
           </a:p>
+        </p:txBody>
+      </p:sp>
+      <p:cxnSp>
+        <p:nvCxnSpPr>
+          <p:cNvPr id="21" name="Connector 20"/>
+          <p:cNvCxnSpPr/>
+          <p:nvPr/>
+        </p:nvCxnSpPr>
+        <p:spPr>
+          <a:xfrm>
+            <a:off x="1143000" y="2226564.0"/>
+            <a:ext cx="411480" cy="0.0"/>
+          </a:xfrm>
+          <a:prstGeom prst="line">
+            <a:avLst/>
+          </a:prstGeom>
+          <a:ln w="15875">
+            <a:solidFill>
+              <a:srgbClr val="46556B"/>
+            </a:solidFill>
+            <a:tailEnd type="triangle" w="med" h="med"/>
+          </a:ln>
+        </p:spPr>
+        <p:style>
+          <a:lnRef idx="2">
+            <a:schemeClr val="accent1"/>
+          </a:lnRef>
+          <a:fillRef idx="0">
+            <a:schemeClr val="accent1"/>
+          </a:fillRef>
+          <a:effectRef idx="1">
+            <a:schemeClr val="accent1"/>
+          </a:effectRef>
+          <a:fontRef idx="minor">
+            <a:schemeClr val="tx1"/>
+          </a:fontRef>
+        </p:style>
+      </p:cxnSp>
+      <p:sp>
+        <p:nvSpPr>
+          <p:cNvPr id="22" name="TextBox 21"/>
+          <p:cNvSpPr txBox="1"/>
+          <p:nvPr/>
+        </p:nvSpPr>
+        <p:spPr>
+          <a:xfrm>
+            <a:off x="1143000" y="1970532"/>
+            <a:ext cx="502920" cy="182880"/>
+          </a:xfrm>
+          <a:prstGeom prst="rect">
+            <a:avLst/>
+          </a:prstGeom>
+          <a:noFill/>
+        </p:spPr>
+        <p:txBody>
+          <a:bodyPr wrap="square" lIns="18288" rIns="18288" tIns="0" bIns="0">
+            <a:spAutoFit/>
+          </a:bodyPr>
+          <a:lstStyle/>
           <a:p>
             <a:pPr algn="ctr"/>
             <a:r>
+              <a:rPr sz="700" b="0" i="1">
+                <a:solidFill>
+                  <a:srgbClr val="6B7380"/>
+                </a:solidFill>
+                <a:latin typeface="Calibri"/>
+              </a:rPr>
+              <a:t>HTTPS</a:t>
+            </a:r>
+          </a:p>
+        </p:txBody>
+      </p:sp>
+      <p:cxnSp>
+        <p:nvCxnSpPr>
+          <p:cNvPr id="23" name="Connector 22"/>
+          <p:cNvCxnSpPr/>
+          <p:nvPr/>
+        </p:nvCxnSpPr>
+        <p:spPr>
+          <a:xfrm>
+            <a:off x="4114800" y="2125980.0"/>
+            <a:ext cx="822960" cy="0.0"/>
+          </a:xfrm>
+          <a:prstGeom prst="line">
+            <a:avLst/>
+          </a:prstGeom>
+          <a:ln w="15875">
+            <a:solidFill>
+              <a:srgbClr val="46556B"/>
+            </a:solidFill>
+            <a:tailEnd type="triangle" w="med" h="med"/>
+          </a:ln>
+        </p:spPr>
+        <p:style>
+          <a:lnRef idx="2">
+            <a:schemeClr val="accent1"/>
+          </a:lnRef>
+          <a:fillRef idx="0">
+            <a:schemeClr val="accent1"/>
+          </a:fillRef>
+          <a:effectRef idx="1">
+            <a:schemeClr val="accent1"/>
+          </a:effectRef>
+          <a:fontRef idx="minor">
+            <a:schemeClr val="tx1"/>
+          </a:fontRef>
+        </p:style>
+      </p:cxnSp>
+      <p:sp>
+        <p:nvSpPr>
+          <p:cNvPr id="24" name="TextBox 23"/>
+          <p:cNvSpPr txBox="1"/>
+          <p:nvPr/>
+        </p:nvSpPr>
+        <p:spPr>
+          <a:xfrm>
+            <a:off x="4114800" y="1933956"/>
+            <a:ext cx="822960" cy="182880"/>
+          </a:xfrm>
+          <a:prstGeom prst="rect">
+            <a:avLst/>
+          </a:prstGeom>
+          <a:noFill/>
+        </p:spPr>
+        <p:txBody>
+          <a:bodyPr wrap="square" lIns="18288" rIns="18288" tIns="0" bIns="0">
+            <a:spAutoFit/>
+          </a:bodyPr>
+          <a:lstStyle/>
+          <a:p>
+            <a:pPr algn="ctr"/>
+            <a:r>
+              <a:rPr sz="700" b="0" i="1">
+                <a:solidFill>
+                  <a:srgbClr val="6B7380"/>
+                </a:solidFill>
+                <a:latin typeface="Calibri"/>
+              </a:rPr>
+              <a:t>predict</a:t>
+            </a:r>
+          </a:p>
+        </p:txBody>
+      </p:sp>
+      <p:cxnSp>
+        <p:nvCxnSpPr>
+          <p:cNvPr id="25" name="Connector 24"/>
+          <p:cNvCxnSpPr/>
+          <p:nvPr/>
+        </p:nvCxnSpPr>
+        <p:spPr>
+          <a:xfrm flipH="1">
+            <a:off x="4114800" y="2400300.0"/>
+            <a:ext cx="822960" cy="0.0"/>
+          </a:xfrm>
+          <a:prstGeom prst="line">
+            <a:avLst/>
+          </a:prstGeom>
+          <a:ln w="15875">
+            <a:solidFill>
+              <a:srgbClr val="46556B"/>
+            </a:solidFill>
+            <a:tailEnd type="triangle" w="med" h="med"/>
+          </a:ln>
+        </p:spPr>
+        <p:style>
+          <a:lnRef idx="2">
+            <a:schemeClr val="accent1"/>
+          </a:lnRef>
+          <a:fillRef idx="0">
+            <a:schemeClr val="accent1"/>
+          </a:fillRef>
+          <a:effectRef idx="1">
+            <a:schemeClr val="accent1"/>
+          </a:effectRef>
+          <a:fontRef idx="minor">
+            <a:schemeClr val="tx1"/>
+          </a:fontRef>
+        </p:style>
+      </p:cxnSp>
+      <p:sp>
+        <p:nvSpPr>
+          <p:cNvPr id="26" name="TextBox 25"/>
+          <p:cNvSpPr txBox="1"/>
+          <p:nvPr/>
+        </p:nvSpPr>
+        <p:spPr>
+          <a:xfrm>
+            <a:off x="4114800" y="2400300"/>
+            <a:ext cx="822960" cy="182880"/>
+          </a:xfrm>
+          <a:prstGeom prst="rect">
+            <a:avLst/>
+          </a:prstGeom>
+          <a:noFill/>
+        </p:spPr>
+        <p:txBody>
+          <a:bodyPr wrap="square" lIns="18288" rIns="18288" tIns="0" bIns="0">
+            <a:spAutoFit/>
+          </a:bodyPr>
+          <a:lstStyle/>
+          <a:p>
+            <a:pPr algn="ctr"/>
+            <a:r>
+              <a:rPr sz="700" b="0" i="1">
+                <a:solidFill>
+                  <a:srgbClr val="6B7380"/>
+                </a:solidFill>
+                <a:latin typeface="Calibri"/>
+              </a:rPr>
+              <a:t>predicted_rpc</a:t>
+            </a:r>
+          </a:p>
+        </p:txBody>
+      </p:sp>
+      <p:cxnSp>
+        <p:nvCxnSpPr>
+          <p:cNvPr id="27" name="Connector 26"/>
+          <p:cNvCxnSpPr/>
+          <p:nvPr/>
+        </p:nvCxnSpPr>
+        <p:spPr>
+          <a:xfrm flipH="1">
+            <a:off x="11430000" y="2263140.0"/>
+            <a:ext cx="45720" cy="0.0"/>
+          </a:xfrm>
+          <a:prstGeom prst="line">
+            <a:avLst/>
+          </a:prstGeom>
+          <a:ln w="15875">
+            <a:solidFill>
+              <a:srgbClr val="46556B"/>
+            </a:solidFill>
+            <a:tailEnd type="triangle" w="med" h="med"/>
+          </a:ln>
+        </p:spPr>
+        <p:style>
+          <a:lnRef idx="2">
+            <a:schemeClr val="accent1"/>
+          </a:lnRef>
+          <a:fillRef idx="0">
+            <a:schemeClr val="accent1"/>
+          </a:fillRef>
+          <a:effectRef idx="1">
+            <a:schemeClr val="accent1"/>
+          </a:effectRef>
+          <a:fontRef idx="minor">
+            <a:schemeClr val="tx1"/>
+          </a:fontRef>
+        </p:style>
+      </p:cxnSp>
+      <p:sp>
+        <p:nvSpPr>
+          <p:cNvPr id="28" name="Hexagon 27"/>
+          <p:cNvSpPr/>
+          <p:nvPr/>
+        </p:nvSpPr>
+        <p:spPr>
+          <a:xfrm>
+            <a:off x="2240280" y="3383280"/>
+            <a:ext cx="1188720" cy="502920"/>
+          </a:xfrm>
+          <a:prstGeom prst="hexagon">
+            <a:avLst/>
+          </a:prstGeom>
+          <a:solidFill>
+            <a:srgbClr val="A06CD6"/>
+          </a:solidFill>
+          <a:ln>
+            <a:noFill/>
+          </a:ln>
+        </p:spPr>
+        <p:style>
+          <a:lnRef idx="1">
+            <a:schemeClr val="accent1"/>
+          </a:lnRef>
+          <a:fillRef idx="3">
+            <a:schemeClr val="accent1"/>
+          </a:fillRef>
+          <a:effectRef idx="2">
+            <a:schemeClr val="accent1"/>
+          </a:effectRef>
+          <a:fontRef idx="minor">
+            <a:schemeClr val="lt1"/>
+          </a:fontRef>
+        </p:style>
+        <p:txBody>
+          <a:bodyPr rtlCol="0" anchor="ctr"/>
+          <a:lstStyle/>
+          <a:p>
+            <a:pPr algn="ctr"/>
+            <a:r>
+              <a:rPr sz="900" b="1" i="0">
+                <a:solidFill>
+                  <a:srgbClr val="FFFFFF"/>
+                </a:solidFill>
+                <a:latin typeface="Calibri"/>
+              </a:rPr>
+              <a:t>Pub/Sub</a:t>
+            </a:r>
+          </a:p>
+        </p:txBody>
+      </p:sp>
+      <p:sp>
+        <p:nvSpPr>
+          <p:cNvPr id="29" name="TextBox 28"/>
+          <p:cNvSpPr txBox="1"/>
+          <p:nvPr/>
+        </p:nvSpPr>
+        <p:spPr>
+          <a:xfrm>
+            <a:off x="2103120" y="3904488"/>
+            <a:ext cx="1463040" cy="201168"/>
+          </a:xfrm>
+          <a:prstGeom prst="rect">
+            <a:avLst/>
+          </a:prstGeom>
+          <a:noFill/>
+        </p:spPr>
+        <p:txBody>
+          <a:bodyPr wrap="none">
+            <a:spAutoFit/>
+          </a:bodyPr>
+          <a:lstStyle/>
+          <a:p>
+            <a:pPr algn="ctr"/>
+            <a:r>
               <a:rPr sz="800" b="0" i="0">
                 <a:solidFill>
-                  <a:srgbClr val="6B7380"/>
-                </a:solidFill>
-                <a:latin typeface="Calibri"/>
-              </a:rPr>
-              <a:t>stakeholders</a:t>
-            </a:r>
-          </a:p>
-        </p:txBody>
-      </p:sp>
-      <p:sp>
-        <p:nvSpPr>
-          <p:cNvPr id="12" name="Can 11"/>
+                  <a:srgbClr val="333F52"/>
+                </a:solidFill>
+                <a:latin typeface="Calibri"/>
+              </a:rPr>
+              <a:t>rpc-predictions-staging</a:t>
+            </a:r>
+          </a:p>
+        </p:txBody>
+      </p:sp>
+      <p:sp>
+        <p:nvSpPr>
+          <p:cNvPr id="30" name="Rounded Rectangle 29"/>
           <p:cNvSpPr/>
           <p:nvPr/>
         </p:nvSpPr>
         <p:spPr>
           <a:xfrm>
-            <a:off x="182880" y="5212080"/>
-            <a:ext cx="365760" cy="457200"/>
+            <a:off x="4937760" y="3264408"/>
+            <a:ext cx="2377440" cy="960120"/>
+          </a:xfrm>
+          <a:prstGeom prst="roundRect">
+            <a:avLst>
+              <a:gd name="adj" fmla="val 8000"/>
+            </a:avLst>
+          </a:prstGeom>
+          <a:solidFill>
+            <a:srgbClr val="7E57C2"/>
+          </a:solidFill>
+          <a:ln>
+            <a:noFill/>
+          </a:ln>
+        </p:spPr>
+        <p:style>
+          <a:lnRef idx="1">
+            <a:schemeClr val="accent1"/>
+          </a:lnRef>
+          <a:fillRef idx="3">
+            <a:schemeClr val="accent1"/>
+          </a:fillRef>
+          <a:effectRef idx="2">
+            <a:schemeClr val="accent1"/>
+          </a:effectRef>
+          <a:fontRef idx="minor">
+            <a:schemeClr val="lt1"/>
+          </a:fontRef>
+        </p:style>
+        <p:txBody>
+          <a:bodyPr rtlCol="0" anchor="ctr" wrap="square" lIns="73152" rIns="73152" tIns="54864"/>
+          <a:lstStyle/>
+          <a:p>
+            <a:pPr algn="ctr"/>
+            <a:r>
+              <a:rPr sz="1100" b="1" i="0">
+                <a:solidFill>
+                  <a:srgbClr val="FFFFFF"/>
+                </a:solidFill>
+                <a:latin typeface="Calibri"/>
+              </a:rPr>
+              <a:t>BigQuery</a:t>
+            </a:r>
+          </a:p>
+          <a:p>
+            <a:pPr algn="ctr"/>
+            <a:r>
+              <a:rPr sz="800" b="0" i="0">
+                <a:solidFill>
+                  <a:srgbClr val="FFFFFF"/>
+                </a:solidFill>
+                <a:latin typeface="Calibri"/>
+              </a:rPr>
+              <a:t>Data warehouse</a:t>
+            </a:r>
+          </a:p>
+          <a:p>
+            <a:pPr algn="ctr">
+              <a:spcBef>
+                <a:spcPts val="300"/>
+              </a:spcBef>
+            </a:pPr>
+            <a:r>
+              <a:rPr sz="700" b="0" i="1">
+                <a:solidFill>
+                  <a:srgbClr val="FFFFFF"/>
+                </a:solidFill>
+                <a:latin typeface="Calibri"/>
+              </a:rPr>
+              <a:t>rpc_predictions  ·  sales_ledger</a:t>
+            </a:r>
+          </a:p>
+          <a:p>
+            <a:pPr algn="ctr"/>
+            <a:r>
+              <a:rPr sz="700" b="0" i="1">
+                <a:solidFill>
+                  <a:srgbClr val="FFFFFF"/>
+                </a:solidFill>
+                <a:latin typeface="Calibri"/>
+              </a:rPr>
+              <a:t>predictions_vs_revenue</a:t>
+            </a:r>
+          </a:p>
+        </p:txBody>
+      </p:sp>
+      <p:sp>
+        <p:nvSpPr>
+          <p:cNvPr id="31" name="Rounded Rectangle 30"/>
+          <p:cNvSpPr/>
+          <p:nvPr/>
+        </p:nvSpPr>
+        <p:spPr>
+          <a:xfrm>
+            <a:off x="8229600" y="3337560"/>
+            <a:ext cx="2194560" cy="777240"/>
+          </a:xfrm>
+          <a:prstGeom prst="roundRect">
+            <a:avLst>
+              <a:gd name="adj" fmla="val 10000"/>
+            </a:avLst>
+          </a:prstGeom>
+          <a:solidFill>
+            <a:srgbClr val="0097A7"/>
+          </a:solidFill>
+          <a:ln>
+            <a:noFill/>
+          </a:ln>
+        </p:spPr>
+        <p:style>
+          <a:lnRef idx="1">
+            <a:schemeClr val="accent1"/>
+          </a:lnRef>
+          <a:fillRef idx="3">
+            <a:schemeClr val="accent1"/>
+          </a:fillRef>
+          <a:effectRef idx="2">
+            <a:schemeClr val="accent1"/>
+          </a:effectRef>
+          <a:fontRef idx="minor">
+            <a:schemeClr val="lt1"/>
+          </a:fontRef>
+        </p:style>
+        <p:txBody>
+          <a:bodyPr rtlCol="0" anchor="ctr" lIns="73152" rIns="73152" wrap="square"/>
+          <a:lstStyle/>
+          <a:p>
+            <a:pPr algn="ctr"/>
+            <a:r>
+              <a:rPr sz="1100" b="1" i="0">
+                <a:solidFill>
+                  <a:srgbClr val="FFFFFF"/>
+                </a:solidFill>
+                <a:latin typeface="Calibri"/>
+              </a:rPr>
+              <a:t>ML Ops Pipeline</a:t>
+            </a:r>
+          </a:p>
+          <a:p>
+            <a:pPr algn="ctr"/>
+            <a:r>
+              <a:rPr sz="800" b="0" i="0">
+                <a:solidFill>
+                  <a:srgbClr val="FFFFFF"/>
+                </a:solidFill>
+                <a:latin typeface="Calibri"/>
+              </a:rPr>
+              <a:t>Python 3.12  ·  Vertex AI Pipelines</a:t>
+            </a:r>
+          </a:p>
+        </p:txBody>
+      </p:sp>
+      <p:sp>
+        <p:nvSpPr>
+          <p:cNvPr id="32" name="Can 31"/>
+          <p:cNvSpPr/>
+          <p:nvPr/>
+        </p:nvSpPr>
+        <p:spPr>
+          <a:xfrm>
+            <a:off x="10698480" y="3337560"/>
+            <a:ext cx="640080" cy="777240"/>
           </a:xfrm>
           <a:prstGeom prst="can">
             <a:avLst/>
@@ -10154,717 +11061,14 @@
       </p:sp>
       <p:sp>
         <p:nvSpPr>
-          <p:cNvPr id="13" name="TextBox 12"/>
+          <p:cNvPr id="33" name="TextBox 32"/>
           <p:cNvSpPr txBox="1"/>
           <p:nvPr/>
         </p:nvSpPr>
         <p:spPr>
           <a:xfrm>
-            <a:off x="-137160" y="5715000"/>
-            <a:ext cx="1005840" cy="411480"/>
-          </a:xfrm>
-          <a:prstGeom prst="rect">
-            <a:avLst/>
-          </a:prstGeom>
-          <a:noFill/>
-        </p:spPr>
-        <p:txBody>
-          <a:bodyPr wrap="square">
-            <a:spAutoFit/>
-          </a:bodyPr>
-          <a:lstStyle/>
-          <a:p>
-            <a:pPr algn="ctr"/>
-            <a:r>
-              <a:rPr sz="900" b="1" i="0">
-                <a:solidFill>
-                  <a:srgbClr val="333F52"/>
-                </a:solidFill>
-                <a:latin typeface="Calibri"/>
-              </a:rPr>
-              <a:t>Sales ledger
-data source</a:t>
-            </a:r>
-          </a:p>
-        </p:txBody>
-      </p:sp>
-      <p:sp>
-        <p:nvSpPr>
-          <p:cNvPr id="14" name="Rounded Rectangle 13"/>
-          <p:cNvSpPr/>
-          <p:nvPr/>
-        </p:nvSpPr>
-        <p:spPr>
-          <a:xfrm>
-            <a:off x="1371600" y="1417320"/>
-            <a:ext cx="2743200" cy="1508760"/>
-          </a:xfrm>
-          <a:prstGeom prst="roundRect">
-            <a:avLst>
-              <a:gd name="adj" fmla="val 12000"/>
-            </a:avLst>
-          </a:prstGeom>
-          <a:solidFill>
-            <a:srgbClr val="4E88E6"/>
-          </a:solidFill>
-          <a:ln>
-            <a:noFill/>
-          </a:ln>
-        </p:spPr>
-        <p:style>
-          <a:lnRef idx="1">
-            <a:schemeClr val="accent1"/>
-          </a:lnRef>
-          <a:fillRef idx="3">
-            <a:schemeClr val="accent1"/>
-          </a:fillRef>
-          <a:effectRef idx="2">
-            <a:schemeClr val="accent1"/>
-          </a:effectRef>
-          <a:fontRef idx="minor">
-            <a:schemeClr val="lt1"/>
-          </a:fontRef>
-        </p:style>
-        <p:txBody>
-          <a:bodyPr rtlCol="0" anchor="ctr" tIns="54864" bIns="54864" wrap="square"/>
-          <a:lstStyle/>
-          <a:p>
-            <a:pPr algn="ctr"/>
-            <a:r>
-              <a:rPr sz="1200" b="1" i="0">
-                <a:solidFill>
-                  <a:srgbClr val="FFFFFF"/>
-                </a:solidFill>
-                <a:latin typeface="Calibri"/>
-              </a:rPr>
-              <a:t>Scoring Service  ·  scoring-api</a:t>
-            </a:r>
-          </a:p>
-          <a:p>
-            <a:pPr algn="ctr"/>
-            <a:r>
-              <a:rPr sz="900" b="0" i="0">
-                <a:solidFill>
-                  <a:srgbClr val="FFFFFF"/>
-                </a:solidFill>
-                <a:latin typeface="Calibri"/>
-              </a:rPr>
-              <a:t>Rust 1.89  ·  Cloud Run</a:t>
-            </a:r>
-          </a:p>
-        </p:txBody>
-      </p:sp>
-      <p:sp>
-        <p:nvSpPr>
-          <p:cNvPr id="15" name="Rounded Rectangle 14"/>
-          <p:cNvSpPr/>
-          <p:nvPr/>
-        </p:nvSpPr>
-        <p:spPr>
-          <a:xfrm>
-            <a:off x="1508760" y="2240280"/>
-            <a:ext cx="2468880" cy="640080"/>
-          </a:xfrm>
-          <a:prstGeom prst="roundRect">
-            <a:avLst>
-              <a:gd name="adj" fmla="val 15000"/>
-            </a:avLst>
-          </a:prstGeom>
-          <a:solidFill>
-            <a:srgbClr val="E8F0FE"/>
-          </a:solidFill>
-          <a:ln>
-            <a:noFill/>
-          </a:ln>
-        </p:spPr>
-        <p:style>
-          <a:lnRef idx="1">
-            <a:schemeClr val="accent1"/>
-          </a:lnRef>
-          <a:fillRef idx="3">
-            <a:schemeClr val="accent1"/>
-          </a:fillRef>
-          <a:effectRef idx="2">
-            <a:schemeClr val="accent1"/>
-          </a:effectRef>
-          <a:fontRef idx="minor">
-            <a:schemeClr val="lt1"/>
-          </a:fontRef>
-        </p:style>
-        <p:txBody>
-          <a:bodyPr rtlCol="0" anchor="ctr" lIns="73152" rIns="73152" tIns="36576" bIns="36576"/>
-          <a:lstStyle/>
-          <a:p>
-            <a:pPr algn="ctr"/>
-            <a:r>
-              <a:rPr sz="900" b="1" i="0">
-                <a:solidFill>
-                  <a:srgbClr val="2A5FC3"/>
-                </a:solidFill>
-                <a:latin typeface="Calibri"/>
-              </a:rPr>
-              <a:t>Safety guardrails</a:t>
-            </a:r>
-          </a:p>
-          <a:p>
-            <a:pPr algn="ctr"/>
-            <a:r>
-              <a:rPr sz="800" b="0" i="0">
-                <a:solidFill>
-                  <a:srgbClr val="2A5FC3"/>
-                </a:solidFill>
-                <a:latin typeface="Calibri"/>
-              </a:rPr>
-              <a:t>Bounds  ·  clamp  ·  timeouts  ·  anomaly  ·  breaker  ·  kill-switch</a:t>
-            </a:r>
-          </a:p>
-        </p:txBody>
-      </p:sp>
-      <p:sp>
-        <p:nvSpPr>
-          <p:cNvPr id="16" name="Rounded Rectangle 15"/>
-          <p:cNvSpPr/>
-          <p:nvPr/>
-        </p:nvSpPr>
-        <p:spPr>
-          <a:xfrm>
-            <a:off x="4572000" y="1417320"/>
-            <a:ext cx="2286000" cy="914400"/>
-          </a:xfrm>
-          <a:prstGeom prst="roundRect">
-            <a:avLst>
-              <a:gd name="adj" fmla="val 12000"/>
-            </a:avLst>
-          </a:prstGeom>
-          <a:solidFill>
-            <a:srgbClr val="34A853"/>
-          </a:solidFill>
-          <a:ln>
-            <a:noFill/>
-          </a:ln>
-        </p:spPr>
-        <p:style>
-          <a:lnRef idx="1">
-            <a:schemeClr val="accent1"/>
-          </a:lnRef>
-          <a:fillRef idx="3">
-            <a:schemeClr val="accent1"/>
-          </a:fillRef>
-          <a:effectRef idx="2">
-            <a:schemeClr val="accent1"/>
-          </a:effectRef>
-          <a:fontRef idx="minor">
-            <a:schemeClr val="lt1"/>
-          </a:fontRef>
-        </p:style>
-        <p:txBody>
-          <a:bodyPr rtlCol="0" anchor="ctr" tIns="54864" bIns="54864" wrap="square"/>
-          <a:lstStyle/>
-          <a:p>
-            <a:pPr algn="ctr"/>
-            <a:r>
-              <a:rPr sz="1200" b="1" i="0">
-                <a:solidFill>
-                  <a:srgbClr val="FFFFFF"/>
-                </a:solidFill>
-                <a:latin typeface="Calibri"/>
-              </a:rPr>
-              <a:t>Vertex AI Endpoint</a:t>
-            </a:r>
-          </a:p>
-          <a:p>
-            <a:pPr algn="ctr"/>
-            <a:r>
-              <a:rPr sz="900" b="0" i="0">
-                <a:solidFill>
-                  <a:srgbClr val="FFFFFF"/>
-                </a:solidFill>
-                <a:latin typeface="Calibri"/>
-              </a:rPr>
-              <a:t>XGBoost regressor  ·  rpc-estimator@1</a:t>
-            </a:r>
-          </a:p>
-        </p:txBody>
-      </p:sp>
-      <p:sp>
-        <p:nvSpPr>
-          <p:cNvPr id="17" name="Rounded Rectangle 16"/>
-          <p:cNvSpPr/>
-          <p:nvPr/>
-        </p:nvSpPr>
-        <p:spPr>
-          <a:xfrm>
-            <a:off x="8732520" y="1417320"/>
-            <a:ext cx="2468880" cy="914400"/>
-          </a:xfrm>
-          <a:prstGeom prst="roundRect">
-            <a:avLst>
-              <a:gd name="adj" fmla="val 12000"/>
-            </a:avLst>
-          </a:prstGeom>
-          <a:solidFill>
-            <a:srgbClr val="4E88E6"/>
-          </a:solidFill>
-          <a:ln>
-            <a:noFill/>
-          </a:ln>
-        </p:spPr>
-        <p:style>
-          <a:lnRef idx="1">
-            <a:schemeClr val="accent1"/>
-          </a:lnRef>
-          <a:fillRef idx="3">
-            <a:schemeClr val="accent1"/>
-          </a:fillRef>
-          <a:effectRef idx="2">
-            <a:schemeClr val="accent1"/>
-          </a:effectRef>
-          <a:fontRef idx="minor">
-            <a:schemeClr val="lt1"/>
-          </a:fontRef>
-        </p:style>
-        <p:txBody>
-          <a:bodyPr rtlCol="0" anchor="ctr" tIns="54864" bIns="54864" wrap="square"/>
-          <a:lstStyle/>
-          <a:p>
-            <a:pPr algn="ctr"/>
-            <a:r>
-              <a:rPr sz="1200" b="1" i="0">
-                <a:solidFill>
-                  <a:srgbClr val="FFFFFF"/>
-                </a:solidFill>
-                <a:latin typeface="Calibri"/>
-              </a:rPr>
-              <a:t>Dashboard UI</a:t>
-            </a:r>
-          </a:p>
-          <a:p>
-            <a:pPr algn="ctr"/>
-            <a:r>
-              <a:rPr sz="900" b="0" i="0">
-                <a:solidFill>
-                  <a:srgbClr val="FFFFFF"/>
-                </a:solidFill>
-                <a:latin typeface="Calibri"/>
-              </a:rPr>
-              <a:t>TypeScript / React / nginx  ·  Cloud Run</a:t>
-            </a:r>
-          </a:p>
-        </p:txBody>
-      </p:sp>
-      <p:sp>
-        <p:nvSpPr>
-          <p:cNvPr id="18" name="Rounded Rectangle 17"/>
-          <p:cNvSpPr/>
-          <p:nvPr/>
-        </p:nvSpPr>
-        <p:spPr>
-          <a:xfrm>
-            <a:off x="1371600" y="3200400"/>
-            <a:ext cx="2194560" cy="777240"/>
-          </a:xfrm>
-          <a:prstGeom prst="roundRect">
-            <a:avLst>
-              <a:gd name="adj" fmla="val 12000"/>
-            </a:avLst>
-          </a:prstGeom>
-          <a:solidFill>
-            <a:srgbClr val="4E88E6"/>
-          </a:solidFill>
-          <a:ln>
-            <a:noFill/>
-          </a:ln>
-        </p:spPr>
-        <p:style>
-          <a:lnRef idx="1">
-            <a:schemeClr val="accent1"/>
-          </a:lnRef>
-          <a:fillRef idx="3">
-            <a:schemeClr val="accent1"/>
-          </a:fillRef>
-          <a:effectRef idx="2">
-            <a:schemeClr val="accent1"/>
-          </a:effectRef>
-          <a:fontRef idx="minor">
-            <a:schemeClr val="lt1"/>
-          </a:fontRef>
-        </p:style>
-        <p:txBody>
-          <a:bodyPr rtlCol="0" anchor="ctr" tIns="54864" bIns="54864" wrap="square"/>
-          <a:lstStyle/>
-          <a:p>
-            <a:pPr algn="ctr"/>
-            <a:r>
-              <a:rPr sz="1200" b="1" i="0">
-                <a:solidFill>
-                  <a:srgbClr val="FFFFFF"/>
-                </a:solidFill>
-                <a:latin typeface="Calibri"/>
-              </a:rPr>
-              <a:t>Bounds Calibration</a:t>
-            </a:r>
-          </a:p>
-          <a:p>
-            <a:pPr algn="ctr"/>
-            <a:r>
-              <a:rPr sz="900" b="0" i="0">
-                <a:solidFill>
-                  <a:srgbClr val="FFFFFF"/>
-                </a:solidFill>
-                <a:latin typeface="Calibri"/>
-              </a:rPr>
-              <a:t>Rust  ·  Cloud Run job</a:t>
-            </a:r>
-          </a:p>
-        </p:txBody>
-      </p:sp>
-      <p:sp>
-        <p:nvSpPr>
-          <p:cNvPr id="19" name="Rounded Rectangle 18"/>
-          <p:cNvSpPr/>
-          <p:nvPr/>
-        </p:nvSpPr>
-        <p:spPr>
-          <a:xfrm>
-            <a:off x="3703320" y="2423160"/>
-            <a:ext cx="1463040" cy="502920"/>
-          </a:xfrm>
-          <a:prstGeom prst="roundRect">
-            <a:avLst>
-              <a:gd name="adj" fmla="val 18000"/>
-            </a:avLst>
-          </a:prstGeom>
-          <a:solidFill>
-            <a:srgbClr val="FFFFFF"/>
-          </a:solidFill>
-          <a:ln w="6350">
-            <a:solidFill>
-              <a:srgbClr val="6B7380"/>
-            </a:solidFill>
-          </a:ln>
-        </p:spPr>
-        <p:style>
-          <a:lnRef idx="1">
-            <a:schemeClr val="accent1"/>
-          </a:lnRef>
-          <a:fillRef idx="3">
-            <a:schemeClr val="accent1"/>
-          </a:fillRef>
-          <a:effectRef idx="2">
-            <a:schemeClr val="accent1"/>
-          </a:effectRef>
-          <a:fontRef idx="minor">
-            <a:schemeClr val="lt1"/>
-          </a:fontRef>
-        </p:style>
-        <p:txBody>
-          <a:bodyPr rtlCol="0" anchor="ctr" lIns="54864" rIns="54864"/>
-          <a:lstStyle/>
-          <a:p>
-            <a:pPr algn="ctr"/>
-            <a:r>
-              <a:rPr sz="900" b="1" i="0">
-                <a:solidFill>
-                  <a:srgbClr val="333F52"/>
-                </a:solidFill>
-                <a:latin typeface="Calibri"/>
-              </a:rPr>
-              <a:t>Secret Manager / Config</a:t>
-            </a:r>
-          </a:p>
-        </p:txBody>
-      </p:sp>
-      <p:sp>
-        <p:nvSpPr>
-          <p:cNvPr id="20" name="Rounded Rectangle 19"/>
-          <p:cNvSpPr/>
-          <p:nvPr/>
-        </p:nvSpPr>
-        <p:spPr>
-          <a:xfrm>
-            <a:off x="4572000" y="2971800"/>
-            <a:ext cx="2286000" cy="1371600"/>
-          </a:xfrm>
-          <a:prstGeom prst="roundRect">
-            <a:avLst>
-              <a:gd name="adj" fmla="val 8000"/>
-            </a:avLst>
-          </a:prstGeom>
-          <a:solidFill>
-            <a:srgbClr val="7E57C2"/>
-          </a:solidFill>
-          <a:ln>
-            <a:noFill/>
-          </a:ln>
-        </p:spPr>
-        <p:style>
-          <a:lnRef idx="1">
-            <a:schemeClr val="accent1"/>
-          </a:lnRef>
-          <a:fillRef idx="3">
-            <a:schemeClr val="accent1"/>
-          </a:fillRef>
-          <a:effectRef idx="2">
-            <a:schemeClr val="accent1"/>
-          </a:effectRef>
-          <a:fontRef idx="minor">
-            <a:schemeClr val="lt1"/>
-          </a:fontRef>
-        </p:style>
-        <p:txBody>
-          <a:bodyPr rtlCol="0" anchor="ctr" wrap="square" tIns="73152"/>
-          <a:lstStyle/>
-          <a:p>
-            <a:pPr algn="ctr"/>
-            <a:r>
-              <a:rPr sz="1200" b="1" i="0">
-                <a:solidFill>
-                  <a:srgbClr val="FFFFFF"/>
-                </a:solidFill>
-                <a:latin typeface="Calibri"/>
-              </a:rPr>
-              <a:t>BigQuery</a:t>
-            </a:r>
-          </a:p>
-          <a:p>
-            <a:pPr algn="ctr"/>
-            <a:r>
-              <a:rPr sz="900" b="0" i="0">
-                <a:solidFill>
-                  <a:srgbClr val="FFFFFF"/>
-                </a:solidFill>
-                <a:latin typeface="Calibri"/>
-              </a:rPr>
-              <a:t>Data warehouse</a:t>
-            </a:r>
-          </a:p>
-          <a:p>
-            <a:pPr algn="ctr">
-              <a:spcBef>
-                <a:spcPts val="600"/>
-              </a:spcBef>
-            </a:pPr>
-            <a:r>
-              <a:rPr sz="800" b="0" i="1">
-                <a:solidFill>
-                  <a:srgbClr val="FFFFFF"/>
-                </a:solidFill>
-                <a:latin typeface="Calibri"/>
-              </a:rPr>
-              <a:t>cm360_clicks  ·  sales_ledger</a:t>
-            </a:r>
-          </a:p>
-          <a:p>
-            <a:pPr algn="ctr"/>
-            <a:r>
-              <a:rPr sz="800" b="0" i="1">
-                <a:solidFill>
-                  <a:srgbClr val="FFFFFF"/>
-                </a:solidFill>
-                <a:latin typeface="Calibri"/>
-              </a:rPr>
-              <a:t>rpc_predictions</a:t>
-            </a:r>
-          </a:p>
-          <a:p>
-            <a:pPr algn="ctr"/>
-            <a:r>
-              <a:rPr sz="800" b="0" i="1">
-                <a:solidFill>
-                  <a:srgbClr val="FFFFFF"/>
-                </a:solidFill>
-                <a:latin typeface="Calibri"/>
-              </a:rPr>
-              <a:t>predictions_vs_revenue</a:t>
-            </a:r>
-          </a:p>
-        </p:txBody>
-      </p:sp>
-      <p:sp>
-        <p:nvSpPr>
-          <p:cNvPr id="21" name="Rounded Rectangle 20"/>
-          <p:cNvSpPr/>
-          <p:nvPr/>
-        </p:nvSpPr>
-        <p:spPr>
-          <a:xfrm>
-            <a:off x="8732520" y="2788920"/>
-            <a:ext cx="2468880" cy="777240"/>
-          </a:xfrm>
-          <a:prstGeom prst="roundRect">
-            <a:avLst>
-              <a:gd name="adj" fmla="val 12000"/>
-            </a:avLst>
-          </a:prstGeom>
-          <a:solidFill>
-            <a:srgbClr val="4E88E6"/>
-          </a:solidFill>
-          <a:ln>
-            <a:noFill/>
-          </a:ln>
-        </p:spPr>
-        <p:style>
-          <a:lnRef idx="1">
-            <a:schemeClr val="accent1"/>
-          </a:lnRef>
-          <a:fillRef idx="3">
-            <a:schemeClr val="accent1"/>
-          </a:fillRef>
-          <a:effectRef idx="2">
-            <a:schemeClr val="accent1"/>
-          </a:effectRef>
-          <a:fontRef idx="minor">
-            <a:schemeClr val="lt1"/>
-          </a:fontRef>
-        </p:style>
-        <p:txBody>
-          <a:bodyPr rtlCol="0" anchor="ctr" tIns="54864" bIns="54864" wrap="square"/>
-          <a:lstStyle/>
-          <a:p>
-            <a:pPr algn="ctr"/>
-            <a:r>
-              <a:rPr sz="1200" b="1" i="0">
-                <a:solidFill>
-                  <a:srgbClr val="FFFFFF"/>
-                </a:solidFill>
-                <a:latin typeface="Calibri"/>
-              </a:rPr>
-              <a:t>Reconciliation Service</a:t>
-            </a:r>
-          </a:p>
-          <a:p>
-            <a:pPr algn="ctr"/>
-            <a:r>
-              <a:rPr sz="900" b="0" i="0">
-                <a:solidFill>
-                  <a:srgbClr val="FFFFFF"/>
-                </a:solidFill>
-                <a:latin typeface="Calibri"/>
-              </a:rPr>
-              <a:t>Python FastAPI  ·  Cloud Run</a:t>
-            </a:r>
-          </a:p>
-        </p:txBody>
-      </p:sp>
-      <p:sp>
-        <p:nvSpPr>
-          <p:cNvPr id="22" name="Rounded Rectangle 21"/>
-          <p:cNvSpPr/>
-          <p:nvPr/>
-        </p:nvSpPr>
-        <p:spPr>
-          <a:xfrm>
-            <a:off x="7315200" y="4160520"/>
-            <a:ext cx="2377440" cy="822960"/>
-          </a:xfrm>
-          <a:prstGeom prst="roundRect">
-            <a:avLst>
-              <a:gd name="adj" fmla="val 12000"/>
-            </a:avLst>
-          </a:prstGeom>
-          <a:solidFill>
-            <a:srgbClr val="0097A7"/>
-          </a:solidFill>
-          <a:ln>
-            <a:noFill/>
-          </a:ln>
-        </p:spPr>
-        <p:style>
-          <a:lnRef idx="1">
-            <a:schemeClr val="accent1"/>
-          </a:lnRef>
-          <a:fillRef idx="3">
-            <a:schemeClr val="accent1"/>
-          </a:fillRef>
-          <a:effectRef idx="2">
-            <a:schemeClr val="accent1"/>
-          </a:effectRef>
-          <a:fontRef idx="minor">
-            <a:schemeClr val="lt1"/>
-          </a:fontRef>
-        </p:style>
-        <p:txBody>
-          <a:bodyPr rtlCol="0" anchor="ctr" tIns="54864" bIns="54864" wrap="square"/>
-          <a:lstStyle/>
-          <a:p>
-            <a:pPr algn="ctr"/>
-            <a:r>
-              <a:rPr sz="1200" b="1" i="0">
-                <a:solidFill>
-                  <a:srgbClr val="FFFFFF"/>
-                </a:solidFill>
-                <a:latin typeface="Calibri"/>
-              </a:rPr>
-              <a:t>ML Ops Pipeline  ·  ml-pipeline</a:t>
-            </a:r>
-          </a:p>
-          <a:p>
-            <a:pPr algn="ctr"/>
-            <a:r>
-              <a:rPr sz="900" b="0" i="0">
-                <a:solidFill>
-                  <a:srgbClr val="FFFFFF"/>
-                </a:solidFill>
-                <a:latin typeface="Calibri"/>
-              </a:rPr>
-              <a:t>Python 3.12  ·  Vertex AI Pipelines</a:t>
-            </a:r>
-          </a:p>
-        </p:txBody>
-      </p:sp>
-      <p:sp>
-        <p:nvSpPr>
-          <p:cNvPr id="23" name="Can 22"/>
-          <p:cNvSpPr/>
-          <p:nvPr/>
-        </p:nvSpPr>
-        <p:spPr>
-          <a:xfrm>
-            <a:off x="10058400" y="4160520"/>
-            <a:ext cx="502920" cy="822960"/>
-          </a:xfrm>
-          <a:prstGeom prst="can">
-            <a:avLst/>
-          </a:prstGeom>
-          <a:solidFill>
-            <a:srgbClr val="6B7380"/>
-          </a:solidFill>
-          <a:ln>
-            <a:noFill/>
-          </a:ln>
-        </p:spPr>
-        <p:style>
-          <a:lnRef idx="1">
-            <a:schemeClr val="accent1"/>
-          </a:lnRef>
-          <a:fillRef idx="3">
-            <a:schemeClr val="accent1"/>
-          </a:fillRef>
-          <a:effectRef idx="2">
-            <a:schemeClr val="accent1"/>
-          </a:effectRef>
-          <a:fontRef idx="minor">
-            <a:schemeClr val="lt1"/>
-          </a:fontRef>
-        </p:style>
-        <p:txBody>
-          <a:bodyPr rtlCol="0" anchor="ctr"/>
-          <a:lstStyle/>
-          <a:p>
-            <a:pPr algn="ctr"/>
-          </a:p>
-        </p:txBody>
-      </p:sp>
-      <p:sp>
-        <p:nvSpPr>
-          <p:cNvPr id="24" name="TextBox 23"/>
-          <p:cNvSpPr txBox="1"/>
-          <p:nvPr/>
-        </p:nvSpPr>
-        <p:spPr>
-          <a:xfrm>
-            <a:off x="9875520" y="5029200"/>
-            <a:ext cx="868680" cy="274320"/>
+            <a:off x="10561320" y="4096512"/>
+            <a:ext cx="914400" cy="228600"/>
           </a:xfrm>
           <a:prstGeom prst="rect">
             <a:avLst/>
@@ -10879,587 +11083,36 @@
           <a:p>
             <a:pPr algn="ctr"/>
             <a:r>
-              <a:rPr sz="800" b="1" i="0">
+              <a:rPr sz="700" b="1" i="0">
                 <a:solidFill>
                   <a:srgbClr val="333F52"/>
                 </a:solidFill>
                 <a:latin typeface="Calibri"/>
               </a:rPr>
               <a:t>Cloud Storage</a:t>
-            </a:r>
-          </a:p>
-        </p:txBody>
-      </p:sp>
-      <p:sp>
-        <p:nvSpPr>
-          <p:cNvPr id="25" name="Hexagon 24"/>
-          <p:cNvSpPr/>
-          <p:nvPr/>
-        </p:nvSpPr>
-        <p:spPr>
-          <a:xfrm>
-            <a:off x="1371600" y="4160520"/>
-            <a:ext cx="1371600" cy="411480"/>
-          </a:xfrm>
-          <a:prstGeom prst="hexagon">
-            <a:avLst/>
-          </a:prstGeom>
-          <a:solidFill>
-            <a:srgbClr val="A96BDB"/>
-          </a:solidFill>
-          <a:ln>
-            <a:noFill/>
-          </a:ln>
-        </p:spPr>
-        <p:style>
-          <a:lnRef idx="1">
-            <a:schemeClr val="accent1"/>
-          </a:lnRef>
-          <a:fillRef idx="3">
-            <a:schemeClr val="accent1"/>
-          </a:fillRef>
-          <a:effectRef idx="2">
-            <a:schemeClr val="accent1"/>
-          </a:effectRef>
-          <a:fontRef idx="minor">
-            <a:schemeClr val="lt1"/>
-          </a:fontRef>
-        </p:style>
-        <p:txBody>
-          <a:bodyPr rtlCol="0" anchor="ctr" lIns="36576" rIns="36576"/>
-          <a:lstStyle/>
-          <a:p>
-            <a:pPr algn="ctr"/>
-            <a:r>
-              <a:rPr sz="800" b="1" i="0">
-                <a:solidFill>
-                  <a:srgbClr val="FFFFFF"/>
-                </a:solidFill>
-                <a:latin typeface="Calibri"/>
-              </a:rPr>
-              <a:t>Pub/Sub</a:t>
-            </a:r>
-          </a:p>
-        </p:txBody>
-      </p:sp>
-      <p:sp>
-        <p:nvSpPr>
-          <p:cNvPr id="26" name="TextBox 25"/>
-          <p:cNvSpPr txBox="1"/>
-          <p:nvPr/>
-        </p:nvSpPr>
-        <p:spPr>
-          <a:xfrm>
-            <a:off x="1371600" y="4581144"/>
-            <a:ext cx="1371600" cy="292608"/>
-          </a:xfrm>
-          <a:prstGeom prst="rect">
-            <a:avLst/>
-          </a:prstGeom>
-          <a:noFill/>
-        </p:spPr>
-        <p:txBody>
-          <a:bodyPr wrap="none">
-            <a:spAutoFit/>
-          </a:bodyPr>
-          <a:lstStyle/>
-          <a:p>
-            <a:pPr algn="ctr"/>
-            <a:r>
-              <a:rPr sz="800" b="0" i="0">
-                <a:solidFill>
-                  <a:srgbClr val="333F52"/>
-                </a:solidFill>
-                <a:latin typeface="Calibri"/>
-              </a:rPr>
-              <a:t>rpc-clicks-staging</a:t>
-            </a:r>
-          </a:p>
-        </p:txBody>
-      </p:sp>
-      <p:sp>
-        <p:nvSpPr>
-          <p:cNvPr id="27" name="Hexagon 26"/>
-          <p:cNvSpPr/>
-          <p:nvPr/>
-        </p:nvSpPr>
-        <p:spPr>
-          <a:xfrm>
-            <a:off x="3017520" y="4160520"/>
-            <a:ext cx="1371600" cy="411480"/>
-          </a:xfrm>
-          <a:prstGeom prst="hexagon">
-            <a:avLst/>
-          </a:prstGeom>
-          <a:solidFill>
-            <a:srgbClr val="A96BDB"/>
-          </a:solidFill>
-          <a:ln>
-            <a:noFill/>
-          </a:ln>
-        </p:spPr>
-        <p:style>
-          <a:lnRef idx="1">
-            <a:schemeClr val="accent1"/>
-          </a:lnRef>
-          <a:fillRef idx="3">
-            <a:schemeClr val="accent1"/>
-          </a:fillRef>
-          <a:effectRef idx="2">
-            <a:schemeClr val="accent1"/>
-          </a:effectRef>
-          <a:fontRef idx="minor">
-            <a:schemeClr val="lt1"/>
-          </a:fontRef>
-        </p:style>
-        <p:txBody>
-          <a:bodyPr rtlCol="0" anchor="ctr" lIns="36576" rIns="36576"/>
-          <a:lstStyle/>
-          <a:p>
-            <a:pPr algn="ctr"/>
-            <a:r>
-              <a:rPr sz="800" b="1" i="0">
-                <a:solidFill>
-                  <a:srgbClr val="FFFFFF"/>
-                </a:solidFill>
-                <a:latin typeface="Calibri"/>
-              </a:rPr>
-              <a:t>Pub/Sub</a:t>
-            </a:r>
-          </a:p>
-        </p:txBody>
-      </p:sp>
-      <p:sp>
-        <p:nvSpPr>
-          <p:cNvPr id="28" name="TextBox 27"/>
-          <p:cNvSpPr txBox="1"/>
-          <p:nvPr/>
-        </p:nvSpPr>
-        <p:spPr>
-          <a:xfrm>
-            <a:off x="3017520" y="4581144"/>
-            <a:ext cx="1371600" cy="292608"/>
-          </a:xfrm>
-          <a:prstGeom prst="rect">
-            <a:avLst/>
-          </a:prstGeom>
-          <a:noFill/>
-        </p:spPr>
-        <p:txBody>
-          <a:bodyPr wrap="none">
-            <a:spAutoFit/>
-          </a:bodyPr>
-          <a:lstStyle/>
-          <a:p>
-            <a:pPr algn="ctr"/>
-            <a:r>
-              <a:rPr sz="800" b="0" i="0">
-                <a:solidFill>
-                  <a:srgbClr val="333F52"/>
-                </a:solidFill>
-                <a:latin typeface="Calibri"/>
-              </a:rPr>
-              <a:t>rpc-predictions-staging</a:t>
-            </a:r>
-          </a:p>
-        </p:txBody>
-      </p:sp>
-      <p:sp>
-        <p:nvSpPr>
-          <p:cNvPr id="29" name="Hexagon 28"/>
-          <p:cNvSpPr/>
-          <p:nvPr/>
-        </p:nvSpPr>
-        <p:spPr>
-          <a:xfrm>
-            <a:off x="4937760" y="4572000"/>
-            <a:ext cx="1371600" cy="411480"/>
-          </a:xfrm>
-          <a:prstGeom prst="hexagon">
-            <a:avLst/>
-          </a:prstGeom>
-          <a:solidFill>
-            <a:srgbClr val="A96BDB"/>
-          </a:solidFill>
-          <a:ln>
-            <a:noFill/>
-          </a:ln>
-        </p:spPr>
-        <p:style>
-          <a:lnRef idx="1">
-            <a:schemeClr val="accent1"/>
-          </a:lnRef>
-          <a:fillRef idx="3">
-            <a:schemeClr val="accent1"/>
-          </a:fillRef>
-          <a:effectRef idx="2">
-            <a:schemeClr val="accent1"/>
-          </a:effectRef>
-          <a:fontRef idx="minor">
-            <a:schemeClr val="lt1"/>
-          </a:fontRef>
-        </p:style>
-        <p:txBody>
-          <a:bodyPr rtlCol="0" anchor="ctr" lIns="36576" rIns="36576"/>
-          <a:lstStyle/>
-          <a:p>
-            <a:pPr algn="ctr"/>
-            <a:r>
-              <a:rPr sz="800" b="1" i="0">
-                <a:solidFill>
-                  <a:srgbClr val="FFFFFF"/>
-                </a:solidFill>
-                <a:latin typeface="Calibri"/>
-              </a:rPr>
-              <a:t>Pub/Sub</a:t>
-            </a:r>
-          </a:p>
-        </p:txBody>
-      </p:sp>
-      <p:sp>
-        <p:nvSpPr>
-          <p:cNvPr id="30" name="TextBox 29"/>
-          <p:cNvSpPr txBox="1"/>
-          <p:nvPr/>
-        </p:nvSpPr>
-        <p:spPr>
-          <a:xfrm>
-            <a:off x="4937760" y="4992624"/>
-            <a:ext cx="1371600" cy="292608"/>
-          </a:xfrm>
-          <a:prstGeom prst="rect">
-            <a:avLst/>
-          </a:prstGeom>
-          <a:noFill/>
-        </p:spPr>
-        <p:txBody>
-          <a:bodyPr wrap="none">
-            <a:spAutoFit/>
-          </a:bodyPr>
-          <a:lstStyle/>
-          <a:p>
-            <a:pPr algn="ctr"/>
-            <a:r>
-              <a:rPr sz="800" b="0" i="0">
-                <a:solidFill>
-                  <a:srgbClr val="333F52"/>
-                </a:solidFill>
-                <a:latin typeface="Calibri"/>
-              </a:rPr>
-              <a:t>rpc-anomaly-staging</a:t>
-            </a:r>
-          </a:p>
-        </p:txBody>
-      </p:sp>
-      <p:sp>
-        <p:nvSpPr>
-          <p:cNvPr id="31" name="Rounded Rectangle 30"/>
-          <p:cNvSpPr/>
-          <p:nvPr/>
-        </p:nvSpPr>
-        <p:spPr>
-          <a:xfrm>
-            <a:off x="4572000" y="5074920"/>
-            <a:ext cx="2286000" cy="777240"/>
-          </a:xfrm>
-          <a:prstGeom prst="roundRect">
-            <a:avLst>
-              <a:gd name="adj" fmla="val 12000"/>
-            </a:avLst>
-          </a:prstGeom>
-          <a:solidFill>
-            <a:srgbClr val="4E88E6"/>
-          </a:solidFill>
-          <a:ln>
-            <a:noFill/>
-          </a:ln>
-        </p:spPr>
-        <p:style>
-          <a:lnRef idx="1">
-            <a:schemeClr val="accent1"/>
-          </a:lnRef>
-          <a:fillRef idx="3">
-            <a:schemeClr val="accent1"/>
-          </a:fillRef>
-          <a:effectRef idx="2">
-            <a:schemeClr val="accent1"/>
-          </a:effectRef>
-          <a:fontRef idx="minor">
-            <a:schemeClr val="lt1"/>
-          </a:fontRef>
-        </p:style>
-        <p:txBody>
-          <a:bodyPr rtlCol="0" anchor="ctr" tIns="54864" bIns="54864" wrap="square"/>
-          <a:lstStyle/>
-          <a:p>
-            <a:pPr algn="ctr"/>
-            <a:r>
-              <a:rPr sz="1200" b="1" i="0">
-                <a:solidFill>
-                  <a:srgbClr val="FFFFFF"/>
-                </a:solidFill>
-                <a:latin typeface="Calibri"/>
-              </a:rPr>
-              <a:t>Breaker Automation</a:t>
-            </a:r>
-          </a:p>
-          <a:p>
-            <a:pPr algn="ctr"/>
-            <a:r>
-              <a:rPr sz="900" b="0" i="0">
-                <a:solidFill>
-                  <a:srgbClr val="FFFFFF"/>
-                </a:solidFill>
-                <a:latin typeface="Calibri"/>
-              </a:rPr>
-              <a:t>Python  ·  Cloud Run / Functions</a:t>
-            </a:r>
-          </a:p>
-        </p:txBody>
-      </p:sp>
-      <p:sp>
-        <p:nvSpPr>
-          <p:cNvPr id="32" name="Rounded Rectangle 31"/>
-          <p:cNvSpPr/>
-          <p:nvPr/>
-        </p:nvSpPr>
-        <p:spPr>
-          <a:xfrm>
-            <a:off x="8732520" y="5074920"/>
-            <a:ext cx="2468880" cy="777240"/>
-          </a:xfrm>
-          <a:prstGeom prst="roundRect">
-            <a:avLst>
-              <a:gd name="adj" fmla="val 12000"/>
-            </a:avLst>
-          </a:prstGeom>
-          <a:solidFill>
-            <a:srgbClr val="4E88E6"/>
-          </a:solidFill>
-          <a:ln>
-            <a:noFill/>
-          </a:ln>
-        </p:spPr>
-        <p:style>
-          <a:lnRef idx="1">
-            <a:schemeClr val="accent1"/>
-          </a:lnRef>
-          <a:fillRef idx="3">
-            <a:schemeClr val="accent1"/>
-          </a:fillRef>
-          <a:effectRef idx="2">
-            <a:schemeClr val="accent1"/>
-          </a:effectRef>
-          <a:fontRef idx="minor">
-            <a:schemeClr val="lt1"/>
-          </a:fontRef>
-        </p:style>
-        <p:txBody>
-          <a:bodyPr rtlCol="0" anchor="ctr" tIns="54864" bIns="54864" wrap="square"/>
-          <a:lstStyle/>
-          <a:p>
-            <a:pPr algn="ctr"/>
-            <a:r>
-              <a:rPr sz="1200" b="1" i="0">
-                <a:solidFill>
-                  <a:srgbClr val="FFFFFF"/>
-                </a:solidFill>
-                <a:latin typeface="Calibri"/>
-              </a:rPr>
-              <a:t>Activation Service</a:t>
-            </a:r>
-          </a:p>
-          <a:p>
-            <a:pPr algn="ctr"/>
-            <a:r>
-              <a:rPr sz="900" b="0" i="0">
-                <a:solidFill>
-                  <a:srgbClr val="FFFFFF"/>
-                </a:solidFill>
-                <a:latin typeface="Calibri"/>
-              </a:rPr>
-              <a:t>Python 3.12  ·  Cloud Run</a:t>
-            </a:r>
-          </a:p>
-        </p:txBody>
-      </p:sp>
-      <p:sp>
-        <p:nvSpPr>
-          <p:cNvPr id="33" name="TextBox 32"/>
-          <p:cNvSpPr txBox="1"/>
-          <p:nvPr/>
-        </p:nvSpPr>
-        <p:spPr>
-          <a:xfrm>
-            <a:off x="11521440" y="5074920"/>
-            <a:ext cx="640080" cy="228600"/>
-          </a:xfrm>
-          <a:prstGeom prst="rect">
-            <a:avLst/>
-          </a:prstGeom>
-          <a:noFill/>
-        </p:spPr>
-        <p:txBody>
-          <a:bodyPr wrap="none">
-            <a:spAutoFit/>
-          </a:bodyPr>
-          <a:lstStyle/>
-          <a:p>
-            <a:r>
-              <a:rPr sz="900" b="1" i="0">
-                <a:solidFill>
-                  <a:srgbClr val="333F52"/>
-                </a:solidFill>
-                <a:latin typeface="Calibri"/>
-              </a:rPr>
-              <a:t>→ SA360</a:t>
-            </a:r>
-          </a:p>
-        </p:txBody>
-      </p:sp>
-      <p:sp>
-        <p:nvSpPr>
-          <p:cNvPr id="34" name="TextBox 33"/>
-          <p:cNvSpPr txBox="1"/>
-          <p:nvPr/>
-        </p:nvSpPr>
-        <p:spPr>
-          <a:xfrm>
-            <a:off x="11521440" y="5330952"/>
-            <a:ext cx="640080" cy="228600"/>
-          </a:xfrm>
-          <a:prstGeom prst="rect">
-            <a:avLst/>
-          </a:prstGeom>
-          <a:noFill/>
-        </p:spPr>
-        <p:txBody>
-          <a:bodyPr wrap="none">
-            <a:spAutoFit/>
-          </a:bodyPr>
-          <a:lstStyle/>
-          <a:p>
-            <a:r>
-              <a:rPr sz="900" b="1" i="0">
-                <a:solidFill>
-                  <a:srgbClr val="333F52"/>
-                </a:solidFill>
-                <a:latin typeface="Calibri"/>
-              </a:rPr>
-              <a:t>→ SSGTM</a:t>
-            </a:r>
-          </a:p>
-        </p:txBody>
-      </p:sp>
-      <p:sp>
-        <p:nvSpPr>
-          <p:cNvPr id="35" name="TextBox 34"/>
-          <p:cNvSpPr txBox="1"/>
-          <p:nvPr/>
-        </p:nvSpPr>
-        <p:spPr>
-          <a:xfrm>
-            <a:off x="11521440" y="5586984"/>
-            <a:ext cx="640080" cy="228600"/>
-          </a:xfrm>
-          <a:prstGeom prst="rect">
-            <a:avLst/>
-          </a:prstGeom>
-          <a:noFill/>
-        </p:spPr>
-        <p:txBody>
-          <a:bodyPr wrap="none">
-            <a:spAutoFit/>
-          </a:bodyPr>
-          <a:lstStyle/>
-          <a:p>
-            <a:r>
-              <a:rPr sz="900" b="1" i="0">
-                <a:solidFill>
-                  <a:srgbClr val="333F52"/>
-                </a:solidFill>
-                <a:latin typeface="Calibri"/>
-              </a:rPr>
-              <a:t>→ OCI</a:t>
-            </a:r>
-          </a:p>
-        </p:txBody>
-      </p:sp>
-      <p:sp>
-        <p:nvSpPr>
-          <p:cNvPr id="36" name="Rounded Rectangle 35"/>
-          <p:cNvSpPr/>
-          <p:nvPr/>
-        </p:nvSpPr>
-        <p:spPr>
-          <a:xfrm>
-            <a:off x="4892040" y="5989320"/>
-            <a:ext cx="1280160" cy="274320"/>
-          </a:xfrm>
-          <a:prstGeom prst="roundRect">
-            <a:avLst>
-              <a:gd name="adj" fmla="val 30000"/>
-            </a:avLst>
-          </a:prstGeom>
-          <a:solidFill>
-            <a:srgbClr val="FFFFFF"/>
-          </a:solidFill>
-          <a:ln w="6350">
-            <a:solidFill>
-              <a:srgbClr val="D7DBE3"/>
-            </a:solidFill>
-          </a:ln>
-        </p:spPr>
-        <p:style>
-          <a:lnRef idx="1">
-            <a:schemeClr val="accent1"/>
-          </a:lnRef>
-          <a:fillRef idx="3">
-            <a:schemeClr val="accent1"/>
-          </a:fillRef>
-          <a:effectRef idx="2">
-            <a:schemeClr val="accent1"/>
-          </a:effectRef>
-          <a:fontRef idx="minor">
-            <a:schemeClr val="lt1"/>
-          </a:fontRef>
-        </p:style>
-        <p:txBody>
-          <a:bodyPr rtlCol="0" anchor="ctr" lIns="36576" rIns="36576"/>
-          <a:lstStyle/>
-          <a:p>
-            <a:pPr algn="ctr"/>
-            <a:r>
-              <a:rPr sz="800" b="1" i="0">
-                <a:solidFill>
-                  <a:srgbClr val="333F52"/>
-                </a:solidFill>
-                <a:latin typeface="Calibri"/>
-              </a:rPr>
-              <a:t>GitHub</a:t>
             </a:r>
           </a:p>
         </p:txBody>
       </p:sp>
       <p:cxnSp>
         <p:nvCxnSpPr>
-          <p:cNvPr id="37" name="Connector 36"/>
+          <p:cNvPr id="34" name="Connector 33"/>
           <p:cNvCxnSpPr/>
           <p:nvPr/>
         </p:nvCxnSpPr>
         <p:spPr>
           <a:xfrm>
-            <a:off x="6172200" y="6126480"/>
-            <a:ext cx="45720" cy="0"/>
+            <a:off x="3429000.0" y="3634740.0"/>
+            <a:ext cx="1508760.0" cy="0.0"/>
           </a:xfrm>
           <a:prstGeom prst="line">
             <a:avLst/>
           </a:prstGeom>
-          <a:ln w="9525">
+          <a:ln w="15875">
             <a:solidFill>
-              <a:srgbClr val="6B7380"/>
+              <a:srgbClr val="46556B"/>
             </a:solidFill>
-            <a:tailEnd type="triangle" w="sm" h="sm"/>
+            <a:tailEnd type="triangle" w="med" h="med"/>
           </a:ln>
         </p:spPr>
         <p:style>
@@ -11479,79 +11132,58 @@
       </p:cxnSp>
       <p:sp>
         <p:nvSpPr>
-          <p:cNvPr id="38" name="Rounded Rectangle 37"/>
-          <p:cNvSpPr/>
-          <p:nvPr/>
-        </p:nvSpPr>
-        <p:spPr>
-          <a:xfrm>
-            <a:off x="6217920" y="5989320"/>
-            <a:ext cx="1280160" cy="274320"/>
-          </a:xfrm>
-          <a:prstGeom prst="roundRect">
-            <a:avLst>
-              <a:gd name="adj" fmla="val 30000"/>
-            </a:avLst>
-          </a:prstGeom>
-          <a:solidFill>
-            <a:srgbClr val="FFFFFF"/>
-          </a:solidFill>
-          <a:ln w="6350">
-            <a:solidFill>
-              <a:srgbClr val="D7DBE3"/>
-            </a:solidFill>
-          </a:ln>
-        </p:spPr>
-        <p:style>
-          <a:lnRef idx="1">
-            <a:schemeClr val="accent1"/>
-          </a:lnRef>
-          <a:fillRef idx="3">
-            <a:schemeClr val="accent1"/>
-          </a:fillRef>
-          <a:effectRef idx="2">
-            <a:schemeClr val="accent1"/>
-          </a:effectRef>
-          <a:fontRef idx="minor">
-            <a:schemeClr val="lt1"/>
-          </a:fontRef>
-        </p:style>
-        <p:txBody>
-          <a:bodyPr rtlCol="0" anchor="ctr" lIns="36576" rIns="36576"/>
+          <p:cNvPr id="35" name="TextBox 34"/>
+          <p:cNvSpPr txBox="1"/>
+          <p:nvPr/>
+        </p:nvSpPr>
+        <p:spPr>
+          <a:xfrm>
+            <a:off x="3429000" y="3255264"/>
+            <a:ext cx="1508760" cy="164592"/>
+          </a:xfrm>
+          <a:prstGeom prst="rect">
+            <a:avLst/>
+          </a:prstGeom>
+          <a:noFill/>
+        </p:spPr>
+        <p:txBody>
+          <a:bodyPr wrap="square" lIns="18288" rIns="18288" tIns="0" bIns="0">
+            <a:spAutoFit/>
+          </a:bodyPr>
           <a:lstStyle/>
           <a:p>
             <a:pPr algn="ctr"/>
             <a:r>
-              <a:rPr sz="800" b="1" i="0">
-                <a:solidFill>
-                  <a:srgbClr val="333F52"/>
-                </a:solidFill>
-                <a:latin typeface="Calibri"/>
-              </a:rPr>
-              <a:t>WIF</a:t>
+              <a:rPr sz="700" b="0" i="1">
+                <a:solidFill>
+                  <a:srgbClr val="6B7380"/>
+                </a:solidFill>
+                <a:latin typeface="Calibri"/>
+              </a:rPr>
+              <a:t>BigQuery sub</a:t>
             </a:r>
           </a:p>
         </p:txBody>
       </p:sp>
       <p:cxnSp>
         <p:nvCxnSpPr>
-          <p:cNvPr id="39" name="Connector 38"/>
+          <p:cNvPr id="36" name="Connector 35"/>
           <p:cNvCxnSpPr/>
           <p:nvPr/>
         </p:nvCxnSpPr>
         <p:spPr>
           <a:xfrm>
-            <a:off x="7498080" y="6126480"/>
-            <a:ext cx="45720" cy="0"/>
+            <a:off x="7315200" y="3726180.0"/>
+            <a:ext cx="914400" cy="0.0"/>
           </a:xfrm>
           <a:prstGeom prst="line">
             <a:avLst/>
           </a:prstGeom>
-          <a:ln w="9525">
+          <a:ln w="15875">
             <a:solidFill>
-              <a:srgbClr val="6B7380"/>
+              <a:srgbClr val="46556B"/>
             </a:solidFill>
-            <a:tailEnd type="triangle" w="sm" h="sm"/>
+            <a:tailEnd type="triangle" w="med" h="med"/>
           </a:ln>
         </p:spPr>
         <p:style>
@@ -11571,79 +11203,58 @@
       </p:cxnSp>
       <p:sp>
         <p:nvSpPr>
-          <p:cNvPr id="40" name="Rounded Rectangle 39"/>
-          <p:cNvSpPr/>
-          <p:nvPr/>
-        </p:nvSpPr>
-        <p:spPr>
-          <a:xfrm>
-            <a:off x="7543800" y="5989320"/>
-            <a:ext cx="1280160" cy="274320"/>
-          </a:xfrm>
-          <a:prstGeom prst="roundRect">
-            <a:avLst>
-              <a:gd name="adj" fmla="val 30000"/>
-            </a:avLst>
-          </a:prstGeom>
-          <a:solidFill>
-            <a:srgbClr val="FFFFFF"/>
-          </a:solidFill>
-          <a:ln w="6350">
-            <a:solidFill>
-              <a:srgbClr val="D7DBE3"/>
-            </a:solidFill>
-          </a:ln>
-        </p:spPr>
-        <p:style>
-          <a:lnRef idx="1">
-            <a:schemeClr val="accent1"/>
-          </a:lnRef>
-          <a:fillRef idx="3">
-            <a:schemeClr val="accent1"/>
-          </a:fillRef>
-          <a:effectRef idx="2">
-            <a:schemeClr val="accent1"/>
-          </a:effectRef>
-          <a:fontRef idx="minor">
-            <a:schemeClr val="lt1"/>
-          </a:fontRef>
-        </p:style>
-        <p:txBody>
-          <a:bodyPr rtlCol="0" anchor="ctr" lIns="36576" rIns="36576"/>
+          <p:cNvPr id="37" name="TextBox 36"/>
+          <p:cNvSpPr txBox="1"/>
+          <p:nvPr/>
+        </p:nvSpPr>
+        <p:spPr>
+          <a:xfrm>
+            <a:off x="7315200" y="3525012"/>
+            <a:ext cx="914400" cy="182880"/>
+          </a:xfrm>
+          <a:prstGeom prst="rect">
+            <a:avLst/>
+          </a:prstGeom>
+          <a:noFill/>
+        </p:spPr>
+        <p:txBody>
+          <a:bodyPr wrap="square" lIns="18288" rIns="18288" tIns="0" bIns="0">
+            <a:spAutoFit/>
+          </a:bodyPr>
           <a:lstStyle/>
           <a:p>
             <a:pPr algn="ctr"/>
             <a:r>
-              <a:rPr sz="800" b="1" i="0">
-                <a:solidFill>
-                  <a:srgbClr val="333F52"/>
-                </a:solidFill>
-                <a:latin typeface="Calibri"/>
-              </a:rPr>
-              <a:t>Cloud Build</a:t>
+              <a:rPr sz="700" b="0" i="1">
+                <a:solidFill>
+                  <a:srgbClr val="6B7380"/>
+                </a:solidFill>
+                <a:latin typeface="Calibri"/>
+              </a:rPr>
+              <a:t>training data</a:t>
             </a:r>
           </a:p>
         </p:txBody>
       </p:sp>
       <p:cxnSp>
         <p:nvCxnSpPr>
-          <p:cNvPr id="41" name="Connector 40"/>
+          <p:cNvPr id="38" name="Connector 37"/>
           <p:cNvCxnSpPr/>
           <p:nvPr/>
         </p:nvCxnSpPr>
         <p:spPr>
           <a:xfrm>
-            <a:off x="8823960" y="6126480"/>
-            <a:ext cx="45720" cy="0"/>
+            <a:off x="10424160" y="3726180.0"/>
+            <a:ext cx="274320" cy="0.0"/>
           </a:xfrm>
           <a:prstGeom prst="line">
             <a:avLst/>
           </a:prstGeom>
-          <a:ln w="9525">
+          <a:ln w="15875">
             <a:solidFill>
-              <a:srgbClr val="6B7380"/>
+              <a:srgbClr val="46556B"/>
             </a:solidFill>
-            <a:tailEnd type="triangle" w="sm" h="sm"/>
+            <a:tailEnd type="triangle" w="med" h="med"/>
           </a:ln>
         </p:spPr>
         <p:style>
@@ -11663,79 +11274,58 @@
       </p:cxnSp>
       <p:sp>
         <p:nvSpPr>
-          <p:cNvPr id="42" name="Rounded Rectangle 41"/>
-          <p:cNvSpPr/>
-          <p:nvPr/>
-        </p:nvSpPr>
-        <p:spPr>
-          <a:xfrm>
-            <a:off x="8869680" y="5989320"/>
-            <a:ext cx="1280160" cy="274320"/>
-          </a:xfrm>
-          <a:prstGeom prst="roundRect">
-            <a:avLst>
-              <a:gd name="adj" fmla="val 30000"/>
-            </a:avLst>
-          </a:prstGeom>
-          <a:solidFill>
-            <a:srgbClr val="FFFFFF"/>
-          </a:solidFill>
-          <a:ln w="6350">
-            <a:solidFill>
-              <a:srgbClr val="D7DBE3"/>
-            </a:solidFill>
-          </a:ln>
-        </p:spPr>
-        <p:style>
-          <a:lnRef idx="1">
-            <a:schemeClr val="accent1"/>
-          </a:lnRef>
-          <a:fillRef idx="3">
-            <a:schemeClr val="accent1"/>
-          </a:fillRef>
-          <a:effectRef idx="2">
-            <a:schemeClr val="accent1"/>
-          </a:effectRef>
-          <a:fontRef idx="minor">
-            <a:schemeClr val="lt1"/>
-          </a:fontRef>
-        </p:style>
-        <p:txBody>
-          <a:bodyPr rtlCol="0" anchor="ctr" lIns="36576" rIns="36576"/>
+          <p:cNvPr id="39" name="TextBox 38"/>
+          <p:cNvSpPr txBox="1"/>
+          <p:nvPr/>
+        </p:nvSpPr>
+        <p:spPr>
+          <a:xfrm>
+            <a:off x="10424160" y="3525012"/>
+            <a:ext cx="274320" cy="164592"/>
+          </a:xfrm>
+          <a:prstGeom prst="rect">
+            <a:avLst/>
+          </a:prstGeom>
+          <a:noFill/>
+        </p:spPr>
+        <p:txBody>
+          <a:bodyPr wrap="square" lIns="18288" rIns="18288" tIns="0" bIns="0">
+            <a:spAutoFit/>
+          </a:bodyPr>
           <a:lstStyle/>
           <a:p>
             <a:pPr algn="ctr"/>
             <a:r>
-              <a:rPr sz="800" b="1" i="0">
-                <a:solidFill>
-                  <a:srgbClr val="333F52"/>
-                </a:solidFill>
-                <a:latin typeface="Calibri"/>
-              </a:rPr>
-              <a:t>Artifact Registry</a:t>
+              <a:rPr sz="700" b="0" i="1">
+                <a:solidFill>
+                  <a:srgbClr val="6B7380"/>
+                </a:solidFill>
+                <a:latin typeface="Calibri"/>
+              </a:rPr>
+              <a:t>artifacts</a:t>
             </a:r>
           </a:p>
         </p:txBody>
       </p:sp>
       <p:cxnSp>
         <p:nvCxnSpPr>
-          <p:cNvPr id="43" name="Connector 42"/>
+          <p:cNvPr id="40" name="Connector 39"/>
           <p:cNvCxnSpPr/>
           <p:nvPr/>
         </p:nvCxnSpPr>
         <p:spPr>
           <a:xfrm>
-            <a:off x="10149840" y="6126480"/>
-            <a:ext cx="45720" cy="0"/>
+            <a:off x="2834640.0" y="2651760"/>
+            <a:ext cx="0.0" cy="731520"/>
           </a:xfrm>
           <a:prstGeom prst="line">
             <a:avLst/>
           </a:prstGeom>
-          <a:ln w="9525">
+          <a:ln w="15875">
             <a:solidFill>
-              <a:srgbClr val="6B7380"/>
+              <a:srgbClr val="46556B"/>
             </a:solidFill>
-            <a:tailEnd type="triangle" w="sm" h="sm"/>
+            <a:tailEnd type="triangle" w="med" h="med"/>
           </a:ln>
         </p:spPr>
         <p:style>
@@ -11755,140 +11345,14 @@
       </p:cxnSp>
       <p:sp>
         <p:nvSpPr>
-          <p:cNvPr id="44" name="Rounded Rectangle 43"/>
-          <p:cNvSpPr/>
-          <p:nvPr/>
-        </p:nvSpPr>
-        <p:spPr>
-          <a:xfrm>
-            <a:off x="10195560" y="5989320"/>
-            <a:ext cx="1280160" cy="274320"/>
-          </a:xfrm>
-          <a:prstGeom prst="roundRect">
-            <a:avLst>
-              <a:gd name="adj" fmla="val 30000"/>
-            </a:avLst>
-          </a:prstGeom>
-          <a:solidFill>
-            <a:srgbClr val="FFFFFF"/>
-          </a:solidFill>
-          <a:ln w="6350">
-            <a:solidFill>
-              <a:srgbClr val="D7DBE3"/>
-            </a:solidFill>
-          </a:ln>
-        </p:spPr>
-        <p:style>
-          <a:lnRef idx="1">
-            <a:schemeClr val="accent1"/>
-          </a:lnRef>
-          <a:fillRef idx="3">
-            <a:schemeClr val="accent1"/>
-          </a:fillRef>
-          <a:effectRef idx="2">
-            <a:schemeClr val="accent1"/>
-          </a:effectRef>
-          <a:fontRef idx="minor">
-            <a:schemeClr val="lt1"/>
-          </a:fontRef>
-        </p:style>
-        <p:txBody>
-          <a:bodyPr rtlCol="0" anchor="ctr" lIns="36576" rIns="36576"/>
-          <a:lstStyle/>
-          <a:p>
-            <a:pPr algn="ctr"/>
-            <a:r>
-              <a:rPr sz="800" b="1" i="0">
-                <a:solidFill>
-                  <a:srgbClr val="333F52"/>
-                </a:solidFill>
-                <a:latin typeface="Calibri"/>
-              </a:rPr>
-              <a:t>Cloud Run</a:t>
-            </a:r>
-          </a:p>
-        </p:txBody>
-      </p:sp>
-      <p:sp>
-        <p:nvSpPr>
-          <p:cNvPr id="45" name="TextBox 44"/>
+          <p:cNvPr id="41" name="TextBox 40"/>
           <p:cNvSpPr txBox="1"/>
           <p:nvPr/>
         </p:nvSpPr>
         <p:spPr>
           <a:xfrm>
-            <a:off x="4892040" y="5760720"/>
-            <a:ext cx="1828800" cy="201168"/>
-          </a:xfrm>
-          <a:prstGeom prst="rect">
-            <a:avLst/>
-          </a:prstGeom>
-          <a:noFill/>
-        </p:spPr>
-        <p:txBody>
-          <a:bodyPr wrap="none">
-            <a:spAutoFit/>
-          </a:bodyPr>
-          <a:lstStyle/>
-          <a:p>
-            <a:r>
-              <a:rPr sz="800" b="1" i="1">
-                <a:solidFill>
-                  <a:srgbClr val="6B7380"/>
-                </a:solidFill>
-                <a:latin typeface="Calibri"/>
-              </a:rPr>
-              <a:t>Continuous delivery</a:t>
-            </a:r>
-          </a:p>
-        </p:txBody>
-      </p:sp>
-      <p:cxnSp>
-        <p:nvCxnSpPr>
-          <p:cNvPr id="46" name="Connector 45"/>
-          <p:cNvCxnSpPr/>
-          <p:nvPr/>
-        </p:nvCxnSpPr>
-        <p:spPr>
-          <a:xfrm>
-            <a:off x="685800" y="1993392"/>
-            <a:ext cx="685800" cy="0"/>
-          </a:xfrm>
-          <a:prstGeom prst="line">
-            <a:avLst/>
-          </a:prstGeom>
-          <a:ln w="19050">
-            <a:solidFill>
-              <a:srgbClr val="5F6B7C"/>
-            </a:solidFill>
-            <a:tailEnd type="triangle" w="sm" h="sm"/>
-          </a:ln>
-        </p:spPr>
-        <p:style>
-          <a:lnRef idx="2">
-            <a:schemeClr val="accent1"/>
-          </a:lnRef>
-          <a:fillRef idx="0">
-            <a:schemeClr val="accent1"/>
-          </a:fillRef>
-          <a:effectRef idx="1">
-            <a:schemeClr val="accent1"/>
-          </a:effectRef>
-          <a:fontRef idx="minor">
-            <a:schemeClr val="tx1"/>
-          </a:fontRef>
-        </p:style>
-      </p:cxnSp>
-      <p:sp>
-        <p:nvSpPr>
-          <p:cNvPr id="47" name="TextBox 46"/>
-          <p:cNvSpPr txBox="1"/>
-          <p:nvPr/>
-        </p:nvSpPr>
-        <p:spPr>
-          <a:xfrm>
-            <a:off x="502920" y="1691640"/>
-            <a:ext cx="960120" cy="274320"/>
+            <a:off x="2331720" y="2670048"/>
+            <a:ext cx="1005840" cy="164592"/>
           </a:xfrm>
           <a:prstGeom prst="rect">
             <a:avLst/>
@@ -11903,178 +11367,35 @@
           <a:p>
             <a:pPr algn="ctr"/>
             <a:r>
-              <a:rPr sz="800" b="0" i="1">
+              <a:rPr sz="700" b="0" i="1">
                 <a:solidFill>
                   <a:srgbClr val="6B7380"/>
                 </a:solidFill>
                 <a:latin typeface="Calibri"/>
               </a:rPr>
-              <a:t>HTTPS click</a:t>
+              <a:t>emit prediction</a:t>
             </a:r>
           </a:p>
         </p:txBody>
       </p:sp>
       <p:cxnSp>
         <p:nvCxnSpPr>
-          <p:cNvPr id="48" name="Connector 47"/>
+          <p:cNvPr id="42" name="Connector 41"/>
           <p:cNvCxnSpPr/>
           <p:nvPr/>
         </p:nvCxnSpPr>
         <p:spPr>
-          <a:xfrm>
-            <a:off x="4114800" y="1691640"/>
-            <a:ext cx="457200" cy="0"/>
+          <a:xfrm flipV="1">
+            <a:off x="9326880.0" y="2857500.0"/>
+            <a:ext cx="0.0" cy="480060.0"/>
           </a:xfrm>
           <a:prstGeom prst="line">
             <a:avLst/>
           </a:prstGeom>
-          <a:ln w="19050">
+          <a:ln w="12700">
             <a:solidFill>
-              <a:srgbClr val="5F6B7C"/>
+              <a:srgbClr val="34A853"/>
             </a:solidFill>
-            <a:tailEnd type="triangle" w="sm" h="sm"/>
-          </a:ln>
-        </p:spPr>
-        <p:style>
-          <a:lnRef idx="2">
-            <a:schemeClr val="accent1"/>
-          </a:lnRef>
-          <a:fillRef idx="0">
-            <a:schemeClr val="accent1"/>
-          </a:fillRef>
-          <a:effectRef idx="1">
-            <a:schemeClr val="accent1"/>
-          </a:effectRef>
-          <a:fontRef idx="minor">
-            <a:schemeClr val="tx1"/>
-          </a:fontRef>
-        </p:style>
-      </p:cxnSp>
-      <p:sp>
-        <p:nvSpPr>
-          <p:cNvPr id="49" name="TextBox 48"/>
-          <p:cNvSpPr txBox="1"/>
-          <p:nvPr/>
-        </p:nvSpPr>
-        <p:spPr>
-          <a:xfrm>
-            <a:off x="4114800" y="1481328"/>
-            <a:ext cx="457200" cy="201168"/>
-          </a:xfrm>
-          <a:prstGeom prst="rect">
-            <a:avLst/>
-          </a:prstGeom>
-          <a:noFill/>
-        </p:spPr>
-        <p:txBody>
-          <a:bodyPr wrap="square" lIns="18288" rIns="18288" tIns="0" bIns="0">
-            <a:spAutoFit/>
-          </a:bodyPr>
-          <a:lstStyle/>
-          <a:p>
-            <a:pPr algn="ctr"/>
-            <a:r>
-              <a:rPr sz="700" b="0" i="1">
-                <a:solidFill>
-                  <a:srgbClr val="6B7380"/>
-                </a:solidFill>
-                <a:latin typeface="Calibri"/>
-              </a:rPr>
-              <a:t>predict</a:t>
-            </a:r>
-          </a:p>
-        </p:txBody>
-      </p:sp>
-      <p:cxnSp>
-        <p:nvCxnSpPr>
-          <p:cNvPr id="50" name="Connector 49"/>
-          <p:cNvCxnSpPr/>
-          <p:nvPr/>
-        </p:nvCxnSpPr>
-        <p:spPr>
-          <a:xfrm flipH="1">
-            <a:off x="4114800" y="2057400"/>
-            <a:ext cx="457200" cy="0"/>
-          </a:xfrm>
-          <a:prstGeom prst="line">
-            <a:avLst/>
-          </a:prstGeom>
-          <a:ln w="19050">
-            <a:solidFill>
-              <a:srgbClr val="E87B1E"/>
-            </a:solidFill>
-            <a:tailEnd type="triangle" w="sm" h="sm"/>
-          </a:ln>
-        </p:spPr>
-        <p:style>
-          <a:lnRef idx="2">
-            <a:schemeClr val="accent1"/>
-          </a:lnRef>
-          <a:fillRef idx="0">
-            <a:schemeClr val="accent1"/>
-          </a:fillRef>
-          <a:effectRef idx="1">
-            <a:schemeClr val="accent1"/>
-          </a:effectRef>
-          <a:fontRef idx="minor">
-            <a:schemeClr val="tx1"/>
-          </a:fontRef>
-        </p:style>
-      </p:cxnSp>
-      <p:sp>
-        <p:nvSpPr>
-          <p:cNvPr id="51" name="TextBox 50"/>
-          <p:cNvSpPr txBox="1"/>
-          <p:nvPr/>
-        </p:nvSpPr>
-        <p:spPr>
-          <a:xfrm>
-            <a:off x="4114800" y="2084831"/>
-            <a:ext cx="457200" cy="201168"/>
-          </a:xfrm>
-          <a:prstGeom prst="rect">
-            <a:avLst/>
-          </a:prstGeom>
-          <a:noFill/>
-        </p:spPr>
-        <p:txBody>
-          <a:bodyPr wrap="square" lIns="18288" rIns="18288" tIns="0" bIns="0">
-            <a:spAutoFit/>
-          </a:bodyPr>
-          <a:lstStyle/>
-          <a:p>
-            <a:pPr algn="ctr"/>
-            <a:r>
-              <a:rPr sz="700" b="0" i="1">
-                <a:solidFill>
-                  <a:srgbClr val="E87B1E"/>
-                </a:solidFill>
-                <a:latin typeface="Calibri"/>
-              </a:rPr>
-              <a:t>rpc</a:t>
-            </a:r>
-          </a:p>
-        </p:txBody>
-      </p:sp>
-      <p:cxnSp>
-        <p:nvCxnSpPr>
-          <p:cNvPr id="52" name="Connector 51"/>
-          <p:cNvCxnSpPr/>
-          <p:nvPr/>
-        </p:nvCxnSpPr>
-        <p:spPr>
-          <a:xfrm>
-            <a:off x="3200400" y="2926080"/>
-            <a:ext cx="502920" cy="1234440"/>
-          </a:xfrm>
-          <a:prstGeom prst="line">
-            <a:avLst/>
-          </a:prstGeom>
-          <a:ln w="15875">
-            <a:solidFill>
-              <a:srgbClr val="E87B1E"/>
-            </a:solidFill>
-            <a:tailEnd type="triangle" w="sm" h="sm"/>
           </a:ln>
         </p:spPr>
         <p:style>
@@ -12094,23 +11415,485 @@
       </p:cxnSp>
       <p:cxnSp>
         <p:nvCxnSpPr>
+          <p:cNvPr id="43" name="Connector 42"/>
+          <p:cNvCxnSpPr/>
+          <p:nvPr/>
+        </p:nvCxnSpPr>
+        <p:spPr>
+          <a:xfrm flipH="1">
+            <a:off x="6126480.0" y="2857500.0"/>
+            <a:ext cx="3200400.0" cy="0.0"/>
+          </a:xfrm>
+          <a:prstGeom prst="line">
+            <a:avLst/>
+          </a:prstGeom>
+          <a:ln w="12700">
+            <a:solidFill>
+              <a:srgbClr val="34A853"/>
+            </a:solidFill>
+          </a:ln>
+        </p:spPr>
+        <p:style>
+          <a:lnRef idx="2">
+            <a:schemeClr val="accent1"/>
+          </a:lnRef>
+          <a:fillRef idx="0">
+            <a:schemeClr val="accent1"/>
+          </a:fillRef>
+          <a:effectRef idx="1">
+            <a:schemeClr val="accent1"/>
+          </a:effectRef>
+          <a:fontRef idx="minor">
+            <a:schemeClr val="tx1"/>
+          </a:fontRef>
+        </p:style>
+      </p:cxnSp>
+      <p:cxnSp>
+        <p:nvCxnSpPr>
+          <p:cNvPr id="44" name="Connector 43"/>
+          <p:cNvCxnSpPr/>
+          <p:nvPr/>
+        </p:nvCxnSpPr>
+        <p:spPr>
+          <a:xfrm flipV="1">
+            <a:off x="6126480.0" y="2651760"/>
+            <a:ext cx="0.0" cy="205740.0"/>
+          </a:xfrm>
+          <a:prstGeom prst="line">
+            <a:avLst/>
+          </a:prstGeom>
+          <a:ln w="12700">
+            <a:solidFill>
+              <a:srgbClr val="34A853"/>
+            </a:solidFill>
+            <a:tailEnd type="triangle" w="med" h="med"/>
+          </a:ln>
+        </p:spPr>
+        <p:style>
+          <a:lnRef idx="2">
+            <a:schemeClr val="accent1"/>
+          </a:lnRef>
+          <a:fillRef idx="0">
+            <a:schemeClr val="accent1"/>
+          </a:fillRef>
+          <a:effectRef idx="1">
+            <a:schemeClr val="accent1"/>
+          </a:effectRef>
+          <a:fontRef idx="minor">
+            <a:schemeClr val="tx1"/>
+          </a:fontRef>
+        </p:style>
+      </p:cxnSp>
+      <p:sp>
+        <p:nvSpPr>
+          <p:cNvPr id="45" name="TextBox 44"/>
+          <p:cNvSpPr txBox="1"/>
+          <p:nvPr/>
+        </p:nvSpPr>
+        <p:spPr>
+          <a:xfrm>
+            <a:off x="7955280" y="2692908"/>
+            <a:ext cx="1280160" cy="164592"/>
+          </a:xfrm>
+          <a:prstGeom prst="rect">
+            <a:avLst/>
+          </a:prstGeom>
+          <a:noFill/>
+        </p:spPr>
+        <p:txBody>
+          <a:bodyPr wrap="square" lIns="18288" rIns="18288" tIns="0" bIns="0">
+            <a:spAutoFit/>
+          </a:bodyPr>
+          <a:lstStyle/>
+          <a:p>
+            <a:pPr algn="ctr"/>
+            <a:r>
+              <a:rPr sz="700" b="0" i="1">
+                <a:solidFill>
+                  <a:srgbClr val="34A853"/>
+                </a:solidFill>
+                <a:latin typeface="Calibri"/>
+              </a:rPr>
+              <a:t>deploy / retrain</a:t>
+            </a:r>
+          </a:p>
+        </p:txBody>
+      </p:sp>
+      <p:sp>
+        <p:nvSpPr>
+          <p:cNvPr id="46" name="Rounded Rectangle 45"/>
+          <p:cNvSpPr/>
+          <p:nvPr/>
+        </p:nvSpPr>
+        <p:spPr>
+          <a:xfrm>
+            <a:off x="1554480" y="4800600"/>
+            <a:ext cx="2011680" cy="777240"/>
+          </a:xfrm>
+          <a:prstGeom prst="roundRect">
+            <a:avLst>
+              <a:gd name="adj" fmla="val 10000"/>
+            </a:avLst>
+          </a:prstGeom>
+          <a:solidFill>
+            <a:srgbClr val="4E88E6"/>
+          </a:solidFill>
+          <a:ln>
+            <a:noFill/>
+          </a:ln>
+        </p:spPr>
+        <p:style>
+          <a:lnRef idx="1">
+            <a:schemeClr val="accent1"/>
+          </a:lnRef>
+          <a:fillRef idx="3">
+            <a:schemeClr val="accent1"/>
+          </a:fillRef>
+          <a:effectRef idx="2">
+            <a:schemeClr val="accent1"/>
+          </a:effectRef>
+          <a:fontRef idx="minor">
+            <a:schemeClr val="lt1"/>
+          </a:fontRef>
+        </p:style>
+        <p:txBody>
+          <a:bodyPr rtlCol="0" anchor="ctr" lIns="73152" rIns="73152" wrap="square"/>
+          <a:lstStyle/>
+          <a:p>
+            <a:pPr algn="ctr"/>
+            <a:r>
+              <a:rPr sz="1100" b="1" i="0">
+                <a:solidFill>
+                  <a:srgbClr val="FFFFFF"/>
+                </a:solidFill>
+                <a:latin typeface="Calibri"/>
+              </a:rPr>
+              <a:t>Breaker Automation</a:t>
+            </a:r>
+          </a:p>
+          <a:p>
+            <a:pPr algn="ctr"/>
+            <a:r>
+              <a:rPr sz="800" b="0" i="0">
+                <a:solidFill>
+                  <a:srgbClr val="FFFFFF"/>
+                </a:solidFill>
+                <a:latin typeface="Calibri"/>
+              </a:rPr>
+              <a:t>Python  ·  flips kill-switch</a:t>
+            </a:r>
+          </a:p>
+        </p:txBody>
+      </p:sp>
+      <p:sp>
+        <p:nvSpPr>
+          <p:cNvPr id="47" name="Rounded Rectangle 46"/>
+          <p:cNvSpPr/>
+          <p:nvPr/>
+        </p:nvSpPr>
+        <p:spPr>
+          <a:xfrm>
+            <a:off x="3749040" y="4937760"/>
+            <a:ext cx="1371600" cy="502920"/>
+          </a:xfrm>
+          <a:prstGeom prst="roundRect">
+            <a:avLst>
+              <a:gd name="adj" fmla="val 20000"/>
+            </a:avLst>
+          </a:prstGeom>
+          <a:solidFill>
+            <a:srgbClr val="FFFFFF"/>
+          </a:solidFill>
+          <a:ln w="9525">
+            <a:solidFill>
+              <a:srgbClr val="C9CFDA"/>
+            </a:solidFill>
+          </a:ln>
+        </p:spPr>
+        <p:style>
+          <a:lnRef idx="1">
+            <a:schemeClr val="accent1"/>
+          </a:lnRef>
+          <a:fillRef idx="3">
+            <a:schemeClr val="accent1"/>
+          </a:fillRef>
+          <a:effectRef idx="2">
+            <a:schemeClr val="accent1"/>
+          </a:effectRef>
+          <a:fontRef idx="minor">
+            <a:schemeClr val="lt1"/>
+          </a:fontRef>
+        </p:style>
+        <p:txBody>
+          <a:bodyPr rtlCol="0" anchor="ctr"/>
+          <a:lstStyle/>
+          <a:p>
+            <a:pPr algn="ctr"/>
+            <a:r>
+              <a:rPr sz="900" b="1" i="0">
+                <a:solidFill>
+                  <a:srgbClr val="0B1F3A"/>
+                </a:solidFill>
+                <a:latin typeface="Calibri"/>
+              </a:rPr>
+              <a:t>Secret Manager</a:t>
+            </a:r>
+          </a:p>
+        </p:txBody>
+      </p:sp>
+      <p:sp>
+        <p:nvSpPr>
+          <p:cNvPr id="48" name="Rounded Rectangle 47"/>
+          <p:cNvSpPr/>
+          <p:nvPr/>
+        </p:nvSpPr>
+        <p:spPr>
+          <a:xfrm>
+            <a:off x="4937760" y="4800600"/>
+            <a:ext cx="2377440" cy="777240"/>
+          </a:xfrm>
+          <a:prstGeom prst="roundRect">
+            <a:avLst>
+              <a:gd name="adj" fmla="val 10000"/>
+            </a:avLst>
+          </a:prstGeom>
+          <a:solidFill>
+            <a:srgbClr val="4E88E6"/>
+          </a:solidFill>
+          <a:ln>
+            <a:noFill/>
+          </a:ln>
+        </p:spPr>
+        <p:style>
+          <a:lnRef idx="1">
+            <a:schemeClr val="accent1"/>
+          </a:lnRef>
+          <a:fillRef idx="3">
+            <a:schemeClr val="accent1"/>
+          </a:fillRef>
+          <a:effectRef idx="2">
+            <a:schemeClr val="accent1"/>
+          </a:effectRef>
+          <a:fontRef idx="minor">
+            <a:schemeClr val="lt1"/>
+          </a:fontRef>
+        </p:style>
+        <p:txBody>
+          <a:bodyPr rtlCol="0" anchor="ctr" lIns="73152" rIns="73152" wrap="square"/>
+          <a:lstStyle/>
+          <a:p>
+            <a:pPr algn="ctr"/>
+            <a:r>
+              <a:rPr sz="1100" b="1" i="0">
+                <a:solidFill>
+                  <a:srgbClr val="FFFFFF"/>
+                </a:solidFill>
+                <a:latin typeface="Calibri"/>
+              </a:rPr>
+              <a:t>Reconciliation Service</a:t>
+            </a:r>
+          </a:p>
+          <a:p>
+            <a:pPr algn="ctr"/>
+            <a:r>
+              <a:rPr sz="800" b="0" i="0">
+                <a:solidFill>
+                  <a:srgbClr val="FFFFFF"/>
+                </a:solidFill>
+                <a:latin typeface="Calibri"/>
+              </a:rPr>
+              <a:t>Python FastAPI  ·  Cloud Run</a:t>
+            </a:r>
+          </a:p>
+        </p:txBody>
+      </p:sp>
+      <p:sp>
+        <p:nvSpPr>
+          <p:cNvPr id="49" name="Rounded Rectangle 48"/>
+          <p:cNvSpPr/>
+          <p:nvPr/>
+        </p:nvSpPr>
+        <p:spPr>
+          <a:xfrm>
+            <a:off x="8229600" y="4800600"/>
+            <a:ext cx="2194560" cy="777240"/>
+          </a:xfrm>
+          <a:prstGeom prst="roundRect">
+            <a:avLst>
+              <a:gd name="adj" fmla="val 10000"/>
+            </a:avLst>
+          </a:prstGeom>
+          <a:solidFill>
+            <a:srgbClr val="4E88E6"/>
+          </a:solidFill>
+          <a:ln>
+            <a:noFill/>
+          </a:ln>
+        </p:spPr>
+        <p:style>
+          <a:lnRef idx="1">
+            <a:schemeClr val="accent1"/>
+          </a:lnRef>
+          <a:fillRef idx="3">
+            <a:schemeClr val="accent1"/>
+          </a:fillRef>
+          <a:effectRef idx="2">
+            <a:schemeClr val="accent1"/>
+          </a:effectRef>
+          <a:fontRef idx="minor">
+            <a:schemeClr val="lt1"/>
+          </a:fontRef>
+        </p:style>
+        <p:txBody>
+          <a:bodyPr rtlCol="0" anchor="ctr" lIns="73152" rIns="73152" wrap="square"/>
+          <a:lstStyle/>
+          <a:p>
+            <a:pPr algn="ctr"/>
+            <a:r>
+              <a:rPr sz="1100" b="1" i="0">
+                <a:solidFill>
+                  <a:srgbClr val="FFFFFF"/>
+                </a:solidFill>
+                <a:latin typeface="Calibri"/>
+              </a:rPr>
+              <a:t>Activation Service</a:t>
+            </a:r>
+          </a:p>
+          <a:p>
+            <a:pPr algn="ctr"/>
+            <a:r>
+              <a:rPr sz="800" b="0" i="0">
+                <a:solidFill>
+                  <a:srgbClr val="FFFFFF"/>
+                </a:solidFill>
+                <a:latin typeface="Calibri"/>
+              </a:rPr>
+              <a:t>Python 3.12  ·  Cloud Run</a:t>
+            </a:r>
+          </a:p>
+        </p:txBody>
+      </p:sp>
+      <p:sp>
+        <p:nvSpPr>
+          <p:cNvPr id="50" name="TextBox 49"/>
+          <p:cNvSpPr txBox="1"/>
+          <p:nvPr/>
+        </p:nvSpPr>
+        <p:spPr>
+          <a:xfrm>
+            <a:off x="10561320" y="4846320"/>
+            <a:ext cx="914400" cy="219456"/>
+          </a:xfrm>
+          <a:prstGeom prst="rect">
+            <a:avLst/>
+          </a:prstGeom>
+          <a:noFill/>
+        </p:spPr>
+        <p:txBody>
+          <a:bodyPr wrap="none">
+            <a:spAutoFit/>
+          </a:bodyPr>
+          <a:lstStyle/>
+          <a:p>
+            <a:r>
+              <a:rPr sz="900" b="1" i="0">
+                <a:solidFill>
+                  <a:srgbClr val="333F52"/>
+                </a:solidFill>
+                <a:latin typeface="Calibri"/>
+              </a:rPr>
+              <a:t>→  SA360</a:t>
+            </a:r>
+          </a:p>
+        </p:txBody>
+      </p:sp>
+      <p:sp>
+        <p:nvSpPr>
+          <p:cNvPr id="51" name="TextBox 50"/>
+          <p:cNvSpPr txBox="1"/>
+          <p:nvPr/>
+        </p:nvSpPr>
+        <p:spPr>
+          <a:xfrm>
+            <a:off x="10561320" y="5084064"/>
+            <a:ext cx="914400" cy="219456"/>
+          </a:xfrm>
+          <a:prstGeom prst="rect">
+            <a:avLst/>
+          </a:prstGeom>
+          <a:noFill/>
+        </p:spPr>
+        <p:txBody>
+          <a:bodyPr wrap="none">
+            <a:spAutoFit/>
+          </a:bodyPr>
+          <a:lstStyle/>
+          <a:p>
+            <a:r>
+              <a:rPr sz="900" b="1" i="0">
+                <a:solidFill>
+                  <a:srgbClr val="333F52"/>
+                </a:solidFill>
+                <a:latin typeface="Calibri"/>
+              </a:rPr>
+              <a:t>→  SSGTM</a:t>
+            </a:r>
+          </a:p>
+        </p:txBody>
+      </p:sp>
+      <p:sp>
+        <p:nvSpPr>
+          <p:cNvPr id="52" name="TextBox 51"/>
+          <p:cNvSpPr txBox="1"/>
+          <p:nvPr/>
+        </p:nvSpPr>
+        <p:spPr>
+          <a:xfrm>
+            <a:off x="10561320" y="5321808"/>
+            <a:ext cx="914400" cy="219456"/>
+          </a:xfrm>
+          <a:prstGeom prst="rect">
+            <a:avLst/>
+          </a:prstGeom>
+          <a:noFill/>
+        </p:spPr>
+        <p:txBody>
+          <a:bodyPr wrap="none">
+            <a:spAutoFit/>
+          </a:bodyPr>
+          <a:lstStyle/>
+          <a:p>
+            <a:r>
+              <a:rPr sz="900" b="1" i="0">
+                <a:solidFill>
+                  <a:srgbClr val="333F52"/>
+                </a:solidFill>
+                <a:latin typeface="Calibri"/>
+              </a:rPr>
+              <a:t>→  OCI</a:t>
+            </a:r>
+          </a:p>
+        </p:txBody>
+      </p:sp>
+      <p:cxnSp>
+        <p:nvCxnSpPr>
           <p:cNvPr id="53" name="Connector 52"/>
           <p:cNvCxnSpPr/>
           <p:nvPr/>
         </p:nvCxnSpPr>
         <p:spPr>
-          <a:xfrm flipV="1">
-            <a:off x="4160520" y="4343400"/>
-            <a:ext cx="868680" cy="27432"/>
+          <a:xfrm>
+            <a:off x="3566160" y="5189220.0"/>
+            <a:ext cx="182880" cy="0.0"/>
           </a:xfrm>
           <a:prstGeom prst="line">
             <a:avLst/>
           </a:prstGeom>
           <a:ln w="15875">
             <a:solidFill>
-              <a:srgbClr val="E87B1E"/>
+              <a:srgbClr val="46556B"/>
             </a:solidFill>
-            <a:tailEnd type="triangle" w="sm" h="sm"/>
+            <a:tailEnd type="triangle" w="med" h="med"/>
           </a:ln>
         </p:spPr>
         <p:style>
@@ -12136,17 +11919,17 @@
         </p:nvCxnSpPr>
         <p:spPr>
           <a:xfrm>
-            <a:off x="4114800" y="2697480"/>
-            <a:ext cx="1371600" cy="1874520"/>
+            <a:off x="10424160" y="5189220.0"/>
+            <a:ext cx="91440" cy="0.0"/>
           </a:xfrm>
           <a:prstGeom prst="line">
             <a:avLst/>
           </a:prstGeom>
-          <a:ln w="12700">
+          <a:ln w="15875">
             <a:solidFill>
-              <a:srgbClr val="E87B1E"/>
+              <a:srgbClr val="46556B"/>
             </a:solidFill>
-            <a:tailEnd type="triangle" w="sm" h="sm"/>
+            <a:tailEnd type="triangle" w="med" h="med"/>
           </a:ln>
         </p:spPr>
         <p:style>
@@ -12171,18 +11954,159 @@
           <p:nvPr/>
         </p:nvCxnSpPr>
         <p:spPr>
-          <a:xfrm>
-            <a:off x="685800" y="2148840"/>
-            <a:ext cx="1143000" cy="2011680"/>
+          <a:xfrm flipV="1">
+            <a:off x="4434840.0" y="2651760"/>
+            <a:ext cx="0.0" cy="2286000"/>
           </a:xfrm>
           <a:prstGeom prst="line">
             <a:avLst/>
           </a:prstGeom>
           <a:ln w="12700">
             <a:solidFill>
-              <a:srgbClr val="A96BDB"/>
+              <a:srgbClr val="46556B"/>
             </a:solidFill>
-            <a:tailEnd type="triangle" w="sm" h="sm"/>
+            <a:tailEnd type="triangle" w="med" h="med"/>
+          </a:ln>
+        </p:spPr>
+        <p:style>
+          <a:lnRef idx="2">
+            <a:schemeClr val="accent1"/>
+          </a:lnRef>
+          <a:fillRef idx="0">
+            <a:schemeClr val="accent1"/>
+          </a:fillRef>
+          <a:effectRef idx="1">
+            <a:schemeClr val="accent1"/>
+          </a:effectRef>
+          <a:fontRef idx="minor">
+            <a:schemeClr val="tx1"/>
+          </a:fontRef>
+        </p:style>
+      </p:cxnSp>
+      <p:sp>
+        <p:nvSpPr>
+          <p:cNvPr id="56" name="TextBox 55"/>
+          <p:cNvSpPr txBox="1"/>
+          <p:nvPr/>
+        </p:nvSpPr>
+        <p:spPr>
+          <a:xfrm>
+            <a:off x="4480560" y="3703320"/>
+            <a:ext cx="1463040" cy="164592"/>
+          </a:xfrm>
+          <a:prstGeom prst="rect">
+            <a:avLst/>
+          </a:prstGeom>
+          <a:noFill/>
+        </p:spPr>
+        <p:txBody>
+          <a:bodyPr wrap="square" lIns="18288" rIns="18288" tIns="0" bIns="0">
+            <a:spAutoFit/>
+          </a:bodyPr>
+          <a:lstStyle/>
+          <a:p>
+            <a:pPr algn="l"/>
+            <a:r>
+              <a:rPr sz="700" b="0" i="1">
+                <a:solidFill>
+                  <a:srgbClr val="6B7380"/>
+                </a:solidFill>
+                <a:latin typeface="Calibri"/>
+              </a:rPr>
+              <a:t>kill-switch flag</a:t>
+            </a:r>
+          </a:p>
+        </p:txBody>
+      </p:sp>
+      <p:cxnSp>
+        <p:nvCxnSpPr>
+          <p:cNvPr id="57" name="Connector 56"/>
+          <p:cNvCxnSpPr/>
+          <p:nvPr/>
+        </p:nvCxnSpPr>
+        <p:spPr>
+          <a:xfrm>
+            <a:off x="6126480.0" y="4224528"/>
+            <a:ext cx="0.0" cy="576072"/>
+          </a:xfrm>
+          <a:prstGeom prst="line">
+            <a:avLst/>
+          </a:prstGeom>
+          <a:ln w="15875">
+            <a:solidFill>
+              <a:srgbClr val="46556B"/>
+            </a:solidFill>
+            <a:tailEnd type="triangle" w="med" h="med"/>
+          </a:ln>
+        </p:spPr>
+        <p:style>
+          <a:lnRef idx="2">
+            <a:schemeClr val="accent1"/>
+          </a:lnRef>
+          <a:fillRef idx="0">
+            <a:schemeClr val="accent1"/>
+          </a:fillRef>
+          <a:effectRef idx="1">
+            <a:schemeClr val="accent1"/>
+          </a:effectRef>
+          <a:fontRef idx="minor">
+            <a:schemeClr val="tx1"/>
+          </a:fontRef>
+        </p:style>
+      </p:cxnSp>
+      <p:sp>
+        <p:nvSpPr>
+          <p:cNvPr id="58" name="TextBox 57"/>
+          <p:cNvSpPr txBox="1"/>
+          <p:nvPr/>
+        </p:nvSpPr>
+        <p:spPr>
+          <a:xfrm>
+            <a:off x="5029200" y="4421124"/>
+            <a:ext cx="1005840" cy="164592"/>
+          </a:xfrm>
+          <a:prstGeom prst="rect">
+            <a:avLst/>
+          </a:prstGeom>
+          <a:noFill/>
+        </p:spPr>
+        <p:txBody>
+          <a:bodyPr wrap="square" lIns="18288" rIns="18288" tIns="0" bIns="0">
+            <a:spAutoFit/>
+          </a:bodyPr>
+          <a:lstStyle/>
+          <a:p>
+            <a:pPr algn="ctr"/>
+            <a:r>
+              <a:rPr sz="700" b="0" i="1">
+                <a:solidFill>
+                  <a:srgbClr val="6B7380"/>
+                </a:solidFill>
+                <a:latin typeface="Calibri"/>
+              </a:rPr>
+              <a:t>predictions_vs_revenue</a:t>
+            </a:r>
+          </a:p>
+        </p:txBody>
+      </p:sp>
+      <p:cxnSp>
+        <p:nvCxnSpPr>
+          <p:cNvPr id="59" name="Connector 58"/>
+          <p:cNvCxnSpPr/>
+          <p:nvPr/>
+        </p:nvCxnSpPr>
+        <p:spPr>
+          <a:xfrm>
+            <a:off x="7315200" y="5189220.0"/>
+            <a:ext cx="365760" cy="0.0"/>
+          </a:xfrm>
+          <a:prstGeom prst="line">
+            <a:avLst/>
+          </a:prstGeom>
+          <a:ln w="12700">
+            <a:solidFill>
+              <a:srgbClr val="46556B"/>
+            </a:solidFill>
           </a:ln>
         </p:spPr>
         <p:style>
@@ -12202,166 +12126,22 @@
       </p:cxnSp>
       <p:cxnSp>
         <p:nvCxnSpPr>
-          <p:cNvPr id="56" name="Connector 55"/>
+          <p:cNvPr id="60" name="Connector 59"/>
           <p:cNvCxnSpPr/>
           <p:nvPr/>
         </p:nvCxnSpPr>
         <p:spPr>
           <a:xfrm flipV="1">
-            <a:off x="2057400" y="3657600"/>
-            <a:ext cx="2514600" cy="914400"/>
+            <a:off x="7680960" y="2263140.0"/>
+            <a:ext cx="0" cy="2926080.0"/>
           </a:xfrm>
           <a:prstGeom prst="line">
             <a:avLst/>
           </a:prstGeom>
           <a:ln w="12700">
             <a:solidFill>
-              <a:srgbClr val="A96BDB"/>
+              <a:srgbClr val="46556B"/>
             </a:solidFill>
-            <a:tailEnd type="triangle" w="sm" h="sm"/>
-          </a:ln>
-        </p:spPr>
-        <p:style>
-          <a:lnRef idx="2">
-            <a:schemeClr val="accent1"/>
-          </a:lnRef>
-          <a:fillRef idx="0">
-            <a:schemeClr val="accent1"/>
-          </a:fillRef>
-          <a:effectRef idx="1">
-            <a:schemeClr val="accent1"/>
-          </a:effectRef>
-          <a:fontRef idx="minor">
-            <a:schemeClr val="tx1"/>
-          </a:fontRef>
-        </p:style>
-      </p:cxnSp>
-      <p:cxnSp>
-        <p:nvCxnSpPr>
-          <p:cNvPr id="57" name="Connector 56"/>
-          <p:cNvCxnSpPr/>
-          <p:nvPr/>
-        </p:nvCxnSpPr>
-        <p:spPr>
-          <a:xfrm flipV="1">
-            <a:off x="548640" y="4160520"/>
-            <a:ext cx="4023360" cy="1280160"/>
-          </a:xfrm>
-          <a:prstGeom prst="line">
-            <a:avLst/>
-          </a:prstGeom>
-          <a:ln w="12700">
-            <a:solidFill>
-              <a:srgbClr val="E87B1E"/>
-            </a:solidFill>
-            <a:tailEnd type="triangle" w="sm" h="sm"/>
-          </a:ln>
-        </p:spPr>
-        <p:style>
-          <a:lnRef idx="2">
-            <a:schemeClr val="accent1"/>
-          </a:lnRef>
-          <a:fillRef idx="0">
-            <a:schemeClr val="accent1"/>
-          </a:fillRef>
-          <a:effectRef idx="1">
-            <a:schemeClr val="accent1"/>
-          </a:effectRef>
-          <a:fontRef idx="minor">
-            <a:schemeClr val="tx1"/>
-          </a:fontRef>
-        </p:style>
-      </p:cxnSp>
-      <p:cxnSp>
-        <p:nvCxnSpPr>
-          <p:cNvPr id="58" name="Connector 57"/>
-          <p:cNvCxnSpPr/>
-          <p:nvPr/>
-        </p:nvCxnSpPr>
-        <p:spPr>
-          <a:xfrm>
-            <a:off x="6858000" y="4023360"/>
-            <a:ext cx="914400" cy="137160"/>
-          </a:xfrm>
-          <a:prstGeom prst="line">
-            <a:avLst/>
-          </a:prstGeom>
-          <a:ln w="15875">
-            <a:solidFill>
-              <a:srgbClr val="5F6B7C"/>
-            </a:solidFill>
-            <a:tailEnd type="triangle" w="sm" h="sm"/>
-          </a:ln>
-        </p:spPr>
-        <p:style>
-          <a:lnRef idx="2">
-            <a:schemeClr val="accent1"/>
-          </a:lnRef>
-          <a:fillRef idx="0">
-            <a:schemeClr val="accent1"/>
-          </a:fillRef>
-          <a:effectRef idx="1">
-            <a:schemeClr val="accent1"/>
-          </a:effectRef>
-          <a:fontRef idx="minor">
-            <a:schemeClr val="tx1"/>
-          </a:fontRef>
-        </p:style>
-      </p:cxnSp>
-      <p:sp>
-        <p:nvSpPr>
-          <p:cNvPr id="59" name="TextBox 58"/>
-          <p:cNvSpPr txBox="1"/>
-          <p:nvPr/>
-        </p:nvSpPr>
-        <p:spPr>
-          <a:xfrm>
-            <a:off x="6903720" y="3822191"/>
-            <a:ext cx="914400" cy="201168"/>
-          </a:xfrm>
-          <a:prstGeom prst="rect">
-            <a:avLst/>
-          </a:prstGeom>
-          <a:noFill/>
-        </p:spPr>
-        <p:txBody>
-          <a:bodyPr wrap="square" lIns="18288" rIns="18288" tIns="0" bIns="0">
-            <a:spAutoFit/>
-          </a:bodyPr>
-          <a:lstStyle/>
-          <a:p>
-            <a:pPr algn="ctr"/>
-            <a:r>
-              <a:rPr sz="700" b="0" i="1">
-                <a:solidFill>
-                  <a:srgbClr val="6B7380"/>
-                </a:solidFill>
-                <a:latin typeface="Calibri"/>
-              </a:rPr>
-              <a:t>training data</a:t>
-            </a:r>
-          </a:p>
-        </p:txBody>
-      </p:sp>
-      <p:cxnSp>
-        <p:nvCxnSpPr>
-          <p:cNvPr id="60" name="Connector 59"/>
-          <p:cNvCxnSpPr/>
-          <p:nvPr/>
-        </p:nvCxnSpPr>
-        <p:spPr>
-          <a:xfrm>
-            <a:off x="9692640" y="4572000"/>
-            <a:ext cx="365760" cy="0"/>
-          </a:xfrm>
-          <a:prstGeom prst="line">
-            <a:avLst/>
-          </a:prstGeom>
-          <a:ln w="12700">
-            <a:solidFill>
-              <a:srgbClr val="5F6B7C"/>
-            </a:solidFill>
-            <a:tailEnd type="triangle" w="sm" h="sm"/>
           </a:ln>
         </p:spPr>
         <p:style>
@@ -12386,19 +12166,18 @@
           <p:nvPr/>
         </p:nvCxnSpPr>
         <p:spPr>
-          <a:xfrm flipH="1" flipV="1">
-            <a:off x="5715000" y="2331720"/>
-            <a:ext cx="2514600" cy="1828800"/>
+          <a:xfrm>
+            <a:off x="7680960" y="2263140.0"/>
+            <a:ext cx="1371600" cy="0.0"/>
           </a:xfrm>
           <a:prstGeom prst="line">
             <a:avLst/>
           </a:prstGeom>
           <a:ln w="12700">
             <a:solidFill>
-              <a:srgbClr val="5F6B7C"/>
+              <a:srgbClr val="46556B"/>
             </a:solidFill>
-            <a:prstDash val="dash"/>
-            <a:tailEnd type="triangle" w="sm" h="sm"/>
+            <a:tailEnd type="triangle" w="med" h="med"/>
           </a:ln>
         </p:spPr>
         <p:style>
@@ -12424,8 +12203,8 @@
         </p:nvSpPr>
         <p:spPr>
           <a:xfrm>
-            <a:off x="7498079" y="3200400"/>
-            <a:ext cx="1463040" cy="201168"/>
+            <a:off x="7726680" y="2061972"/>
+            <a:ext cx="1005840" cy="164592"/>
           </a:xfrm>
           <a:prstGeom prst="rect">
             <a:avLst/>
@@ -12438,7 +12217,7 @@
           </a:bodyPr>
           <a:lstStyle/>
           <a:p>
-            <a:pPr algn="ctr"/>
+            <a:pPr algn="l"/>
             <a:r>
               <a:rPr sz="700" b="0" i="1">
                 <a:solidFill>
@@ -12446,7 +12225,7 @@
                 </a:solidFill>
                 <a:latin typeface="Calibri"/>
               </a:rPr>
-              <a:t>deploy / retrain</a:t>
+              <a:t>HTTPS /api</a:t>
             </a:r>
           </a:p>
         </p:txBody>
@@ -12459,159 +12238,16 @@
         </p:nvCxnSpPr>
         <p:spPr>
           <a:xfrm>
-            <a:off x="6858000" y="3200400"/>
-            <a:ext cx="1874520" cy="0"/>
+            <a:off x="7315200" y="3995928"/>
+            <a:ext cx="1280160" cy="0"/>
           </a:xfrm>
           <a:prstGeom prst="line">
             <a:avLst/>
           </a:prstGeom>
-          <a:ln w="15875">
+          <a:ln w="12700">
             <a:solidFill>
-              <a:srgbClr val="E87B1E"/>
+              <a:srgbClr val="46556B"/>
             </a:solidFill>
-            <a:tailEnd type="triangle" w="sm" h="sm"/>
-          </a:ln>
-        </p:spPr>
-        <p:style>
-          <a:lnRef idx="2">
-            <a:schemeClr val="accent1"/>
-          </a:lnRef>
-          <a:fillRef idx="0">
-            <a:schemeClr val="accent1"/>
-          </a:fillRef>
-          <a:effectRef idx="1">
-            <a:schemeClr val="accent1"/>
-          </a:effectRef>
-          <a:fontRef idx="minor">
-            <a:schemeClr val="tx1"/>
-          </a:fontRef>
-        </p:style>
-      </p:cxnSp>
-      <p:sp>
-        <p:nvSpPr>
-          <p:cNvPr id="64" name="TextBox 63"/>
-          <p:cNvSpPr txBox="1"/>
-          <p:nvPr/>
-        </p:nvSpPr>
-        <p:spPr>
-          <a:xfrm>
-            <a:off x="6949440" y="2944368"/>
-            <a:ext cx="1783080" cy="201168"/>
-          </a:xfrm>
-          <a:prstGeom prst="rect">
-            <a:avLst/>
-          </a:prstGeom>
-          <a:noFill/>
-        </p:spPr>
-        <p:txBody>
-          <a:bodyPr wrap="square" lIns="18288" rIns="18288" tIns="0" bIns="0">
-            <a:spAutoFit/>
-          </a:bodyPr>
-          <a:lstStyle/>
-          <a:p>
-            <a:pPr algn="ctr"/>
-            <a:r>
-              <a:rPr sz="700" b="0" i="1">
-                <a:solidFill>
-                  <a:srgbClr val="E87B1E"/>
-                </a:solidFill>
-                <a:latin typeface="Calibri"/>
-              </a:rPr>
-              <a:t>read predictions_vs_revenue</a:t>
-            </a:r>
-          </a:p>
-        </p:txBody>
-      </p:sp>
-      <p:cxnSp>
-        <p:nvCxnSpPr>
-          <p:cNvPr id="65" name="Connector 64"/>
-          <p:cNvCxnSpPr/>
-          <p:nvPr/>
-        </p:nvCxnSpPr>
-        <p:spPr>
-          <a:xfrm flipV="1">
-            <a:off x="9966960" y="2331720"/>
-            <a:ext cx="0" cy="457200"/>
-          </a:xfrm>
-          <a:prstGeom prst="line">
-            <a:avLst/>
-          </a:prstGeom>
-          <a:ln w="15875">
-            <a:solidFill>
-              <a:srgbClr val="5F6B7C"/>
-            </a:solidFill>
-            <a:tailEnd type="triangle" w="sm" h="sm"/>
-          </a:ln>
-        </p:spPr>
-        <p:style>
-          <a:lnRef idx="2">
-            <a:schemeClr val="accent1"/>
-          </a:lnRef>
-          <a:fillRef idx="0">
-            <a:schemeClr val="accent1"/>
-          </a:fillRef>
-          <a:effectRef idx="1">
-            <a:schemeClr val="accent1"/>
-          </a:effectRef>
-          <a:fontRef idx="minor">
-            <a:schemeClr val="tx1"/>
-          </a:fontRef>
-        </p:style>
-      </p:cxnSp>
-      <p:sp>
-        <p:nvSpPr>
-          <p:cNvPr id="66" name="TextBox 65"/>
-          <p:cNvSpPr txBox="1"/>
-          <p:nvPr/>
-        </p:nvSpPr>
-        <p:spPr>
-          <a:xfrm>
-            <a:off x="10104120" y="2423160"/>
-            <a:ext cx="1097280" cy="201168"/>
-          </a:xfrm>
-          <a:prstGeom prst="rect">
-            <a:avLst/>
-          </a:prstGeom>
-          <a:noFill/>
-        </p:spPr>
-        <p:txBody>
-          <a:bodyPr wrap="square" lIns="18288" rIns="18288" tIns="0" bIns="0">
-            <a:spAutoFit/>
-          </a:bodyPr>
-          <a:lstStyle/>
-          <a:p>
-            <a:pPr algn="ctr"/>
-            <a:r>
-              <a:rPr sz="700" b="0" i="1">
-                <a:solidFill>
-                  <a:srgbClr val="6B7380"/>
-                </a:solidFill>
-                <a:latin typeface="Calibri"/>
-              </a:rPr>
-              <a:t>HTTPS /api</a:t>
-            </a:r>
-          </a:p>
-        </p:txBody>
-      </p:sp>
-      <p:cxnSp>
-        <p:nvCxnSpPr>
-          <p:cNvPr id="67" name="Connector 66"/>
-          <p:cNvCxnSpPr/>
-          <p:nvPr/>
-        </p:nvCxnSpPr>
-        <p:spPr>
-          <a:xfrm flipH="1">
-            <a:off x="11201400" y="1874519"/>
-            <a:ext cx="365760" cy="0"/>
-          </a:xfrm>
-          <a:prstGeom prst="line">
-            <a:avLst/>
-          </a:prstGeom>
-          <a:ln w="15875">
-            <a:solidFill>
-              <a:srgbClr val="5F6B7C"/>
-            </a:solidFill>
-            <a:tailEnd type="triangle" w="sm" h="sm"/>
           </a:ln>
         </p:spPr>
         <p:style>
@@ -12631,23 +12267,23 @@
       </p:cxnSp>
       <p:cxnSp>
         <p:nvCxnSpPr>
-          <p:cNvPr id="68" name="Connector 67"/>
+          <p:cNvPr id="64" name="Connector 63"/>
           <p:cNvCxnSpPr/>
           <p:nvPr/>
         </p:nvCxnSpPr>
         <p:spPr>
-          <a:xfrm flipH="1" flipV="1">
-            <a:off x="4434840" y="2926080"/>
-            <a:ext cx="137160" cy="2423160"/>
+          <a:xfrm>
+            <a:off x="8595360" y="3995928"/>
+            <a:ext cx="0" cy="804672"/>
           </a:xfrm>
           <a:prstGeom prst="line">
             <a:avLst/>
           </a:prstGeom>
           <a:ln w="12700">
             <a:solidFill>
-              <a:srgbClr val="5F6B7C"/>
+              <a:srgbClr val="46556B"/>
             </a:solidFill>
-            <a:tailEnd type="triangle" w="sm" h="sm"/>
+            <a:tailEnd type="triangle" w="med" h="med"/>
           </a:ln>
         </p:spPr>
         <p:style>
@@ -12665,52 +12301,16 @@
           </a:fontRef>
         </p:style>
       </p:cxnSp>
-      <p:cxnSp>
-        <p:nvCxnSpPr>
-          <p:cNvPr id="69" name="Connector 68"/>
-          <p:cNvCxnSpPr/>
-          <p:nvPr/>
-        </p:nvCxnSpPr>
-        <p:spPr>
-          <a:xfrm flipH="1">
-            <a:off x="4114800" y="2423160"/>
-            <a:ext cx="320040" cy="0"/>
-          </a:xfrm>
-          <a:prstGeom prst="line">
-            <a:avLst/>
-          </a:prstGeom>
-          <a:ln w="12700">
-            <a:solidFill>
-              <a:srgbClr val="5F6B7C"/>
-            </a:solidFill>
-            <a:tailEnd type="triangle" w="sm" h="sm"/>
-          </a:ln>
-        </p:spPr>
-        <p:style>
-          <a:lnRef idx="2">
-            <a:schemeClr val="accent1"/>
-          </a:lnRef>
-          <a:fillRef idx="0">
-            <a:schemeClr val="accent1"/>
-          </a:fillRef>
-          <a:effectRef idx="1">
-            <a:schemeClr val="accent1"/>
-          </a:effectRef>
-          <a:fontRef idx="minor">
-            <a:schemeClr val="tx1"/>
-          </a:fontRef>
-        </p:style>
-      </p:cxnSp>
-      <p:sp>
-        <p:nvSpPr>
-          <p:cNvPr id="70" name="TextBox 69"/>
+      <p:sp>
+        <p:nvSpPr>
+          <p:cNvPr id="65" name="TextBox 64"/>
           <p:cNvSpPr txBox="1"/>
           <p:nvPr/>
         </p:nvSpPr>
         <p:spPr>
           <a:xfrm>
-            <a:off x="3611880" y="4754880"/>
-            <a:ext cx="1828800" cy="201168"/>
+            <a:off x="7863840" y="3813048"/>
+            <a:ext cx="1463040" cy="164592"/>
           </a:xfrm>
           <a:prstGeom prst="rect">
             <a:avLst/>
@@ -12731,93 +12331,21 @@
                 </a:solidFill>
                 <a:latin typeface="Calibri"/>
               </a:rPr>
-              <a:t>flip kill-switch</a:t>
-            </a:r>
-          </a:p>
-        </p:txBody>
-      </p:sp>
-      <p:cxnSp>
-        <p:nvCxnSpPr>
-          <p:cNvPr id="71" name="Connector 70"/>
-          <p:cNvCxnSpPr/>
-          <p:nvPr/>
-        </p:nvCxnSpPr>
-        <p:spPr>
-          <a:xfrm>
-            <a:off x="11201400" y="5458968"/>
-            <a:ext cx="320040" cy="0"/>
-          </a:xfrm>
-          <a:prstGeom prst="line">
-            <a:avLst/>
-          </a:prstGeom>
-          <a:ln w="12700">
-            <a:solidFill>
-              <a:srgbClr val="5F6B7C"/>
-            </a:solidFill>
-            <a:tailEnd type="triangle" w="sm" h="sm"/>
-          </a:ln>
-        </p:spPr>
-        <p:style>
-          <a:lnRef idx="2">
-            <a:schemeClr val="accent1"/>
-          </a:lnRef>
-          <a:fillRef idx="0">
-            <a:schemeClr val="accent1"/>
-          </a:fillRef>
-          <a:effectRef idx="1">
-            <a:schemeClr val="accent1"/>
-          </a:effectRef>
-          <a:fontRef idx="minor">
-            <a:schemeClr val="tx1"/>
-          </a:fontRef>
-        </p:style>
-      </p:cxnSp>
-      <p:cxnSp>
-        <p:nvCxnSpPr>
-          <p:cNvPr id="72" name="Connector 71"/>
-          <p:cNvCxnSpPr/>
-          <p:nvPr/>
-        </p:nvCxnSpPr>
-        <p:spPr>
-          <a:xfrm flipV="1">
-            <a:off x="2468880" y="2926080"/>
-            <a:ext cx="0" cy="274320"/>
-          </a:xfrm>
-          <a:prstGeom prst="line">
-            <a:avLst/>
-          </a:prstGeom>
-          <a:ln w="12700">
-            <a:solidFill>
-              <a:srgbClr val="5F6B7C"/>
-            </a:solidFill>
-            <a:tailEnd type="triangle" w="sm" h="sm"/>
-          </a:ln>
-        </p:spPr>
-        <p:style>
-          <a:lnRef idx="2">
-            <a:schemeClr val="accent1"/>
-          </a:lnRef>
-          <a:fillRef idx="0">
-            <a:schemeClr val="accent1"/>
-          </a:fillRef>
-          <a:effectRef idx="1">
-            <a:schemeClr val="accent1"/>
-          </a:effectRef>
-          <a:fontRef idx="minor">
-            <a:schemeClr val="tx1"/>
-          </a:fontRef>
-        </p:style>
-      </p:cxnSp>
-      <p:sp>
-        <p:nvSpPr>
-          <p:cNvPr id="73" name="TextBox 72"/>
+              <a:t>predictions</a:t>
+            </a:r>
+          </a:p>
+        </p:txBody>
+      </p:sp>
+      <p:sp>
+        <p:nvSpPr>
+          <p:cNvPr id="66" name="TextBox 65"/>
           <p:cNvSpPr txBox="1"/>
           <p:nvPr/>
         </p:nvSpPr>
         <p:spPr>
           <a:xfrm>
-            <a:off x="2514600" y="2971800"/>
-            <a:ext cx="1371600" cy="201168"/>
+            <a:off x="594360" y="5623560"/>
+            <a:ext cx="11002975" cy="457200"/>
           </a:xfrm>
           <a:prstGeom prst="rect">
             <a:avLst/>
@@ -12825,489 +12353,55 @@
           <a:noFill/>
         </p:spPr>
         <p:txBody>
-          <a:bodyPr wrap="square" lIns="18288" rIns="18288" tIns="0" bIns="0">
+          <a:bodyPr wrap="square">
             <a:spAutoFit/>
           </a:bodyPr>
           <a:lstStyle/>
           <a:p>
-            <a:pPr algn="ctr"/>
-            <a:r>
-              <a:rPr sz="700" b="0" i="1">
-                <a:solidFill>
-                  <a:srgbClr val="6B7380"/>
-                </a:solidFill>
-                <a:latin typeface="Calibri"/>
-              </a:rPr>
-              <a:t>segment bounds</a:t>
-            </a:r>
-          </a:p>
-        </p:txBody>
-      </p:sp>
-      <p:sp>
-        <p:nvSpPr>
-          <p:cNvPr id="74" name="Oval 73"/>
-          <p:cNvSpPr/>
-          <p:nvPr/>
-        </p:nvSpPr>
-        <p:spPr>
-          <a:xfrm>
-            <a:off x="457200" y="6373368"/>
-            <a:ext cx="109728" cy="109728"/>
-          </a:xfrm>
-          <a:prstGeom prst="ellipse">
-            <a:avLst/>
-          </a:prstGeom>
-          <a:solidFill>
-            <a:srgbClr val="4E88E6"/>
-          </a:solidFill>
-          <a:ln>
-            <a:noFill/>
-          </a:ln>
-        </p:spPr>
-        <p:style>
-          <a:lnRef idx="1">
-            <a:schemeClr val="accent1"/>
-          </a:lnRef>
-          <a:fillRef idx="3">
-            <a:schemeClr val="accent1"/>
-          </a:fillRef>
-          <a:effectRef idx="2">
-            <a:schemeClr val="accent1"/>
-          </a:effectRef>
-          <a:fontRef idx="minor">
-            <a:schemeClr val="lt1"/>
-          </a:fontRef>
-        </p:style>
-        <p:txBody>
-          <a:bodyPr rtlCol="0" anchor="ctr"/>
-          <a:lstStyle/>
-          <a:p>
-            <a:pPr algn="ctr"/>
-          </a:p>
-        </p:txBody>
-      </p:sp>
-      <p:sp>
-        <p:nvSpPr>
-          <p:cNvPr id="75" name="TextBox 74"/>
-          <p:cNvSpPr txBox="1"/>
-          <p:nvPr/>
-        </p:nvSpPr>
-        <p:spPr>
-          <a:xfrm>
-            <a:off x="621792" y="6336792"/>
-            <a:ext cx="1463040" cy="201168"/>
-          </a:xfrm>
-          <a:prstGeom prst="rect">
-            <a:avLst/>
-          </a:prstGeom>
-          <a:noFill/>
-        </p:spPr>
-        <p:txBody>
-          <a:bodyPr wrap="none">
-            <a:spAutoFit/>
-          </a:bodyPr>
-          <a:lstStyle/>
-          <a:p>
-            <a:r>
-              <a:rPr sz="800" b="0" i="0">
+            <a:r>
+              <a:rPr sz="900" b="1" i="0">
+                <a:solidFill>
+                  <a:srgbClr val="1F4CA6"/>
+                </a:solidFill>
+                <a:latin typeface="Calibri"/>
+              </a:rPr>
+              <a:t>Scoring API guardrails:  </a:t>
+            </a:r>
+            <a:r>
+              <a:rPr sz="900" b="0" i="0">
                 <a:solidFill>
                   <a:srgbClr val="333F52"/>
                 </a:solidFill>
                 <a:latin typeface="Calibri"/>
               </a:rPr>
-              <a:t>Service</a:t>
-            </a:r>
-          </a:p>
-        </p:txBody>
-      </p:sp>
-      <p:sp>
-        <p:nvSpPr>
-          <p:cNvPr id="76" name="Oval 75"/>
-          <p:cNvSpPr/>
-          <p:nvPr/>
-        </p:nvSpPr>
-        <p:spPr>
-          <a:xfrm>
-            <a:off x="1874520" y="6373368"/>
-            <a:ext cx="109728" cy="109728"/>
-          </a:xfrm>
-          <a:prstGeom prst="ellipse">
-            <a:avLst/>
-          </a:prstGeom>
-          <a:solidFill>
-            <a:srgbClr val="34A853"/>
-          </a:solidFill>
-          <a:ln>
-            <a:noFill/>
-          </a:ln>
-        </p:spPr>
-        <p:style>
-          <a:lnRef idx="1">
-            <a:schemeClr val="accent1"/>
-          </a:lnRef>
-          <a:fillRef idx="3">
-            <a:schemeClr val="accent1"/>
-          </a:fillRef>
-          <a:effectRef idx="2">
-            <a:schemeClr val="accent1"/>
-          </a:effectRef>
-          <a:fontRef idx="minor">
-            <a:schemeClr val="lt1"/>
-          </a:fontRef>
-        </p:style>
-        <p:txBody>
-          <a:bodyPr rtlCol="0" anchor="ctr"/>
-          <a:lstStyle/>
-          <a:p>
-            <a:pPr algn="ctr"/>
-          </a:p>
-        </p:txBody>
-      </p:sp>
-      <p:sp>
-        <p:nvSpPr>
-          <p:cNvPr id="77" name="TextBox 76"/>
-          <p:cNvSpPr txBox="1"/>
-          <p:nvPr/>
-        </p:nvSpPr>
-        <p:spPr>
-          <a:xfrm>
-            <a:off x="2039112" y="6336792"/>
-            <a:ext cx="1463040" cy="201168"/>
-          </a:xfrm>
-          <a:prstGeom prst="rect">
-            <a:avLst/>
-          </a:prstGeom>
-          <a:noFill/>
-        </p:spPr>
-        <p:txBody>
-          <a:bodyPr wrap="none">
-            <a:spAutoFit/>
-          </a:bodyPr>
-          <a:lstStyle/>
-          <a:p>
-            <a:r>
-              <a:rPr sz="800" b="0" i="0">
+              <a:t>prediction bounds  ·  negative clamp  ·  model &amp; BigQuery timeouts  ·  anomaly window  ·  circuit-breaker  ·  kill-switch.</a:t>
+            </a:r>
+          </a:p>
+          <a:p>
+            <a:r>
+              <a:rPr sz="900" b="1" i="0">
+                <a:solidFill>
+                  <a:srgbClr val="1F4CA6"/>
+                </a:solidFill>
+                <a:latin typeface="Calibri"/>
+              </a:rPr>
+              <a:t>Delivery:  </a:t>
+            </a:r>
+            <a:r>
+              <a:rPr sz="900" b="0" i="0">
                 <a:solidFill>
                   <a:srgbClr val="333F52"/>
                 </a:solidFill>
                 <a:latin typeface="Calibri"/>
               </a:rPr>
-              <a:t>ML/AI runtime</a:t>
-            </a:r>
-          </a:p>
-        </p:txBody>
-      </p:sp>
-      <p:sp>
-        <p:nvSpPr>
-          <p:cNvPr id="78" name="Oval 77"/>
-          <p:cNvSpPr/>
-          <p:nvPr/>
-        </p:nvSpPr>
-        <p:spPr>
-          <a:xfrm>
-            <a:off x="3291840" y="6373368"/>
-            <a:ext cx="109728" cy="109728"/>
-          </a:xfrm>
-          <a:prstGeom prst="ellipse">
-            <a:avLst/>
-          </a:prstGeom>
-          <a:solidFill>
-            <a:srgbClr val="0097A7"/>
-          </a:solidFill>
-          <a:ln>
-            <a:noFill/>
-          </a:ln>
-        </p:spPr>
-        <p:style>
-          <a:lnRef idx="1">
-            <a:schemeClr val="accent1"/>
-          </a:lnRef>
-          <a:fillRef idx="3">
-            <a:schemeClr val="accent1"/>
-          </a:fillRef>
-          <a:effectRef idx="2">
-            <a:schemeClr val="accent1"/>
-          </a:effectRef>
-          <a:fontRef idx="minor">
-            <a:schemeClr val="lt1"/>
-          </a:fontRef>
-        </p:style>
-        <p:txBody>
-          <a:bodyPr rtlCol="0" anchor="ctr"/>
-          <a:lstStyle/>
-          <a:p>
-            <a:pPr algn="ctr"/>
-          </a:p>
-        </p:txBody>
-      </p:sp>
-      <p:sp>
-        <p:nvSpPr>
-          <p:cNvPr id="79" name="TextBox 78"/>
-          <p:cNvSpPr txBox="1"/>
-          <p:nvPr/>
-        </p:nvSpPr>
-        <p:spPr>
-          <a:xfrm>
-            <a:off x="3456432" y="6336792"/>
-            <a:ext cx="1463040" cy="201168"/>
-          </a:xfrm>
-          <a:prstGeom prst="rect">
-            <a:avLst/>
-          </a:prstGeom>
-          <a:noFill/>
-        </p:spPr>
-        <p:txBody>
-          <a:bodyPr wrap="none">
-            <a:spAutoFit/>
-          </a:bodyPr>
-          <a:lstStyle/>
-          <a:p>
-            <a:r>
-              <a:rPr sz="800" b="0" i="0">
-                <a:solidFill>
-                  <a:srgbClr val="333F52"/>
-                </a:solidFill>
-                <a:latin typeface="Calibri"/>
-              </a:rPr>
-              <a:t>ML pipeline</a:t>
-            </a:r>
-          </a:p>
-        </p:txBody>
-      </p:sp>
-      <p:sp>
-        <p:nvSpPr>
-          <p:cNvPr id="80" name="Oval 79"/>
-          <p:cNvSpPr/>
-          <p:nvPr/>
-        </p:nvSpPr>
-        <p:spPr>
-          <a:xfrm>
-            <a:off x="4709160" y="6373368"/>
-            <a:ext cx="109728" cy="109728"/>
-          </a:xfrm>
-          <a:prstGeom prst="ellipse">
-            <a:avLst/>
-          </a:prstGeom>
-          <a:solidFill>
-            <a:srgbClr val="7E57C2"/>
-          </a:solidFill>
-          <a:ln>
-            <a:noFill/>
-          </a:ln>
-        </p:spPr>
-        <p:style>
-          <a:lnRef idx="1">
-            <a:schemeClr val="accent1"/>
-          </a:lnRef>
-          <a:fillRef idx="3">
-            <a:schemeClr val="accent1"/>
-          </a:fillRef>
-          <a:effectRef idx="2">
-            <a:schemeClr val="accent1"/>
-          </a:effectRef>
-          <a:fontRef idx="minor">
-            <a:schemeClr val="lt1"/>
-          </a:fontRef>
-        </p:style>
-        <p:txBody>
-          <a:bodyPr rtlCol="0" anchor="ctr"/>
-          <a:lstStyle/>
-          <a:p>
-            <a:pPr algn="ctr"/>
-          </a:p>
-        </p:txBody>
-      </p:sp>
-      <p:sp>
-        <p:nvSpPr>
-          <p:cNvPr id="81" name="TextBox 80"/>
-          <p:cNvSpPr txBox="1"/>
-          <p:nvPr/>
-        </p:nvSpPr>
-        <p:spPr>
-          <a:xfrm>
-            <a:off x="4873752" y="6336792"/>
-            <a:ext cx="1463040" cy="201168"/>
-          </a:xfrm>
-          <a:prstGeom prst="rect">
-            <a:avLst/>
-          </a:prstGeom>
-          <a:noFill/>
-        </p:spPr>
-        <p:txBody>
-          <a:bodyPr wrap="none">
-            <a:spAutoFit/>
-          </a:bodyPr>
-          <a:lstStyle/>
-          <a:p>
-            <a:r>
-              <a:rPr sz="800" b="0" i="0">
-                <a:solidFill>
-                  <a:srgbClr val="333F52"/>
-                </a:solidFill>
-                <a:latin typeface="Calibri"/>
-              </a:rPr>
-              <a:t>Data warehouse</a:t>
-            </a:r>
-          </a:p>
-        </p:txBody>
-      </p:sp>
-      <p:sp>
-        <p:nvSpPr>
-          <p:cNvPr id="82" name="Oval 81"/>
-          <p:cNvSpPr/>
-          <p:nvPr/>
-        </p:nvSpPr>
-        <p:spPr>
-          <a:xfrm>
-            <a:off x="6126480" y="6373368"/>
-            <a:ext cx="109728" cy="109728"/>
-          </a:xfrm>
-          <a:prstGeom prst="ellipse">
-            <a:avLst/>
-          </a:prstGeom>
-          <a:solidFill>
-            <a:srgbClr val="A96BDB"/>
-          </a:solidFill>
-          <a:ln>
-            <a:noFill/>
-          </a:ln>
-        </p:spPr>
-        <p:style>
-          <a:lnRef idx="1">
-            <a:schemeClr val="accent1"/>
-          </a:lnRef>
-          <a:fillRef idx="3">
-            <a:schemeClr val="accent1"/>
-          </a:fillRef>
-          <a:effectRef idx="2">
-            <a:schemeClr val="accent1"/>
-          </a:effectRef>
-          <a:fontRef idx="minor">
-            <a:schemeClr val="lt1"/>
-          </a:fontRef>
-        </p:style>
-        <p:txBody>
-          <a:bodyPr rtlCol="0" anchor="ctr"/>
-          <a:lstStyle/>
-          <a:p>
-            <a:pPr algn="ctr"/>
-          </a:p>
-        </p:txBody>
-      </p:sp>
-      <p:sp>
-        <p:nvSpPr>
-          <p:cNvPr id="83" name="TextBox 82"/>
-          <p:cNvSpPr txBox="1"/>
-          <p:nvPr/>
-        </p:nvSpPr>
-        <p:spPr>
-          <a:xfrm>
-            <a:off x="6291072" y="6336792"/>
-            <a:ext cx="1463040" cy="201168"/>
-          </a:xfrm>
-          <a:prstGeom prst="rect">
-            <a:avLst/>
-          </a:prstGeom>
-          <a:noFill/>
-        </p:spPr>
-        <p:txBody>
-          <a:bodyPr wrap="none">
-            <a:spAutoFit/>
-          </a:bodyPr>
-          <a:lstStyle/>
-          <a:p>
-            <a:r>
-              <a:rPr sz="800" b="0" i="0">
-                <a:solidFill>
-                  <a:srgbClr val="333F52"/>
-                </a:solidFill>
-                <a:latin typeface="Calibri"/>
-              </a:rPr>
-              <a:t>Pub/Sub</a:t>
-            </a:r>
-          </a:p>
-        </p:txBody>
-      </p:sp>
-      <p:sp>
-        <p:nvSpPr>
-          <p:cNvPr id="84" name="Oval 83"/>
-          <p:cNvSpPr/>
-          <p:nvPr/>
-        </p:nvSpPr>
-        <p:spPr>
-          <a:xfrm>
-            <a:off x="7543800" y="6373368"/>
-            <a:ext cx="109728" cy="109728"/>
-          </a:xfrm>
-          <a:prstGeom prst="ellipse">
-            <a:avLst/>
-          </a:prstGeom>
-          <a:solidFill>
-            <a:srgbClr val="E87B1E"/>
-          </a:solidFill>
-          <a:ln>
-            <a:noFill/>
-          </a:ln>
-        </p:spPr>
-        <p:style>
-          <a:lnRef idx="1">
-            <a:schemeClr val="accent1"/>
-          </a:lnRef>
-          <a:fillRef idx="3">
-            <a:schemeClr val="accent1"/>
-          </a:fillRef>
-          <a:effectRef idx="2">
-            <a:schemeClr val="accent1"/>
-          </a:effectRef>
-          <a:fontRef idx="minor">
-            <a:schemeClr val="lt1"/>
-          </a:fontRef>
-        </p:style>
-        <p:txBody>
-          <a:bodyPr rtlCol="0" anchor="ctr"/>
-          <a:lstStyle/>
-          <a:p>
-            <a:pPr algn="ctr"/>
-          </a:p>
-        </p:txBody>
-      </p:sp>
-      <p:sp>
-        <p:nvSpPr>
-          <p:cNvPr id="85" name="TextBox 84"/>
-          <p:cNvSpPr txBox="1"/>
-          <p:nvPr/>
-        </p:nvSpPr>
-        <p:spPr>
-          <a:xfrm>
-            <a:off x="7708392" y="6336792"/>
-            <a:ext cx="1463040" cy="201168"/>
-          </a:xfrm>
-          <a:prstGeom prst="rect">
-            <a:avLst/>
-          </a:prstGeom>
-          <a:noFill/>
-        </p:spPr>
-        <p:txBody>
-          <a:bodyPr wrap="none">
-            <a:spAutoFit/>
-          </a:bodyPr>
-          <a:lstStyle/>
-          <a:p>
-            <a:r>
-              <a:rPr sz="800" b="0" i="0">
-                <a:solidFill>
-                  <a:srgbClr val="333F52"/>
-                </a:solidFill>
-                <a:latin typeface="Calibri"/>
-              </a:rPr>
-              <a:t>Data flow</a:t>
-            </a:r>
-          </a:p>
-        </p:txBody>
-      </p:sp>
-      <p:sp>
-        <p:nvSpPr>
-          <p:cNvPr id="86" name="Rectangle 85"/>
+              <a:t>GitHub  →  Workload Identity Federation  →  Cloud Build  →  Artifact Registry  →  Cloud Run, gated on test, coverage and supply-chain scans.</a:t>
+            </a:r>
+          </a:p>
+        </p:txBody>
+      </p:sp>
+      <p:sp>
+        <p:nvSpPr>
+          <p:cNvPr id="67" name="Rectangle 66"/>
           <p:cNvSpPr/>
           <p:nvPr/>
         </p:nvSpPr>
@@ -13359,7 +12453,7 @@
       </p:sp>
       <p:sp>
         <p:nvSpPr>
-          <p:cNvPr id="87" name="TextBox 86"/>
+          <p:cNvPr id="68" name="TextBox 67"/>
           <p:cNvSpPr txBox="1"/>
           <p:nvPr/>
         </p:nvSpPr>

</xml_diff>

<commit_message>
deck: embed external architecture diagram on slide 6
Uses the 11:57 render from the image tool (two known typos remain:
'Pyihon' → Python, 'Calbration' → Calibration). slide_architecture
now auto-embeds docs/architecture.png with aspect-preserving fit;
regenerate after replacing the image to refresh the slide.

Co-Authored-By: Claude Opus 4.7 (1M context) <noreply@anthropic.com>
</commit_message>
<xml_diff>
--- a/docs/client-demo-deck.pptx
+++ b/docs/client-demo-deck.pptx
@@ -9753,2655 +9753,33 @@
           </a:p>
         </p:txBody>
       </p:sp>
-      <p:sp>
-        <p:nvSpPr>
-          <p:cNvPr id="4" name="Rounded Rectangle 3"/>
-          <p:cNvSpPr/>
-          <p:nvPr/>
-        </p:nvSpPr>
-        <p:spPr>
-          <a:xfrm>
-            <a:off x="365760" y="1005840"/>
-            <a:ext cx="11460175" cy="5120640"/>
-          </a:xfrm>
-          <a:prstGeom prst="roundRect">
-            <a:avLst>
-              <a:gd name="adj" fmla="val 1500"/>
-            </a:avLst>
-          </a:prstGeom>
-          <a:solidFill>
-            <a:srgbClr val="F1F3F8"/>
-          </a:solidFill>
-          <a:ln w="12700">
-            <a:solidFill>
-              <a:srgbClr val="C9CFDA"/>
-            </a:solidFill>
-          </a:ln>
-        </p:spPr>
-        <p:style>
-          <a:lnRef idx="1">
-            <a:schemeClr val="accent1"/>
-          </a:lnRef>
-          <a:fillRef idx="3">
-            <a:schemeClr val="accent1"/>
-          </a:fillRef>
-          <a:effectRef idx="2">
-            <a:schemeClr val="accent1"/>
-          </a:effectRef>
-          <a:fontRef idx="minor">
-            <a:schemeClr val="lt1"/>
-          </a:fontRef>
-        </p:style>
-        <p:txBody>
-          <a:bodyPr rtlCol="0" anchor="ctr"/>
-          <a:lstStyle/>
-          <a:p>
-            <a:pPr algn="ctr"/>
-          </a:p>
-        </p:txBody>
-      </p:sp>
-      <p:sp>
-        <p:nvSpPr>
-          <p:cNvPr id="5" name="TextBox 4"/>
-          <p:cNvSpPr txBox="1"/>
-          <p:nvPr/>
-        </p:nvSpPr>
-        <p:spPr>
-          <a:xfrm>
-            <a:off x="530352" y="1060704"/>
-            <a:ext cx="7315200" cy="274320"/>
-          </a:xfrm>
-          <a:prstGeom prst="rect">
-            <a:avLst/>
-          </a:prstGeom>
-          <a:noFill/>
-        </p:spPr>
-        <p:txBody>
-          <a:bodyPr wrap="none">
-            <a:spAutoFit/>
-          </a:bodyPr>
-          <a:lstStyle/>
-          <a:p>
-            <a:r>
-              <a:rPr sz="1100" b="1" i="0">
-                <a:solidFill>
-                  <a:srgbClr val="0B1F3A"/>
-                </a:solidFill>
-                <a:latin typeface="Calibri"/>
-              </a:rPr>
-              <a:t>Google Cloud Platform</a:t>
-            </a:r>
-            <a:r>
-              <a:rPr sz="1000" b="0" i="1">
-                <a:solidFill>
-                  <a:srgbClr val="6B7380"/>
-                </a:solidFill>
-                <a:latin typeface="Calibri"/>
-              </a:rPr>
-              <a:t>    europe-west2 (London)</a:t>
-            </a:r>
-          </a:p>
-        </p:txBody>
-      </p:sp>
-      <p:sp>
-        <p:nvSpPr>
-          <p:cNvPr id="6" name="Rectangle 5"/>
-          <p:cNvSpPr/>
-          <p:nvPr/>
-        </p:nvSpPr>
-        <p:spPr>
-          <a:xfrm>
-            <a:off x="594360" y="1463040"/>
-            <a:ext cx="11002975" cy="1325880"/>
-          </a:xfrm>
-          <a:prstGeom prst="rect">
-            <a:avLst/>
-          </a:prstGeom>
-          <a:solidFill>
-            <a:srgbClr val="E8EFF7"/>
-          </a:solidFill>
-          <a:ln w="6350">
-            <a:solidFill>
-              <a:srgbClr val="C9CFDA"/>
-            </a:solidFill>
-          </a:ln>
-        </p:spPr>
-        <p:style>
-          <a:lnRef idx="1">
-            <a:schemeClr val="accent1"/>
-          </a:lnRef>
-          <a:fillRef idx="3">
-            <a:schemeClr val="accent1"/>
-          </a:fillRef>
-          <a:effectRef idx="2">
-            <a:schemeClr val="accent1"/>
-          </a:effectRef>
-          <a:fontRef idx="minor">
-            <a:schemeClr val="lt1"/>
-          </a:fontRef>
-        </p:style>
-        <p:txBody>
-          <a:bodyPr rtlCol="0" anchor="ctr"/>
-          <a:lstStyle/>
-          <a:p>
-            <a:pPr algn="ctr"/>
-          </a:p>
-        </p:txBody>
-      </p:sp>
-      <p:sp>
-        <p:nvSpPr>
-          <p:cNvPr id="7" name="TextBox 6"/>
-          <p:cNvSpPr txBox="1"/>
-          <p:nvPr/>
-        </p:nvSpPr>
-        <p:spPr>
-          <a:xfrm>
-            <a:off x="685800" y="1508760"/>
-            <a:ext cx="2743200" cy="228600"/>
-          </a:xfrm>
-          <a:prstGeom prst="rect">
-            <a:avLst/>
-          </a:prstGeom>
-          <a:noFill/>
-        </p:spPr>
-        <p:txBody>
-          <a:bodyPr wrap="none">
-            <a:spAutoFit/>
-          </a:bodyPr>
-          <a:lstStyle/>
-          <a:p>
-            <a:r>
-              <a:rPr sz="800" b="1" i="0">
-                <a:solidFill>
-                  <a:srgbClr val="6B7380"/>
-                </a:solidFill>
-                <a:latin typeface="Calibri"/>
-              </a:rPr>
-              <a:t>HOT PATH · SERVING</a:t>
-            </a:r>
-          </a:p>
-        </p:txBody>
-      </p:sp>
-      <p:sp>
-        <p:nvSpPr>
-          <p:cNvPr id="8" name="Rectangle 7"/>
-          <p:cNvSpPr/>
-          <p:nvPr/>
-        </p:nvSpPr>
-        <p:spPr>
-          <a:xfrm>
-            <a:off x="594360" y="2926080"/>
-            <a:ext cx="11002975" cy="1325880"/>
-          </a:xfrm>
-          <a:prstGeom prst="rect">
-            <a:avLst/>
-          </a:prstGeom>
-          <a:solidFill>
-            <a:srgbClr val="F1ECF8"/>
-          </a:solidFill>
-          <a:ln w="6350">
-            <a:solidFill>
-              <a:srgbClr val="C9CFDA"/>
-            </a:solidFill>
-          </a:ln>
-        </p:spPr>
-        <p:style>
-          <a:lnRef idx="1">
-            <a:schemeClr val="accent1"/>
-          </a:lnRef>
-          <a:fillRef idx="3">
-            <a:schemeClr val="accent1"/>
-          </a:fillRef>
-          <a:effectRef idx="2">
-            <a:schemeClr val="accent1"/>
-          </a:effectRef>
-          <a:fontRef idx="minor">
-            <a:schemeClr val="lt1"/>
-          </a:fontRef>
-        </p:style>
-        <p:txBody>
-          <a:bodyPr rtlCol="0" anchor="ctr"/>
-          <a:lstStyle/>
-          <a:p>
-            <a:pPr algn="ctr"/>
-          </a:p>
-        </p:txBody>
-      </p:sp>
-      <p:sp>
-        <p:nvSpPr>
-          <p:cNvPr id="9" name="TextBox 8"/>
-          <p:cNvSpPr txBox="1"/>
-          <p:nvPr/>
-        </p:nvSpPr>
-        <p:spPr>
-          <a:xfrm>
-            <a:off x="685800" y="2971800"/>
-            <a:ext cx="2743200" cy="228600"/>
-          </a:xfrm>
-          <a:prstGeom prst="rect">
-            <a:avLst/>
-          </a:prstGeom>
-          <a:noFill/>
-        </p:spPr>
-        <p:txBody>
-          <a:bodyPr wrap="none">
-            <a:spAutoFit/>
-          </a:bodyPr>
-          <a:lstStyle/>
-          <a:p>
-            <a:r>
-              <a:rPr sz="800" b="1" i="0">
-                <a:solidFill>
-                  <a:srgbClr val="6B7380"/>
-                </a:solidFill>
-                <a:latin typeface="Calibri"/>
-              </a:rPr>
-              <a:t>DATA PLANE · WAREHOUSE AND TRAINING</a:t>
-            </a:r>
-          </a:p>
-        </p:txBody>
-      </p:sp>
-      <p:sp>
-        <p:nvSpPr>
-          <p:cNvPr id="10" name="Rectangle 9"/>
-          <p:cNvSpPr/>
-          <p:nvPr/>
-        </p:nvSpPr>
-        <p:spPr>
-          <a:xfrm>
-            <a:off x="594360" y="4389120"/>
-            <a:ext cx="11002975" cy="1325880"/>
-          </a:xfrm>
-          <a:prstGeom prst="rect">
-            <a:avLst/>
-          </a:prstGeom>
-          <a:solidFill>
-            <a:srgbClr val="ECF3EE"/>
-          </a:solidFill>
-          <a:ln w="6350">
-            <a:solidFill>
-              <a:srgbClr val="C9CFDA"/>
-            </a:solidFill>
-          </a:ln>
-        </p:spPr>
-        <p:style>
-          <a:lnRef idx="1">
-            <a:schemeClr val="accent1"/>
-          </a:lnRef>
-          <a:fillRef idx="3">
-            <a:schemeClr val="accent1"/>
-          </a:fillRef>
-          <a:effectRef idx="2">
-            <a:schemeClr val="accent1"/>
-          </a:effectRef>
-          <a:fontRef idx="minor">
-            <a:schemeClr val="lt1"/>
-          </a:fontRef>
-        </p:style>
-        <p:txBody>
-          <a:bodyPr rtlCol="0" anchor="ctr"/>
-          <a:lstStyle/>
-          <a:p>
-            <a:pPr algn="ctr"/>
-          </a:p>
-        </p:txBody>
-      </p:sp>
-      <p:sp>
-        <p:nvSpPr>
-          <p:cNvPr id="11" name="TextBox 10"/>
-          <p:cNvSpPr txBox="1"/>
-          <p:nvPr/>
-        </p:nvSpPr>
-        <p:spPr>
-          <a:xfrm>
-            <a:off x="685800" y="4434840"/>
-            <a:ext cx="2743200" cy="228600"/>
-          </a:xfrm>
-          <a:prstGeom prst="rect">
-            <a:avLst/>
-          </a:prstGeom>
-          <a:noFill/>
-        </p:spPr>
-        <p:txBody>
-          <a:bodyPr wrap="none">
-            <a:spAutoFit/>
-          </a:bodyPr>
-          <a:lstStyle/>
-          <a:p>
-            <a:r>
-              <a:rPr sz="800" b="1" i="0">
-                <a:solidFill>
-                  <a:srgbClr val="6B7380"/>
-                </a:solidFill>
-                <a:latin typeface="Calibri"/>
-              </a:rPr>
-              <a:t>CONSUMPTION · RESILIENCE AND ACTIVATION</a:t>
-            </a:r>
-          </a:p>
-        </p:txBody>
-      </p:sp>
-      <p:sp>
-        <p:nvSpPr>
-          <p:cNvPr id="12" name="Rounded Rectangle 11"/>
-          <p:cNvSpPr/>
-          <p:nvPr/>
-        </p:nvSpPr>
-        <p:spPr>
-          <a:xfrm>
-            <a:off x="1554480" y="1874520"/>
-            <a:ext cx="2560320" cy="777240"/>
-          </a:xfrm>
-          <a:prstGeom prst="roundRect">
-            <a:avLst>
-              <a:gd name="adj" fmla="val 10000"/>
-            </a:avLst>
-          </a:prstGeom>
-          <a:solidFill>
-            <a:srgbClr val="4E88E6"/>
-          </a:solidFill>
-          <a:ln>
-            <a:noFill/>
-          </a:ln>
-        </p:spPr>
-        <p:style>
-          <a:lnRef idx="1">
-            <a:schemeClr val="accent1"/>
-          </a:lnRef>
-          <a:fillRef idx="3">
-            <a:schemeClr val="accent1"/>
-          </a:fillRef>
-          <a:effectRef idx="2">
-            <a:schemeClr val="accent1"/>
-          </a:effectRef>
-          <a:fontRef idx="minor">
-            <a:schemeClr val="lt1"/>
-          </a:fontRef>
-        </p:style>
-        <p:txBody>
-          <a:bodyPr rtlCol="0" anchor="ctr" lIns="73152" rIns="73152" wrap="square"/>
-          <a:lstStyle/>
-          <a:p>
-            <a:pPr algn="ctr"/>
-            <a:r>
-              <a:rPr sz="1100" b="1" i="0">
-                <a:solidFill>
-                  <a:srgbClr val="FFFFFF"/>
-                </a:solidFill>
-                <a:latin typeface="Calibri"/>
-              </a:rPr>
-              <a:t>Scoring API</a:t>
-            </a:r>
-          </a:p>
-          <a:p>
-            <a:pPr algn="ctr"/>
-            <a:r>
-              <a:rPr sz="800" b="0" i="0">
-                <a:solidFill>
-                  <a:srgbClr val="FFFFFF"/>
-                </a:solidFill>
-                <a:latin typeface="Calibri"/>
-              </a:rPr>
-              <a:t>Rust 1.89  ·  Cloud Run</a:t>
-            </a:r>
-          </a:p>
-        </p:txBody>
-      </p:sp>
-      <p:sp>
-        <p:nvSpPr>
-          <p:cNvPr id="13" name="Rounded Rectangle 12"/>
-          <p:cNvSpPr/>
-          <p:nvPr/>
-        </p:nvSpPr>
-        <p:spPr>
-          <a:xfrm>
-            <a:off x="4937760" y="1874520"/>
-            <a:ext cx="2377440" cy="777240"/>
-          </a:xfrm>
-          <a:prstGeom prst="roundRect">
-            <a:avLst>
-              <a:gd name="adj" fmla="val 10000"/>
-            </a:avLst>
-          </a:prstGeom>
-          <a:solidFill>
-            <a:srgbClr val="34A853"/>
-          </a:solidFill>
-          <a:ln>
-            <a:noFill/>
-          </a:ln>
-        </p:spPr>
-        <p:style>
-          <a:lnRef idx="1">
-            <a:schemeClr val="accent1"/>
-          </a:lnRef>
-          <a:fillRef idx="3">
-            <a:schemeClr val="accent1"/>
-          </a:fillRef>
-          <a:effectRef idx="2">
-            <a:schemeClr val="accent1"/>
-          </a:effectRef>
-          <a:fontRef idx="minor">
-            <a:schemeClr val="lt1"/>
-          </a:fontRef>
-        </p:style>
-        <p:txBody>
-          <a:bodyPr rtlCol="0" anchor="ctr" lIns="73152" rIns="73152" wrap="square"/>
-          <a:lstStyle/>
-          <a:p>
-            <a:pPr algn="ctr"/>
-            <a:r>
-              <a:rPr sz="1100" b="1" i="0">
-                <a:solidFill>
-                  <a:srgbClr val="FFFFFF"/>
-                </a:solidFill>
-                <a:latin typeface="Calibri"/>
-              </a:rPr>
-              <a:t>Vertex AI Endpoint</a:t>
-            </a:r>
-          </a:p>
-          <a:p>
-            <a:pPr algn="ctr"/>
-            <a:r>
-              <a:rPr sz="800" b="0" i="0">
-                <a:solidFill>
-                  <a:srgbClr val="FFFFFF"/>
-                </a:solidFill>
-                <a:latin typeface="Calibri"/>
-              </a:rPr>
-              <a:t>XGBoost regressor</a:t>
-            </a:r>
-          </a:p>
-        </p:txBody>
-      </p:sp>
-      <p:sp>
-        <p:nvSpPr>
-          <p:cNvPr id="14" name="Rounded Rectangle 13"/>
-          <p:cNvSpPr/>
-          <p:nvPr/>
-        </p:nvSpPr>
-        <p:spPr>
-          <a:xfrm>
-            <a:off x="9052560" y="1874520"/>
-            <a:ext cx="2377440" cy="777240"/>
-          </a:xfrm>
-          <a:prstGeom prst="roundRect">
-            <a:avLst>
-              <a:gd name="adj" fmla="val 10000"/>
-            </a:avLst>
-          </a:prstGeom>
-          <a:solidFill>
-            <a:srgbClr val="4E88E6"/>
-          </a:solidFill>
-          <a:ln>
-            <a:noFill/>
-          </a:ln>
-        </p:spPr>
-        <p:style>
-          <a:lnRef idx="1">
-            <a:schemeClr val="accent1"/>
-          </a:lnRef>
-          <a:fillRef idx="3">
-            <a:schemeClr val="accent1"/>
-          </a:fillRef>
-          <a:effectRef idx="2">
-            <a:schemeClr val="accent1"/>
-          </a:effectRef>
-          <a:fontRef idx="minor">
-            <a:schemeClr val="lt1"/>
-          </a:fontRef>
-        </p:style>
-        <p:txBody>
-          <a:bodyPr rtlCol="0" anchor="ctr" lIns="73152" rIns="73152" wrap="square"/>
-          <a:lstStyle/>
-          <a:p>
-            <a:pPr algn="ctr"/>
-            <a:r>
-              <a:rPr sz="1100" b="1" i="0">
-                <a:solidFill>
-                  <a:srgbClr val="FFFFFF"/>
-                </a:solidFill>
-                <a:latin typeface="Calibri"/>
-              </a:rPr>
-              <a:t>Dashboard UI</a:t>
-            </a:r>
-          </a:p>
-          <a:p>
-            <a:pPr algn="ctr"/>
-            <a:r>
-              <a:rPr sz="800" b="0" i="0">
-                <a:solidFill>
-                  <a:srgbClr val="FFFFFF"/>
-                </a:solidFill>
-                <a:latin typeface="Calibri"/>
-              </a:rPr>
-              <a:t>TypeScript · React · nginx · Cloud Run</a:t>
-            </a:r>
-          </a:p>
-        </p:txBody>
-      </p:sp>
-      <p:sp>
-        <p:nvSpPr>
-          <p:cNvPr id="15" name="Oval 14"/>
-          <p:cNvSpPr/>
-          <p:nvPr/>
-        </p:nvSpPr>
-        <p:spPr>
-          <a:xfrm>
-            <a:off x="777240" y="1920240"/>
-            <a:ext cx="201168" cy="201168"/>
-          </a:xfrm>
-          <a:prstGeom prst="ellipse">
-            <a:avLst/>
-          </a:prstGeom>
-          <a:solidFill>
-            <a:srgbClr val="333F52"/>
-          </a:solidFill>
-          <a:ln>
-            <a:noFill/>
-          </a:ln>
-        </p:spPr>
-        <p:style>
-          <a:lnRef idx="1">
-            <a:schemeClr val="accent1"/>
-          </a:lnRef>
-          <a:fillRef idx="3">
-            <a:schemeClr val="accent1"/>
-          </a:fillRef>
-          <a:effectRef idx="2">
-            <a:schemeClr val="accent1"/>
-          </a:effectRef>
-          <a:fontRef idx="minor">
-            <a:schemeClr val="lt1"/>
-          </a:fontRef>
-        </p:style>
-        <p:txBody>
-          <a:bodyPr rtlCol="0" anchor="ctr"/>
-          <a:lstStyle/>
-          <a:p>
-            <a:pPr algn="ctr"/>
-          </a:p>
-        </p:txBody>
-      </p:sp>
-      <p:sp>
-        <p:nvSpPr>
-          <p:cNvPr id="16" name="Isosceles Triangle 15"/>
-          <p:cNvSpPr/>
-          <p:nvPr/>
-        </p:nvSpPr>
-        <p:spPr>
-          <a:xfrm>
-            <a:off x="640080" y="2103120"/>
-            <a:ext cx="475488" cy="384048"/>
-          </a:xfrm>
-          <a:prstGeom prst="triangle">
-            <a:avLst/>
-          </a:prstGeom>
-          <a:solidFill>
-            <a:srgbClr val="333F52"/>
-          </a:solidFill>
-          <a:ln>
-            <a:noFill/>
-          </a:ln>
-        </p:spPr>
-        <p:style>
-          <a:lnRef idx="1">
-            <a:schemeClr val="accent1"/>
-          </a:lnRef>
-          <a:fillRef idx="3">
-            <a:schemeClr val="accent1"/>
-          </a:fillRef>
-          <a:effectRef idx="2">
-            <a:schemeClr val="accent1"/>
-          </a:effectRef>
-          <a:fontRef idx="minor">
-            <a:schemeClr val="lt1"/>
-          </a:fontRef>
-        </p:style>
-        <p:txBody>
-          <a:bodyPr rtlCol="0" anchor="ctr"/>
-          <a:lstStyle/>
-          <a:p>
-            <a:pPr algn="ctr"/>
-          </a:p>
-        </p:txBody>
-      </p:sp>
-      <p:sp>
-        <p:nvSpPr>
-          <p:cNvPr id="17" name="TextBox 16"/>
-          <p:cNvSpPr txBox="1"/>
-          <p:nvPr/>
-        </p:nvSpPr>
-        <p:spPr>
-          <a:xfrm>
-            <a:off x="457200" y="2514600"/>
-            <a:ext cx="841248" cy="274320"/>
-          </a:xfrm>
-          <a:prstGeom prst="rect">
-            <a:avLst/>
-          </a:prstGeom>
-          <a:noFill/>
-        </p:spPr>
-        <p:txBody>
-          <a:bodyPr wrap="none">
-            <a:spAutoFit/>
-          </a:bodyPr>
-          <a:lstStyle/>
-          <a:p>
-            <a:pPr algn="ctr"/>
-            <a:r>
-              <a:rPr sz="900" b="1" i="0">
-                <a:solidFill>
-                  <a:srgbClr val="333F52"/>
-                </a:solidFill>
-                <a:latin typeface="Calibri"/>
-              </a:rPr>
-              <a:t>Client</a:t>
-            </a:r>
-          </a:p>
-        </p:txBody>
-      </p:sp>
-      <p:sp>
-        <p:nvSpPr>
-          <p:cNvPr id="18" name="Oval 17"/>
-          <p:cNvSpPr/>
-          <p:nvPr/>
-        </p:nvSpPr>
-        <p:spPr>
-          <a:xfrm>
-            <a:off x="11155680" y="1920240"/>
-            <a:ext cx="201168" cy="201168"/>
-          </a:xfrm>
-          <a:prstGeom prst="ellipse">
-            <a:avLst/>
-          </a:prstGeom>
-          <a:solidFill>
-            <a:srgbClr val="333F52"/>
-          </a:solidFill>
-          <a:ln>
-            <a:noFill/>
-          </a:ln>
-        </p:spPr>
-        <p:style>
-          <a:lnRef idx="1">
-            <a:schemeClr val="accent1"/>
-          </a:lnRef>
-          <a:fillRef idx="3">
-            <a:schemeClr val="accent1"/>
-          </a:fillRef>
-          <a:effectRef idx="2">
-            <a:schemeClr val="accent1"/>
-          </a:effectRef>
-          <a:fontRef idx="minor">
-            <a:schemeClr val="lt1"/>
-          </a:fontRef>
-        </p:style>
-        <p:txBody>
-          <a:bodyPr rtlCol="0" anchor="ctr"/>
-          <a:lstStyle/>
-          <a:p>
-            <a:pPr algn="ctr"/>
-          </a:p>
-        </p:txBody>
-      </p:sp>
-      <p:sp>
-        <p:nvSpPr>
-          <p:cNvPr id="19" name="Isosceles Triangle 18"/>
-          <p:cNvSpPr/>
-          <p:nvPr/>
-        </p:nvSpPr>
-        <p:spPr>
-          <a:xfrm>
-            <a:off x="11018520" y="2103120"/>
-            <a:ext cx="475488" cy="384048"/>
-          </a:xfrm>
-          <a:prstGeom prst="triangle">
-            <a:avLst/>
-          </a:prstGeom>
-          <a:solidFill>
-            <a:srgbClr val="333F52"/>
-          </a:solidFill>
-          <a:ln>
-            <a:noFill/>
-          </a:ln>
-        </p:spPr>
-        <p:style>
-          <a:lnRef idx="1">
-            <a:schemeClr val="accent1"/>
-          </a:lnRef>
-          <a:fillRef idx="3">
-            <a:schemeClr val="accent1"/>
-          </a:fillRef>
-          <a:effectRef idx="2">
-            <a:schemeClr val="accent1"/>
-          </a:effectRef>
-          <a:fontRef idx="minor">
-            <a:schemeClr val="lt1"/>
-          </a:fontRef>
-        </p:style>
-        <p:txBody>
-          <a:bodyPr rtlCol="0" anchor="ctr"/>
-          <a:lstStyle/>
-          <a:p>
-            <a:pPr algn="ctr"/>
-          </a:p>
-        </p:txBody>
-      </p:sp>
-      <p:sp>
-        <p:nvSpPr>
-          <p:cNvPr id="20" name="TextBox 19"/>
-          <p:cNvSpPr txBox="1"/>
-          <p:nvPr/>
-        </p:nvSpPr>
-        <p:spPr>
-          <a:xfrm>
-            <a:off x="10835640" y="2514600"/>
-            <a:ext cx="841248" cy="274320"/>
-          </a:xfrm>
-          <a:prstGeom prst="rect">
-            <a:avLst/>
-          </a:prstGeom>
-          <a:noFill/>
-        </p:spPr>
-        <p:txBody>
-          <a:bodyPr wrap="none">
-            <a:spAutoFit/>
-          </a:bodyPr>
-          <a:lstStyle/>
-          <a:p>
-            <a:pPr algn="ctr"/>
-            <a:r>
-              <a:rPr sz="900" b="1" i="0">
-                <a:solidFill>
-                  <a:srgbClr val="333F52"/>
-                </a:solidFill>
-                <a:latin typeface="Calibri"/>
-              </a:rPr>
-              <a:t>Executive</a:t>
-            </a:r>
-          </a:p>
-        </p:txBody>
-      </p:sp>
-      <p:cxnSp>
-        <p:nvCxnSpPr>
-          <p:cNvPr id="21" name="Connector 20"/>
-          <p:cNvCxnSpPr/>
-          <p:nvPr/>
-        </p:nvCxnSpPr>
-        <p:spPr>
-          <a:xfrm>
-            <a:off x="1143000" y="2226564.0"/>
-            <a:ext cx="411480" cy="0.0"/>
-          </a:xfrm>
-          <a:prstGeom prst="line">
-            <a:avLst/>
-          </a:prstGeom>
-          <a:ln w="15875">
-            <a:solidFill>
-              <a:srgbClr val="46556B"/>
-            </a:solidFill>
-            <a:tailEnd type="triangle" w="med" h="med"/>
-          </a:ln>
-        </p:spPr>
-        <p:style>
-          <a:lnRef idx="2">
-            <a:schemeClr val="accent1"/>
-          </a:lnRef>
-          <a:fillRef idx="0">
-            <a:schemeClr val="accent1"/>
-          </a:fillRef>
-          <a:effectRef idx="1">
-            <a:schemeClr val="accent1"/>
-          </a:effectRef>
-          <a:fontRef idx="minor">
-            <a:schemeClr val="tx1"/>
-          </a:fontRef>
-        </p:style>
-      </p:cxnSp>
-      <p:sp>
-        <p:nvSpPr>
-          <p:cNvPr id="22" name="TextBox 21"/>
-          <p:cNvSpPr txBox="1"/>
-          <p:nvPr/>
-        </p:nvSpPr>
-        <p:spPr>
-          <a:xfrm>
-            <a:off x="1143000" y="1970532"/>
-            <a:ext cx="502920" cy="182880"/>
-          </a:xfrm>
-          <a:prstGeom prst="rect">
-            <a:avLst/>
-          </a:prstGeom>
-          <a:noFill/>
-        </p:spPr>
-        <p:txBody>
-          <a:bodyPr wrap="square" lIns="18288" rIns="18288" tIns="0" bIns="0">
-            <a:spAutoFit/>
-          </a:bodyPr>
-          <a:lstStyle/>
-          <a:p>
-            <a:pPr algn="ctr"/>
-            <a:r>
-              <a:rPr sz="700" b="0" i="1">
-                <a:solidFill>
-                  <a:srgbClr val="6B7380"/>
-                </a:solidFill>
-                <a:latin typeface="Calibri"/>
-              </a:rPr>
-              <a:t>HTTPS</a:t>
-            </a:r>
-          </a:p>
-        </p:txBody>
-      </p:sp>
-      <p:cxnSp>
-        <p:nvCxnSpPr>
-          <p:cNvPr id="23" name="Connector 22"/>
-          <p:cNvCxnSpPr/>
-          <p:nvPr/>
-        </p:nvCxnSpPr>
-        <p:spPr>
-          <a:xfrm>
-            <a:off x="4114800" y="2125980.0"/>
-            <a:ext cx="822960" cy="0.0"/>
-          </a:xfrm>
-          <a:prstGeom prst="line">
-            <a:avLst/>
-          </a:prstGeom>
-          <a:ln w="15875">
-            <a:solidFill>
-              <a:srgbClr val="46556B"/>
-            </a:solidFill>
-            <a:tailEnd type="triangle" w="med" h="med"/>
-          </a:ln>
-        </p:spPr>
-        <p:style>
-          <a:lnRef idx="2">
-            <a:schemeClr val="accent1"/>
-          </a:lnRef>
-          <a:fillRef idx="0">
-            <a:schemeClr val="accent1"/>
-          </a:fillRef>
-          <a:effectRef idx="1">
-            <a:schemeClr val="accent1"/>
-          </a:effectRef>
-          <a:fontRef idx="minor">
-            <a:schemeClr val="tx1"/>
-          </a:fontRef>
-        </p:style>
-      </p:cxnSp>
-      <p:sp>
-        <p:nvSpPr>
-          <p:cNvPr id="24" name="TextBox 23"/>
-          <p:cNvSpPr txBox="1"/>
-          <p:nvPr/>
-        </p:nvSpPr>
-        <p:spPr>
-          <a:xfrm>
-            <a:off x="4114800" y="1933956"/>
-            <a:ext cx="822960" cy="182880"/>
-          </a:xfrm>
-          <a:prstGeom prst="rect">
-            <a:avLst/>
-          </a:prstGeom>
-          <a:noFill/>
-        </p:spPr>
-        <p:txBody>
-          <a:bodyPr wrap="square" lIns="18288" rIns="18288" tIns="0" bIns="0">
-            <a:spAutoFit/>
-          </a:bodyPr>
-          <a:lstStyle/>
-          <a:p>
-            <a:pPr algn="ctr"/>
-            <a:r>
-              <a:rPr sz="700" b="0" i="1">
-                <a:solidFill>
-                  <a:srgbClr val="6B7380"/>
-                </a:solidFill>
-                <a:latin typeface="Calibri"/>
-              </a:rPr>
-              <a:t>predict</a:t>
-            </a:r>
-          </a:p>
-        </p:txBody>
-      </p:sp>
-      <p:cxnSp>
-        <p:nvCxnSpPr>
-          <p:cNvPr id="25" name="Connector 24"/>
-          <p:cNvCxnSpPr/>
-          <p:nvPr/>
-        </p:nvCxnSpPr>
-        <p:spPr>
-          <a:xfrm flipH="1">
-            <a:off x="4114800" y="2400300.0"/>
-            <a:ext cx="822960" cy="0.0"/>
-          </a:xfrm>
-          <a:prstGeom prst="line">
-            <a:avLst/>
-          </a:prstGeom>
-          <a:ln w="15875">
-            <a:solidFill>
-              <a:srgbClr val="46556B"/>
-            </a:solidFill>
-            <a:tailEnd type="triangle" w="med" h="med"/>
-          </a:ln>
-        </p:spPr>
-        <p:style>
-          <a:lnRef idx="2">
-            <a:schemeClr val="accent1"/>
-          </a:lnRef>
-          <a:fillRef idx="0">
-            <a:schemeClr val="accent1"/>
-          </a:fillRef>
-          <a:effectRef idx="1">
-            <a:schemeClr val="accent1"/>
-          </a:effectRef>
-          <a:fontRef idx="minor">
-            <a:schemeClr val="tx1"/>
-          </a:fontRef>
-        </p:style>
-      </p:cxnSp>
-      <p:sp>
-        <p:nvSpPr>
-          <p:cNvPr id="26" name="TextBox 25"/>
-          <p:cNvSpPr txBox="1"/>
-          <p:nvPr/>
-        </p:nvSpPr>
-        <p:spPr>
-          <a:xfrm>
-            <a:off x="4114800" y="2400300"/>
-            <a:ext cx="822960" cy="182880"/>
-          </a:xfrm>
-          <a:prstGeom prst="rect">
-            <a:avLst/>
-          </a:prstGeom>
-          <a:noFill/>
-        </p:spPr>
-        <p:txBody>
-          <a:bodyPr wrap="square" lIns="18288" rIns="18288" tIns="0" bIns="0">
-            <a:spAutoFit/>
-          </a:bodyPr>
-          <a:lstStyle/>
-          <a:p>
-            <a:pPr algn="ctr"/>
-            <a:r>
-              <a:rPr sz="700" b="0" i="1">
-                <a:solidFill>
-                  <a:srgbClr val="6B7380"/>
-                </a:solidFill>
-                <a:latin typeface="Calibri"/>
-              </a:rPr>
-              <a:t>predicted_rpc</a:t>
-            </a:r>
-          </a:p>
-        </p:txBody>
-      </p:sp>
-      <p:cxnSp>
-        <p:nvCxnSpPr>
-          <p:cNvPr id="27" name="Connector 26"/>
-          <p:cNvCxnSpPr/>
-          <p:nvPr/>
-        </p:nvCxnSpPr>
-        <p:spPr>
-          <a:xfrm flipH="1">
-            <a:off x="11430000" y="2263140.0"/>
-            <a:ext cx="45720" cy="0.0"/>
-          </a:xfrm>
-          <a:prstGeom prst="line">
-            <a:avLst/>
-          </a:prstGeom>
-          <a:ln w="15875">
-            <a:solidFill>
-              <a:srgbClr val="46556B"/>
-            </a:solidFill>
-            <a:tailEnd type="triangle" w="med" h="med"/>
-          </a:ln>
-        </p:spPr>
-        <p:style>
-          <a:lnRef idx="2">
-            <a:schemeClr val="accent1"/>
-          </a:lnRef>
-          <a:fillRef idx="0">
-            <a:schemeClr val="accent1"/>
-          </a:fillRef>
-          <a:effectRef idx="1">
-            <a:schemeClr val="accent1"/>
-          </a:effectRef>
-          <a:fontRef idx="minor">
-            <a:schemeClr val="tx1"/>
-          </a:fontRef>
-        </p:style>
-      </p:cxnSp>
-      <p:sp>
-        <p:nvSpPr>
-          <p:cNvPr id="28" name="Hexagon 27"/>
-          <p:cNvSpPr/>
-          <p:nvPr/>
-        </p:nvSpPr>
-        <p:spPr>
-          <a:xfrm>
-            <a:off x="2240280" y="3383280"/>
-            <a:ext cx="1188720" cy="502920"/>
-          </a:xfrm>
-          <a:prstGeom prst="hexagon">
-            <a:avLst/>
-          </a:prstGeom>
-          <a:solidFill>
-            <a:srgbClr val="A06CD6"/>
-          </a:solidFill>
-          <a:ln>
-            <a:noFill/>
-          </a:ln>
-        </p:spPr>
-        <p:style>
-          <a:lnRef idx="1">
-            <a:schemeClr val="accent1"/>
-          </a:lnRef>
-          <a:fillRef idx="3">
-            <a:schemeClr val="accent1"/>
-          </a:fillRef>
-          <a:effectRef idx="2">
-            <a:schemeClr val="accent1"/>
-          </a:effectRef>
-          <a:fontRef idx="minor">
-            <a:schemeClr val="lt1"/>
-          </a:fontRef>
-        </p:style>
-        <p:txBody>
-          <a:bodyPr rtlCol="0" anchor="ctr"/>
-          <a:lstStyle/>
-          <a:p>
-            <a:pPr algn="ctr"/>
-            <a:r>
-              <a:rPr sz="900" b="1" i="0">
-                <a:solidFill>
-                  <a:srgbClr val="FFFFFF"/>
-                </a:solidFill>
-                <a:latin typeface="Calibri"/>
-              </a:rPr>
-              <a:t>Pub/Sub</a:t>
-            </a:r>
-          </a:p>
-        </p:txBody>
-      </p:sp>
-      <p:sp>
-        <p:nvSpPr>
-          <p:cNvPr id="29" name="TextBox 28"/>
-          <p:cNvSpPr txBox="1"/>
-          <p:nvPr/>
-        </p:nvSpPr>
-        <p:spPr>
-          <a:xfrm>
-            <a:off x="2103120" y="3904488"/>
-            <a:ext cx="1463040" cy="201168"/>
-          </a:xfrm>
-          <a:prstGeom prst="rect">
-            <a:avLst/>
-          </a:prstGeom>
-          <a:noFill/>
-        </p:spPr>
-        <p:txBody>
-          <a:bodyPr wrap="none">
-            <a:spAutoFit/>
-          </a:bodyPr>
-          <a:lstStyle/>
-          <a:p>
-            <a:pPr algn="ctr"/>
-            <a:r>
-              <a:rPr sz="800" b="0" i="0">
-                <a:solidFill>
-                  <a:srgbClr val="333F52"/>
-                </a:solidFill>
-                <a:latin typeface="Calibri"/>
-              </a:rPr>
-              <a:t>rpc-predictions-staging</a:t>
-            </a:r>
-          </a:p>
-        </p:txBody>
-      </p:sp>
-      <p:sp>
-        <p:nvSpPr>
-          <p:cNvPr id="30" name="Rounded Rectangle 29"/>
-          <p:cNvSpPr/>
-          <p:nvPr/>
-        </p:nvSpPr>
-        <p:spPr>
-          <a:xfrm>
-            <a:off x="4937760" y="3264408"/>
-            <a:ext cx="2377440" cy="960120"/>
-          </a:xfrm>
-          <a:prstGeom prst="roundRect">
-            <a:avLst>
-              <a:gd name="adj" fmla="val 8000"/>
-            </a:avLst>
-          </a:prstGeom>
-          <a:solidFill>
-            <a:srgbClr val="7E57C2"/>
-          </a:solidFill>
-          <a:ln>
-            <a:noFill/>
-          </a:ln>
-        </p:spPr>
-        <p:style>
-          <a:lnRef idx="1">
-            <a:schemeClr val="accent1"/>
-          </a:lnRef>
-          <a:fillRef idx="3">
-            <a:schemeClr val="accent1"/>
-          </a:fillRef>
-          <a:effectRef idx="2">
-            <a:schemeClr val="accent1"/>
-          </a:effectRef>
-          <a:fontRef idx="minor">
-            <a:schemeClr val="lt1"/>
-          </a:fontRef>
-        </p:style>
-        <p:txBody>
-          <a:bodyPr rtlCol="0" anchor="ctr" wrap="square" lIns="73152" rIns="73152" tIns="54864"/>
-          <a:lstStyle/>
-          <a:p>
-            <a:pPr algn="ctr"/>
-            <a:r>
-              <a:rPr sz="1100" b="1" i="0">
-                <a:solidFill>
-                  <a:srgbClr val="FFFFFF"/>
-                </a:solidFill>
-                <a:latin typeface="Calibri"/>
-              </a:rPr>
-              <a:t>BigQuery</a:t>
-            </a:r>
-          </a:p>
-          <a:p>
-            <a:pPr algn="ctr"/>
-            <a:r>
-              <a:rPr sz="800" b="0" i="0">
-                <a:solidFill>
-                  <a:srgbClr val="FFFFFF"/>
-                </a:solidFill>
-                <a:latin typeface="Calibri"/>
-              </a:rPr>
-              <a:t>Data warehouse</a:t>
-            </a:r>
-          </a:p>
-          <a:p>
-            <a:pPr algn="ctr">
-              <a:spcBef>
-                <a:spcPts val="300"/>
-              </a:spcBef>
-            </a:pPr>
-            <a:r>
-              <a:rPr sz="700" b="0" i="1">
-                <a:solidFill>
-                  <a:srgbClr val="FFFFFF"/>
-                </a:solidFill>
-                <a:latin typeface="Calibri"/>
-              </a:rPr>
-              <a:t>rpc_predictions  ·  sales_ledger</a:t>
-            </a:r>
-          </a:p>
-          <a:p>
-            <a:pPr algn="ctr"/>
-            <a:r>
-              <a:rPr sz="700" b="0" i="1">
-                <a:solidFill>
-                  <a:srgbClr val="FFFFFF"/>
-                </a:solidFill>
-                <a:latin typeface="Calibri"/>
-              </a:rPr>
-              <a:t>predictions_vs_revenue</a:t>
-            </a:r>
-          </a:p>
-        </p:txBody>
-      </p:sp>
-      <p:sp>
-        <p:nvSpPr>
-          <p:cNvPr id="31" name="Rounded Rectangle 30"/>
-          <p:cNvSpPr/>
-          <p:nvPr/>
-        </p:nvSpPr>
-        <p:spPr>
-          <a:xfrm>
-            <a:off x="8229600" y="3337560"/>
-            <a:ext cx="2194560" cy="777240"/>
-          </a:xfrm>
-          <a:prstGeom prst="roundRect">
-            <a:avLst>
-              <a:gd name="adj" fmla="val 10000"/>
-            </a:avLst>
-          </a:prstGeom>
-          <a:solidFill>
-            <a:srgbClr val="0097A7"/>
-          </a:solidFill>
-          <a:ln>
-            <a:noFill/>
-          </a:ln>
-        </p:spPr>
-        <p:style>
-          <a:lnRef idx="1">
-            <a:schemeClr val="accent1"/>
-          </a:lnRef>
-          <a:fillRef idx="3">
-            <a:schemeClr val="accent1"/>
-          </a:fillRef>
-          <a:effectRef idx="2">
-            <a:schemeClr val="accent1"/>
-          </a:effectRef>
-          <a:fontRef idx="minor">
-            <a:schemeClr val="lt1"/>
-          </a:fontRef>
-        </p:style>
-        <p:txBody>
-          <a:bodyPr rtlCol="0" anchor="ctr" lIns="73152" rIns="73152" wrap="square"/>
-          <a:lstStyle/>
-          <a:p>
-            <a:pPr algn="ctr"/>
-            <a:r>
-              <a:rPr sz="1100" b="1" i="0">
-                <a:solidFill>
-                  <a:srgbClr val="FFFFFF"/>
-                </a:solidFill>
-                <a:latin typeface="Calibri"/>
-              </a:rPr>
-              <a:t>ML Ops Pipeline</a:t>
-            </a:r>
-          </a:p>
-          <a:p>
-            <a:pPr algn="ctr"/>
-            <a:r>
-              <a:rPr sz="800" b="0" i="0">
-                <a:solidFill>
-                  <a:srgbClr val="FFFFFF"/>
-                </a:solidFill>
-                <a:latin typeface="Calibri"/>
-              </a:rPr>
-              <a:t>Python 3.12  ·  Vertex AI Pipelines</a:t>
-            </a:r>
-          </a:p>
-        </p:txBody>
-      </p:sp>
-      <p:sp>
-        <p:nvSpPr>
-          <p:cNvPr id="32" name="Can 31"/>
-          <p:cNvSpPr/>
-          <p:nvPr/>
-        </p:nvSpPr>
-        <p:spPr>
-          <a:xfrm>
-            <a:off x="10698480" y="3337560"/>
-            <a:ext cx="640080" cy="777240"/>
-          </a:xfrm>
-          <a:prstGeom prst="can">
-            <a:avLst/>
-          </a:prstGeom>
-          <a:solidFill>
-            <a:srgbClr val="6B7380"/>
-          </a:solidFill>
-          <a:ln>
-            <a:noFill/>
-          </a:ln>
-        </p:spPr>
-        <p:style>
-          <a:lnRef idx="1">
-            <a:schemeClr val="accent1"/>
-          </a:lnRef>
-          <a:fillRef idx="3">
-            <a:schemeClr val="accent1"/>
-          </a:fillRef>
-          <a:effectRef idx="2">
-            <a:schemeClr val="accent1"/>
-          </a:effectRef>
-          <a:fontRef idx="minor">
-            <a:schemeClr val="lt1"/>
-          </a:fontRef>
-        </p:style>
-        <p:txBody>
-          <a:bodyPr rtlCol="0" anchor="ctr"/>
-          <a:lstStyle/>
-          <a:p>
-            <a:pPr algn="ctr"/>
-          </a:p>
-        </p:txBody>
-      </p:sp>
-      <p:sp>
-        <p:nvSpPr>
-          <p:cNvPr id="33" name="TextBox 32"/>
-          <p:cNvSpPr txBox="1"/>
-          <p:nvPr/>
-        </p:nvSpPr>
-        <p:spPr>
-          <a:xfrm>
-            <a:off x="10561320" y="4096512"/>
-            <a:ext cx="914400" cy="228600"/>
-          </a:xfrm>
-          <a:prstGeom prst="rect">
-            <a:avLst/>
-          </a:prstGeom>
-          <a:noFill/>
-        </p:spPr>
-        <p:txBody>
-          <a:bodyPr wrap="none">
-            <a:spAutoFit/>
-          </a:bodyPr>
-          <a:lstStyle/>
-          <a:p>
-            <a:pPr algn="ctr"/>
-            <a:r>
-              <a:rPr sz="700" b="1" i="0">
-                <a:solidFill>
-                  <a:srgbClr val="333F52"/>
-                </a:solidFill>
-                <a:latin typeface="Calibri"/>
-              </a:rPr>
-              <a:t>Cloud Storage</a:t>
-            </a:r>
-          </a:p>
-        </p:txBody>
-      </p:sp>
-      <p:cxnSp>
-        <p:nvCxnSpPr>
-          <p:cNvPr id="34" name="Connector 33"/>
-          <p:cNvCxnSpPr/>
-          <p:nvPr/>
-        </p:nvCxnSpPr>
-        <p:spPr>
-          <a:xfrm>
-            <a:off x="3429000.0" y="3634740.0"/>
-            <a:ext cx="1508760.0" cy="0.0"/>
-          </a:xfrm>
-          <a:prstGeom prst="line">
-            <a:avLst/>
-          </a:prstGeom>
-          <a:ln w="15875">
-            <a:solidFill>
-              <a:srgbClr val="46556B"/>
-            </a:solidFill>
-            <a:tailEnd type="triangle" w="med" h="med"/>
-          </a:ln>
-        </p:spPr>
-        <p:style>
-          <a:lnRef idx="2">
-            <a:schemeClr val="accent1"/>
-          </a:lnRef>
-          <a:fillRef idx="0">
-            <a:schemeClr val="accent1"/>
-          </a:fillRef>
-          <a:effectRef idx="1">
-            <a:schemeClr val="accent1"/>
-          </a:effectRef>
-          <a:fontRef idx="minor">
-            <a:schemeClr val="tx1"/>
-          </a:fontRef>
-        </p:style>
-      </p:cxnSp>
-      <p:sp>
-        <p:nvSpPr>
-          <p:cNvPr id="35" name="TextBox 34"/>
-          <p:cNvSpPr txBox="1"/>
-          <p:nvPr/>
-        </p:nvSpPr>
-        <p:spPr>
-          <a:xfrm>
-            <a:off x="3429000" y="3255264"/>
-            <a:ext cx="1508760" cy="164592"/>
-          </a:xfrm>
-          <a:prstGeom prst="rect">
-            <a:avLst/>
-          </a:prstGeom>
-          <a:noFill/>
-        </p:spPr>
-        <p:txBody>
-          <a:bodyPr wrap="square" lIns="18288" rIns="18288" tIns="0" bIns="0">
-            <a:spAutoFit/>
-          </a:bodyPr>
-          <a:lstStyle/>
-          <a:p>
-            <a:pPr algn="ctr"/>
-            <a:r>
-              <a:rPr sz="700" b="0" i="1">
-                <a:solidFill>
-                  <a:srgbClr val="6B7380"/>
-                </a:solidFill>
-                <a:latin typeface="Calibri"/>
-              </a:rPr>
-              <a:t>BigQuery sub</a:t>
-            </a:r>
-          </a:p>
-        </p:txBody>
-      </p:sp>
-      <p:cxnSp>
-        <p:nvCxnSpPr>
-          <p:cNvPr id="36" name="Connector 35"/>
-          <p:cNvCxnSpPr/>
-          <p:nvPr/>
-        </p:nvCxnSpPr>
-        <p:spPr>
-          <a:xfrm>
-            <a:off x="7315200" y="3726180.0"/>
-            <a:ext cx="914400" cy="0.0"/>
-          </a:xfrm>
-          <a:prstGeom prst="line">
-            <a:avLst/>
-          </a:prstGeom>
-          <a:ln w="15875">
-            <a:solidFill>
-              <a:srgbClr val="46556B"/>
-            </a:solidFill>
-            <a:tailEnd type="triangle" w="med" h="med"/>
-          </a:ln>
-        </p:spPr>
-        <p:style>
-          <a:lnRef idx="2">
-            <a:schemeClr val="accent1"/>
-          </a:lnRef>
-          <a:fillRef idx="0">
-            <a:schemeClr val="accent1"/>
-          </a:fillRef>
-          <a:effectRef idx="1">
-            <a:schemeClr val="accent1"/>
-          </a:effectRef>
-          <a:fontRef idx="minor">
-            <a:schemeClr val="tx1"/>
-          </a:fontRef>
-        </p:style>
-      </p:cxnSp>
-      <p:sp>
-        <p:nvSpPr>
-          <p:cNvPr id="37" name="TextBox 36"/>
-          <p:cNvSpPr txBox="1"/>
-          <p:nvPr/>
-        </p:nvSpPr>
-        <p:spPr>
-          <a:xfrm>
-            <a:off x="7315200" y="3525012"/>
-            <a:ext cx="914400" cy="182880"/>
-          </a:xfrm>
-          <a:prstGeom prst="rect">
-            <a:avLst/>
-          </a:prstGeom>
-          <a:noFill/>
-        </p:spPr>
-        <p:txBody>
-          <a:bodyPr wrap="square" lIns="18288" rIns="18288" tIns="0" bIns="0">
-            <a:spAutoFit/>
-          </a:bodyPr>
-          <a:lstStyle/>
-          <a:p>
-            <a:pPr algn="ctr"/>
-            <a:r>
-              <a:rPr sz="700" b="0" i="1">
-                <a:solidFill>
-                  <a:srgbClr val="6B7380"/>
-                </a:solidFill>
-                <a:latin typeface="Calibri"/>
-              </a:rPr>
-              <a:t>training data</a:t>
-            </a:r>
-          </a:p>
-        </p:txBody>
-      </p:sp>
-      <p:cxnSp>
-        <p:nvCxnSpPr>
-          <p:cNvPr id="38" name="Connector 37"/>
-          <p:cNvCxnSpPr/>
-          <p:nvPr/>
-        </p:nvCxnSpPr>
-        <p:spPr>
-          <a:xfrm>
-            <a:off x="10424160" y="3726180.0"/>
-            <a:ext cx="274320" cy="0.0"/>
-          </a:xfrm>
-          <a:prstGeom prst="line">
-            <a:avLst/>
-          </a:prstGeom>
-          <a:ln w="15875">
-            <a:solidFill>
-              <a:srgbClr val="46556B"/>
-            </a:solidFill>
-            <a:tailEnd type="triangle" w="med" h="med"/>
-          </a:ln>
-        </p:spPr>
-        <p:style>
-          <a:lnRef idx="2">
-            <a:schemeClr val="accent1"/>
-          </a:lnRef>
-          <a:fillRef idx="0">
-            <a:schemeClr val="accent1"/>
-          </a:fillRef>
-          <a:effectRef idx="1">
-            <a:schemeClr val="accent1"/>
-          </a:effectRef>
-          <a:fontRef idx="minor">
-            <a:schemeClr val="tx1"/>
-          </a:fontRef>
-        </p:style>
-      </p:cxnSp>
-      <p:sp>
-        <p:nvSpPr>
-          <p:cNvPr id="39" name="TextBox 38"/>
-          <p:cNvSpPr txBox="1"/>
-          <p:nvPr/>
-        </p:nvSpPr>
-        <p:spPr>
-          <a:xfrm>
-            <a:off x="10424160" y="3525012"/>
-            <a:ext cx="274320" cy="164592"/>
-          </a:xfrm>
-          <a:prstGeom prst="rect">
-            <a:avLst/>
-          </a:prstGeom>
-          <a:noFill/>
-        </p:spPr>
-        <p:txBody>
-          <a:bodyPr wrap="square" lIns="18288" rIns="18288" tIns="0" bIns="0">
-            <a:spAutoFit/>
-          </a:bodyPr>
-          <a:lstStyle/>
-          <a:p>
-            <a:pPr algn="ctr"/>
-            <a:r>
-              <a:rPr sz="700" b="0" i="1">
-                <a:solidFill>
-                  <a:srgbClr val="6B7380"/>
-                </a:solidFill>
-                <a:latin typeface="Calibri"/>
-              </a:rPr>
-              <a:t>artifacts</a:t>
-            </a:r>
-          </a:p>
-        </p:txBody>
-      </p:sp>
-      <p:cxnSp>
-        <p:nvCxnSpPr>
-          <p:cNvPr id="40" name="Connector 39"/>
-          <p:cNvCxnSpPr/>
-          <p:nvPr/>
-        </p:nvCxnSpPr>
-        <p:spPr>
-          <a:xfrm>
-            <a:off x="2834640.0" y="2651760"/>
-            <a:ext cx="0.0" cy="731520"/>
-          </a:xfrm>
-          <a:prstGeom prst="line">
-            <a:avLst/>
-          </a:prstGeom>
-          <a:ln w="15875">
-            <a:solidFill>
-              <a:srgbClr val="46556B"/>
-            </a:solidFill>
-            <a:tailEnd type="triangle" w="med" h="med"/>
-          </a:ln>
-        </p:spPr>
-        <p:style>
-          <a:lnRef idx="2">
-            <a:schemeClr val="accent1"/>
-          </a:lnRef>
-          <a:fillRef idx="0">
-            <a:schemeClr val="accent1"/>
-          </a:fillRef>
-          <a:effectRef idx="1">
-            <a:schemeClr val="accent1"/>
-          </a:effectRef>
-          <a:fontRef idx="minor">
-            <a:schemeClr val="tx1"/>
-          </a:fontRef>
-        </p:style>
-      </p:cxnSp>
-      <p:sp>
-        <p:nvSpPr>
-          <p:cNvPr id="41" name="TextBox 40"/>
-          <p:cNvSpPr txBox="1"/>
-          <p:nvPr/>
-        </p:nvSpPr>
-        <p:spPr>
-          <a:xfrm>
-            <a:off x="2331720" y="2670048"/>
-            <a:ext cx="1005840" cy="164592"/>
-          </a:xfrm>
-          <a:prstGeom prst="rect">
-            <a:avLst/>
-          </a:prstGeom>
-          <a:noFill/>
-        </p:spPr>
-        <p:txBody>
-          <a:bodyPr wrap="square" lIns="18288" rIns="18288" tIns="0" bIns="0">
-            <a:spAutoFit/>
-          </a:bodyPr>
-          <a:lstStyle/>
-          <a:p>
-            <a:pPr algn="ctr"/>
-            <a:r>
-              <a:rPr sz="700" b="0" i="1">
-                <a:solidFill>
-                  <a:srgbClr val="6B7380"/>
-                </a:solidFill>
-                <a:latin typeface="Calibri"/>
-              </a:rPr>
-              <a:t>emit prediction</a:t>
-            </a:r>
-          </a:p>
-        </p:txBody>
-      </p:sp>
-      <p:cxnSp>
-        <p:nvCxnSpPr>
-          <p:cNvPr id="42" name="Connector 41"/>
-          <p:cNvCxnSpPr/>
-          <p:nvPr/>
-        </p:nvCxnSpPr>
-        <p:spPr>
-          <a:xfrm flipV="1">
-            <a:off x="9326880.0" y="2857500.0"/>
-            <a:ext cx="0.0" cy="480060.0"/>
-          </a:xfrm>
-          <a:prstGeom prst="line">
-            <a:avLst/>
-          </a:prstGeom>
-          <a:ln w="12700">
-            <a:solidFill>
-              <a:srgbClr val="34A853"/>
-            </a:solidFill>
-          </a:ln>
-        </p:spPr>
-        <p:style>
-          <a:lnRef idx="2">
-            <a:schemeClr val="accent1"/>
-          </a:lnRef>
-          <a:fillRef idx="0">
-            <a:schemeClr val="accent1"/>
-          </a:fillRef>
-          <a:effectRef idx="1">
-            <a:schemeClr val="accent1"/>
-          </a:effectRef>
-          <a:fontRef idx="minor">
-            <a:schemeClr val="tx1"/>
-          </a:fontRef>
-        </p:style>
-      </p:cxnSp>
-      <p:cxnSp>
-        <p:nvCxnSpPr>
-          <p:cNvPr id="43" name="Connector 42"/>
-          <p:cNvCxnSpPr/>
-          <p:nvPr/>
-        </p:nvCxnSpPr>
-        <p:spPr>
-          <a:xfrm flipH="1">
-            <a:off x="6126480.0" y="2857500.0"/>
-            <a:ext cx="3200400.0" cy="0.0"/>
-          </a:xfrm>
-          <a:prstGeom prst="line">
-            <a:avLst/>
-          </a:prstGeom>
-          <a:ln w="12700">
-            <a:solidFill>
-              <a:srgbClr val="34A853"/>
-            </a:solidFill>
-          </a:ln>
-        </p:spPr>
-        <p:style>
-          <a:lnRef idx="2">
-            <a:schemeClr val="accent1"/>
-          </a:lnRef>
-          <a:fillRef idx="0">
-            <a:schemeClr val="accent1"/>
-          </a:fillRef>
-          <a:effectRef idx="1">
-            <a:schemeClr val="accent1"/>
-          </a:effectRef>
-          <a:fontRef idx="minor">
-            <a:schemeClr val="tx1"/>
-          </a:fontRef>
-        </p:style>
-      </p:cxnSp>
-      <p:cxnSp>
-        <p:nvCxnSpPr>
-          <p:cNvPr id="44" name="Connector 43"/>
-          <p:cNvCxnSpPr/>
-          <p:nvPr/>
-        </p:nvCxnSpPr>
-        <p:spPr>
-          <a:xfrm flipV="1">
-            <a:off x="6126480.0" y="2651760"/>
-            <a:ext cx="0.0" cy="205740.0"/>
-          </a:xfrm>
-          <a:prstGeom prst="line">
-            <a:avLst/>
-          </a:prstGeom>
-          <a:ln w="12700">
-            <a:solidFill>
-              <a:srgbClr val="34A853"/>
-            </a:solidFill>
-            <a:tailEnd type="triangle" w="med" h="med"/>
-          </a:ln>
-        </p:spPr>
-        <p:style>
-          <a:lnRef idx="2">
-            <a:schemeClr val="accent1"/>
-          </a:lnRef>
-          <a:fillRef idx="0">
-            <a:schemeClr val="accent1"/>
-          </a:fillRef>
-          <a:effectRef idx="1">
-            <a:schemeClr val="accent1"/>
-          </a:effectRef>
-          <a:fontRef idx="minor">
-            <a:schemeClr val="tx1"/>
-          </a:fontRef>
-        </p:style>
-      </p:cxnSp>
-      <p:sp>
-        <p:nvSpPr>
-          <p:cNvPr id="45" name="TextBox 44"/>
-          <p:cNvSpPr txBox="1"/>
-          <p:nvPr/>
-        </p:nvSpPr>
-        <p:spPr>
-          <a:xfrm>
-            <a:off x="7955280" y="2692908"/>
-            <a:ext cx="1280160" cy="164592"/>
-          </a:xfrm>
-          <a:prstGeom prst="rect">
-            <a:avLst/>
-          </a:prstGeom>
-          <a:noFill/>
-        </p:spPr>
-        <p:txBody>
-          <a:bodyPr wrap="square" lIns="18288" rIns="18288" tIns="0" bIns="0">
-            <a:spAutoFit/>
-          </a:bodyPr>
-          <a:lstStyle/>
-          <a:p>
-            <a:pPr algn="ctr"/>
-            <a:r>
-              <a:rPr sz="700" b="0" i="1">
-                <a:solidFill>
-                  <a:srgbClr val="34A853"/>
-                </a:solidFill>
-                <a:latin typeface="Calibri"/>
-              </a:rPr>
-              <a:t>deploy / retrain</a:t>
-            </a:r>
-          </a:p>
-        </p:txBody>
-      </p:sp>
-      <p:sp>
-        <p:nvSpPr>
-          <p:cNvPr id="46" name="Rounded Rectangle 45"/>
-          <p:cNvSpPr/>
-          <p:nvPr/>
-        </p:nvSpPr>
-        <p:spPr>
-          <a:xfrm>
-            <a:off x="1554480" y="4800600"/>
-            <a:ext cx="2011680" cy="777240"/>
-          </a:xfrm>
-          <a:prstGeom prst="roundRect">
-            <a:avLst>
-              <a:gd name="adj" fmla="val 10000"/>
-            </a:avLst>
-          </a:prstGeom>
-          <a:solidFill>
-            <a:srgbClr val="4E88E6"/>
-          </a:solidFill>
-          <a:ln>
-            <a:noFill/>
-          </a:ln>
-        </p:spPr>
-        <p:style>
-          <a:lnRef idx="1">
-            <a:schemeClr val="accent1"/>
-          </a:lnRef>
-          <a:fillRef idx="3">
-            <a:schemeClr val="accent1"/>
-          </a:fillRef>
-          <a:effectRef idx="2">
-            <a:schemeClr val="accent1"/>
-          </a:effectRef>
-          <a:fontRef idx="minor">
-            <a:schemeClr val="lt1"/>
-          </a:fontRef>
-        </p:style>
-        <p:txBody>
-          <a:bodyPr rtlCol="0" anchor="ctr" lIns="73152" rIns="73152" wrap="square"/>
-          <a:lstStyle/>
-          <a:p>
-            <a:pPr algn="ctr"/>
-            <a:r>
-              <a:rPr sz="1100" b="1" i="0">
-                <a:solidFill>
-                  <a:srgbClr val="FFFFFF"/>
-                </a:solidFill>
-                <a:latin typeface="Calibri"/>
-              </a:rPr>
-              <a:t>Breaker Automation</a:t>
-            </a:r>
-          </a:p>
-          <a:p>
-            <a:pPr algn="ctr"/>
-            <a:r>
-              <a:rPr sz="800" b="0" i="0">
-                <a:solidFill>
-                  <a:srgbClr val="FFFFFF"/>
-                </a:solidFill>
-                <a:latin typeface="Calibri"/>
-              </a:rPr>
-              <a:t>Python  ·  flips kill-switch</a:t>
-            </a:r>
-          </a:p>
-        </p:txBody>
-      </p:sp>
-      <p:sp>
-        <p:nvSpPr>
-          <p:cNvPr id="47" name="Rounded Rectangle 46"/>
-          <p:cNvSpPr/>
-          <p:nvPr/>
-        </p:nvSpPr>
-        <p:spPr>
-          <a:xfrm>
-            <a:off x="3749040" y="4937760"/>
-            <a:ext cx="1371600" cy="502920"/>
-          </a:xfrm>
-          <a:prstGeom prst="roundRect">
-            <a:avLst>
-              <a:gd name="adj" fmla="val 20000"/>
-            </a:avLst>
-          </a:prstGeom>
-          <a:solidFill>
-            <a:srgbClr val="FFFFFF"/>
-          </a:solidFill>
-          <a:ln w="9525">
-            <a:solidFill>
-              <a:srgbClr val="C9CFDA"/>
-            </a:solidFill>
-          </a:ln>
-        </p:spPr>
-        <p:style>
-          <a:lnRef idx="1">
-            <a:schemeClr val="accent1"/>
-          </a:lnRef>
-          <a:fillRef idx="3">
-            <a:schemeClr val="accent1"/>
-          </a:fillRef>
-          <a:effectRef idx="2">
-            <a:schemeClr val="accent1"/>
-          </a:effectRef>
-          <a:fontRef idx="minor">
-            <a:schemeClr val="lt1"/>
-          </a:fontRef>
-        </p:style>
-        <p:txBody>
-          <a:bodyPr rtlCol="0" anchor="ctr"/>
-          <a:lstStyle/>
-          <a:p>
-            <a:pPr algn="ctr"/>
-            <a:r>
-              <a:rPr sz="900" b="1" i="0">
-                <a:solidFill>
-                  <a:srgbClr val="0B1F3A"/>
-                </a:solidFill>
-                <a:latin typeface="Calibri"/>
-              </a:rPr>
-              <a:t>Secret Manager</a:t>
-            </a:r>
-          </a:p>
-        </p:txBody>
-      </p:sp>
-      <p:sp>
-        <p:nvSpPr>
-          <p:cNvPr id="48" name="Rounded Rectangle 47"/>
-          <p:cNvSpPr/>
-          <p:nvPr/>
-        </p:nvSpPr>
-        <p:spPr>
-          <a:xfrm>
-            <a:off x="4937760" y="4800600"/>
-            <a:ext cx="2377440" cy="777240"/>
-          </a:xfrm>
-          <a:prstGeom prst="roundRect">
-            <a:avLst>
-              <a:gd name="adj" fmla="val 10000"/>
-            </a:avLst>
-          </a:prstGeom>
-          <a:solidFill>
-            <a:srgbClr val="4E88E6"/>
-          </a:solidFill>
-          <a:ln>
-            <a:noFill/>
-          </a:ln>
-        </p:spPr>
-        <p:style>
-          <a:lnRef idx="1">
-            <a:schemeClr val="accent1"/>
-          </a:lnRef>
-          <a:fillRef idx="3">
-            <a:schemeClr val="accent1"/>
-          </a:fillRef>
-          <a:effectRef idx="2">
-            <a:schemeClr val="accent1"/>
-          </a:effectRef>
-          <a:fontRef idx="minor">
-            <a:schemeClr val="lt1"/>
-          </a:fontRef>
-        </p:style>
-        <p:txBody>
-          <a:bodyPr rtlCol="0" anchor="ctr" lIns="73152" rIns="73152" wrap="square"/>
-          <a:lstStyle/>
-          <a:p>
-            <a:pPr algn="ctr"/>
-            <a:r>
-              <a:rPr sz="1100" b="1" i="0">
-                <a:solidFill>
-                  <a:srgbClr val="FFFFFF"/>
-                </a:solidFill>
-                <a:latin typeface="Calibri"/>
-              </a:rPr>
-              <a:t>Reconciliation Service</a:t>
-            </a:r>
-          </a:p>
-          <a:p>
-            <a:pPr algn="ctr"/>
-            <a:r>
-              <a:rPr sz="800" b="0" i="0">
-                <a:solidFill>
-                  <a:srgbClr val="FFFFFF"/>
-                </a:solidFill>
-                <a:latin typeface="Calibri"/>
-              </a:rPr>
-              <a:t>Python FastAPI  ·  Cloud Run</a:t>
-            </a:r>
-          </a:p>
-        </p:txBody>
-      </p:sp>
-      <p:sp>
-        <p:nvSpPr>
-          <p:cNvPr id="49" name="Rounded Rectangle 48"/>
-          <p:cNvSpPr/>
-          <p:nvPr/>
-        </p:nvSpPr>
-        <p:spPr>
-          <a:xfrm>
-            <a:off x="8229600" y="4800600"/>
-            <a:ext cx="2194560" cy="777240"/>
-          </a:xfrm>
-          <a:prstGeom prst="roundRect">
-            <a:avLst>
-              <a:gd name="adj" fmla="val 10000"/>
-            </a:avLst>
-          </a:prstGeom>
-          <a:solidFill>
-            <a:srgbClr val="4E88E6"/>
-          </a:solidFill>
-          <a:ln>
-            <a:noFill/>
-          </a:ln>
-        </p:spPr>
-        <p:style>
-          <a:lnRef idx="1">
-            <a:schemeClr val="accent1"/>
-          </a:lnRef>
-          <a:fillRef idx="3">
-            <a:schemeClr val="accent1"/>
-          </a:fillRef>
-          <a:effectRef idx="2">
-            <a:schemeClr val="accent1"/>
-          </a:effectRef>
-          <a:fontRef idx="minor">
-            <a:schemeClr val="lt1"/>
-          </a:fontRef>
-        </p:style>
-        <p:txBody>
-          <a:bodyPr rtlCol="0" anchor="ctr" lIns="73152" rIns="73152" wrap="square"/>
-          <a:lstStyle/>
-          <a:p>
-            <a:pPr algn="ctr"/>
-            <a:r>
-              <a:rPr sz="1100" b="1" i="0">
-                <a:solidFill>
-                  <a:srgbClr val="FFFFFF"/>
-                </a:solidFill>
-                <a:latin typeface="Calibri"/>
-              </a:rPr>
-              <a:t>Activation Service</a:t>
-            </a:r>
-          </a:p>
-          <a:p>
-            <a:pPr algn="ctr"/>
-            <a:r>
-              <a:rPr sz="800" b="0" i="0">
-                <a:solidFill>
-                  <a:srgbClr val="FFFFFF"/>
-                </a:solidFill>
-                <a:latin typeface="Calibri"/>
-              </a:rPr>
-              <a:t>Python 3.12  ·  Cloud Run</a:t>
-            </a:r>
-          </a:p>
-        </p:txBody>
-      </p:sp>
-      <p:sp>
-        <p:nvSpPr>
-          <p:cNvPr id="50" name="TextBox 49"/>
-          <p:cNvSpPr txBox="1"/>
-          <p:nvPr/>
-        </p:nvSpPr>
-        <p:spPr>
-          <a:xfrm>
-            <a:off x="10561320" y="4846320"/>
-            <a:ext cx="914400" cy="219456"/>
-          </a:xfrm>
-          <a:prstGeom prst="rect">
-            <a:avLst/>
-          </a:prstGeom>
-          <a:noFill/>
-        </p:spPr>
-        <p:txBody>
-          <a:bodyPr wrap="none">
-            <a:spAutoFit/>
-          </a:bodyPr>
-          <a:lstStyle/>
-          <a:p>
-            <a:r>
-              <a:rPr sz="900" b="1" i="0">
-                <a:solidFill>
-                  <a:srgbClr val="333F52"/>
-                </a:solidFill>
-                <a:latin typeface="Calibri"/>
-              </a:rPr>
-              <a:t>→  SA360</a:t>
-            </a:r>
-          </a:p>
-        </p:txBody>
-      </p:sp>
-      <p:sp>
-        <p:nvSpPr>
-          <p:cNvPr id="51" name="TextBox 50"/>
-          <p:cNvSpPr txBox="1"/>
-          <p:nvPr/>
-        </p:nvSpPr>
-        <p:spPr>
-          <a:xfrm>
-            <a:off x="10561320" y="5084064"/>
-            <a:ext cx="914400" cy="219456"/>
-          </a:xfrm>
-          <a:prstGeom prst="rect">
-            <a:avLst/>
-          </a:prstGeom>
-          <a:noFill/>
-        </p:spPr>
-        <p:txBody>
-          <a:bodyPr wrap="none">
-            <a:spAutoFit/>
-          </a:bodyPr>
-          <a:lstStyle/>
-          <a:p>
-            <a:r>
-              <a:rPr sz="900" b="1" i="0">
-                <a:solidFill>
-                  <a:srgbClr val="333F52"/>
-                </a:solidFill>
-                <a:latin typeface="Calibri"/>
-              </a:rPr>
-              <a:t>→  SSGTM</a:t>
-            </a:r>
-          </a:p>
-        </p:txBody>
-      </p:sp>
-      <p:sp>
-        <p:nvSpPr>
-          <p:cNvPr id="52" name="TextBox 51"/>
-          <p:cNvSpPr txBox="1"/>
-          <p:nvPr/>
-        </p:nvSpPr>
-        <p:spPr>
-          <a:xfrm>
-            <a:off x="10561320" y="5321808"/>
-            <a:ext cx="914400" cy="219456"/>
-          </a:xfrm>
-          <a:prstGeom prst="rect">
-            <a:avLst/>
-          </a:prstGeom>
-          <a:noFill/>
-        </p:spPr>
-        <p:txBody>
-          <a:bodyPr wrap="none">
-            <a:spAutoFit/>
-          </a:bodyPr>
-          <a:lstStyle/>
-          <a:p>
-            <a:r>
-              <a:rPr sz="900" b="1" i="0">
-                <a:solidFill>
-                  <a:srgbClr val="333F52"/>
-                </a:solidFill>
-                <a:latin typeface="Calibri"/>
-              </a:rPr>
-              <a:t>→  OCI</a:t>
-            </a:r>
-          </a:p>
-        </p:txBody>
-      </p:sp>
-      <p:cxnSp>
-        <p:nvCxnSpPr>
-          <p:cNvPr id="53" name="Connector 52"/>
-          <p:cNvCxnSpPr/>
-          <p:nvPr/>
-        </p:nvCxnSpPr>
-        <p:spPr>
-          <a:xfrm>
-            <a:off x="3566160" y="5189220.0"/>
-            <a:ext cx="182880" cy="0.0"/>
-          </a:xfrm>
-          <a:prstGeom prst="line">
-            <a:avLst/>
-          </a:prstGeom>
-          <a:ln w="15875">
-            <a:solidFill>
-              <a:srgbClr val="46556B"/>
-            </a:solidFill>
-            <a:tailEnd type="triangle" w="med" h="med"/>
-          </a:ln>
-        </p:spPr>
-        <p:style>
-          <a:lnRef idx="2">
-            <a:schemeClr val="accent1"/>
-          </a:lnRef>
-          <a:fillRef idx="0">
-            <a:schemeClr val="accent1"/>
-          </a:fillRef>
-          <a:effectRef idx="1">
-            <a:schemeClr val="accent1"/>
-          </a:effectRef>
-          <a:fontRef idx="minor">
-            <a:schemeClr val="tx1"/>
-          </a:fontRef>
-        </p:style>
-      </p:cxnSp>
-      <p:cxnSp>
-        <p:nvCxnSpPr>
-          <p:cNvPr id="54" name="Connector 53"/>
-          <p:cNvCxnSpPr/>
-          <p:nvPr/>
-        </p:nvCxnSpPr>
-        <p:spPr>
-          <a:xfrm>
-            <a:off x="10424160" y="5189220.0"/>
-            <a:ext cx="91440" cy="0.0"/>
-          </a:xfrm>
-          <a:prstGeom prst="line">
-            <a:avLst/>
-          </a:prstGeom>
-          <a:ln w="15875">
-            <a:solidFill>
-              <a:srgbClr val="46556B"/>
-            </a:solidFill>
-            <a:tailEnd type="triangle" w="med" h="med"/>
-          </a:ln>
-        </p:spPr>
-        <p:style>
-          <a:lnRef idx="2">
-            <a:schemeClr val="accent1"/>
-          </a:lnRef>
-          <a:fillRef idx="0">
-            <a:schemeClr val="accent1"/>
-          </a:fillRef>
-          <a:effectRef idx="1">
-            <a:schemeClr val="accent1"/>
-          </a:effectRef>
-          <a:fontRef idx="minor">
-            <a:schemeClr val="tx1"/>
-          </a:fontRef>
-        </p:style>
-      </p:cxnSp>
-      <p:cxnSp>
-        <p:nvCxnSpPr>
-          <p:cNvPr id="55" name="Connector 54"/>
-          <p:cNvCxnSpPr/>
-          <p:nvPr/>
-        </p:nvCxnSpPr>
-        <p:spPr>
-          <a:xfrm flipV="1">
-            <a:off x="4434840.0" y="2651760"/>
-            <a:ext cx="0.0" cy="2286000"/>
-          </a:xfrm>
-          <a:prstGeom prst="line">
-            <a:avLst/>
-          </a:prstGeom>
-          <a:ln w="12700">
-            <a:solidFill>
-              <a:srgbClr val="46556B"/>
-            </a:solidFill>
-            <a:tailEnd type="triangle" w="med" h="med"/>
-          </a:ln>
-        </p:spPr>
-        <p:style>
-          <a:lnRef idx="2">
-            <a:schemeClr val="accent1"/>
-          </a:lnRef>
-          <a:fillRef idx="0">
-            <a:schemeClr val="accent1"/>
-          </a:fillRef>
-          <a:effectRef idx="1">
-            <a:schemeClr val="accent1"/>
-          </a:effectRef>
-          <a:fontRef idx="minor">
-            <a:schemeClr val="tx1"/>
-          </a:fontRef>
-        </p:style>
-      </p:cxnSp>
-      <p:sp>
-        <p:nvSpPr>
-          <p:cNvPr id="56" name="TextBox 55"/>
-          <p:cNvSpPr txBox="1"/>
-          <p:nvPr/>
-        </p:nvSpPr>
-        <p:spPr>
-          <a:xfrm>
-            <a:off x="4480560" y="3703320"/>
-            <a:ext cx="1463040" cy="164592"/>
-          </a:xfrm>
-          <a:prstGeom prst="rect">
-            <a:avLst/>
-          </a:prstGeom>
-          <a:noFill/>
-        </p:spPr>
-        <p:txBody>
-          <a:bodyPr wrap="square" lIns="18288" rIns="18288" tIns="0" bIns="0">
-            <a:spAutoFit/>
-          </a:bodyPr>
-          <a:lstStyle/>
-          <a:p>
-            <a:pPr algn="l"/>
-            <a:r>
-              <a:rPr sz="700" b="0" i="1">
-                <a:solidFill>
-                  <a:srgbClr val="6B7380"/>
-                </a:solidFill>
-                <a:latin typeface="Calibri"/>
-              </a:rPr>
-              <a:t>kill-switch flag</a:t>
-            </a:r>
-          </a:p>
-        </p:txBody>
-      </p:sp>
-      <p:cxnSp>
-        <p:nvCxnSpPr>
-          <p:cNvPr id="57" name="Connector 56"/>
-          <p:cNvCxnSpPr/>
-          <p:nvPr/>
-        </p:nvCxnSpPr>
-        <p:spPr>
-          <a:xfrm>
-            <a:off x="6126480.0" y="4224528"/>
-            <a:ext cx="0.0" cy="576072"/>
-          </a:xfrm>
-          <a:prstGeom prst="line">
-            <a:avLst/>
-          </a:prstGeom>
-          <a:ln w="15875">
-            <a:solidFill>
-              <a:srgbClr val="46556B"/>
-            </a:solidFill>
-            <a:tailEnd type="triangle" w="med" h="med"/>
-          </a:ln>
-        </p:spPr>
-        <p:style>
-          <a:lnRef idx="2">
-            <a:schemeClr val="accent1"/>
-          </a:lnRef>
-          <a:fillRef idx="0">
-            <a:schemeClr val="accent1"/>
-          </a:fillRef>
-          <a:effectRef idx="1">
-            <a:schemeClr val="accent1"/>
-          </a:effectRef>
-          <a:fontRef idx="minor">
-            <a:schemeClr val="tx1"/>
-          </a:fontRef>
-        </p:style>
-      </p:cxnSp>
-      <p:sp>
-        <p:nvSpPr>
-          <p:cNvPr id="58" name="TextBox 57"/>
-          <p:cNvSpPr txBox="1"/>
-          <p:nvPr/>
-        </p:nvSpPr>
-        <p:spPr>
-          <a:xfrm>
-            <a:off x="5029200" y="4421124"/>
-            <a:ext cx="1005840" cy="164592"/>
-          </a:xfrm>
-          <a:prstGeom prst="rect">
-            <a:avLst/>
-          </a:prstGeom>
-          <a:noFill/>
-        </p:spPr>
-        <p:txBody>
-          <a:bodyPr wrap="square" lIns="18288" rIns="18288" tIns="0" bIns="0">
-            <a:spAutoFit/>
-          </a:bodyPr>
-          <a:lstStyle/>
-          <a:p>
-            <a:pPr algn="ctr"/>
-            <a:r>
-              <a:rPr sz="700" b="0" i="1">
-                <a:solidFill>
-                  <a:srgbClr val="6B7380"/>
-                </a:solidFill>
-                <a:latin typeface="Calibri"/>
-              </a:rPr>
-              <a:t>predictions_vs_revenue</a:t>
-            </a:r>
-          </a:p>
-        </p:txBody>
-      </p:sp>
-      <p:cxnSp>
-        <p:nvCxnSpPr>
-          <p:cNvPr id="59" name="Connector 58"/>
-          <p:cNvCxnSpPr/>
-          <p:nvPr/>
-        </p:nvCxnSpPr>
-        <p:spPr>
-          <a:xfrm>
-            <a:off x="7315200" y="5189220.0"/>
-            <a:ext cx="365760" cy="0.0"/>
-          </a:xfrm>
-          <a:prstGeom prst="line">
-            <a:avLst/>
-          </a:prstGeom>
-          <a:ln w="12700">
-            <a:solidFill>
-              <a:srgbClr val="46556B"/>
-            </a:solidFill>
-          </a:ln>
-        </p:spPr>
-        <p:style>
-          <a:lnRef idx="2">
-            <a:schemeClr val="accent1"/>
-          </a:lnRef>
-          <a:fillRef idx="0">
-            <a:schemeClr val="accent1"/>
-          </a:fillRef>
-          <a:effectRef idx="1">
-            <a:schemeClr val="accent1"/>
-          </a:effectRef>
-          <a:fontRef idx="minor">
-            <a:schemeClr val="tx1"/>
-          </a:fontRef>
-        </p:style>
-      </p:cxnSp>
-      <p:cxnSp>
-        <p:nvCxnSpPr>
-          <p:cNvPr id="60" name="Connector 59"/>
-          <p:cNvCxnSpPr/>
-          <p:nvPr/>
-        </p:nvCxnSpPr>
-        <p:spPr>
-          <a:xfrm flipV="1">
-            <a:off x="7680960" y="2263140.0"/>
-            <a:ext cx="0" cy="2926080.0"/>
-          </a:xfrm>
-          <a:prstGeom prst="line">
-            <a:avLst/>
-          </a:prstGeom>
-          <a:ln w="12700">
-            <a:solidFill>
-              <a:srgbClr val="46556B"/>
-            </a:solidFill>
-          </a:ln>
-        </p:spPr>
-        <p:style>
-          <a:lnRef idx="2">
-            <a:schemeClr val="accent1"/>
-          </a:lnRef>
-          <a:fillRef idx="0">
-            <a:schemeClr val="accent1"/>
-          </a:fillRef>
-          <a:effectRef idx="1">
-            <a:schemeClr val="accent1"/>
-          </a:effectRef>
-          <a:fontRef idx="minor">
-            <a:schemeClr val="tx1"/>
-          </a:fontRef>
-        </p:style>
-      </p:cxnSp>
-      <p:cxnSp>
-        <p:nvCxnSpPr>
-          <p:cNvPr id="61" name="Connector 60"/>
-          <p:cNvCxnSpPr/>
-          <p:nvPr/>
-        </p:nvCxnSpPr>
-        <p:spPr>
-          <a:xfrm>
-            <a:off x="7680960" y="2263140.0"/>
-            <a:ext cx="1371600" cy="0.0"/>
-          </a:xfrm>
-          <a:prstGeom prst="line">
-            <a:avLst/>
-          </a:prstGeom>
-          <a:ln w="12700">
-            <a:solidFill>
-              <a:srgbClr val="46556B"/>
-            </a:solidFill>
-            <a:tailEnd type="triangle" w="med" h="med"/>
-          </a:ln>
-        </p:spPr>
-        <p:style>
-          <a:lnRef idx="2">
-            <a:schemeClr val="accent1"/>
-          </a:lnRef>
-          <a:fillRef idx="0">
-            <a:schemeClr val="accent1"/>
-          </a:fillRef>
-          <a:effectRef idx="1">
-            <a:schemeClr val="accent1"/>
-          </a:effectRef>
-          <a:fontRef idx="minor">
-            <a:schemeClr val="tx1"/>
-          </a:fontRef>
-        </p:style>
-      </p:cxnSp>
-      <p:sp>
-        <p:nvSpPr>
-          <p:cNvPr id="62" name="TextBox 61"/>
-          <p:cNvSpPr txBox="1"/>
-          <p:nvPr/>
-        </p:nvSpPr>
-        <p:spPr>
-          <a:xfrm>
-            <a:off x="7726680" y="2061972"/>
-            <a:ext cx="1005840" cy="164592"/>
-          </a:xfrm>
-          <a:prstGeom prst="rect">
-            <a:avLst/>
-          </a:prstGeom>
-          <a:noFill/>
-        </p:spPr>
-        <p:txBody>
-          <a:bodyPr wrap="square" lIns="18288" rIns="18288" tIns="0" bIns="0">
-            <a:spAutoFit/>
-          </a:bodyPr>
-          <a:lstStyle/>
-          <a:p>
-            <a:pPr algn="l"/>
-            <a:r>
-              <a:rPr sz="700" b="0" i="1">
-                <a:solidFill>
-                  <a:srgbClr val="6B7380"/>
-                </a:solidFill>
-                <a:latin typeface="Calibri"/>
-              </a:rPr>
-              <a:t>HTTPS /api</a:t>
-            </a:r>
-          </a:p>
-        </p:txBody>
-      </p:sp>
-      <p:cxnSp>
-        <p:nvCxnSpPr>
-          <p:cNvPr id="63" name="Connector 62"/>
-          <p:cNvCxnSpPr/>
-          <p:nvPr/>
-        </p:nvCxnSpPr>
-        <p:spPr>
-          <a:xfrm>
-            <a:off x="7315200" y="3995928"/>
-            <a:ext cx="1280160" cy="0"/>
-          </a:xfrm>
-          <a:prstGeom prst="line">
-            <a:avLst/>
-          </a:prstGeom>
-          <a:ln w="12700">
-            <a:solidFill>
-              <a:srgbClr val="46556B"/>
-            </a:solidFill>
-          </a:ln>
-        </p:spPr>
-        <p:style>
-          <a:lnRef idx="2">
-            <a:schemeClr val="accent1"/>
-          </a:lnRef>
-          <a:fillRef idx="0">
-            <a:schemeClr val="accent1"/>
-          </a:fillRef>
-          <a:effectRef idx="1">
-            <a:schemeClr val="accent1"/>
-          </a:effectRef>
-          <a:fontRef idx="minor">
-            <a:schemeClr val="tx1"/>
-          </a:fontRef>
-        </p:style>
-      </p:cxnSp>
-      <p:cxnSp>
-        <p:nvCxnSpPr>
-          <p:cNvPr id="64" name="Connector 63"/>
-          <p:cNvCxnSpPr/>
-          <p:nvPr/>
-        </p:nvCxnSpPr>
-        <p:spPr>
-          <a:xfrm>
-            <a:off x="8595360" y="3995928"/>
-            <a:ext cx="0" cy="804672"/>
-          </a:xfrm>
-          <a:prstGeom prst="line">
-            <a:avLst/>
-          </a:prstGeom>
-          <a:ln w="12700">
-            <a:solidFill>
-              <a:srgbClr val="46556B"/>
-            </a:solidFill>
-            <a:tailEnd type="triangle" w="med" h="med"/>
-          </a:ln>
-        </p:spPr>
-        <p:style>
-          <a:lnRef idx="2">
-            <a:schemeClr val="accent1"/>
-          </a:lnRef>
-          <a:fillRef idx="0">
-            <a:schemeClr val="accent1"/>
-          </a:fillRef>
-          <a:effectRef idx="1">
-            <a:schemeClr val="accent1"/>
-          </a:effectRef>
-          <a:fontRef idx="minor">
-            <a:schemeClr val="tx1"/>
-          </a:fontRef>
-        </p:style>
-      </p:cxnSp>
-      <p:sp>
-        <p:nvSpPr>
-          <p:cNvPr id="65" name="TextBox 64"/>
-          <p:cNvSpPr txBox="1"/>
-          <p:nvPr/>
-        </p:nvSpPr>
-        <p:spPr>
-          <a:xfrm>
-            <a:off x="7863840" y="3813048"/>
-            <a:ext cx="1463040" cy="164592"/>
-          </a:xfrm>
-          <a:prstGeom prst="rect">
-            <a:avLst/>
-          </a:prstGeom>
-          <a:noFill/>
-        </p:spPr>
-        <p:txBody>
-          <a:bodyPr wrap="square" lIns="18288" rIns="18288" tIns="0" bIns="0">
-            <a:spAutoFit/>
-          </a:bodyPr>
-          <a:lstStyle/>
-          <a:p>
-            <a:pPr algn="ctr"/>
-            <a:r>
-              <a:rPr sz="700" b="0" i="1">
-                <a:solidFill>
-                  <a:srgbClr val="6B7380"/>
-                </a:solidFill>
-                <a:latin typeface="Calibri"/>
-              </a:rPr>
-              <a:t>predictions</a:t>
-            </a:r>
-          </a:p>
-        </p:txBody>
-      </p:sp>
-      <p:sp>
-        <p:nvSpPr>
-          <p:cNvPr id="66" name="TextBox 65"/>
-          <p:cNvSpPr txBox="1"/>
-          <p:nvPr/>
-        </p:nvSpPr>
-        <p:spPr>
-          <a:xfrm>
-            <a:off x="594360" y="5623560"/>
-            <a:ext cx="11002975" cy="457200"/>
-          </a:xfrm>
-          <a:prstGeom prst="rect">
-            <a:avLst/>
-          </a:prstGeom>
-          <a:noFill/>
-        </p:spPr>
-        <p:txBody>
-          <a:bodyPr wrap="square">
-            <a:spAutoFit/>
-          </a:bodyPr>
-          <a:lstStyle/>
-          <a:p>
-            <a:r>
-              <a:rPr sz="900" b="1" i="0">
-                <a:solidFill>
-                  <a:srgbClr val="1F4CA6"/>
-                </a:solidFill>
-                <a:latin typeface="Calibri"/>
-              </a:rPr>
-              <a:t>Scoring API guardrails:  </a:t>
-            </a:r>
-            <a:r>
-              <a:rPr sz="900" b="0" i="0">
-                <a:solidFill>
-                  <a:srgbClr val="333F52"/>
-                </a:solidFill>
-                <a:latin typeface="Calibri"/>
-              </a:rPr>
-              <a:t>prediction bounds  ·  negative clamp  ·  model &amp; BigQuery timeouts  ·  anomaly window  ·  circuit-breaker  ·  kill-switch.</a:t>
-            </a:r>
-          </a:p>
-          <a:p>
-            <a:r>
-              <a:rPr sz="900" b="1" i="0">
-                <a:solidFill>
-                  <a:srgbClr val="1F4CA6"/>
-                </a:solidFill>
-                <a:latin typeface="Calibri"/>
-              </a:rPr>
-              <a:t>Delivery:  </a:t>
-            </a:r>
-            <a:r>
-              <a:rPr sz="900" b="0" i="0">
-                <a:solidFill>
-                  <a:srgbClr val="333F52"/>
-                </a:solidFill>
-                <a:latin typeface="Calibri"/>
-              </a:rPr>
-              <a:t>GitHub  →  Workload Identity Federation  →  Cloud Build  →  Artifact Registry  →  Cloud Run, gated on test, coverage and supply-chain scans.</a:t>
-            </a:r>
-          </a:p>
-        </p:txBody>
-      </p:sp>
-      <p:sp>
-        <p:nvSpPr>
-          <p:cNvPr id="67" name="Rectangle 66"/>
+      <p:pic>
+        <p:nvPicPr>
+          <p:cNvPr id="4" name="Picture 3" descr="architecture.png"/>
+          <p:cNvPicPr>
+            <a:picLocks noChangeAspect="1"/>
+          </p:cNvPicPr>
+          <p:nvPr/>
+        </p:nvPicPr>
+        <p:blipFill>
+          <a:blip r:embed="rId2"/>
+          <a:stretch>
+            <a:fillRect/>
+          </a:stretch>
+        </p:blipFill>
+        <p:spPr>
+          <a:xfrm>
+            <a:off x="1360017" y="1051560"/>
+            <a:ext cx="9471660" cy="5166360"/>
+          </a:xfrm>
+          <a:prstGeom prst="rect">
+            <a:avLst/>
+          </a:prstGeom>
+        </p:spPr>
+      </p:pic>
+      <p:sp>
+        <p:nvSpPr>
+          <p:cNvPr id="5" name="Rectangle 4"/>
           <p:cNvSpPr/>
           <p:nvPr/>
         </p:nvSpPr>
@@ -12453,7 +9831,7 @@
       </p:sp>
       <p:sp>
         <p:nvSpPr>
-          <p:cNvPr id="68" name="TextBox 67"/>
+          <p:cNvPr id="6" name="TextBox 5"/>
           <p:cNvSpPr txBox="1"/>
           <p:nvPr/>
         </p:nvSpPr>

</xml_diff>

<commit_message>
deck: overlay 'Calbration' typo fix on architecture image
Adds a programmatic overlay on slide 6 that covers the misspelled
'Bounds Calbration Job' label with a colour-matched rectangle and
the correctly-spelled 'Bounds Calibration Job' text. The 'Pyihon'
typo I flagged earlier turned out to be a misread under magnification
— the source image is correct. Single overlay only.

Co-Authored-By: Claude Opus 4.7 (1M context) <noreply@anthropic.com>
</commit_message>
<xml_diff>
--- a/docs/client-demo-deck.pptx
+++ b/docs/client-demo-deck.pptx
@@ -9785,6 +9785,58 @@
         </p:nvSpPr>
         <p:spPr>
           <a:xfrm>
+            <a:off x="2570882" y="3358931"/>
+            <a:ext cx="1177230" cy="174902"/>
+          </a:xfrm>
+          <a:prstGeom prst="rect">
+            <a:avLst/>
+          </a:prstGeom>
+          <a:solidFill>
+            <a:srgbClr val="4E82D5"/>
+          </a:solidFill>
+          <a:ln>
+            <a:noFill/>
+          </a:ln>
+        </p:spPr>
+        <p:style>
+          <a:lnRef idx="1">
+            <a:schemeClr val="accent1"/>
+          </a:lnRef>
+          <a:fillRef idx="3">
+            <a:schemeClr val="accent1"/>
+          </a:fillRef>
+          <a:effectRef idx="2">
+            <a:schemeClr val="accent1"/>
+          </a:effectRef>
+          <a:fontRef idx="minor">
+            <a:schemeClr val="lt1"/>
+          </a:fontRef>
+        </p:style>
+        <p:txBody>
+          <a:bodyPr rtlCol="0" anchor="ctr" lIns="0" rIns="0" tIns="0" bIns="0"/>
+          <a:lstStyle/>
+          <a:p>
+            <a:pPr algn="ctr"/>
+            <a:r>
+              <a:rPr sz="1000" b="1">
+                <a:solidFill>
+                  <a:srgbClr val="FFFFFF"/>
+                </a:solidFill>
+                <a:latin typeface="Calibri"/>
+              </a:rPr>
+              <a:t>Bounds Calibration Job</a:t>
+            </a:r>
+          </a:p>
+        </p:txBody>
+      </p:sp>
+      <p:sp>
+        <p:nvSpPr>
+          <p:cNvPr id="6" name="Rectangle 5"/>
+          <p:cNvSpPr/>
+          <p:nvPr/>
+        </p:nvSpPr>
+        <p:spPr>
+          <a:xfrm>
             <a:off x="0" y="6537960"/>
             <a:ext cx="12191695" cy="320040"/>
           </a:xfrm>
@@ -9831,7 +9883,7 @@
       </p:sp>
       <p:sp>
         <p:nvSpPr>
-          <p:cNvPr id="6" name="TextBox 5"/>
+          <p:cNvPr id="7" name="TextBox 6"/>
           <p:cNvSpPr txBox="1"/>
           <p:nvPr/>
         </p:nvSpPr>

</xml_diff>

<commit_message>
deck: reflect interactive prediction + plain-English UI
Three slides updated to match what the dashboard actually does now.

Slide 2 (Executive summary):
- 'Working software you can touch' replaces the API-only framing.
- 'Explainable by default' lifted from a footnote into one of the three
  takeaways — finance/compliance angle.

Slide 4 (Solution overview):
- Reframed around the dashboard, not the REST API.
- New bullets for the interactive prediction panel and the explainable-AI
  rendering. REST API is still there but second-tier.

Slide 7 (Live demo script):
- Rewrote the demo flow as four steps: dashboard in business language →
  the executive runs the model themselves → see why it said that → the
  safety net on cue.
- Replaces the previous curl-based step with the browser-driven panel and
  the live pipeline trace.
- Footer shows only the dashboard URL (the API URL is no longer needed in
  the demo).

Co-Authored-By: Claude Opus 4.7 (1M context) <noreply@anthropic.com>
</commit_message>
<xml_diff>
--- a/docs/client-demo-deck.pptx
+++ b/docs/client-demo-deck.pptx
@@ -6809,7 +6809,7 @@
                 </a:solidFill>
                 <a:latin typeface="Calibri"/>
               </a:rPr>
-              <a:t>We have built and deployed an end-to-end machine-learning service that predicts revenue-per-click in real time, with the engineering controls required to run it safely in production.</a:t>
+              <a:t>We have built and deployed an end-to-end machine-learning service that predicts revenue-per-click in real time, with the engineering controls required to run it safely in production. You can run the live model yourself in today's demo.</a:t>
             </a:r>
           </a:p>
           <a:p>
@@ -6856,7 +6856,7 @@
                 </a:solidFill>
                 <a:latin typeface="Calibri"/>
               </a:rPr>
-              <a:t>Working software — a live API on Google Cloud is serving predictions right now, with measured p95 latency under one second.</a:t>
+              <a:t>Working software you can touch — a browser-based dashboard fronts the live model on Google Cloud, with measured p95 latency under one second.</a:t>
             </a:r>
           </a:p>
           <a:p>
@@ -6884,7 +6884,7 @@
                 </a:solidFill>
                 <a:latin typeface="Calibri"/>
               </a:rPr>
-              <a:t>Production engineering — circuit breakers, drift monitoring, explainability, alerting, runbooks, and a tested rollback path are all in place.</a:t>
+              <a:t>Explainable by default — every prediction returns per-feature attributions, rendered alongside the price so finance and compliance can audit any decision.</a:t>
             </a:r>
           </a:p>
           <a:p>
@@ -6912,7 +6912,7 @@
                 </a:solidFill>
                 <a:latin typeface="Calibri"/>
               </a:rPr>
-              <a:t>A clear path to your data — the platform is ready to ingest real click and sales-ledger feeds; the model retrains and canary-deploys without downtime.</a:t>
+              <a:t>Production engineering — circuit breakers, drift monitoring, alerting, runbooks, and a tested rollback path are all in place; a clear path to your real data follows in eight weeks.</a:t>
             </a:r>
           </a:p>
         </p:txBody>
@@ -7562,13 +7562,13 @@
               </a:spcAft>
             </a:pPr>
             <a:r>
-              <a:rPr sz="1800" b="1" i="0">
+              <a:rPr sz="1700" b="1" i="0">
                 <a:solidFill>
                   <a:srgbClr val="0F6E7A"/>
                 </a:solidFill>
                 <a:latin typeface="Calibri"/>
               </a:rPr>
-              <a:t>A managed prediction service on Google Cloud.</a:t>
+              <a:t>A managed prediction service on Google Cloud, with a browser UI for non-technical users.</a:t>
             </a:r>
           </a:p>
           <a:p>
@@ -7581,7 +7581,7 @@
               </a:spcAft>
             </a:pPr>
             <a:r>
-              <a:rPr sz="1400" b="1" i="0">
+              <a:rPr sz="1300" b="1" i="0">
                 <a:solidFill>
                   <a:srgbClr val="D97306"/>
                 </a:solidFill>
@@ -7590,13 +7590,13 @@
               <a:t>•  </a:t>
             </a:r>
             <a:r>
-              <a:rPr sz="1400" b="0" i="0">
+              <a:rPr sz="1300" b="0" i="0">
                 <a:solidFill>
                   <a:srgbClr val="333F52"/>
                 </a:solidFill>
                 <a:latin typeface="Calibri"/>
               </a:rPr>
-              <a:t>REST API — POST a click context, receive an RPC estimate in under a second.</a:t>
+              <a:t>Executive dashboard — KPIs, daily forecast-vs-reality charts, residual distribution, and a live model-health panel, all in business language.</a:t>
             </a:r>
           </a:p>
           <a:p>
@@ -7609,7 +7609,7 @@
               </a:spcAft>
             </a:pPr>
             <a:r>
-              <a:rPr sz="1400" b="1" i="0">
+              <a:rPr sz="1300" b="1" i="0">
                 <a:solidFill>
                   <a:srgbClr val="D97306"/>
                 </a:solidFill>
@@ -7618,13 +7618,13 @@
               <a:t>•  </a:t>
             </a:r>
             <a:r>
-              <a:rPr sz="1400" b="0" i="0">
+              <a:rPr sz="1300" b="0" i="0">
                 <a:solidFill>
                   <a:srgbClr val="333F52"/>
                 </a:solidFill>
                 <a:latin typeface="Calibri"/>
               </a:rPr>
-              <a:t>Explainability — every prediction can return per-feature attributions so analysts can see why the model said what it said.</a:t>
+              <a:t>Interactive prediction — describe a click in eight plain-English fields, press Predict, watch the pipeline execute step-by-step in real time.</a:t>
             </a:r>
           </a:p>
           <a:p>
@@ -7637,7 +7637,7 @@
               </a:spcAft>
             </a:pPr>
             <a:r>
-              <a:rPr sz="1400" b="1" i="0">
+              <a:rPr sz="1300" b="1" i="0">
                 <a:solidFill>
                   <a:srgbClr val="D97306"/>
                 </a:solidFill>
@@ -7646,13 +7646,13 @@
               <a:t>•  </a:t>
             </a:r>
             <a:r>
-              <a:rPr sz="1400" b="0" i="0">
+              <a:rPr sz="1300" b="0" i="0">
                 <a:solidFill>
                   <a:srgbClr val="333F52"/>
                 </a:solidFill>
                 <a:latin typeface="Calibri"/>
               </a:rPr>
-              <a:t>Streaming ingestion — predictions land in BigQuery for analytics, reconciliation, and downstream activation.</a:t>
+              <a:t>Explainable AI — every prediction returns per-feature attributions, rendered as horizontal bars so anyone can see why the model said what it said.</a:t>
             </a:r>
           </a:p>
           <a:p>
@@ -7665,7 +7665,7 @@
               </a:spcAft>
             </a:pPr>
             <a:r>
-              <a:rPr sz="1400" b="1" i="0">
+              <a:rPr sz="1300" b="1" i="0">
                 <a:solidFill>
                   <a:srgbClr val="D97306"/>
                 </a:solidFill>
@@ -7674,13 +7674,13 @@
               <a:t>•  </a:t>
             </a:r>
             <a:r>
-              <a:rPr sz="1400" b="0" i="0">
+              <a:rPr sz="1300" b="0" i="0">
                 <a:solidFill>
                   <a:srgbClr val="333F52"/>
                 </a:solidFill>
                 <a:latin typeface="Calibri"/>
               </a:rPr>
-              <a:t>Safety net — anomaly detection, automatic circuit-breaker, negative-prediction guards, configurable timeouts.</a:t>
+              <a:t>REST API — the same predictions are available programmatically for SA360, SSGTM and downstream activation.</a:t>
             </a:r>
           </a:p>
           <a:p>
@@ -7693,7 +7693,7 @@
               </a:spcAft>
             </a:pPr>
             <a:r>
-              <a:rPr sz="1400" b="1" i="0">
+              <a:rPr sz="1300" b="1" i="0">
                 <a:solidFill>
                   <a:srgbClr val="D97306"/>
                 </a:solidFill>
@@ -7702,7 +7702,35 @@
               <a:t>•  </a:t>
             </a:r>
             <a:r>
-              <a:rPr sz="1400" b="0" i="0">
+              <a:rPr sz="1300" b="0" i="0">
+                <a:solidFill>
+                  <a:srgbClr val="333F52"/>
+                </a:solidFill>
+                <a:latin typeface="Calibri"/>
+              </a:rPr>
+              <a:t>Safety net — anomaly detection, automatic circuit-breaker, negative-prediction guards, configurable timeouts, kill-switch flag.</a:t>
+            </a:r>
+          </a:p>
+          <a:p>
+            <a:pPr>
+              <a:lnSpc>
+                <a:spcPct val="120000"/>
+              </a:lnSpc>
+              <a:spcAft>
+                <a:spcPts val="300"/>
+              </a:spcAft>
+            </a:pPr>
+            <a:r>
+              <a:rPr sz="1300" b="1" i="0">
+                <a:solidFill>
+                  <a:srgbClr val="D97306"/>
+                </a:solidFill>
+                <a:latin typeface="Calibri"/>
+              </a:rPr>
+              <a:t>•  </a:t>
+            </a:r>
+            <a:r>
+              <a:rPr sz="1300" b="0" i="0">
                 <a:solidFill>
                   <a:srgbClr val="333F52"/>
                 </a:solidFill>
@@ -7721,7 +7749,7 @@
               </a:spcAft>
             </a:pPr>
             <a:r>
-              <a:rPr sz="1800" b="1" i="0">
+              <a:rPr sz="1700" b="1" i="0">
                 <a:solidFill>
                   <a:srgbClr val="0F6E7A"/>
                 </a:solidFill>
@@ -7737,7 +7765,7 @@
               </a:lnSpc>
             </a:pPr>
             <a:r>
-              <a:rPr sz="1200" b="0" i="1">
+              <a:rPr sz="1100" b="0" i="1">
                 <a:solidFill>
                   <a:srgbClr val="6B7380"/>
                 </a:solidFill>
@@ -10071,13 +10099,13 @@
               </a:spcAft>
             </a:pPr>
             <a:r>
-              <a:rPr sz="1800" b="1" i="0">
+              <a:rPr sz="1600" b="1" i="0">
                 <a:solidFill>
                   <a:srgbClr val="0F6E7A"/>
                 </a:solidFill>
                 <a:latin typeface="Calibri"/>
               </a:rPr>
-              <a:t>1.  The reconciliation dashboard</a:t>
+              <a:t>1.  The dashboard, in business language</a:t>
             </a:r>
           </a:p>
           <a:p>
@@ -10090,13 +10118,13 @@
               </a:spcAft>
             </a:pPr>
             <a:r>
-              <a:rPr sz="1400" b="0" i="0">
+              <a:rPr sz="1200" b="0" i="0">
                 <a:solidFill>
                   <a:srgbClr val="333F52"/>
                 </a:solidFill>
                 <a:latin typeface="Calibri"/>
               </a:rPr>
-              <a:t>We open the live dashboard. It shows the last seven days of predictions paired with realized revenue from the sales ledger — predicted RPC, realized RPC, residual, and which model branch served each click.</a:t>
+              <a:t>We open the live dashboard. KPIs in pounds and percentages explain how much we earned, how accurate the model was, and how many clicks ended up converting. Daily and residual charts answer 'is the model right, and which direction does it err?' in one glance.</a:t>
             </a:r>
           </a:p>
           <a:p>
@@ -10109,13 +10137,13 @@
               </a:spcAft>
             </a:pPr>
             <a:r>
-              <a:rPr sz="1800" b="1" i="0">
+              <a:rPr sz="1600" b="1" i="0">
                 <a:solidFill>
                   <a:srgbClr val="0F6E7A"/>
                 </a:solidFill>
                 <a:latin typeface="Calibri"/>
               </a:rPr>
-              <a:t>2.  A prediction in flight</a:t>
+              <a:t>2.  You drive the model — yourself</a:t>
             </a:r>
           </a:p>
           <a:p>
@@ -10128,13 +10156,13 @@
               </a:spcAft>
             </a:pPr>
             <a:r>
-              <a:rPr sz="1400" b="0" i="0">
+              <a:rPr sz="1200" b="0" i="0">
                 <a:solidFill>
                   <a:srgbClr val="333F52"/>
                 </a:solidFill>
                 <a:latin typeface="Calibri"/>
               </a:rPr>
-              <a:t>We send a sample click context to the live scoring API and receive an RPC estimate, end-to-end, in under a second. The same input is then sent to the explain path to show per-feature attributions.</a:t>
+              <a:t>We hand you the keyboard. Describe a click in plain English — device, country, hour of day, search intent, user trust score, auction pressure, recent earnings, repeat visits — and press Predict. In under a second you see the predicted revenue, the model version that priced it, and the latency. Below it, a live pipeline trace lights up the five backend steps as they happen: validate, guardrails, AI model on Vertex, BigQuery stream, SHAP explanation.</a:t>
             </a:r>
           </a:p>
           <a:p>
@@ -10147,13 +10175,13 @@
               </a:spcAft>
             </a:pPr>
             <a:r>
-              <a:rPr sz="1800" b="1" i="0">
+              <a:rPr sz="1600" b="1" i="0">
                 <a:solidFill>
                   <a:srgbClr val="0F6E7A"/>
                 </a:solidFill>
                 <a:latin typeface="Calibri"/>
               </a:rPr>
-              <a:t>3.  The safety net in action</a:t>
+              <a:t>3.  Why the model said that</a:t>
             </a:r>
           </a:p>
           <a:p>
@@ -10166,13 +10194,51 @@
               </a:spcAft>
             </a:pPr>
             <a:r>
-              <a:rPr sz="1400" b="0" i="0">
+              <a:rPr sz="1200" b="0" i="0">
                 <a:solidFill>
                   <a:srgbClr val="333F52"/>
                 </a:solidFill>
                 <a:latin typeface="Calibri"/>
               </a:rPr>
-              <a:t>We send a deliberately malformed payload. The service rejects it cleanly, the circuit-breaker counters tick, and the request never reaches the model. No degradation visible to clean traffic.</a:t>
+              <a:t>The same prediction renders a horizontal-bar attribution chart: green bars pushed the price up, red pushed it down, starting from the model's baseline. Every prediction is auditable, and the names on the chart are plain English ('User trust score', 'Recent 7-day earnings'), not engineering jargon.</a:t>
+            </a:r>
+          </a:p>
+          <a:p>
+            <a:pPr>
+              <a:lnSpc>
+                <a:spcPct val="120000"/>
+              </a:lnSpc>
+              <a:spcAft>
+                <a:spcPts val="600"/>
+              </a:spcAft>
+            </a:pPr>
+            <a:r>
+              <a:rPr sz="1600" b="1" i="0">
+                <a:solidFill>
+                  <a:srgbClr val="0F6E7A"/>
+                </a:solidFill>
+                <a:latin typeface="Calibri"/>
+              </a:rPr>
+              <a:t>4.  The safety net, on cue</a:t>
+            </a:r>
+          </a:p>
+          <a:p>
+            <a:pPr>
+              <a:lnSpc>
+                <a:spcPct val="120000"/>
+              </a:lnSpc>
+              <a:spcAft>
+                <a:spcPts val="600"/>
+              </a:spcAft>
+            </a:pPr>
+            <a:r>
+              <a:rPr sz="1200" b="0" i="0">
+                <a:solidFill>
+                  <a:srgbClr val="333F52"/>
+                </a:solidFill>
+                <a:latin typeface="Calibri"/>
+              </a:rPr>
+              <a:t>We send a deliberately malformed click. The service rejects it cleanly, the circuit-breaker counters tick on the model-health panel, and the request never reaches the model. No degradation visible to clean traffic.</a:t>
             </a:r>
           </a:p>
           <a:p>
@@ -10182,29 +10248,13 @@
               </a:lnSpc>
             </a:pPr>
             <a:r>
-              <a:rPr sz="1200" b="0" i="1">
+              <a:rPr sz="1000" b="0" i="1">
                 <a:solidFill>
                   <a:srgbClr val="6B7380"/>
                 </a:solidFill>
                 <a:latin typeface="Calibri"/>
               </a:rPr>
-              <a:t>Dashboard  ·  https://dashboard-staging-794974391956.europe-west2.run.app</a:t>
-            </a:r>
-          </a:p>
-          <a:p>
-            <a:pPr>
-              <a:lnSpc>
-                <a:spcPct val="120000"/>
-              </a:lnSpc>
-            </a:pPr>
-            <a:r>
-              <a:rPr sz="1200" b="0" i="1">
-                <a:solidFill>
-                  <a:srgbClr val="6B7380"/>
-                </a:solidFill>
-                <a:latin typeface="Calibri"/>
-              </a:rPr>
-              <a:t>Scoring API  ·  https://scoring-api-staging-794974391956.europe-west2.run.app</a:t>
+              <a:t>Live dashboard  ·  https://dashboard-staging-794974391956.europe-west2.run.app</a:t>
             </a:r>
           </a:p>
         </p:txBody>

</xml_diff>

<commit_message>
deck: regenerate client-demo + searce-build decks (fix corrupt pptx)
client-demo-deck had the same fractional-EMU connector bug (arrows + the line()
helper) that flagged the pptx corrupt in PowerPoint — coerce connector coords to
int. searce-build-overview has no connectors (already valid); regenerated to keep
the committed pptx in sync with its generator. Verified both: 0 fractional-EMU
attributes, all slides well-formed, reopen cleanly.

Co-Authored-By: Claude Opus 4.8 (1M context) <noreply@anthropic.com>
</commit_message>
<xml_diff>
--- a/docs/client-demo-deck.pptx
+++ b/docs/client-demo-deck.pptx
@@ -6176,8 +6176,8 @@
         </p:nvCxnSpPr>
         <p:spPr>
           <a:xfrm>
-            <a:off x="2981883.75" y="3634740.0"/>
-            <a:ext cx="314960.0" cy="0.0"/>
+            <a:off x="2981883" y="3634740"/>
+            <a:ext cx="314960" cy="0"/>
           </a:xfrm>
           <a:prstGeom prst="bentConnector3">
             <a:avLst/>
@@ -6623,8 +6623,8 @@
         </p:nvCxnSpPr>
         <p:spPr>
           <a:xfrm>
-            <a:off x="5938367.5" y="3634740.0"/>
-            <a:ext cx="314960.0" cy="0.0"/>
+            <a:off x="5938367" y="3634740"/>
+            <a:ext cx="314960" cy="0"/>
           </a:xfrm>
           <a:prstGeom prst="bentConnector3">
             <a:avLst/>
@@ -7070,8 +7070,8 @@
         </p:nvCxnSpPr>
         <p:spPr>
           <a:xfrm>
-            <a:off x="8894851.25" y="3634740.0"/>
-            <a:ext cx="314960.0" cy="0.0"/>
+            <a:off x="8894851" y="3634740"/>
+            <a:ext cx="314960" cy="0"/>
           </a:xfrm>
           <a:prstGeom prst="bentConnector3">
             <a:avLst/>

</xml_diff>